<commit_message>
Destaca apresentação e esclarece equivalência de API e mensalidade
</commit_message>
<xml_diff>
--- a/media/one-pager.pptx
+++ b/media/one-pager.pptx
@@ -2,13 +2,13 @@
 <file path=ppt/presentation.xml><?xml version="1.0" encoding="utf-8"?>
 <p:presentation xmlns:p="http://schemas.openxmlformats.org/presentationml/2006/main">
   <p:sldMasterIdLst>
-    <p:sldMasterId xmlns:r="http://schemas.openxmlformats.org/officeDocument/2006/relationships" id="2147483648" r:id="R64da7c71a6b343e0"/>
+    <p:sldMasterId xmlns:r="http://schemas.openxmlformats.org/officeDocument/2006/relationships" id="2147483648" r:id="R7fd23f08cd594c93"/>
   </p:sldMasterIdLst>
   <p:notesMasterIdLst>
-    <p:notesMasterId xmlns:r="http://schemas.openxmlformats.org/officeDocument/2006/relationships" r:id="Rfda922835a1d4399"/>
+    <p:notesMasterId xmlns:r="http://schemas.openxmlformats.org/officeDocument/2006/relationships" r:id="Rbc9c9e03c80c4e29"/>
   </p:notesMasterIdLst>
   <p:sldIdLst>
-    <p:sldId xmlns:r="http://schemas.openxmlformats.org/officeDocument/2006/relationships" id="256" r:id="R52ee033a584d446d"/>
+    <p:sldId xmlns:r="http://schemas.openxmlformats.org/officeDocument/2006/relationships" id="256" r:id="R841bca4cad034949"/>
   </p:sldIdLst>
   <p:sldSz cx="12192000" cy="6858000"/>
   <p:notesSz cx="6858000" cy="9144000"/>
@@ -472,7 +472,7 @@
           </a:p>
           <a:p xmlns:a="http://schemas.openxmlformats.org/drawingml/2006/main">
             <a:r>
-              <a:t>R$36/milhão é premissa hipotética de processamento de API, mantida para comparar este exemplo; não afirma preço atual de um modelo, câmbio atual nem cobrança observada. Antes R$36/dia, agora R$25,20/dia, diferença R$10,80/dia, R$54/semana e R$237,60/mês. O usuário informou mensalidade igual: não há desconto na assinatura. O cenário assume acesso auxiliar incluído ou local, com margem disponível e sem cobrança avulsa; energia e tokens dos auxiliares não foram precificados.</a:t>
+              <a:t>R$36/milhão é premissa hipotética de processamento de API, mantida para comparar este exemplo; não afirma preço atual de um modelo, câmbio atual nem cobrança observada. Antes R$36/dia, agora R$25,20/dia, diferença R$10,80/dia, R$54/semana e R$237,60/mês. O usuário informou mensalidade igual: economia financeira na assinatura é R$0. Os R$237,60 são duzentos e trinta e sete reais e sessenta centavos de processamento equivalente de API, não desconto nem despesa observada. Com mais entregas pela mesma mensalidade, o custo médio por entrega pode cair. Exemplo meramente aritmético: mensalidade M / 10 entregas versus M / 14 entregas, redução de28,6% por entrega. Não há medição do número de entregas ou da espera real. O cenário assume acesso auxiliar incluído ou local, com margem disponível e sem cobrança avulsa; energia e tokens dos auxiliares não foram precificados.</a:t>
             </a:r>
           </a:p>
           <a:p xmlns:a="http://schemas.openxmlformats.org/drawingml/2006/main">
@@ -539,7 +539,7 @@
           <p:cNvPr id="3" name="Title">
             <a:extLst xmlns:a="http://schemas.openxmlformats.org/drawingml/2006/main">
               <a:ext uri="{FF2B5EF4-FFF2-40B4-BE49-F238E27FC236}">
-                <a16:creationId xmlns:a16="http://schemas.microsoft.com/office/drawing/2014/main" id="{D78AF395-A714-4FF6-97B7-6587FBC6937D}"/>
+                <a16:creationId xmlns:a16="http://schemas.microsoft.com/office/drawing/2014/main" id="{72B9C44B-CEB7-48E5-A4AB-9204620FCD01}"/>
               </a:ext>
             </a:extLst>
           </p:cNvPr>
@@ -696,7 +696,7 @@
           <p:cNvPr id="2" name="Subtitle">
             <a:extLst xmlns:a="http://schemas.openxmlformats.org/drawingml/2006/main">
               <a:ext uri="{FF2B5EF4-FFF2-40B4-BE49-F238E27FC236}">
-                <a16:creationId xmlns:a16="http://schemas.microsoft.com/office/drawing/2014/main" id="{A4704D67-0B9E-4B4D-968E-036E1D80CFC9}"/>
+                <a16:creationId xmlns:a16="http://schemas.microsoft.com/office/drawing/2014/main" id="{1563BA4A-2AB4-4B70-BDAE-841C39FF0C49}"/>
               </a:ext>
             </a:extLst>
           </p:cNvPr>
@@ -870,7 +870,7 @@
           <p:cNvPr id="2" name="Section title">
             <a:extLst xmlns:a="http://schemas.openxmlformats.org/drawingml/2006/main">
               <a:ext uri="{FF2B5EF4-FFF2-40B4-BE49-F238E27FC236}">
-                <a16:creationId xmlns:a16="http://schemas.microsoft.com/office/drawing/2014/main" id="{013990F2-5514-4186-B71D-FFE9E9ED1EAF}"/>
+                <a16:creationId xmlns:a16="http://schemas.microsoft.com/office/drawing/2014/main" id="{6C667B96-F746-4FB9-B514-AD97CB54352D}"/>
               </a:ext>
             </a:extLst>
           </p:cNvPr>
@@ -1044,7 +1044,7 @@
           <p:cNvPr id="3" name="Title">
             <a:extLst xmlns:a="http://schemas.openxmlformats.org/drawingml/2006/main">
               <a:ext uri="{FF2B5EF4-FFF2-40B4-BE49-F238E27FC236}">
-                <a16:creationId xmlns:a16="http://schemas.microsoft.com/office/drawing/2014/main" id="{87A11708-FC1B-488F-8E4A-BCC1D78BF575}"/>
+                <a16:creationId xmlns:a16="http://schemas.microsoft.com/office/drawing/2014/main" id="{B293D361-9101-454F-8F81-AACF04ABCE71}"/>
               </a:ext>
             </a:extLst>
           </p:cNvPr>
@@ -1201,7 +1201,7 @@
           <p:cNvPr id="2" name="Body">
             <a:extLst xmlns:a="http://schemas.openxmlformats.org/drawingml/2006/main">
               <a:ext uri="{FF2B5EF4-FFF2-40B4-BE49-F238E27FC236}">
-                <a16:creationId xmlns:a16="http://schemas.microsoft.com/office/drawing/2014/main" id="{BF091CAE-1993-4451-A32A-580972A8FEBA}"/>
+                <a16:creationId xmlns:a16="http://schemas.microsoft.com/office/drawing/2014/main" id="{552D83E6-5D72-4A63-8FBE-374F8B6DCB80}"/>
               </a:ext>
             </a:extLst>
           </p:cNvPr>
@@ -1375,7 +1375,7 @@
           <p:cNvPr id="4" name="Title">
             <a:extLst xmlns:a="http://schemas.openxmlformats.org/drawingml/2006/main">
               <a:ext uri="{FF2B5EF4-FFF2-40B4-BE49-F238E27FC236}">
-                <a16:creationId xmlns:a16="http://schemas.microsoft.com/office/drawing/2014/main" id="{777FF309-90E3-4A22-902A-A3A35E8A4B4A}"/>
+                <a16:creationId xmlns:a16="http://schemas.microsoft.com/office/drawing/2014/main" id="{CD1DEFDC-F6F1-4E8B-B315-FF97EE772654}"/>
               </a:ext>
             </a:extLst>
           </p:cNvPr>
@@ -1532,7 +1532,7 @@
           <p:cNvPr id="2" name="Left column">
             <a:extLst xmlns:a="http://schemas.openxmlformats.org/drawingml/2006/main">
               <a:ext uri="{FF2B5EF4-FFF2-40B4-BE49-F238E27FC236}">
-                <a16:creationId xmlns:a16="http://schemas.microsoft.com/office/drawing/2014/main" id="{37D7BA6E-3EA4-4C28-8C5F-5B3988017376}"/>
+                <a16:creationId xmlns:a16="http://schemas.microsoft.com/office/drawing/2014/main" id="{B06C76A5-1377-413D-B77F-A5F9EC35A588}"/>
               </a:ext>
             </a:extLst>
           </p:cNvPr>
@@ -1689,7 +1689,7 @@
           <p:cNvPr id="3" name="Right column">
             <a:extLst xmlns:a="http://schemas.openxmlformats.org/drawingml/2006/main">
               <a:ext uri="{FF2B5EF4-FFF2-40B4-BE49-F238E27FC236}">
-                <a16:creationId xmlns:a16="http://schemas.microsoft.com/office/drawing/2014/main" id="{169CE1E0-E7A4-4ED5-B244-8C62C5503920}"/>
+                <a16:creationId xmlns:a16="http://schemas.microsoft.com/office/drawing/2014/main" id="{B2336450-ADE1-4436-BAB4-00A43E5A1485}"/>
               </a:ext>
             </a:extLst>
           </p:cNvPr>
@@ -1863,7 +1863,7 @@
           <p:cNvPr id="3" name="Title">
             <a:extLst xmlns:a="http://schemas.openxmlformats.org/drawingml/2006/main">
               <a:ext uri="{FF2B5EF4-FFF2-40B4-BE49-F238E27FC236}">
-                <a16:creationId xmlns:a16="http://schemas.microsoft.com/office/drawing/2014/main" id="{D471E0DB-446A-49A4-B9DF-6753088459F4}"/>
+                <a16:creationId xmlns:a16="http://schemas.microsoft.com/office/drawing/2014/main" id="{D2CBE39E-090F-4086-ACBF-8CF623B0F309}"/>
               </a:ext>
             </a:extLst>
           </p:cNvPr>
@@ -2020,7 +2020,7 @@
           <p:cNvPr id="2" name="Left column">
             <a:extLst xmlns:a="http://schemas.openxmlformats.org/drawingml/2006/main">
               <a:ext uri="{FF2B5EF4-FFF2-40B4-BE49-F238E27FC236}">
-                <a16:creationId xmlns:a16="http://schemas.microsoft.com/office/drawing/2014/main" id="{B71AFDF7-4873-4D85-BD8D-CC7E25484BA7}"/>
+                <a16:creationId xmlns:a16="http://schemas.microsoft.com/office/drawing/2014/main" id="{F7FB93EA-BF20-4B6A-A880-FF36811F53DA}"/>
               </a:ext>
             </a:extLst>
           </p:cNvPr>
@@ -2215,12 +2215,12 @@
   </p:cSld>
   <p:clrMap bg1="lt1" tx1="dk1" bg2="lt2" tx2="dk2" accent1="accent1" accent2="accent2" accent3="accent3" accent4="accent4" accent5="accent5" accent6="accent6" hlink="hlink" folHlink="folHlink"/>
   <p:sldLayoutIdLst>
-    <p:sldLayoutId xmlns:r="http://schemas.openxmlformats.org/officeDocument/2006/relationships" id="2147483649" r:id="R77d386b959484af7"/>
-    <p:sldLayoutId xmlns:r="http://schemas.openxmlformats.org/officeDocument/2006/relationships" id="2147483650" r:id="R9b5fb433e61049cd"/>
-    <p:sldLayoutId xmlns:r="http://schemas.openxmlformats.org/officeDocument/2006/relationships" id="2147483651" r:id="R5df1550d812a4221"/>
-    <p:sldLayoutId xmlns:r="http://schemas.openxmlformats.org/officeDocument/2006/relationships" id="2147483652" r:id="R7b0b1fd930254326"/>
-    <p:sldLayoutId xmlns:r="http://schemas.openxmlformats.org/officeDocument/2006/relationships" id="2147483653" r:id="Rc5a2286916ab4445"/>
-    <p:sldLayoutId xmlns:r="http://schemas.openxmlformats.org/officeDocument/2006/relationships" id="2147483654" r:id="R9301a0d636d7440d"/>
+    <p:sldLayoutId xmlns:r="http://schemas.openxmlformats.org/officeDocument/2006/relationships" id="2147483649" r:id="Rc1801f6a62b744cc"/>
+    <p:sldLayoutId xmlns:r="http://schemas.openxmlformats.org/officeDocument/2006/relationships" id="2147483650" r:id="R5a9e5649e86548af"/>
+    <p:sldLayoutId xmlns:r="http://schemas.openxmlformats.org/officeDocument/2006/relationships" id="2147483651" r:id="R7e8f3d7c888e4e9b"/>
+    <p:sldLayoutId xmlns:r="http://schemas.openxmlformats.org/officeDocument/2006/relationships" id="2147483652" r:id="Rc8df512d408c48c8"/>
+    <p:sldLayoutId xmlns:r="http://schemas.openxmlformats.org/officeDocument/2006/relationships" id="2147483653" r:id="R6687e298e21d47c1"/>
+    <p:sldLayoutId xmlns:r="http://schemas.openxmlformats.org/officeDocument/2006/relationships" id="2147483654" r:id="Ra42f588b204d4feb"/>
   </p:sldLayoutIdLst>
   <p:txStyles>
     <p:titleStyle>
@@ -2753,7 +2753,7 @@
   <c:chart>
     <c:plotArea>
       <c:barChart>
-        <c:barDir val="col"/>
+        <c:barDir val="bar"/>
         <c:grouping val="clustered"/>
         <c:varyColors val="1"/>
         <c:ser>
@@ -2768,7 +2768,7 @@
             <c:invertIfNegative val="0"/>
             <c:spPr>
               <a:solidFill xmlns:a="http://schemas.openxmlformats.org/drawingml/2006/main">
-                <a:srgbClr val="607487"/>
+                <a:srgbClr val="70DEC9"/>
               </a:solidFill>
             </c:spPr>
           </c:dPt>
@@ -2777,7 +2777,7 @@
             <c:invertIfNegative val="0"/>
             <c:spPr>
               <a:solidFill xmlns:a="http://schemas.openxmlformats.org/drawingml/2006/main">
-                <a:srgbClr val="70DEC9"/>
+                <a:srgbClr val="607487"/>
               </a:solidFill>
             </c:spPr>
           </c:dPt>
@@ -2790,7 +2790,47 @@
                   <a:lstStyle xmlns:a="http://schemas.openxmlformats.org/drawingml/2006/main"/>
                   <a:p xmlns:a="http://schemas.openxmlformats.org/drawingml/2006/main">
                     <a:r>
-                      <a:rPr sz="2025" b="1">
+                      <a:rPr sz="1800" b="1">
+                        <a:solidFill>
+                          <a:srgbClr val="101923"/>
+                        </a:solidFill>
+                        <a:latin typeface="Arial"/>
+                        <a:ea typeface="Arial"/>
+                        <a:cs typeface="Arial"/>
+                      </a:rPr>
+                      <a:t>700 mil</a:t>
+                    </a:r>
+                  </a:p>
+                </c:rich>
+              </c:tx>
+              <c:txPr>
+                <a:bodyPr xmlns:a="http://schemas.openxmlformats.org/drawingml/2006/main" anchorCtr="1"/>
+                <a:lstStyle xmlns:a="http://schemas.openxmlformats.org/drawingml/2006/main"/>
+                <a:p xmlns:a="http://schemas.openxmlformats.org/drawingml/2006/main">
+                  <a:pPr>
+                    <a:defRPr sz="1800" b="1">
+                      <a:solidFill>
+                        <a:srgbClr val="101923"/>
+                      </a:solidFill>
+                      <a:latin typeface="Arial"/>
+                      <a:ea typeface="Arial"/>
+                      <a:cs typeface="Arial"/>
+                    </a:defRPr>
+                  </a:pPr>
+                </a:p>
+              </c:txPr>
+              <c:dLblPos val="inEnd"/>
+              <c:showVal val="0"/>
+            </c:dLbl>
+            <c:dLbl>
+              <c:idx val="1"/>
+              <c:tx>
+                <c:rich>
+                  <a:bodyPr xmlns:a="http://schemas.openxmlformats.org/drawingml/2006/main"/>
+                  <a:lstStyle xmlns:a="http://schemas.openxmlformats.org/drawingml/2006/main"/>
+                  <a:p xmlns:a="http://schemas.openxmlformats.org/drawingml/2006/main">
+                    <a:r>
+                      <a:rPr sz="1800" b="1">
                         <a:solidFill>
                           <a:srgbClr val="F5F6F0"/>
                         </a:solidFill>
@@ -2808,7 +2848,7 @@
                 <a:lstStyle xmlns:a="http://schemas.openxmlformats.org/drawingml/2006/main"/>
                 <a:p xmlns:a="http://schemas.openxmlformats.org/drawingml/2006/main">
                   <a:pPr>
-                    <a:defRPr sz="2025" b="1">
+                    <a:defRPr sz="1800" b="1">
                       <a:solidFill>
                         <a:srgbClr val="F5F6F0"/>
                       </a:solidFill>
@@ -2819,47 +2859,7 @@
                   </a:pPr>
                 </a:p>
               </c:txPr>
-              <c:dLblPos val="outEnd"/>
-              <c:showVal val="0"/>
-            </c:dLbl>
-            <c:dLbl>
-              <c:idx val="1"/>
-              <c:tx>
-                <c:rich>
-                  <a:bodyPr xmlns:a="http://schemas.openxmlformats.org/drawingml/2006/main"/>
-                  <a:lstStyle xmlns:a="http://schemas.openxmlformats.org/drawingml/2006/main"/>
-                  <a:p xmlns:a="http://schemas.openxmlformats.org/drawingml/2006/main">
-                    <a:r>
-                      <a:rPr sz="2025" b="1">
-                        <a:solidFill>
-                          <a:srgbClr val="70DEC9"/>
-                        </a:solidFill>
-                        <a:latin typeface="Arial"/>
-                        <a:ea typeface="Arial"/>
-                        <a:cs typeface="Arial"/>
-                      </a:rPr>
-                      <a:t>700 mil</a:t>
-                    </a:r>
-                  </a:p>
-                </c:rich>
-              </c:tx>
-              <c:txPr>
-                <a:bodyPr xmlns:a="http://schemas.openxmlformats.org/drawingml/2006/main" anchorCtr="1"/>
-                <a:lstStyle xmlns:a="http://schemas.openxmlformats.org/drawingml/2006/main"/>
-                <a:p xmlns:a="http://schemas.openxmlformats.org/drawingml/2006/main">
-                  <a:pPr>
-                    <a:defRPr sz="2025" b="1">
-                      <a:solidFill>
-                        <a:srgbClr val="70DEC9"/>
-                      </a:solidFill>
-                      <a:latin typeface="Arial"/>
-                      <a:ea typeface="Arial"/>
-                      <a:cs typeface="Arial"/>
-                    </a:defRPr>
-                  </a:pPr>
-                </a:p>
-              </c:txPr>
-              <c:dLblPos val="outEnd"/>
+              <c:dLblPos val="inEnd"/>
               <c:showVal val="0"/>
             </c:dLbl>
           </c:dLbls>
@@ -2869,10 +2869,10 @@
               <c:strCache>
                 <c:ptCount val="2"/>
                 <c:pt idx="0">
-                  <c:v>Antes</c:v>
+                  <c:v>Agora</c:v>
                 </c:pt>
                 <c:pt idx="1">
-                  <c:v>Agora</c:v>
+                  <c:v>Antes</c:v>
                 </c:pt>
               </c:strCache>
             </c:strRef>
@@ -2884,10 +2884,10 @@
                 <c:formatCode>General</c:formatCode>
                 <c:ptCount val="2"/>
                 <c:pt idx="0">
-                  <c:v>1000000</c:v>
+                  <c:v>700000</c:v>
                 </c:pt>
                 <c:pt idx="1">
-                  <c:v>700000</c:v>
+                  <c:v>1000000</c:v>
                 </c:pt>
               </c:numCache>
             </c:numRef>
@@ -2908,7 +2908,7 @@
               </a:pPr>
             </a:p>
           </c:txPr>
-          <c:dLblPos val="outEnd"/>
+          <c:dLblPos val="inEnd"/>
           <c:showLegendKey val="0"/>
           <c:showVal val="1"/>
           <c:showCatName val="0"/>
@@ -2917,7 +2917,7 @@
           <c:showBubbleSize val="0"/>
           <c:showLeaderLines val="0"/>
         </c:dLbls>
-        <c:gapWidth val="120"/>
+        <c:gapWidth val="60"/>
         <c:axId val="48650112"/>
         <c:axId val="48672768"/>
       </c:barChart>
@@ -2927,7 +2927,7 @@
           <c:orientation val="minMax"/>
         </c:scaling>
         <c:delete val="0"/>
-        <c:axPos val="b"/>
+        <c:axPos val="l"/>
         <c:numFmt formatCode="General"/>
         <c:majorTickMark val="none"/>
         <c:minorTickMark val="none"/>
@@ -2941,7 +2941,7 @@
           <a:lstStyle xmlns:a="http://schemas.openxmlformats.org/drawingml/2006/main"/>
           <a:p xmlns:a="http://schemas.openxmlformats.org/drawingml/2006/main">
             <a:pPr>
-              <a:defRPr sz="1725" b="1">
+              <a:defRPr sz="1575" b="1">
                 <a:solidFill>
                   <a:srgbClr val="F5F6F0"/>
                 </a:solidFill>
@@ -2958,11 +2958,11 @@
         <c:axId val="48672768"/>
         <c:scaling>
           <c:orientation val="minMax"/>
-          <c:max val="1200000"/>
+          <c:max val="1100000"/>
           <c:min val="0"/>
         </c:scaling>
         <c:delete val="1"/>
-        <c:axPos val="l"/>
+        <c:axPos val="b"/>
         <c:numFmt formatCode="General"/>
         <c:majorTickMark val="none"/>
         <c:minorTickMark val="none"/>
@@ -3039,10 +3039,10 @@
       </p:grpSpPr>
       <p:sp>
         <p:nvSpPr>
-          <p:cNvPr id="23" name="">
+          <p:cNvPr id="25" name="">
             <a:extLst xmlns:a="http://schemas.openxmlformats.org/drawingml/2006/main">
               <a:ext uri="{FF2B5EF4-FFF2-40B4-BE49-F238E27FC236}">
-                <a16:creationId xmlns:a16="http://schemas.microsoft.com/office/drawing/2014/main" id="{0F8CE783-9A9B-419F-BE14-2A714048FB2E}"/>
+                <a16:creationId xmlns:a16="http://schemas.microsoft.com/office/drawing/2014/main" id="{B249E381-6774-4E56-BC9A-83F7CA70DC71}"/>
               </a:ext>
             </a:extLst>
           </p:cNvPr>
@@ -3110,7 +3110,7 @@
           <p:cNvPr id="2" name="">
             <a:extLst xmlns:a="http://schemas.openxmlformats.org/drawingml/2006/main">
               <a:ext uri="{FF2B5EF4-FFF2-40B4-BE49-F238E27FC236}">
-                <a16:creationId xmlns:a16="http://schemas.microsoft.com/office/drawing/2014/main" id="{A765D082-B4AE-4775-9A62-8CCDBCDD13C6}"/>
+                <a16:creationId xmlns:a16="http://schemas.microsoft.com/office/drawing/2014/main" id="{F5A314CE-6A2F-46B4-ABFD-2652AD2D7547}"/>
               </a:ext>
             </a:extLst>
           </p:cNvPr>
@@ -3178,7 +3178,7 @@
           <p:cNvPr id="3" name="">
             <a:extLst xmlns:a="http://schemas.openxmlformats.org/drawingml/2006/main">
               <a:ext uri="{FF2B5EF4-FFF2-40B4-BE49-F238E27FC236}">
-                <a16:creationId xmlns:a16="http://schemas.microsoft.com/office/drawing/2014/main" id="{BB6A16BD-B659-4265-9586-69A0C5B83910}"/>
+                <a16:creationId xmlns:a16="http://schemas.microsoft.com/office/drawing/2014/main" id="{AFA04C1A-E9BA-4E56-9BBF-802B400A209C}"/>
               </a:ext>
             </a:extLst>
           </p:cNvPr>
@@ -3241,34 +3241,12 @@
           </a:p>
         </p:txBody>
       </p:sp>
-      <p:graphicFrame>
-        <p:nvGraphicFramePr>
-          <p:cNvPr id="4" name="Chart">
+      <p:sp>
+        <p:nvSpPr>
+          <p:cNvPr id="4" name="">
             <a:extLst xmlns:a="http://schemas.openxmlformats.org/drawingml/2006/main">
               <a:ext uri="{FF2B5EF4-FFF2-40B4-BE49-F238E27FC236}">
-                <a16:creationId xmlns:a16="http://schemas.microsoft.com/office/drawing/2014/main" id="{62EC5842-EF53-4D69-87C5-8F441020D3DB}"/>
-              </a:ext>
-            </a:extLst>
-          </p:cNvPr>
-          <p:cNvGraphicFramePr/>
-          <p:nvPr/>
-        </p:nvGraphicFramePr>
-        <p:xfrm>
-          <a:off xmlns:a="http://schemas.openxmlformats.org/drawingml/2006/main" x="533400" y="1504950"/>
-          <a:ext xmlns:a="http://schemas.openxmlformats.org/drawingml/2006/main" cx="4000500" cy="1571625"/>
-        </p:xfrm>
-        <a:graphic xmlns:a="http://schemas.openxmlformats.org/drawingml/2006/main">
-          <a:graphicData uri="http://schemas.openxmlformats.org/drawingml/2006/chart">
-            <c:chart xmlns:r="http://schemas.openxmlformats.org/officeDocument/2006/relationships" xmlns:c="http://schemas.openxmlformats.org/drawingml/2006/chart" r:id="Rb38dc8f509c44e0e"/>
-          </a:graphicData>
-        </a:graphic>
-      </p:graphicFrame>
-      <p:sp>
-        <p:nvSpPr>
-          <p:cNvPr id="5" name="">
-            <a:extLst xmlns:a="http://schemas.openxmlformats.org/drawingml/2006/main">
-              <a:ext uri="{FF2B5EF4-FFF2-40B4-BE49-F238E27FC236}">
-                <a16:creationId xmlns:a16="http://schemas.microsoft.com/office/drawing/2014/main" id="{59DA0F69-B1EA-4459-8991-BC3AB2FBC144}"/>
+                <a16:creationId xmlns:a16="http://schemas.microsoft.com/office/drawing/2014/main" id="{1EE048EF-72FF-4FE5-9E28-7BC255791DEC}"/>
               </a:ext>
             </a:extLst>
           </p:cNvPr>
@@ -3279,8 +3257,8 @@
         </p:nvSpPr>
         <p:spPr>
           <a:xfrm xmlns:a="http://schemas.openxmlformats.org/drawingml/2006/main">
-            <a:off x="866775" y="3028950"/>
-            <a:ext cx="3857625" cy="238125"/>
+            <a:off x="533400" y="1524000"/>
+            <a:ext cx="4000500" cy="266700"/>
           </a:xfrm>
           <a:prstGeom xmlns:a="http://schemas.openxmlformats.org/drawingml/2006/main" prst="rect">
             <a:avLst/>
@@ -3296,7 +3274,7 @@
           </a:bodyPr>
           <a:lstStyle xmlns:a="http://schemas.openxmlformats.org/drawingml/2006/main">
             <a:defPPr>
-              <a:defRPr sz="1350" b="0">
+              <a:defRPr sz="1425" b="0">
                 <a:solidFill>
                   <a:srgbClr val="AAB8C5"/>
                 </a:solidFill>
@@ -3308,7 +3286,7 @@
           </a:lstStyle>
           <a:p xmlns:a="http://schemas.openxmlformats.org/drawingml/2006/main">
             <a:pPr>
-              <a:defRPr sz="1350" b="0">
+              <a:defRPr sz="1425" b="0">
                 <a:solidFill>
                   <a:srgbClr val="AAB8C5"/>
                 </a:solidFill>
@@ -3318,7 +3296,7 @@
               </a:defRPr>
             </a:pPr>
             <a:r>
-              <a:rPr sz="1350" b="0">
+              <a:rPr sz="1425" b="0">
                 <a:solidFill>
                   <a:srgbClr val="AAB8C5"/>
                 </a:solidFill>
@@ -3326,17 +3304,107 @@
                 <a:ea typeface="Arial"/>
                 <a:cs typeface="Arial"/>
               </a:rPr>
-              <a:t>tokens por dia no principal</a:t>
+              <a:t>Consumo diário do principal</a:t>
+            </a:r>
+          </a:p>
+        </p:txBody>
+      </p:sp>
+      <p:graphicFrame>
+        <p:nvGraphicFramePr>
+          <p:cNvPr id="5" name="Chart">
+            <a:extLst xmlns:a="http://schemas.openxmlformats.org/drawingml/2006/main">
+              <a:ext uri="{FF2B5EF4-FFF2-40B4-BE49-F238E27FC236}">
+                <a16:creationId xmlns:a16="http://schemas.microsoft.com/office/drawing/2014/main" id="{0EE0A955-9C23-48E6-B390-09C900663FF2}"/>
+              </a:ext>
+            </a:extLst>
+          </p:cNvPr>
+          <p:cNvGraphicFramePr/>
+          <p:nvPr/>
+        </p:nvGraphicFramePr>
+        <p:xfrm>
+          <a:off xmlns:a="http://schemas.openxmlformats.org/drawingml/2006/main" x="533400" y="1847850"/>
+          <a:ext xmlns:a="http://schemas.openxmlformats.org/drawingml/2006/main" cx="4133850" cy="1257300"/>
+        </p:xfrm>
+        <a:graphic xmlns:a="http://schemas.openxmlformats.org/drawingml/2006/main">
+          <a:graphicData uri="http://schemas.openxmlformats.org/drawingml/2006/chart">
+            <c:chart xmlns:r="http://schemas.openxmlformats.org/officeDocument/2006/relationships" xmlns:c="http://schemas.openxmlformats.org/drawingml/2006/chart" r:id="R51637a1f667b44a8"/>
+          </a:graphicData>
+        </a:graphic>
+      </p:graphicFrame>
+      <p:sp>
+        <p:nvSpPr>
+          <p:cNvPr id="6" name="">
+            <a:extLst xmlns:a="http://schemas.openxmlformats.org/drawingml/2006/main">
+              <a:ext uri="{FF2B5EF4-FFF2-40B4-BE49-F238E27FC236}">
+                <a16:creationId xmlns:a16="http://schemas.microsoft.com/office/drawing/2014/main" id="{FA30BE0E-B0A6-4D99-8076-41DC17CBCACF}"/>
+              </a:ext>
+            </a:extLst>
+          </p:cNvPr>
+          <p:cNvSpPr>
+            <a:spLocks xmlns:a="http://schemas.openxmlformats.org/drawingml/2006/main" noGrp="1"/>
+          </p:cNvSpPr>
+          <p:nvPr/>
+        </p:nvSpPr>
+        <p:spPr>
+          <a:xfrm xmlns:a="http://schemas.openxmlformats.org/drawingml/2006/main">
+            <a:off x="533400" y="3057525"/>
+            <a:ext cx="4133850" cy="266700"/>
+          </a:xfrm>
+          <a:prstGeom xmlns:a="http://schemas.openxmlformats.org/drawingml/2006/main" prst="rect">
+            <a:avLst/>
+          </a:prstGeom>
+          <a:noFill xmlns:a="http://schemas.openxmlformats.org/drawingml/2006/main"/>
+          <a:ln xmlns:a="http://schemas.openxmlformats.org/drawingml/2006/main" w="0">
+            <a:noFill/>
+          </a:ln>
+        </p:spPr>
+        <p:txBody>
+          <a:bodyPr xmlns:a="http://schemas.openxmlformats.org/drawingml/2006/main" wrap="square" lIns="0" tIns="0" rIns="0" bIns="0" anchor="t">
+            <a:noAutofit/>
+          </a:bodyPr>
+          <a:lstStyle xmlns:a="http://schemas.openxmlformats.org/drawingml/2006/main">
+            <a:defPPr>
+              <a:defRPr sz="1500" b="1">
+                <a:solidFill>
+                  <a:srgbClr val="70DEC9"/>
+                </a:solidFill>
+                <a:latin typeface="Arial"/>
+                <a:ea typeface="Arial"/>
+                <a:cs typeface="Arial"/>
+              </a:defRPr>
+            </a:defPPr>
+          </a:lstStyle>
+          <a:p xmlns:a="http://schemas.openxmlformats.org/drawingml/2006/main">
+            <a:pPr>
+              <a:defRPr sz="1500" b="1">
+                <a:solidFill>
+                  <a:srgbClr val="70DEC9"/>
+                </a:solidFill>
+                <a:latin typeface="Arial"/>
+                <a:ea typeface="Arial"/>
+                <a:cs typeface="Arial"/>
+              </a:defRPr>
+            </a:pPr>
+            <a:r>
+              <a:rPr sz="1500" b="1">
+                <a:solidFill>
+                  <a:srgbClr val="70DEC9"/>
+                </a:solidFill>
+                <a:latin typeface="Arial"/>
+                <a:ea typeface="Arial"/>
+                <a:cs typeface="Arial"/>
+              </a:rPr>
+              <a:t>300 mil tokens a menos por dia (30%)</a:t>
             </a:r>
           </a:p>
         </p:txBody>
       </p:sp>
       <p:sp>
         <p:nvSpPr>
-          <p:cNvPr id="6" name="">
+          <p:cNvPr id="7" name="">
             <a:extLst xmlns:a="http://schemas.openxmlformats.org/drawingml/2006/main">
               <a:ext uri="{FF2B5EF4-FFF2-40B4-BE49-F238E27FC236}">
-                <a16:creationId xmlns:a16="http://schemas.microsoft.com/office/drawing/2014/main" id="{CB70A9AB-BD7F-4BBB-8317-5FDBED5E439C}"/>
+                <a16:creationId xmlns:a16="http://schemas.microsoft.com/office/drawing/2014/main" id="{EC45B421-8C98-4C8C-9E95-61B673161686}"/>
               </a:ext>
             </a:extLst>
           </p:cNvPr>
@@ -3401,10 +3469,10 @@
       </p:sp>
       <p:sp>
         <p:nvSpPr>
-          <p:cNvPr id="7" name="">
+          <p:cNvPr id="8" name="">
             <a:extLst xmlns:a="http://schemas.openxmlformats.org/drawingml/2006/main">
               <a:ext uri="{FF2B5EF4-FFF2-40B4-BE49-F238E27FC236}">
-                <a16:creationId xmlns:a16="http://schemas.microsoft.com/office/drawing/2014/main" id="{EC049477-140D-404D-B7F1-A32A5D39E0AC}"/>
+                <a16:creationId xmlns:a16="http://schemas.microsoft.com/office/drawing/2014/main" id="{7E338BA4-7C9D-40DB-8AFD-C0A806B4BEA5}"/>
               </a:ext>
             </a:extLst>
           </p:cNvPr>
@@ -3469,10 +3537,10 @@
       </p:sp>
       <p:sp>
         <p:nvSpPr>
-          <p:cNvPr id="8" name="">
+          <p:cNvPr id="9" name="">
             <a:extLst xmlns:a="http://schemas.openxmlformats.org/drawingml/2006/main">
               <a:ext uri="{FF2B5EF4-FFF2-40B4-BE49-F238E27FC236}">
-                <a16:creationId xmlns:a16="http://schemas.microsoft.com/office/drawing/2014/main" id="{4E606411-BD84-4F70-A496-874D15F073CB}"/>
+                <a16:creationId xmlns:a16="http://schemas.microsoft.com/office/drawing/2014/main" id="{BCADE662-877D-4CD6-82B8-8A04BE05A594}"/>
               </a:ext>
             </a:extLst>
           </p:cNvPr>
@@ -3537,10 +3605,10 @@
       </p:sp>
       <p:sp>
         <p:nvSpPr>
-          <p:cNvPr id="9" name="">
+          <p:cNvPr id="10" name="">
             <a:extLst xmlns:a="http://schemas.openxmlformats.org/drawingml/2006/main">
               <a:ext uri="{FF2B5EF4-FFF2-40B4-BE49-F238E27FC236}">
-                <a16:creationId xmlns:a16="http://schemas.microsoft.com/office/drawing/2014/main" id="{E9E1AD2C-6CF3-4BB8-AD2E-963C23C5B877}"/>
+                <a16:creationId xmlns:a16="http://schemas.microsoft.com/office/drawing/2014/main" id="{1E55CE58-E17E-49DB-B061-37E9B3C79A27}"/>
               </a:ext>
             </a:extLst>
           </p:cNvPr>
@@ -3605,10 +3673,10 @@
       </p:sp>
       <p:sp>
         <p:nvSpPr>
-          <p:cNvPr id="10" name="">
+          <p:cNvPr id="11" name="">
             <a:extLst xmlns:a="http://schemas.openxmlformats.org/drawingml/2006/main">
               <a:ext uri="{FF2B5EF4-FFF2-40B4-BE49-F238E27FC236}">
-                <a16:creationId xmlns:a16="http://schemas.microsoft.com/office/drawing/2014/main" id="{F17B92F4-86E1-458C-BD13-8ACDCD183E40}"/>
+                <a16:creationId xmlns:a16="http://schemas.microsoft.com/office/drawing/2014/main" id="{F38A7876-FFD8-47F2-9099-69F3357165FA}"/>
               </a:ext>
             </a:extLst>
           </p:cNvPr>
@@ -3673,10 +3741,10 @@
       </p:sp>
       <p:sp>
         <p:nvSpPr>
-          <p:cNvPr id="11" name="">
+          <p:cNvPr id="12" name="">
             <a:extLst xmlns:a="http://schemas.openxmlformats.org/drawingml/2006/main">
               <a:ext uri="{FF2B5EF4-FFF2-40B4-BE49-F238E27FC236}">
-                <a16:creationId xmlns:a16="http://schemas.microsoft.com/office/drawing/2014/main" id="{8F7E10D8-6D1E-42CC-8DE9-07EF4564893D}"/>
+                <a16:creationId xmlns:a16="http://schemas.microsoft.com/office/drawing/2014/main" id="{507BB1EB-3E87-4413-9747-F1529AC54BF0}"/>
               </a:ext>
             </a:extLst>
           </p:cNvPr>
@@ -3741,10 +3809,10 @@
       </p:sp>
       <p:sp>
         <p:nvSpPr>
-          <p:cNvPr id="12" name="">
+          <p:cNvPr id="13" name="">
             <a:extLst xmlns:a="http://schemas.openxmlformats.org/drawingml/2006/main">
               <a:ext uri="{FF2B5EF4-FFF2-40B4-BE49-F238E27FC236}">
-                <a16:creationId xmlns:a16="http://schemas.microsoft.com/office/drawing/2014/main" id="{20AF3885-B2EE-4F34-8CDA-841487D6B377}"/>
+                <a16:creationId xmlns:a16="http://schemas.microsoft.com/office/drawing/2014/main" id="{783520EE-BF46-4BA9-8B44-3C49FAB36408}"/>
               </a:ext>
             </a:extLst>
           </p:cNvPr>
@@ -3809,10 +3877,10 @@
       </p:sp>
       <p:graphicFrame>
         <p:nvGraphicFramePr>
-          <p:cNvPr id="13" name="">
+          <p:cNvPr id="14" name="">
             <a:extLst xmlns:a="http://schemas.openxmlformats.org/drawingml/2006/main">
               <a:ext uri="{FF2B5EF4-FFF2-40B4-BE49-F238E27FC236}">
-                <a16:creationId xmlns:a16="http://schemas.microsoft.com/office/drawing/2014/main" id="{8688E04A-5ADB-41AD-BCF3-5BC1DAFFCC52}"/>
+                <a16:creationId xmlns:a16="http://schemas.microsoft.com/office/drawing/2014/main" id="{3E024B88-2632-438F-816D-99F40B4C2625}"/>
               </a:ext>
             </a:extLst>
           </p:cNvPr>
@@ -3855,7 +3923,7 @@
                       </a:r>
                     </a:p>
                   </a:txBody>
-                  <a:tcPr marL="91440" marR="91440" marT="45720" marB="45720" anchor="ctr">
+                  <a:tcPr marL="95250" marR="95250" marT="0" marB="0" anchor="ctr">
                     <a:lnL w="0">
                       <a:noFill/>
                     </a:lnL>
@@ -3894,7 +3962,7 @@
                       </a:r>
                     </a:p>
                   </a:txBody>
-                  <a:tcPr marL="91440" marR="91440" marT="45720" marB="45720" anchor="ctr">
+                  <a:tcPr marL="95250" marR="95250" marT="0" marB="0" anchor="ctr">
                     <a:lnR w="0">
                       <a:noFill/>
                     </a:lnR>
@@ -3930,7 +3998,7 @@
                       </a:r>
                     </a:p>
                   </a:txBody>
-                  <a:tcPr marL="91440" marR="91440" marT="45720" marB="45720" anchor="ctr">
+                  <a:tcPr marL="95250" marR="95250" marT="0" marB="0" anchor="ctr">
                     <a:lnR w="0">
                       <a:noFill/>
                     </a:lnR>
@@ -3966,7 +4034,7 @@
                       </a:r>
                     </a:p>
                   </a:txBody>
-                  <a:tcPr marL="91440" marR="91440" marT="45720" marB="45720" anchor="ctr">
+                  <a:tcPr marL="95250" marR="95250" marT="0" marB="0" anchor="ctr">
                     <a:lnR w="0">
                       <a:noFill/>
                     </a:lnR>
@@ -4004,7 +4072,7 @@
                       </a:r>
                     </a:p>
                   </a:txBody>
-                  <a:tcPr marL="91440" marR="91440" marT="45720" marB="45720" anchor="ctr">
+                  <a:tcPr marL="95250" marR="95250" marT="0" marB="0" anchor="ctr">
                     <a:lnL w="0">
                       <a:noFill/>
                     </a:lnL>
@@ -4040,7 +4108,7 @@
                       </a:r>
                     </a:p>
                   </a:txBody>
-                  <a:tcPr marL="91440" marR="91440" marT="45720" marB="45720" anchor="ctr">
+                  <a:tcPr marL="95250" marR="95250" marT="0" marB="0" anchor="ctr">
                     <a:lnR w="0">
                       <a:noFill/>
                     </a:lnR>
@@ -4073,7 +4141,7 @@
                       </a:r>
                     </a:p>
                   </a:txBody>
-                  <a:tcPr marL="91440" marR="91440" marT="45720" marB="45720" anchor="ctr">
+                  <a:tcPr marL="95250" marR="95250" marT="0" marB="0" anchor="ctr">
                     <a:lnR w="0">
                       <a:noFill/>
                     </a:lnR>
@@ -4106,7 +4174,7 @@
                       </a:r>
                     </a:p>
                   </a:txBody>
-                  <a:tcPr marL="91440" marR="91440" marT="45720" marB="45720" anchor="ctr">
+                  <a:tcPr marL="95250" marR="95250" marT="0" marB="0" anchor="ctr">
                     <a:lnR w="0">
                       <a:noFill/>
                     </a:lnR>
@@ -4141,7 +4209,7 @@
                       </a:r>
                     </a:p>
                   </a:txBody>
-                  <a:tcPr marL="91440" marR="91440" marT="45720" marB="45720" anchor="ctr">
+                  <a:tcPr marL="95250" marR="95250" marT="0" marB="0" anchor="ctr">
                     <a:lnL w="0">
                       <a:noFill/>
                     </a:lnL>
@@ -4177,7 +4245,7 @@
                       </a:r>
                     </a:p>
                   </a:txBody>
-                  <a:tcPr marL="91440" marR="91440" marT="45720" marB="45720" anchor="ctr">
+                  <a:tcPr marL="95250" marR="95250" marT="0" marB="0" anchor="ctr">
                     <a:lnR w="0">
                       <a:noFill/>
                     </a:lnR>
@@ -4210,7 +4278,7 @@
                       </a:r>
                     </a:p>
                   </a:txBody>
-                  <a:tcPr marL="91440" marR="91440" marT="45720" marB="45720" anchor="ctr">
+                  <a:tcPr marL="95250" marR="95250" marT="0" marB="0" anchor="ctr">
                     <a:lnR w="0">
                       <a:noFill/>
                     </a:lnR>
@@ -4243,7 +4311,7 @@
                       </a:r>
                     </a:p>
                   </a:txBody>
-                  <a:tcPr marL="91440" marR="91440" marT="45720" marB="45720" anchor="ctr">
+                  <a:tcPr marL="95250" marR="95250" marT="0" marB="0" anchor="ctr">
                     <a:lnR w="0">
                       <a:noFill/>
                     </a:lnR>
@@ -4278,7 +4346,7 @@
                       </a:r>
                     </a:p>
                   </a:txBody>
-                  <a:tcPr marL="91440" marR="91440" marT="45720" marB="45720" anchor="ctr">
+                  <a:tcPr marL="95250" marR="95250" marT="0" marB="0" anchor="ctr">
                     <a:lnL w="0">
                       <a:noFill/>
                     </a:lnL>
@@ -4314,7 +4382,7 @@
                       </a:r>
                     </a:p>
                   </a:txBody>
-                  <a:tcPr marL="91440" marR="91440" marT="45720" marB="45720" anchor="ctr">
+                  <a:tcPr marL="95250" marR="95250" marT="0" marB="0" anchor="ctr">
                     <a:lnR w="0">
                       <a:noFill/>
                     </a:lnR>
@@ -4347,7 +4415,7 @@
                       </a:r>
                     </a:p>
                   </a:txBody>
-                  <a:tcPr marL="91440" marR="91440" marT="45720" marB="45720" anchor="ctr">
+                  <a:tcPr marL="95250" marR="95250" marT="0" marB="0" anchor="ctr">
                     <a:lnR w="0">
                       <a:noFill/>
                     </a:lnR>
@@ -4380,7 +4448,7 @@
                       </a:r>
                     </a:p>
                   </a:txBody>
-                  <a:tcPr marL="91440" marR="91440" marT="45720" marB="45720" anchor="ctr">
+                  <a:tcPr marL="95250" marR="95250" marT="0" marB="0" anchor="ctr">
                     <a:lnR w="0">
                       <a:noFill/>
                     </a:lnR>
@@ -4415,7 +4483,7 @@
                       </a:r>
                     </a:p>
                   </a:txBody>
-                  <a:tcPr marL="91440" marR="91440" marT="45720" marB="45720" anchor="ctr">
+                  <a:tcPr marL="95250" marR="95250" marT="0" marB="0" anchor="ctr">
                     <a:lnL w="0">
                       <a:noFill/>
                     </a:lnL>
@@ -4451,7 +4519,7 @@
                       </a:r>
                     </a:p>
                   </a:txBody>
-                  <a:tcPr marL="91440" marR="91440" marT="45720" marB="45720" anchor="ctr">
+                  <a:tcPr marL="95250" marR="95250" marT="0" marB="0" anchor="ctr">
                     <a:lnR w="0">
                       <a:noFill/>
                     </a:lnR>
@@ -4484,7 +4552,7 @@
                       </a:r>
                     </a:p>
                   </a:txBody>
-                  <a:tcPr marL="91440" marR="91440" marT="45720" marB="45720" anchor="ctr">
+                  <a:tcPr marL="95250" marR="95250" marT="0" marB="0" anchor="ctr">
                     <a:lnR w="0">
                       <a:noFill/>
                     </a:lnR>
@@ -4517,7 +4585,7 @@
                       </a:r>
                     </a:p>
                   </a:txBody>
-                  <a:tcPr marL="91440" marR="91440" marT="45720" marB="45720" anchor="ctr">
+                  <a:tcPr marL="95250" marR="95250" marT="0" marB="0" anchor="ctr">
                     <a:lnR w="0">
                       <a:noFill/>
                     </a:lnR>
@@ -4552,7 +4620,7 @@
                       </a:r>
                     </a:p>
                   </a:txBody>
-                  <a:tcPr marL="91440" marR="91440" marT="45720" marB="45720" anchor="ctr">
+                  <a:tcPr marL="95250" marR="95250" marT="0" marB="0" anchor="ctr">
                     <a:lnL w="0">
                       <a:noFill/>
                     </a:lnL>
@@ -4588,7 +4656,7 @@
                       </a:r>
                     </a:p>
                   </a:txBody>
-                  <a:tcPr marL="91440" marR="91440" marT="45720" marB="45720" anchor="ctr">
+                  <a:tcPr marL="95250" marR="95250" marT="0" marB="0" anchor="ctr">
                     <a:lnR w="0">
                       <a:noFill/>
                     </a:lnR>
@@ -4621,7 +4689,7 @@
                       </a:r>
                     </a:p>
                   </a:txBody>
-                  <a:tcPr marL="91440" marR="91440" marT="45720" marB="45720" anchor="ctr">
+                  <a:tcPr marL="95250" marR="95250" marT="0" marB="0" anchor="ctr">
                     <a:lnR w="0">
                       <a:noFill/>
                     </a:lnR>
@@ -4654,7 +4722,7 @@
                       </a:r>
                     </a:p>
                   </a:txBody>
-                  <a:tcPr marL="91440" marR="91440" marT="45720" marB="45720" anchor="ctr">
+                  <a:tcPr marL="95250" marR="95250" marT="0" marB="0" anchor="ctr">
                     <a:lnR w="0">
                       <a:noFill/>
                     </a:lnR>
@@ -4673,10 +4741,10 @@
       </p:graphicFrame>
       <p:sp>
         <p:nvSpPr>
-          <p:cNvPr id="14" name="">
+          <p:cNvPr id="15" name="">
             <a:extLst xmlns:a="http://schemas.openxmlformats.org/drawingml/2006/main">
               <a:ext uri="{FF2B5EF4-FFF2-40B4-BE49-F238E27FC236}">
-                <a16:creationId xmlns:a16="http://schemas.microsoft.com/office/drawing/2014/main" id="{F13243D1-9A5F-4C7D-ABEB-AABA7CF6D977}"/>
+                <a16:creationId xmlns:a16="http://schemas.microsoft.com/office/drawing/2014/main" id="{8DFAC1FC-4FAE-4E95-8F62-20670D4D058B}"/>
               </a:ext>
             </a:extLst>
           </p:cNvPr>
@@ -4741,10 +4809,10 @@
       </p:sp>
       <p:sp>
         <p:nvSpPr>
-          <p:cNvPr id="15" name="">
+          <p:cNvPr id="16" name="">
             <a:extLst xmlns:a="http://schemas.openxmlformats.org/drawingml/2006/main">
               <a:ext uri="{FF2B5EF4-FFF2-40B4-BE49-F238E27FC236}">
-                <a16:creationId xmlns:a16="http://schemas.microsoft.com/office/drawing/2014/main" id="{F0A148C7-3D53-4B81-9E44-935C8F4FEA14}"/>
+                <a16:creationId xmlns:a16="http://schemas.microsoft.com/office/drawing/2014/main" id="{68DE3D6B-E13B-4D25-BB2B-9CA9CF9D9790}"/>
               </a:ext>
             </a:extLst>
           </p:cNvPr>
@@ -4809,10 +4877,10 @@
       </p:sp>
       <p:sp>
         <p:nvSpPr>
-          <p:cNvPr id="16" name="">
+          <p:cNvPr id="17" name="">
             <a:extLst xmlns:a="http://schemas.openxmlformats.org/drawingml/2006/main">
               <a:ext uri="{FF2B5EF4-FFF2-40B4-BE49-F238E27FC236}">
-                <a16:creationId xmlns:a16="http://schemas.microsoft.com/office/drawing/2014/main" id="{9BEF8D58-5282-42F7-9806-831F9BADAEEA}"/>
+                <a16:creationId xmlns:a16="http://schemas.microsoft.com/office/drawing/2014/main" id="{A9BCBB4D-8FD2-4975-81B5-1DAB991B8066}"/>
               </a:ext>
             </a:extLst>
           </p:cNvPr>
@@ -4877,10 +4945,10 @@
       </p:sp>
       <p:sp>
         <p:nvSpPr>
-          <p:cNvPr id="17" name="">
+          <p:cNvPr id="18" name="">
             <a:extLst xmlns:a="http://schemas.openxmlformats.org/drawingml/2006/main">
               <a:ext uri="{FF2B5EF4-FFF2-40B4-BE49-F238E27FC236}">
-                <a16:creationId xmlns:a16="http://schemas.microsoft.com/office/drawing/2014/main" id="{ADA1B885-5E8D-42B8-A32B-3E0AE9761A01}"/>
+                <a16:creationId xmlns:a16="http://schemas.microsoft.com/office/drawing/2014/main" id="{C6CC9C67-E640-4889-A987-D5565AACA889}"/>
               </a:ext>
             </a:extLst>
           </p:cNvPr>
@@ -4968,10 +5036,10 @@
       </p:sp>
       <p:sp>
         <p:nvSpPr>
-          <p:cNvPr id="18" name="">
+          <p:cNvPr id="19" name="">
             <a:extLst xmlns:a="http://schemas.openxmlformats.org/drawingml/2006/main">
               <a:ext uri="{FF2B5EF4-FFF2-40B4-BE49-F238E27FC236}">
-                <a16:creationId xmlns:a16="http://schemas.microsoft.com/office/drawing/2014/main" id="{A8829525-2970-4604-BA7E-8F26FF2F2C1C}"/>
+                <a16:creationId xmlns:a16="http://schemas.microsoft.com/office/drawing/2014/main" id="{74575D0C-687A-45F2-BB84-078D21996A5A}"/>
               </a:ext>
             </a:extLst>
           </p:cNvPr>
@@ -5036,10 +5104,10 @@
       </p:sp>
       <p:sp>
         <p:nvSpPr>
-          <p:cNvPr id="19" name="">
+          <p:cNvPr id="20" name="">
             <a:extLst xmlns:a="http://schemas.openxmlformats.org/drawingml/2006/main">
               <a:ext uri="{FF2B5EF4-FFF2-40B4-BE49-F238E27FC236}">
-                <a16:creationId xmlns:a16="http://schemas.microsoft.com/office/drawing/2014/main" id="{7490F420-34EC-410A-BDE2-0391087BBC5B}"/>
+                <a16:creationId xmlns:a16="http://schemas.microsoft.com/office/drawing/2014/main" id="{BA508A3F-17E1-4547-977D-467497A9F0B5}"/>
               </a:ext>
             </a:extLst>
           </p:cNvPr>
@@ -5050,7 +5118,7 @@
         </p:nvSpPr>
         <p:spPr>
           <a:xfrm xmlns:a="http://schemas.openxmlformats.org/drawingml/2006/main">
-            <a:off x="533400" y="5505450"/>
+            <a:off x="533400" y="5410200"/>
             <a:ext cx="11125200" cy="295275"/>
           </a:xfrm>
           <a:prstGeom xmlns:a="http://schemas.openxmlformats.org/drawingml/2006/main" prst="rect">
@@ -5067,7 +5135,7 @@
           </a:bodyPr>
           <a:lstStyle xmlns:a="http://schemas.openxmlformats.org/drawingml/2006/main">
             <a:defPPr>
-              <a:defRPr sz="1725" b="1">
+              <a:defRPr sz="1800" b="1">
                 <a:solidFill>
                   <a:srgbClr val="F5F6F0"/>
                 </a:solidFill>
@@ -5079,7 +5147,7 @@
           </a:lstStyle>
           <a:p xmlns:a="http://schemas.openxmlformats.org/drawingml/2006/main">
             <a:pPr>
-              <a:defRPr sz="1725" b="1">
+              <a:defRPr sz="1800" b="1">
                 <a:solidFill>
                   <a:srgbClr val="F5F6F0"/>
                 </a:solidFill>
@@ -5089,7 +5157,7 @@
               </a:defRPr>
             </a:pPr>
             <a:r>
-              <a:rPr sz="1725" b="1">
+              <a:rPr sz="1800" b="1">
                 <a:solidFill>
                   <a:srgbClr val="F5F6F0"/>
                 </a:solidFill>
@@ -5097,17 +5165,17 @@
                 <a:ea typeface="Arial"/>
                 <a:cs typeface="Arial"/>
               </a:rPr>
-              <a:t>Processamento equivalente: R$ 36/dia → R$ 25,20/dia</a:t>
+              <a:t>Cota preservada pode reduzir o tempo parado</a:t>
             </a:r>
           </a:p>
         </p:txBody>
       </p:sp>
       <p:sp>
         <p:nvSpPr>
-          <p:cNvPr id="20" name="">
+          <p:cNvPr id="21" name="">
             <a:extLst xmlns:a="http://schemas.openxmlformats.org/drawingml/2006/main">
               <a:ext uri="{FF2B5EF4-FFF2-40B4-BE49-F238E27FC236}">
-                <a16:creationId xmlns:a16="http://schemas.microsoft.com/office/drawing/2014/main" id="{0798A0C5-5091-47F2-BDD9-C25A2409B754}"/>
+                <a16:creationId xmlns:a16="http://schemas.microsoft.com/office/drawing/2014/main" id="{F34807C5-CBCF-4E93-B825-7C443AC1A1C0}"/>
               </a:ext>
             </a:extLst>
           </p:cNvPr>
@@ -5118,7 +5186,7 @@
         </p:nvSpPr>
         <p:spPr>
           <a:xfrm xmlns:a="http://schemas.openxmlformats.org/drawingml/2006/main">
-            <a:off x="533400" y="5829300"/>
+            <a:off x="533400" y="5734050"/>
             <a:ext cx="11125200" cy="266700"/>
           </a:xfrm>
           <a:prstGeom xmlns:a="http://schemas.openxmlformats.org/drawingml/2006/main" prst="rect">
@@ -5135,9 +5203,9 @@
           </a:bodyPr>
           <a:lstStyle xmlns:a="http://schemas.openxmlformats.org/drawingml/2006/main">
             <a:defPPr>
-              <a:defRPr sz="1575" b="0">
-                <a:solidFill>
-                  <a:srgbClr val="70DEC9"/>
+              <a:defRPr sz="1388" b="0">
+                <a:solidFill>
+                  <a:srgbClr val="92BFFF"/>
                 </a:solidFill>
                 <a:latin typeface="Arial"/>
                 <a:ea typeface="Arial"/>
@@ -5147,9 +5215,9 @@
           </a:lstStyle>
           <a:p xmlns:a="http://schemas.openxmlformats.org/drawingml/2006/main">
             <a:pPr>
-              <a:defRPr sz="1575" b="0">
-                <a:solidFill>
-                  <a:srgbClr val="70DEC9"/>
+              <a:defRPr sz="1388" b="0">
+                <a:solidFill>
+                  <a:srgbClr val="92BFFF"/>
                 </a:solidFill>
                 <a:latin typeface="Arial"/>
                 <a:ea typeface="Arial"/>
@@ -5157,25 +5225,25 @@
               </a:defRPr>
             </a:pPr>
             <a:r>
-              <a:rPr sz="1575" b="0">
-                <a:solidFill>
-                  <a:srgbClr val="70DEC9"/>
+              <a:rPr sz="1388" b="0">
+                <a:solidFill>
+                  <a:srgbClr val="92BFFF"/>
                 </a:solidFill>
                 <a:latin typeface="Arial"/>
                 <a:ea typeface="Arial"/>
                 <a:cs typeface="Arial"/>
               </a:rPr>
-              <a:t>Diferença: R$ 10,80/dia · R$ 54/semana · R$ 237,60/mês</a:t>
+              <a:t>Neste cenário: até 2h/dia, 10h/semana ou 44h/mês de espera evitada, com auxiliares disponíveis.</a:t>
             </a:r>
           </a:p>
         </p:txBody>
       </p:sp>
       <p:sp>
         <p:nvSpPr>
-          <p:cNvPr id="21" name="">
+          <p:cNvPr id="22" name="">
             <a:extLst xmlns:a="http://schemas.openxmlformats.org/drawingml/2006/main">
               <a:ext uri="{FF2B5EF4-FFF2-40B4-BE49-F238E27FC236}">
-                <a16:creationId xmlns:a16="http://schemas.microsoft.com/office/drawing/2014/main" id="{7C3328F4-179B-4367-9AF3-5DD99AFFC1CB}"/>
+                <a16:creationId xmlns:a16="http://schemas.microsoft.com/office/drawing/2014/main" id="{BC6EDD20-AC63-490E-8480-3172ED1DD12A}"/>
               </a:ext>
             </a:extLst>
           </p:cNvPr>
@@ -5186,8 +5254,8 @@
         </p:nvSpPr>
         <p:spPr>
           <a:xfrm xmlns:a="http://schemas.openxmlformats.org/drawingml/2006/main">
-            <a:off x="533400" y="6172200"/>
-            <a:ext cx="11125200" cy="276225"/>
+            <a:off x="533400" y="6096000"/>
+            <a:ext cx="11125200" cy="238125"/>
           </a:xfrm>
           <a:prstGeom xmlns:a="http://schemas.openxmlformats.org/drawingml/2006/main" prst="rect">
             <a:avLst/>
@@ -5203,9 +5271,9 @@
           </a:bodyPr>
           <a:lstStyle xmlns:a="http://schemas.openxmlformats.org/drawingml/2006/main">
             <a:defPPr>
-              <a:defRPr sz="1500" b="1">
-                <a:solidFill>
-                  <a:srgbClr val="92BFFF"/>
+              <a:defRPr sz="1350" b="0">
+                <a:solidFill>
+                  <a:srgbClr val="70DEC9"/>
                 </a:solidFill>
                 <a:latin typeface="Arial"/>
                 <a:ea typeface="Arial"/>
@@ -5215,9 +5283,9 @@
           </a:lstStyle>
           <a:p xmlns:a="http://schemas.openxmlformats.org/drawingml/2006/main">
             <a:pPr>
-              <a:defRPr sz="1500" b="1">
-                <a:solidFill>
-                  <a:srgbClr val="92BFFF"/>
+              <a:defRPr sz="1350" b="0">
+                <a:solidFill>
+                  <a:srgbClr val="70DEC9"/>
                 </a:solidFill>
                 <a:latin typeface="Arial"/>
                 <a:ea typeface="Arial"/>
@@ -5225,25 +5293,25 @@
               </a:defRPr>
             </a:pPr>
             <a:r>
-              <a:rPr sz="1500" b="1">
-                <a:solidFill>
-                  <a:srgbClr val="92BFFF"/>
+              <a:rPr sz="1350" b="0">
+                <a:solidFill>
+                  <a:srgbClr val="70DEC9"/>
                 </a:solidFill>
                 <a:latin typeface="Arial"/>
                 <a:ea typeface="Arial"/>
                 <a:cs typeface="Arial"/>
               </a:rPr>
-              <a:t>Espera no cenário: 2h/dia → 0h/dia · potencial de 10h/semana ou 44h/mês</a:t>
+              <a:t>Equivalência de API: R$ 10,80/dia, R$ 54/semana e R$ 237,60/mês, a R$ 36/milhão hipotéticos.</a:t>
             </a:r>
           </a:p>
         </p:txBody>
       </p:sp>
       <p:sp>
         <p:nvSpPr>
-          <p:cNvPr id="22" name="">
+          <p:cNvPr id="23" name="">
             <a:extLst xmlns:a="http://schemas.openxmlformats.org/drawingml/2006/main">
               <a:ext uri="{FF2B5EF4-FFF2-40B4-BE49-F238E27FC236}">
-                <a16:creationId xmlns:a16="http://schemas.microsoft.com/office/drawing/2014/main" id="{F96AE0B4-374B-41D1-863B-686D60DBB204}"/>
+                <a16:creationId xmlns:a16="http://schemas.microsoft.com/office/drawing/2014/main" id="{22C544F0-F3F1-4B8C-8779-F777E88F1D16}"/>
               </a:ext>
             </a:extLst>
           </p:cNvPr>
@@ -5254,8 +5322,8 @@
         </p:nvSpPr>
         <p:spPr>
           <a:xfrm xmlns:a="http://schemas.openxmlformats.org/drawingml/2006/main">
-            <a:off x="533400" y="6515100"/>
-            <a:ext cx="11125200" cy="323850"/>
+            <a:off x="533400" y="6362700"/>
+            <a:ext cx="11125200" cy="238125"/>
           </a:xfrm>
           <a:prstGeom xmlns:a="http://schemas.openxmlformats.org/drawingml/2006/main" prst="rect">
             <a:avLst/>
@@ -5271,9 +5339,9 @@
           </a:bodyPr>
           <a:lstStyle xmlns:a="http://schemas.openxmlformats.org/drawingml/2006/main">
             <a:defPPr>
-              <a:defRPr sz="1013" b="0">
-                <a:solidFill>
-                  <a:srgbClr val="AAB8C5"/>
+              <a:defRPr sz="1350" b="0">
+                <a:solidFill>
+                  <a:srgbClr val="F5F6F0"/>
                 </a:solidFill>
                 <a:latin typeface="Arial"/>
                 <a:ea typeface="Arial"/>
@@ -5283,9 +5351,9 @@
           </a:lstStyle>
           <a:p xmlns:a="http://schemas.openxmlformats.org/drawingml/2006/main">
             <a:pPr>
-              <a:defRPr sz="1013" b="0">
-                <a:solidFill>
-                  <a:srgbClr val="AAB8C5"/>
+              <a:defRPr sz="1350" b="0">
+                <a:solidFill>
+                  <a:srgbClr val="F5F6F0"/>
                 </a:solidFill>
                 <a:latin typeface="Arial"/>
                 <a:ea typeface="Arial"/>
@@ -5293,20 +5361,65 @@
               </a:defRPr>
             </a:pPr>
             <a:r>
-              <a:rPr sz="1013" b="0">
-                <a:solidFill>
-                  <a:srgbClr val="AAB8C5"/>
+              <a:rPr sz="1350" b="0">
+                <a:solidFill>
+                  <a:srgbClr val="F5F6F0"/>
                 </a:solidFill>
                 <a:latin typeface="Arial"/>
                 <a:ea typeface="Arial"/>
                 <a:cs typeface="Arial"/>
               </a:rPr>
-              <a:t>Hipóteses: 8h/dia; 5 dias/semana; 22 dias/mês; cota antes durava 6h; auxiliares disponíveis. Ganhos ainda não medidos.</a:t>
+              <a:t>Equivalência na mensalidade: R$ 0 de desconto. Ganho potencial: mais entregas e menos espera.</a:t>
             </a:r>
           </a:p>
+        </p:txBody>
+      </p:sp>
+      <p:sp>
+        <p:nvSpPr>
+          <p:cNvPr id="24" name="">
+            <a:extLst xmlns:a="http://schemas.openxmlformats.org/drawingml/2006/main">
+              <a:ext uri="{FF2B5EF4-FFF2-40B4-BE49-F238E27FC236}">
+                <a16:creationId xmlns:a16="http://schemas.microsoft.com/office/drawing/2014/main" id="{E88916E3-D514-4D87-97D1-FE2D34CC16A5}"/>
+              </a:ext>
+            </a:extLst>
+          </p:cNvPr>
+          <p:cNvSpPr>
+            <a:spLocks xmlns:a="http://schemas.openxmlformats.org/drawingml/2006/main" noGrp="1"/>
+          </p:cNvSpPr>
+          <p:nvPr/>
+        </p:nvSpPr>
+        <p:spPr>
+          <a:xfrm xmlns:a="http://schemas.openxmlformats.org/drawingml/2006/main">
+            <a:off x="533400" y="6667500"/>
+            <a:ext cx="11125200" cy="152400"/>
+          </a:xfrm>
+          <a:prstGeom xmlns:a="http://schemas.openxmlformats.org/drawingml/2006/main" prst="rect">
+            <a:avLst/>
+          </a:prstGeom>
+          <a:noFill xmlns:a="http://schemas.openxmlformats.org/drawingml/2006/main"/>
+          <a:ln xmlns:a="http://schemas.openxmlformats.org/drawingml/2006/main" w="0">
+            <a:noFill/>
+          </a:ln>
+        </p:spPr>
+        <p:txBody>
+          <a:bodyPr xmlns:a="http://schemas.openxmlformats.org/drawingml/2006/main" wrap="square" lIns="0" tIns="0" rIns="0" bIns="0" anchor="t">
+            <a:noAutofit/>
+          </a:bodyPr>
+          <a:lstStyle xmlns:a="http://schemas.openxmlformats.org/drawingml/2006/main">
+            <a:defPPr>
+              <a:defRPr sz="825" b="0">
+                <a:solidFill>
+                  <a:srgbClr val="AAB8C5"/>
+                </a:solidFill>
+                <a:latin typeface="Arial"/>
+                <a:ea typeface="Arial"/>
+                <a:cs typeface="Arial"/>
+              </a:defRPr>
+            </a:defPPr>
+          </a:lstStyle>
           <a:p xmlns:a="http://schemas.openxmlformats.org/drawingml/2006/main">
             <a:pPr>
-              <a:defRPr sz="1013" b="0">
+              <a:defRPr sz="825" b="0">
                 <a:solidFill>
                   <a:srgbClr val="AAB8C5"/>
                 </a:solidFill>
@@ -5316,7 +5429,7 @@
               </a:defRPr>
             </a:pPr>
             <a:r>
-              <a:rPr sz="1013" b="0">
+              <a:rPr sz="825" b="0">
                 <a:solidFill>
                   <a:srgbClr val="AAB8C5"/>
                 </a:solidFill>
@@ -5324,7 +5437,7 @@
                 <a:ea typeface="Arial"/>
                 <a:cs typeface="Arial"/>
               </a:rPr>
-              <a:t>R$ 36/milhão é uma referência hipotética de API. A mensalidade fica igual; tokens auxiliares e energia não foram precificados.</a:t>
+              <a:t>Simulação, não medição. 8h/dia, 5 dias/semana, 22 dias/mês e cota antes de 6h. Limites reais variam. Energia e tokens auxiliares fora do cálculo.</a:t>
             </a:r>
           </a:p>
         </p:txBody>
@@ -5332,7 +5445,7 @@
     </p:spTree>
     <p:extLst>
       <p:ext uri="{BB962C8B-B14F-4D97-AF65-F5344CB8AC3E}">
-        <p14:creationId xmlns:p14="http://schemas.microsoft.com/office/powerpoint/2010/main" val="2140008147"/>
+        <p14:creationId xmlns:p14="http://schemas.microsoft.com/office/powerpoint/2010/main" val="576253058"/>
       </p:ext>
     </p:extLst>
   </p:cSld>

</xml_diff>

<commit_message>
chore: highlight the presentation and clarify API and subscription equivalence
</commit_message>
<xml_diff>
--- a/media/one-pager.pptx
+++ b/media/one-pager.pptx
@@ -2,13 +2,13 @@
 <file path=ppt/presentation.xml><?xml version="1.0" encoding="utf-8"?>
 <p:presentation xmlns:p="http://schemas.openxmlformats.org/presentationml/2006/main">
   <p:sldMasterIdLst>
-    <p:sldMasterId xmlns:r="http://schemas.openxmlformats.org/officeDocument/2006/relationships" id="2147483648" r:id="R64da7c71a6b343e0"/>
+    <p:sldMasterId xmlns:r="http://schemas.openxmlformats.org/officeDocument/2006/relationships" id="2147483648" r:id="R7fd23f08cd594c93"/>
   </p:sldMasterIdLst>
   <p:notesMasterIdLst>
-    <p:notesMasterId xmlns:r="http://schemas.openxmlformats.org/officeDocument/2006/relationships" r:id="Rfda922835a1d4399"/>
+    <p:notesMasterId xmlns:r="http://schemas.openxmlformats.org/officeDocument/2006/relationships" r:id="Rbc9c9e03c80c4e29"/>
   </p:notesMasterIdLst>
   <p:sldIdLst>
-    <p:sldId xmlns:r="http://schemas.openxmlformats.org/officeDocument/2006/relationships" id="256" r:id="R52ee033a584d446d"/>
+    <p:sldId xmlns:r="http://schemas.openxmlformats.org/officeDocument/2006/relationships" id="256" r:id="R841bca4cad034949"/>
   </p:sldIdLst>
   <p:sldSz cx="12192000" cy="6858000"/>
   <p:notesSz cx="6858000" cy="9144000"/>
@@ -472,7 +472,7 @@
           </a:p>
           <a:p xmlns:a="http://schemas.openxmlformats.org/drawingml/2006/main">
             <a:r>
-              <a:t>R$36/milhão é premissa hipotética de processamento de API, mantida para comparar este exemplo; não afirma preço atual de um modelo, câmbio atual nem cobrança observada. Antes R$36/dia, agora R$25,20/dia, diferença R$10,80/dia, R$54/semana e R$237,60/mês. O usuário informou mensalidade igual: não há desconto na assinatura. O cenário assume acesso auxiliar incluído ou local, com margem disponível e sem cobrança avulsa; energia e tokens dos auxiliares não foram precificados.</a:t>
+              <a:t>R$36/milhão é premissa hipotética de processamento de API, mantida para comparar este exemplo; não afirma preço atual de um modelo, câmbio atual nem cobrança observada. Antes R$36/dia, agora R$25,20/dia, diferença R$10,80/dia, R$54/semana e R$237,60/mês. O usuário informou mensalidade igual: economia financeira na assinatura é R$0. Os R$237,60 são duzentos e trinta e sete reais e sessenta centavos de processamento equivalente de API, não desconto nem despesa observada. Com mais entregas pela mesma mensalidade, o custo médio por entrega pode cair. Exemplo meramente aritmético: mensalidade M / 10 entregas versus M / 14 entregas, redução de28,6% por entrega. Não há medição do número de entregas ou da espera real. O cenário assume acesso auxiliar incluído ou local, com margem disponível e sem cobrança avulsa; energia e tokens dos auxiliares não foram precificados.</a:t>
             </a:r>
           </a:p>
           <a:p xmlns:a="http://schemas.openxmlformats.org/drawingml/2006/main">
@@ -539,7 +539,7 @@
           <p:cNvPr id="3" name="Title">
             <a:extLst xmlns:a="http://schemas.openxmlformats.org/drawingml/2006/main">
               <a:ext uri="{FF2B5EF4-FFF2-40B4-BE49-F238E27FC236}">
-                <a16:creationId xmlns:a16="http://schemas.microsoft.com/office/drawing/2014/main" id="{D78AF395-A714-4FF6-97B7-6587FBC6937D}"/>
+                <a16:creationId xmlns:a16="http://schemas.microsoft.com/office/drawing/2014/main" id="{72B9C44B-CEB7-48E5-A4AB-9204620FCD01}"/>
               </a:ext>
             </a:extLst>
           </p:cNvPr>
@@ -696,7 +696,7 @@
           <p:cNvPr id="2" name="Subtitle">
             <a:extLst xmlns:a="http://schemas.openxmlformats.org/drawingml/2006/main">
               <a:ext uri="{FF2B5EF4-FFF2-40B4-BE49-F238E27FC236}">
-                <a16:creationId xmlns:a16="http://schemas.microsoft.com/office/drawing/2014/main" id="{A4704D67-0B9E-4B4D-968E-036E1D80CFC9}"/>
+                <a16:creationId xmlns:a16="http://schemas.microsoft.com/office/drawing/2014/main" id="{1563BA4A-2AB4-4B70-BDAE-841C39FF0C49}"/>
               </a:ext>
             </a:extLst>
           </p:cNvPr>
@@ -870,7 +870,7 @@
           <p:cNvPr id="2" name="Section title">
             <a:extLst xmlns:a="http://schemas.openxmlformats.org/drawingml/2006/main">
               <a:ext uri="{FF2B5EF4-FFF2-40B4-BE49-F238E27FC236}">
-                <a16:creationId xmlns:a16="http://schemas.microsoft.com/office/drawing/2014/main" id="{013990F2-5514-4186-B71D-FFE9E9ED1EAF}"/>
+                <a16:creationId xmlns:a16="http://schemas.microsoft.com/office/drawing/2014/main" id="{6C667B96-F746-4FB9-B514-AD97CB54352D}"/>
               </a:ext>
             </a:extLst>
           </p:cNvPr>
@@ -1044,7 +1044,7 @@
           <p:cNvPr id="3" name="Title">
             <a:extLst xmlns:a="http://schemas.openxmlformats.org/drawingml/2006/main">
               <a:ext uri="{FF2B5EF4-FFF2-40B4-BE49-F238E27FC236}">
-                <a16:creationId xmlns:a16="http://schemas.microsoft.com/office/drawing/2014/main" id="{87A11708-FC1B-488F-8E4A-BCC1D78BF575}"/>
+                <a16:creationId xmlns:a16="http://schemas.microsoft.com/office/drawing/2014/main" id="{B293D361-9101-454F-8F81-AACF04ABCE71}"/>
               </a:ext>
             </a:extLst>
           </p:cNvPr>
@@ -1201,7 +1201,7 @@
           <p:cNvPr id="2" name="Body">
             <a:extLst xmlns:a="http://schemas.openxmlformats.org/drawingml/2006/main">
               <a:ext uri="{FF2B5EF4-FFF2-40B4-BE49-F238E27FC236}">
-                <a16:creationId xmlns:a16="http://schemas.microsoft.com/office/drawing/2014/main" id="{BF091CAE-1993-4451-A32A-580972A8FEBA}"/>
+                <a16:creationId xmlns:a16="http://schemas.microsoft.com/office/drawing/2014/main" id="{552D83E6-5D72-4A63-8FBE-374F8B6DCB80}"/>
               </a:ext>
             </a:extLst>
           </p:cNvPr>
@@ -1375,7 +1375,7 @@
           <p:cNvPr id="4" name="Title">
             <a:extLst xmlns:a="http://schemas.openxmlformats.org/drawingml/2006/main">
               <a:ext uri="{FF2B5EF4-FFF2-40B4-BE49-F238E27FC236}">
-                <a16:creationId xmlns:a16="http://schemas.microsoft.com/office/drawing/2014/main" id="{777FF309-90E3-4A22-902A-A3A35E8A4B4A}"/>
+                <a16:creationId xmlns:a16="http://schemas.microsoft.com/office/drawing/2014/main" id="{CD1DEFDC-F6F1-4E8B-B315-FF97EE772654}"/>
               </a:ext>
             </a:extLst>
           </p:cNvPr>
@@ -1532,7 +1532,7 @@
           <p:cNvPr id="2" name="Left column">
             <a:extLst xmlns:a="http://schemas.openxmlformats.org/drawingml/2006/main">
               <a:ext uri="{FF2B5EF4-FFF2-40B4-BE49-F238E27FC236}">
-                <a16:creationId xmlns:a16="http://schemas.microsoft.com/office/drawing/2014/main" id="{37D7BA6E-3EA4-4C28-8C5F-5B3988017376}"/>
+                <a16:creationId xmlns:a16="http://schemas.microsoft.com/office/drawing/2014/main" id="{B06C76A5-1377-413D-B77F-A5F9EC35A588}"/>
               </a:ext>
             </a:extLst>
           </p:cNvPr>
@@ -1689,7 +1689,7 @@
           <p:cNvPr id="3" name="Right column">
             <a:extLst xmlns:a="http://schemas.openxmlformats.org/drawingml/2006/main">
               <a:ext uri="{FF2B5EF4-FFF2-40B4-BE49-F238E27FC236}">
-                <a16:creationId xmlns:a16="http://schemas.microsoft.com/office/drawing/2014/main" id="{169CE1E0-E7A4-4ED5-B244-8C62C5503920}"/>
+                <a16:creationId xmlns:a16="http://schemas.microsoft.com/office/drawing/2014/main" id="{B2336450-ADE1-4436-BAB4-00A43E5A1485}"/>
               </a:ext>
             </a:extLst>
           </p:cNvPr>
@@ -1863,7 +1863,7 @@
           <p:cNvPr id="3" name="Title">
             <a:extLst xmlns:a="http://schemas.openxmlformats.org/drawingml/2006/main">
               <a:ext uri="{FF2B5EF4-FFF2-40B4-BE49-F238E27FC236}">
-                <a16:creationId xmlns:a16="http://schemas.microsoft.com/office/drawing/2014/main" id="{D471E0DB-446A-49A4-B9DF-6753088459F4}"/>
+                <a16:creationId xmlns:a16="http://schemas.microsoft.com/office/drawing/2014/main" id="{D2CBE39E-090F-4086-ACBF-8CF623B0F309}"/>
               </a:ext>
             </a:extLst>
           </p:cNvPr>
@@ -2020,7 +2020,7 @@
           <p:cNvPr id="2" name="Left column">
             <a:extLst xmlns:a="http://schemas.openxmlformats.org/drawingml/2006/main">
               <a:ext uri="{FF2B5EF4-FFF2-40B4-BE49-F238E27FC236}">
-                <a16:creationId xmlns:a16="http://schemas.microsoft.com/office/drawing/2014/main" id="{B71AFDF7-4873-4D85-BD8D-CC7E25484BA7}"/>
+                <a16:creationId xmlns:a16="http://schemas.microsoft.com/office/drawing/2014/main" id="{F7FB93EA-BF20-4B6A-A880-FF36811F53DA}"/>
               </a:ext>
             </a:extLst>
           </p:cNvPr>
@@ -2215,12 +2215,12 @@
   </p:cSld>
   <p:clrMap bg1="lt1" tx1="dk1" bg2="lt2" tx2="dk2" accent1="accent1" accent2="accent2" accent3="accent3" accent4="accent4" accent5="accent5" accent6="accent6" hlink="hlink" folHlink="folHlink"/>
   <p:sldLayoutIdLst>
-    <p:sldLayoutId xmlns:r="http://schemas.openxmlformats.org/officeDocument/2006/relationships" id="2147483649" r:id="R77d386b959484af7"/>
-    <p:sldLayoutId xmlns:r="http://schemas.openxmlformats.org/officeDocument/2006/relationships" id="2147483650" r:id="R9b5fb433e61049cd"/>
-    <p:sldLayoutId xmlns:r="http://schemas.openxmlformats.org/officeDocument/2006/relationships" id="2147483651" r:id="R5df1550d812a4221"/>
-    <p:sldLayoutId xmlns:r="http://schemas.openxmlformats.org/officeDocument/2006/relationships" id="2147483652" r:id="R7b0b1fd930254326"/>
-    <p:sldLayoutId xmlns:r="http://schemas.openxmlformats.org/officeDocument/2006/relationships" id="2147483653" r:id="Rc5a2286916ab4445"/>
-    <p:sldLayoutId xmlns:r="http://schemas.openxmlformats.org/officeDocument/2006/relationships" id="2147483654" r:id="R9301a0d636d7440d"/>
+    <p:sldLayoutId xmlns:r="http://schemas.openxmlformats.org/officeDocument/2006/relationships" id="2147483649" r:id="Rc1801f6a62b744cc"/>
+    <p:sldLayoutId xmlns:r="http://schemas.openxmlformats.org/officeDocument/2006/relationships" id="2147483650" r:id="R5a9e5649e86548af"/>
+    <p:sldLayoutId xmlns:r="http://schemas.openxmlformats.org/officeDocument/2006/relationships" id="2147483651" r:id="R7e8f3d7c888e4e9b"/>
+    <p:sldLayoutId xmlns:r="http://schemas.openxmlformats.org/officeDocument/2006/relationships" id="2147483652" r:id="Rc8df512d408c48c8"/>
+    <p:sldLayoutId xmlns:r="http://schemas.openxmlformats.org/officeDocument/2006/relationships" id="2147483653" r:id="R6687e298e21d47c1"/>
+    <p:sldLayoutId xmlns:r="http://schemas.openxmlformats.org/officeDocument/2006/relationships" id="2147483654" r:id="Ra42f588b204d4feb"/>
   </p:sldLayoutIdLst>
   <p:txStyles>
     <p:titleStyle>
@@ -2753,7 +2753,7 @@
   <c:chart>
     <c:plotArea>
       <c:barChart>
-        <c:barDir val="col"/>
+        <c:barDir val="bar"/>
         <c:grouping val="clustered"/>
         <c:varyColors val="1"/>
         <c:ser>
@@ -2768,7 +2768,7 @@
             <c:invertIfNegative val="0"/>
             <c:spPr>
               <a:solidFill xmlns:a="http://schemas.openxmlformats.org/drawingml/2006/main">
-                <a:srgbClr val="607487"/>
+                <a:srgbClr val="70DEC9"/>
               </a:solidFill>
             </c:spPr>
           </c:dPt>
@@ -2777,7 +2777,7 @@
             <c:invertIfNegative val="0"/>
             <c:spPr>
               <a:solidFill xmlns:a="http://schemas.openxmlformats.org/drawingml/2006/main">
-                <a:srgbClr val="70DEC9"/>
+                <a:srgbClr val="607487"/>
               </a:solidFill>
             </c:spPr>
           </c:dPt>
@@ -2790,7 +2790,47 @@
                   <a:lstStyle xmlns:a="http://schemas.openxmlformats.org/drawingml/2006/main"/>
                   <a:p xmlns:a="http://schemas.openxmlformats.org/drawingml/2006/main">
                     <a:r>
-                      <a:rPr sz="2025" b="1">
+                      <a:rPr sz="1800" b="1">
+                        <a:solidFill>
+                          <a:srgbClr val="101923"/>
+                        </a:solidFill>
+                        <a:latin typeface="Arial"/>
+                        <a:ea typeface="Arial"/>
+                        <a:cs typeface="Arial"/>
+                      </a:rPr>
+                      <a:t>700 mil</a:t>
+                    </a:r>
+                  </a:p>
+                </c:rich>
+              </c:tx>
+              <c:txPr>
+                <a:bodyPr xmlns:a="http://schemas.openxmlformats.org/drawingml/2006/main" anchorCtr="1"/>
+                <a:lstStyle xmlns:a="http://schemas.openxmlformats.org/drawingml/2006/main"/>
+                <a:p xmlns:a="http://schemas.openxmlformats.org/drawingml/2006/main">
+                  <a:pPr>
+                    <a:defRPr sz="1800" b="1">
+                      <a:solidFill>
+                        <a:srgbClr val="101923"/>
+                      </a:solidFill>
+                      <a:latin typeface="Arial"/>
+                      <a:ea typeface="Arial"/>
+                      <a:cs typeface="Arial"/>
+                    </a:defRPr>
+                  </a:pPr>
+                </a:p>
+              </c:txPr>
+              <c:dLblPos val="inEnd"/>
+              <c:showVal val="0"/>
+            </c:dLbl>
+            <c:dLbl>
+              <c:idx val="1"/>
+              <c:tx>
+                <c:rich>
+                  <a:bodyPr xmlns:a="http://schemas.openxmlformats.org/drawingml/2006/main"/>
+                  <a:lstStyle xmlns:a="http://schemas.openxmlformats.org/drawingml/2006/main"/>
+                  <a:p xmlns:a="http://schemas.openxmlformats.org/drawingml/2006/main">
+                    <a:r>
+                      <a:rPr sz="1800" b="1">
                         <a:solidFill>
                           <a:srgbClr val="F5F6F0"/>
                         </a:solidFill>
@@ -2808,7 +2848,7 @@
                 <a:lstStyle xmlns:a="http://schemas.openxmlformats.org/drawingml/2006/main"/>
                 <a:p xmlns:a="http://schemas.openxmlformats.org/drawingml/2006/main">
                   <a:pPr>
-                    <a:defRPr sz="2025" b="1">
+                    <a:defRPr sz="1800" b="1">
                       <a:solidFill>
                         <a:srgbClr val="F5F6F0"/>
                       </a:solidFill>
@@ -2819,47 +2859,7 @@
                   </a:pPr>
                 </a:p>
               </c:txPr>
-              <c:dLblPos val="outEnd"/>
-              <c:showVal val="0"/>
-            </c:dLbl>
-            <c:dLbl>
-              <c:idx val="1"/>
-              <c:tx>
-                <c:rich>
-                  <a:bodyPr xmlns:a="http://schemas.openxmlformats.org/drawingml/2006/main"/>
-                  <a:lstStyle xmlns:a="http://schemas.openxmlformats.org/drawingml/2006/main"/>
-                  <a:p xmlns:a="http://schemas.openxmlformats.org/drawingml/2006/main">
-                    <a:r>
-                      <a:rPr sz="2025" b="1">
-                        <a:solidFill>
-                          <a:srgbClr val="70DEC9"/>
-                        </a:solidFill>
-                        <a:latin typeface="Arial"/>
-                        <a:ea typeface="Arial"/>
-                        <a:cs typeface="Arial"/>
-                      </a:rPr>
-                      <a:t>700 mil</a:t>
-                    </a:r>
-                  </a:p>
-                </c:rich>
-              </c:tx>
-              <c:txPr>
-                <a:bodyPr xmlns:a="http://schemas.openxmlformats.org/drawingml/2006/main" anchorCtr="1"/>
-                <a:lstStyle xmlns:a="http://schemas.openxmlformats.org/drawingml/2006/main"/>
-                <a:p xmlns:a="http://schemas.openxmlformats.org/drawingml/2006/main">
-                  <a:pPr>
-                    <a:defRPr sz="2025" b="1">
-                      <a:solidFill>
-                        <a:srgbClr val="70DEC9"/>
-                      </a:solidFill>
-                      <a:latin typeface="Arial"/>
-                      <a:ea typeface="Arial"/>
-                      <a:cs typeface="Arial"/>
-                    </a:defRPr>
-                  </a:pPr>
-                </a:p>
-              </c:txPr>
-              <c:dLblPos val="outEnd"/>
+              <c:dLblPos val="inEnd"/>
               <c:showVal val="0"/>
             </c:dLbl>
           </c:dLbls>
@@ -2869,10 +2869,10 @@
               <c:strCache>
                 <c:ptCount val="2"/>
                 <c:pt idx="0">
-                  <c:v>Antes</c:v>
+                  <c:v>Agora</c:v>
                 </c:pt>
                 <c:pt idx="1">
-                  <c:v>Agora</c:v>
+                  <c:v>Antes</c:v>
                 </c:pt>
               </c:strCache>
             </c:strRef>
@@ -2884,10 +2884,10 @@
                 <c:formatCode>General</c:formatCode>
                 <c:ptCount val="2"/>
                 <c:pt idx="0">
-                  <c:v>1000000</c:v>
+                  <c:v>700000</c:v>
                 </c:pt>
                 <c:pt idx="1">
-                  <c:v>700000</c:v>
+                  <c:v>1000000</c:v>
                 </c:pt>
               </c:numCache>
             </c:numRef>
@@ -2908,7 +2908,7 @@
               </a:pPr>
             </a:p>
           </c:txPr>
-          <c:dLblPos val="outEnd"/>
+          <c:dLblPos val="inEnd"/>
           <c:showLegendKey val="0"/>
           <c:showVal val="1"/>
           <c:showCatName val="0"/>
@@ -2917,7 +2917,7 @@
           <c:showBubbleSize val="0"/>
           <c:showLeaderLines val="0"/>
         </c:dLbls>
-        <c:gapWidth val="120"/>
+        <c:gapWidth val="60"/>
         <c:axId val="48650112"/>
         <c:axId val="48672768"/>
       </c:barChart>
@@ -2927,7 +2927,7 @@
           <c:orientation val="minMax"/>
         </c:scaling>
         <c:delete val="0"/>
-        <c:axPos val="b"/>
+        <c:axPos val="l"/>
         <c:numFmt formatCode="General"/>
         <c:majorTickMark val="none"/>
         <c:minorTickMark val="none"/>
@@ -2941,7 +2941,7 @@
           <a:lstStyle xmlns:a="http://schemas.openxmlformats.org/drawingml/2006/main"/>
           <a:p xmlns:a="http://schemas.openxmlformats.org/drawingml/2006/main">
             <a:pPr>
-              <a:defRPr sz="1725" b="1">
+              <a:defRPr sz="1575" b="1">
                 <a:solidFill>
                   <a:srgbClr val="F5F6F0"/>
                 </a:solidFill>
@@ -2958,11 +2958,11 @@
         <c:axId val="48672768"/>
         <c:scaling>
           <c:orientation val="minMax"/>
-          <c:max val="1200000"/>
+          <c:max val="1100000"/>
           <c:min val="0"/>
         </c:scaling>
         <c:delete val="1"/>
-        <c:axPos val="l"/>
+        <c:axPos val="b"/>
         <c:numFmt formatCode="General"/>
         <c:majorTickMark val="none"/>
         <c:minorTickMark val="none"/>
@@ -3039,10 +3039,10 @@
       </p:grpSpPr>
       <p:sp>
         <p:nvSpPr>
-          <p:cNvPr id="23" name="">
+          <p:cNvPr id="25" name="">
             <a:extLst xmlns:a="http://schemas.openxmlformats.org/drawingml/2006/main">
               <a:ext uri="{FF2B5EF4-FFF2-40B4-BE49-F238E27FC236}">
-                <a16:creationId xmlns:a16="http://schemas.microsoft.com/office/drawing/2014/main" id="{0F8CE783-9A9B-419F-BE14-2A714048FB2E}"/>
+                <a16:creationId xmlns:a16="http://schemas.microsoft.com/office/drawing/2014/main" id="{B249E381-6774-4E56-BC9A-83F7CA70DC71}"/>
               </a:ext>
             </a:extLst>
           </p:cNvPr>
@@ -3110,7 +3110,7 @@
           <p:cNvPr id="2" name="">
             <a:extLst xmlns:a="http://schemas.openxmlformats.org/drawingml/2006/main">
               <a:ext uri="{FF2B5EF4-FFF2-40B4-BE49-F238E27FC236}">
-                <a16:creationId xmlns:a16="http://schemas.microsoft.com/office/drawing/2014/main" id="{A765D082-B4AE-4775-9A62-8CCDBCDD13C6}"/>
+                <a16:creationId xmlns:a16="http://schemas.microsoft.com/office/drawing/2014/main" id="{F5A314CE-6A2F-46B4-ABFD-2652AD2D7547}"/>
               </a:ext>
             </a:extLst>
           </p:cNvPr>
@@ -3178,7 +3178,7 @@
           <p:cNvPr id="3" name="">
             <a:extLst xmlns:a="http://schemas.openxmlformats.org/drawingml/2006/main">
               <a:ext uri="{FF2B5EF4-FFF2-40B4-BE49-F238E27FC236}">
-                <a16:creationId xmlns:a16="http://schemas.microsoft.com/office/drawing/2014/main" id="{BB6A16BD-B659-4265-9586-69A0C5B83910}"/>
+                <a16:creationId xmlns:a16="http://schemas.microsoft.com/office/drawing/2014/main" id="{AFA04C1A-E9BA-4E56-9BBF-802B400A209C}"/>
               </a:ext>
             </a:extLst>
           </p:cNvPr>
@@ -3241,34 +3241,12 @@
           </a:p>
         </p:txBody>
       </p:sp>
-      <p:graphicFrame>
-        <p:nvGraphicFramePr>
-          <p:cNvPr id="4" name="Chart">
+      <p:sp>
+        <p:nvSpPr>
+          <p:cNvPr id="4" name="">
             <a:extLst xmlns:a="http://schemas.openxmlformats.org/drawingml/2006/main">
               <a:ext uri="{FF2B5EF4-FFF2-40B4-BE49-F238E27FC236}">
-                <a16:creationId xmlns:a16="http://schemas.microsoft.com/office/drawing/2014/main" id="{62EC5842-EF53-4D69-87C5-8F441020D3DB}"/>
-              </a:ext>
-            </a:extLst>
-          </p:cNvPr>
-          <p:cNvGraphicFramePr/>
-          <p:nvPr/>
-        </p:nvGraphicFramePr>
-        <p:xfrm>
-          <a:off xmlns:a="http://schemas.openxmlformats.org/drawingml/2006/main" x="533400" y="1504950"/>
-          <a:ext xmlns:a="http://schemas.openxmlformats.org/drawingml/2006/main" cx="4000500" cy="1571625"/>
-        </p:xfrm>
-        <a:graphic xmlns:a="http://schemas.openxmlformats.org/drawingml/2006/main">
-          <a:graphicData uri="http://schemas.openxmlformats.org/drawingml/2006/chart">
-            <c:chart xmlns:r="http://schemas.openxmlformats.org/officeDocument/2006/relationships" xmlns:c="http://schemas.openxmlformats.org/drawingml/2006/chart" r:id="Rb38dc8f509c44e0e"/>
-          </a:graphicData>
-        </a:graphic>
-      </p:graphicFrame>
-      <p:sp>
-        <p:nvSpPr>
-          <p:cNvPr id="5" name="">
-            <a:extLst xmlns:a="http://schemas.openxmlformats.org/drawingml/2006/main">
-              <a:ext uri="{FF2B5EF4-FFF2-40B4-BE49-F238E27FC236}">
-                <a16:creationId xmlns:a16="http://schemas.microsoft.com/office/drawing/2014/main" id="{59DA0F69-B1EA-4459-8991-BC3AB2FBC144}"/>
+                <a16:creationId xmlns:a16="http://schemas.microsoft.com/office/drawing/2014/main" id="{1EE048EF-72FF-4FE5-9E28-7BC255791DEC}"/>
               </a:ext>
             </a:extLst>
           </p:cNvPr>
@@ -3279,8 +3257,8 @@
         </p:nvSpPr>
         <p:spPr>
           <a:xfrm xmlns:a="http://schemas.openxmlformats.org/drawingml/2006/main">
-            <a:off x="866775" y="3028950"/>
-            <a:ext cx="3857625" cy="238125"/>
+            <a:off x="533400" y="1524000"/>
+            <a:ext cx="4000500" cy="266700"/>
           </a:xfrm>
           <a:prstGeom xmlns:a="http://schemas.openxmlformats.org/drawingml/2006/main" prst="rect">
             <a:avLst/>
@@ -3296,7 +3274,7 @@
           </a:bodyPr>
           <a:lstStyle xmlns:a="http://schemas.openxmlformats.org/drawingml/2006/main">
             <a:defPPr>
-              <a:defRPr sz="1350" b="0">
+              <a:defRPr sz="1425" b="0">
                 <a:solidFill>
                   <a:srgbClr val="AAB8C5"/>
                 </a:solidFill>
@@ -3308,7 +3286,7 @@
           </a:lstStyle>
           <a:p xmlns:a="http://schemas.openxmlformats.org/drawingml/2006/main">
             <a:pPr>
-              <a:defRPr sz="1350" b="0">
+              <a:defRPr sz="1425" b="0">
                 <a:solidFill>
                   <a:srgbClr val="AAB8C5"/>
                 </a:solidFill>
@@ -3318,7 +3296,7 @@
               </a:defRPr>
             </a:pPr>
             <a:r>
-              <a:rPr sz="1350" b="0">
+              <a:rPr sz="1425" b="0">
                 <a:solidFill>
                   <a:srgbClr val="AAB8C5"/>
                 </a:solidFill>
@@ -3326,17 +3304,107 @@
                 <a:ea typeface="Arial"/>
                 <a:cs typeface="Arial"/>
               </a:rPr>
-              <a:t>tokens por dia no principal</a:t>
+              <a:t>Consumo diário do principal</a:t>
+            </a:r>
+          </a:p>
+        </p:txBody>
+      </p:sp>
+      <p:graphicFrame>
+        <p:nvGraphicFramePr>
+          <p:cNvPr id="5" name="Chart">
+            <a:extLst xmlns:a="http://schemas.openxmlformats.org/drawingml/2006/main">
+              <a:ext uri="{FF2B5EF4-FFF2-40B4-BE49-F238E27FC236}">
+                <a16:creationId xmlns:a16="http://schemas.microsoft.com/office/drawing/2014/main" id="{0EE0A955-9C23-48E6-B390-09C900663FF2}"/>
+              </a:ext>
+            </a:extLst>
+          </p:cNvPr>
+          <p:cNvGraphicFramePr/>
+          <p:nvPr/>
+        </p:nvGraphicFramePr>
+        <p:xfrm>
+          <a:off xmlns:a="http://schemas.openxmlformats.org/drawingml/2006/main" x="533400" y="1847850"/>
+          <a:ext xmlns:a="http://schemas.openxmlformats.org/drawingml/2006/main" cx="4133850" cy="1257300"/>
+        </p:xfrm>
+        <a:graphic xmlns:a="http://schemas.openxmlformats.org/drawingml/2006/main">
+          <a:graphicData uri="http://schemas.openxmlformats.org/drawingml/2006/chart">
+            <c:chart xmlns:r="http://schemas.openxmlformats.org/officeDocument/2006/relationships" xmlns:c="http://schemas.openxmlformats.org/drawingml/2006/chart" r:id="R51637a1f667b44a8"/>
+          </a:graphicData>
+        </a:graphic>
+      </p:graphicFrame>
+      <p:sp>
+        <p:nvSpPr>
+          <p:cNvPr id="6" name="">
+            <a:extLst xmlns:a="http://schemas.openxmlformats.org/drawingml/2006/main">
+              <a:ext uri="{FF2B5EF4-FFF2-40B4-BE49-F238E27FC236}">
+                <a16:creationId xmlns:a16="http://schemas.microsoft.com/office/drawing/2014/main" id="{FA30BE0E-B0A6-4D99-8076-41DC17CBCACF}"/>
+              </a:ext>
+            </a:extLst>
+          </p:cNvPr>
+          <p:cNvSpPr>
+            <a:spLocks xmlns:a="http://schemas.openxmlformats.org/drawingml/2006/main" noGrp="1"/>
+          </p:cNvSpPr>
+          <p:nvPr/>
+        </p:nvSpPr>
+        <p:spPr>
+          <a:xfrm xmlns:a="http://schemas.openxmlformats.org/drawingml/2006/main">
+            <a:off x="533400" y="3057525"/>
+            <a:ext cx="4133850" cy="266700"/>
+          </a:xfrm>
+          <a:prstGeom xmlns:a="http://schemas.openxmlformats.org/drawingml/2006/main" prst="rect">
+            <a:avLst/>
+          </a:prstGeom>
+          <a:noFill xmlns:a="http://schemas.openxmlformats.org/drawingml/2006/main"/>
+          <a:ln xmlns:a="http://schemas.openxmlformats.org/drawingml/2006/main" w="0">
+            <a:noFill/>
+          </a:ln>
+        </p:spPr>
+        <p:txBody>
+          <a:bodyPr xmlns:a="http://schemas.openxmlformats.org/drawingml/2006/main" wrap="square" lIns="0" tIns="0" rIns="0" bIns="0" anchor="t">
+            <a:noAutofit/>
+          </a:bodyPr>
+          <a:lstStyle xmlns:a="http://schemas.openxmlformats.org/drawingml/2006/main">
+            <a:defPPr>
+              <a:defRPr sz="1500" b="1">
+                <a:solidFill>
+                  <a:srgbClr val="70DEC9"/>
+                </a:solidFill>
+                <a:latin typeface="Arial"/>
+                <a:ea typeface="Arial"/>
+                <a:cs typeface="Arial"/>
+              </a:defRPr>
+            </a:defPPr>
+          </a:lstStyle>
+          <a:p xmlns:a="http://schemas.openxmlformats.org/drawingml/2006/main">
+            <a:pPr>
+              <a:defRPr sz="1500" b="1">
+                <a:solidFill>
+                  <a:srgbClr val="70DEC9"/>
+                </a:solidFill>
+                <a:latin typeface="Arial"/>
+                <a:ea typeface="Arial"/>
+                <a:cs typeface="Arial"/>
+              </a:defRPr>
+            </a:pPr>
+            <a:r>
+              <a:rPr sz="1500" b="1">
+                <a:solidFill>
+                  <a:srgbClr val="70DEC9"/>
+                </a:solidFill>
+                <a:latin typeface="Arial"/>
+                <a:ea typeface="Arial"/>
+                <a:cs typeface="Arial"/>
+              </a:rPr>
+              <a:t>300 mil tokens a menos por dia (30%)</a:t>
             </a:r>
           </a:p>
         </p:txBody>
       </p:sp>
       <p:sp>
         <p:nvSpPr>
-          <p:cNvPr id="6" name="">
+          <p:cNvPr id="7" name="">
             <a:extLst xmlns:a="http://schemas.openxmlformats.org/drawingml/2006/main">
               <a:ext uri="{FF2B5EF4-FFF2-40B4-BE49-F238E27FC236}">
-                <a16:creationId xmlns:a16="http://schemas.microsoft.com/office/drawing/2014/main" id="{CB70A9AB-BD7F-4BBB-8317-5FDBED5E439C}"/>
+                <a16:creationId xmlns:a16="http://schemas.microsoft.com/office/drawing/2014/main" id="{EC45B421-8C98-4C8C-9E95-61B673161686}"/>
               </a:ext>
             </a:extLst>
           </p:cNvPr>
@@ -3401,10 +3469,10 @@
       </p:sp>
       <p:sp>
         <p:nvSpPr>
-          <p:cNvPr id="7" name="">
+          <p:cNvPr id="8" name="">
             <a:extLst xmlns:a="http://schemas.openxmlformats.org/drawingml/2006/main">
               <a:ext uri="{FF2B5EF4-FFF2-40B4-BE49-F238E27FC236}">
-                <a16:creationId xmlns:a16="http://schemas.microsoft.com/office/drawing/2014/main" id="{EC049477-140D-404D-B7F1-A32A5D39E0AC}"/>
+                <a16:creationId xmlns:a16="http://schemas.microsoft.com/office/drawing/2014/main" id="{7E338BA4-7C9D-40DB-8AFD-C0A806B4BEA5}"/>
               </a:ext>
             </a:extLst>
           </p:cNvPr>
@@ -3469,10 +3537,10 @@
       </p:sp>
       <p:sp>
         <p:nvSpPr>
-          <p:cNvPr id="8" name="">
+          <p:cNvPr id="9" name="">
             <a:extLst xmlns:a="http://schemas.openxmlformats.org/drawingml/2006/main">
               <a:ext uri="{FF2B5EF4-FFF2-40B4-BE49-F238E27FC236}">
-                <a16:creationId xmlns:a16="http://schemas.microsoft.com/office/drawing/2014/main" id="{4E606411-BD84-4F70-A496-874D15F073CB}"/>
+                <a16:creationId xmlns:a16="http://schemas.microsoft.com/office/drawing/2014/main" id="{BCADE662-877D-4CD6-82B8-8A04BE05A594}"/>
               </a:ext>
             </a:extLst>
           </p:cNvPr>
@@ -3537,10 +3605,10 @@
       </p:sp>
       <p:sp>
         <p:nvSpPr>
-          <p:cNvPr id="9" name="">
+          <p:cNvPr id="10" name="">
             <a:extLst xmlns:a="http://schemas.openxmlformats.org/drawingml/2006/main">
               <a:ext uri="{FF2B5EF4-FFF2-40B4-BE49-F238E27FC236}">
-                <a16:creationId xmlns:a16="http://schemas.microsoft.com/office/drawing/2014/main" id="{E9E1AD2C-6CF3-4BB8-AD2E-963C23C5B877}"/>
+                <a16:creationId xmlns:a16="http://schemas.microsoft.com/office/drawing/2014/main" id="{1E55CE58-E17E-49DB-B061-37E9B3C79A27}"/>
               </a:ext>
             </a:extLst>
           </p:cNvPr>
@@ -3605,10 +3673,10 @@
       </p:sp>
       <p:sp>
         <p:nvSpPr>
-          <p:cNvPr id="10" name="">
+          <p:cNvPr id="11" name="">
             <a:extLst xmlns:a="http://schemas.openxmlformats.org/drawingml/2006/main">
               <a:ext uri="{FF2B5EF4-FFF2-40B4-BE49-F238E27FC236}">
-                <a16:creationId xmlns:a16="http://schemas.microsoft.com/office/drawing/2014/main" id="{F17B92F4-86E1-458C-BD13-8ACDCD183E40}"/>
+                <a16:creationId xmlns:a16="http://schemas.microsoft.com/office/drawing/2014/main" id="{F38A7876-FFD8-47F2-9099-69F3357165FA}"/>
               </a:ext>
             </a:extLst>
           </p:cNvPr>
@@ -3673,10 +3741,10 @@
       </p:sp>
       <p:sp>
         <p:nvSpPr>
-          <p:cNvPr id="11" name="">
+          <p:cNvPr id="12" name="">
             <a:extLst xmlns:a="http://schemas.openxmlformats.org/drawingml/2006/main">
               <a:ext uri="{FF2B5EF4-FFF2-40B4-BE49-F238E27FC236}">
-                <a16:creationId xmlns:a16="http://schemas.microsoft.com/office/drawing/2014/main" id="{8F7E10D8-6D1E-42CC-8DE9-07EF4564893D}"/>
+                <a16:creationId xmlns:a16="http://schemas.microsoft.com/office/drawing/2014/main" id="{507BB1EB-3E87-4413-9747-F1529AC54BF0}"/>
               </a:ext>
             </a:extLst>
           </p:cNvPr>
@@ -3741,10 +3809,10 @@
       </p:sp>
       <p:sp>
         <p:nvSpPr>
-          <p:cNvPr id="12" name="">
+          <p:cNvPr id="13" name="">
             <a:extLst xmlns:a="http://schemas.openxmlformats.org/drawingml/2006/main">
               <a:ext uri="{FF2B5EF4-FFF2-40B4-BE49-F238E27FC236}">
-                <a16:creationId xmlns:a16="http://schemas.microsoft.com/office/drawing/2014/main" id="{20AF3885-B2EE-4F34-8CDA-841487D6B377}"/>
+                <a16:creationId xmlns:a16="http://schemas.microsoft.com/office/drawing/2014/main" id="{783520EE-BF46-4BA9-8B44-3C49FAB36408}"/>
               </a:ext>
             </a:extLst>
           </p:cNvPr>
@@ -3809,10 +3877,10 @@
       </p:sp>
       <p:graphicFrame>
         <p:nvGraphicFramePr>
-          <p:cNvPr id="13" name="">
+          <p:cNvPr id="14" name="">
             <a:extLst xmlns:a="http://schemas.openxmlformats.org/drawingml/2006/main">
               <a:ext uri="{FF2B5EF4-FFF2-40B4-BE49-F238E27FC236}">
-                <a16:creationId xmlns:a16="http://schemas.microsoft.com/office/drawing/2014/main" id="{8688E04A-5ADB-41AD-BCF3-5BC1DAFFCC52}"/>
+                <a16:creationId xmlns:a16="http://schemas.microsoft.com/office/drawing/2014/main" id="{3E024B88-2632-438F-816D-99F40B4C2625}"/>
               </a:ext>
             </a:extLst>
           </p:cNvPr>
@@ -3855,7 +3923,7 @@
                       </a:r>
                     </a:p>
                   </a:txBody>
-                  <a:tcPr marL="91440" marR="91440" marT="45720" marB="45720" anchor="ctr">
+                  <a:tcPr marL="95250" marR="95250" marT="0" marB="0" anchor="ctr">
                     <a:lnL w="0">
                       <a:noFill/>
                     </a:lnL>
@@ -3894,7 +3962,7 @@
                       </a:r>
                     </a:p>
                   </a:txBody>
-                  <a:tcPr marL="91440" marR="91440" marT="45720" marB="45720" anchor="ctr">
+                  <a:tcPr marL="95250" marR="95250" marT="0" marB="0" anchor="ctr">
                     <a:lnR w="0">
                       <a:noFill/>
                     </a:lnR>
@@ -3930,7 +3998,7 @@
                       </a:r>
                     </a:p>
                   </a:txBody>
-                  <a:tcPr marL="91440" marR="91440" marT="45720" marB="45720" anchor="ctr">
+                  <a:tcPr marL="95250" marR="95250" marT="0" marB="0" anchor="ctr">
                     <a:lnR w="0">
                       <a:noFill/>
                     </a:lnR>
@@ -3966,7 +4034,7 @@
                       </a:r>
                     </a:p>
                   </a:txBody>
-                  <a:tcPr marL="91440" marR="91440" marT="45720" marB="45720" anchor="ctr">
+                  <a:tcPr marL="95250" marR="95250" marT="0" marB="0" anchor="ctr">
                     <a:lnR w="0">
                       <a:noFill/>
                     </a:lnR>
@@ -4004,7 +4072,7 @@
                       </a:r>
                     </a:p>
                   </a:txBody>
-                  <a:tcPr marL="91440" marR="91440" marT="45720" marB="45720" anchor="ctr">
+                  <a:tcPr marL="95250" marR="95250" marT="0" marB="0" anchor="ctr">
                     <a:lnL w="0">
                       <a:noFill/>
                     </a:lnL>
@@ -4040,7 +4108,7 @@
                       </a:r>
                     </a:p>
                   </a:txBody>
-                  <a:tcPr marL="91440" marR="91440" marT="45720" marB="45720" anchor="ctr">
+                  <a:tcPr marL="95250" marR="95250" marT="0" marB="0" anchor="ctr">
                     <a:lnR w="0">
                       <a:noFill/>
                     </a:lnR>
@@ -4073,7 +4141,7 @@
                       </a:r>
                     </a:p>
                   </a:txBody>
-                  <a:tcPr marL="91440" marR="91440" marT="45720" marB="45720" anchor="ctr">
+                  <a:tcPr marL="95250" marR="95250" marT="0" marB="0" anchor="ctr">
                     <a:lnR w="0">
                       <a:noFill/>
                     </a:lnR>
@@ -4106,7 +4174,7 @@
                       </a:r>
                     </a:p>
                   </a:txBody>
-                  <a:tcPr marL="91440" marR="91440" marT="45720" marB="45720" anchor="ctr">
+                  <a:tcPr marL="95250" marR="95250" marT="0" marB="0" anchor="ctr">
                     <a:lnR w="0">
                       <a:noFill/>
                     </a:lnR>
@@ -4141,7 +4209,7 @@
                       </a:r>
                     </a:p>
                   </a:txBody>
-                  <a:tcPr marL="91440" marR="91440" marT="45720" marB="45720" anchor="ctr">
+                  <a:tcPr marL="95250" marR="95250" marT="0" marB="0" anchor="ctr">
                     <a:lnL w="0">
                       <a:noFill/>
                     </a:lnL>
@@ -4177,7 +4245,7 @@
                       </a:r>
                     </a:p>
                   </a:txBody>
-                  <a:tcPr marL="91440" marR="91440" marT="45720" marB="45720" anchor="ctr">
+                  <a:tcPr marL="95250" marR="95250" marT="0" marB="0" anchor="ctr">
                     <a:lnR w="0">
                       <a:noFill/>
                     </a:lnR>
@@ -4210,7 +4278,7 @@
                       </a:r>
                     </a:p>
                   </a:txBody>
-                  <a:tcPr marL="91440" marR="91440" marT="45720" marB="45720" anchor="ctr">
+                  <a:tcPr marL="95250" marR="95250" marT="0" marB="0" anchor="ctr">
                     <a:lnR w="0">
                       <a:noFill/>
                     </a:lnR>
@@ -4243,7 +4311,7 @@
                       </a:r>
                     </a:p>
                   </a:txBody>
-                  <a:tcPr marL="91440" marR="91440" marT="45720" marB="45720" anchor="ctr">
+                  <a:tcPr marL="95250" marR="95250" marT="0" marB="0" anchor="ctr">
                     <a:lnR w="0">
                       <a:noFill/>
                     </a:lnR>
@@ -4278,7 +4346,7 @@
                       </a:r>
                     </a:p>
                   </a:txBody>
-                  <a:tcPr marL="91440" marR="91440" marT="45720" marB="45720" anchor="ctr">
+                  <a:tcPr marL="95250" marR="95250" marT="0" marB="0" anchor="ctr">
                     <a:lnL w="0">
                       <a:noFill/>
                     </a:lnL>
@@ -4314,7 +4382,7 @@
                       </a:r>
                     </a:p>
                   </a:txBody>
-                  <a:tcPr marL="91440" marR="91440" marT="45720" marB="45720" anchor="ctr">
+                  <a:tcPr marL="95250" marR="95250" marT="0" marB="0" anchor="ctr">
                     <a:lnR w="0">
                       <a:noFill/>
                     </a:lnR>
@@ -4347,7 +4415,7 @@
                       </a:r>
                     </a:p>
                   </a:txBody>
-                  <a:tcPr marL="91440" marR="91440" marT="45720" marB="45720" anchor="ctr">
+                  <a:tcPr marL="95250" marR="95250" marT="0" marB="0" anchor="ctr">
                     <a:lnR w="0">
                       <a:noFill/>
                     </a:lnR>
@@ -4380,7 +4448,7 @@
                       </a:r>
                     </a:p>
                   </a:txBody>
-                  <a:tcPr marL="91440" marR="91440" marT="45720" marB="45720" anchor="ctr">
+                  <a:tcPr marL="95250" marR="95250" marT="0" marB="0" anchor="ctr">
                     <a:lnR w="0">
                       <a:noFill/>
                     </a:lnR>
@@ -4415,7 +4483,7 @@
                       </a:r>
                     </a:p>
                   </a:txBody>
-                  <a:tcPr marL="91440" marR="91440" marT="45720" marB="45720" anchor="ctr">
+                  <a:tcPr marL="95250" marR="95250" marT="0" marB="0" anchor="ctr">
                     <a:lnL w="0">
                       <a:noFill/>
                     </a:lnL>
@@ -4451,7 +4519,7 @@
                       </a:r>
                     </a:p>
                   </a:txBody>
-                  <a:tcPr marL="91440" marR="91440" marT="45720" marB="45720" anchor="ctr">
+                  <a:tcPr marL="95250" marR="95250" marT="0" marB="0" anchor="ctr">
                     <a:lnR w="0">
                       <a:noFill/>
                     </a:lnR>
@@ -4484,7 +4552,7 @@
                       </a:r>
                     </a:p>
                   </a:txBody>
-                  <a:tcPr marL="91440" marR="91440" marT="45720" marB="45720" anchor="ctr">
+                  <a:tcPr marL="95250" marR="95250" marT="0" marB="0" anchor="ctr">
                     <a:lnR w="0">
                       <a:noFill/>
                     </a:lnR>
@@ -4517,7 +4585,7 @@
                       </a:r>
                     </a:p>
                   </a:txBody>
-                  <a:tcPr marL="91440" marR="91440" marT="45720" marB="45720" anchor="ctr">
+                  <a:tcPr marL="95250" marR="95250" marT="0" marB="0" anchor="ctr">
                     <a:lnR w="0">
                       <a:noFill/>
                     </a:lnR>
@@ -4552,7 +4620,7 @@
                       </a:r>
                     </a:p>
                   </a:txBody>
-                  <a:tcPr marL="91440" marR="91440" marT="45720" marB="45720" anchor="ctr">
+                  <a:tcPr marL="95250" marR="95250" marT="0" marB="0" anchor="ctr">
                     <a:lnL w="0">
                       <a:noFill/>
                     </a:lnL>
@@ -4588,7 +4656,7 @@
                       </a:r>
                     </a:p>
                   </a:txBody>
-                  <a:tcPr marL="91440" marR="91440" marT="45720" marB="45720" anchor="ctr">
+                  <a:tcPr marL="95250" marR="95250" marT="0" marB="0" anchor="ctr">
                     <a:lnR w="0">
                       <a:noFill/>
                     </a:lnR>
@@ -4621,7 +4689,7 @@
                       </a:r>
                     </a:p>
                   </a:txBody>
-                  <a:tcPr marL="91440" marR="91440" marT="45720" marB="45720" anchor="ctr">
+                  <a:tcPr marL="95250" marR="95250" marT="0" marB="0" anchor="ctr">
                     <a:lnR w="0">
                       <a:noFill/>
                     </a:lnR>
@@ -4654,7 +4722,7 @@
                       </a:r>
                     </a:p>
                   </a:txBody>
-                  <a:tcPr marL="91440" marR="91440" marT="45720" marB="45720" anchor="ctr">
+                  <a:tcPr marL="95250" marR="95250" marT="0" marB="0" anchor="ctr">
                     <a:lnR w="0">
                       <a:noFill/>
                     </a:lnR>
@@ -4673,10 +4741,10 @@
       </p:graphicFrame>
       <p:sp>
         <p:nvSpPr>
-          <p:cNvPr id="14" name="">
+          <p:cNvPr id="15" name="">
             <a:extLst xmlns:a="http://schemas.openxmlformats.org/drawingml/2006/main">
               <a:ext uri="{FF2B5EF4-FFF2-40B4-BE49-F238E27FC236}">
-                <a16:creationId xmlns:a16="http://schemas.microsoft.com/office/drawing/2014/main" id="{F13243D1-9A5F-4C7D-ABEB-AABA7CF6D977}"/>
+                <a16:creationId xmlns:a16="http://schemas.microsoft.com/office/drawing/2014/main" id="{8DFAC1FC-4FAE-4E95-8F62-20670D4D058B}"/>
               </a:ext>
             </a:extLst>
           </p:cNvPr>
@@ -4741,10 +4809,10 @@
       </p:sp>
       <p:sp>
         <p:nvSpPr>
-          <p:cNvPr id="15" name="">
+          <p:cNvPr id="16" name="">
             <a:extLst xmlns:a="http://schemas.openxmlformats.org/drawingml/2006/main">
               <a:ext uri="{FF2B5EF4-FFF2-40B4-BE49-F238E27FC236}">
-                <a16:creationId xmlns:a16="http://schemas.microsoft.com/office/drawing/2014/main" id="{F0A148C7-3D53-4B81-9E44-935C8F4FEA14}"/>
+                <a16:creationId xmlns:a16="http://schemas.microsoft.com/office/drawing/2014/main" id="{68DE3D6B-E13B-4D25-BB2B-9CA9CF9D9790}"/>
               </a:ext>
             </a:extLst>
           </p:cNvPr>
@@ -4809,10 +4877,10 @@
       </p:sp>
       <p:sp>
         <p:nvSpPr>
-          <p:cNvPr id="16" name="">
+          <p:cNvPr id="17" name="">
             <a:extLst xmlns:a="http://schemas.openxmlformats.org/drawingml/2006/main">
               <a:ext uri="{FF2B5EF4-FFF2-40B4-BE49-F238E27FC236}">
-                <a16:creationId xmlns:a16="http://schemas.microsoft.com/office/drawing/2014/main" id="{9BEF8D58-5282-42F7-9806-831F9BADAEEA}"/>
+                <a16:creationId xmlns:a16="http://schemas.microsoft.com/office/drawing/2014/main" id="{A9BCBB4D-8FD2-4975-81B5-1DAB991B8066}"/>
               </a:ext>
             </a:extLst>
           </p:cNvPr>
@@ -4877,10 +4945,10 @@
       </p:sp>
       <p:sp>
         <p:nvSpPr>
-          <p:cNvPr id="17" name="">
+          <p:cNvPr id="18" name="">
             <a:extLst xmlns:a="http://schemas.openxmlformats.org/drawingml/2006/main">
               <a:ext uri="{FF2B5EF4-FFF2-40B4-BE49-F238E27FC236}">
-                <a16:creationId xmlns:a16="http://schemas.microsoft.com/office/drawing/2014/main" id="{ADA1B885-5E8D-42B8-A32B-3E0AE9761A01}"/>
+                <a16:creationId xmlns:a16="http://schemas.microsoft.com/office/drawing/2014/main" id="{C6CC9C67-E640-4889-A987-D5565AACA889}"/>
               </a:ext>
             </a:extLst>
           </p:cNvPr>
@@ -4968,10 +5036,10 @@
       </p:sp>
       <p:sp>
         <p:nvSpPr>
-          <p:cNvPr id="18" name="">
+          <p:cNvPr id="19" name="">
             <a:extLst xmlns:a="http://schemas.openxmlformats.org/drawingml/2006/main">
               <a:ext uri="{FF2B5EF4-FFF2-40B4-BE49-F238E27FC236}">
-                <a16:creationId xmlns:a16="http://schemas.microsoft.com/office/drawing/2014/main" id="{A8829525-2970-4604-BA7E-8F26FF2F2C1C}"/>
+                <a16:creationId xmlns:a16="http://schemas.microsoft.com/office/drawing/2014/main" id="{74575D0C-687A-45F2-BB84-078D21996A5A}"/>
               </a:ext>
             </a:extLst>
           </p:cNvPr>
@@ -5036,10 +5104,10 @@
       </p:sp>
       <p:sp>
         <p:nvSpPr>
-          <p:cNvPr id="19" name="">
+          <p:cNvPr id="20" name="">
             <a:extLst xmlns:a="http://schemas.openxmlformats.org/drawingml/2006/main">
               <a:ext uri="{FF2B5EF4-FFF2-40B4-BE49-F238E27FC236}">
-                <a16:creationId xmlns:a16="http://schemas.microsoft.com/office/drawing/2014/main" id="{7490F420-34EC-410A-BDE2-0391087BBC5B}"/>
+                <a16:creationId xmlns:a16="http://schemas.microsoft.com/office/drawing/2014/main" id="{BA508A3F-17E1-4547-977D-467497A9F0B5}"/>
               </a:ext>
             </a:extLst>
           </p:cNvPr>
@@ -5050,7 +5118,7 @@
         </p:nvSpPr>
         <p:spPr>
           <a:xfrm xmlns:a="http://schemas.openxmlformats.org/drawingml/2006/main">
-            <a:off x="533400" y="5505450"/>
+            <a:off x="533400" y="5410200"/>
             <a:ext cx="11125200" cy="295275"/>
           </a:xfrm>
           <a:prstGeom xmlns:a="http://schemas.openxmlformats.org/drawingml/2006/main" prst="rect">
@@ -5067,7 +5135,7 @@
           </a:bodyPr>
           <a:lstStyle xmlns:a="http://schemas.openxmlformats.org/drawingml/2006/main">
             <a:defPPr>
-              <a:defRPr sz="1725" b="1">
+              <a:defRPr sz="1800" b="1">
                 <a:solidFill>
                   <a:srgbClr val="F5F6F0"/>
                 </a:solidFill>
@@ -5079,7 +5147,7 @@
           </a:lstStyle>
           <a:p xmlns:a="http://schemas.openxmlformats.org/drawingml/2006/main">
             <a:pPr>
-              <a:defRPr sz="1725" b="1">
+              <a:defRPr sz="1800" b="1">
                 <a:solidFill>
                   <a:srgbClr val="F5F6F0"/>
                 </a:solidFill>
@@ -5089,7 +5157,7 @@
               </a:defRPr>
             </a:pPr>
             <a:r>
-              <a:rPr sz="1725" b="1">
+              <a:rPr sz="1800" b="1">
                 <a:solidFill>
                   <a:srgbClr val="F5F6F0"/>
                 </a:solidFill>
@@ -5097,17 +5165,17 @@
                 <a:ea typeface="Arial"/>
                 <a:cs typeface="Arial"/>
               </a:rPr>
-              <a:t>Processamento equivalente: R$ 36/dia → R$ 25,20/dia</a:t>
+              <a:t>Cota preservada pode reduzir o tempo parado</a:t>
             </a:r>
           </a:p>
         </p:txBody>
       </p:sp>
       <p:sp>
         <p:nvSpPr>
-          <p:cNvPr id="20" name="">
+          <p:cNvPr id="21" name="">
             <a:extLst xmlns:a="http://schemas.openxmlformats.org/drawingml/2006/main">
               <a:ext uri="{FF2B5EF4-FFF2-40B4-BE49-F238E27FC236}">
-                <a16:creationId xmlns:a16="http://schemas.microsoft.com/office/drawing/2014/main" id="{0798A0C5-5091-47F2-BDD9-C25A2409B754}"/>
+                <a16:creationId xmlns:a16="http://schemas.microsoft.com/office/drawing/2014/main" id="{F34807C5-CBCF-4E93-B825-7C443AC1A1C0}"/>
               </a:ext>
             </a:extLst>
           </p:cNvPr>
@@ -5118,7 +5186,7 @@
         </p:nvSpPr>
         <p:spPr>
           <a:xfrm xmlns:a="http://schemas.openxmlformats.org/drawingml/2006/main">
-            <a:off x="533400" y="5829300"/>
+            <a:off x="533400" y="5734050"/>
             <a:ext cx="11125200" cy="266700"/>
           </a:xfrm>
           <a:prstGeom xmlns:a="http://schemas.openxmlformats.org/drawingml/2006/main" prst="rect">
@@ -5135,9 +5203,9 @@
           </a:bodyPr>
           <a:lstStyle xmlns:a="http://schemas.openxmlformats.org/drawingml/2006/main">
             <a:defPPr>
-              <a:defRPr sz="1575" b="0">
-                <a:solidFill>
-                  <a:srgbClr val="70DEC9"/>
+              <a:defRPr sz="1388" b="0">
+                <a:solidFill>
+                  <a:srgbClr val="92BFFF"/>
                 </a:solidFill>
                 <a:latin typeface="Arial"/>
                 <a:ea typeface="Arial"/>
@@ -5147,9 +5215,9 @@
           </a:lstStyle>
           <a:p xmlns:a="http://schemas.openxmlformats.org/drawingml/2006/main">
             <a:pPr>
-              <a:defRPr sz="1575" b="0">
-                <a:solidFill>
-                  <a:srgbClr val="70DEC9"/>
+              <a:defRPr sz="1388" b="0">
+                <a:solidFill>
+                  <a:srgbClr val="92BFFF"/>
                 </a:solidFill>
                 <a:latin typeface="Arial"/>
                 <a:ea typeface="Arial"/>
@@ -5157,25 +5225,25 @@
               </a:defRPr>
             </a:pPr>
             <a:r>
-              <a:rPr sz="1575" b="0">
-                <a:solidFill>
-                  <a:srgbClr val="70DEC9"/>
+              <a:rPr sz="1388" b="0">
+                <a:solidFill>
+                  <a:srgbClr val="92BFFF"/>
                 </a:solidFill>
                 <a:latin typeface="Arial"/>
                 <a:ea typeface="Arial"/>
                 <a:cs typeface="Arial"/>
               </a:rPr>
-              <a:t>Diferença: R$ 10,80/dia · R$ 54/semana · R$ 237,60/mês</a:t>
+              <a:t>Neste cenário: até 2h/dia, 10h/semana ou 44h/mês de espera evitada, com auxiliares disponíveis.</a:t>
             </a:r>
           </a:p>
         </p:txBody>
       </p:sp>
       <p:sp>
         <p:nvSpPr>
-          <p:cNvPr id="21" name="">
+          <p:cNvPr id="22" name="">
             <a:extLst xmlns:a="http://schemas.openxmlformats.org/drawingml/2006/main">
               <a:ext uri="{FF2B5EF4-FFF2-40B4-BE49-F238E27FC236}">
-                <a16:creationId xmlns:a16="http://schemas.microsoft.com/office/drawing/2014/main" id="{7C3328F4-179B-4367-9AF3-5DD99AFFC1CB}"/>
+                <a16:creationId xmlns:a16="http://schemas.microsoft.com/office/drawing/2014/main" id="{BC6EDD20-AC63-490E-8480-3172ED1DD12A}"/>
               </a:ext>
             </a:extLst>
           </p:cNvPr>
@@ -5186,8 +5254,8 @@
         </p:nvSpPr>
         <p:spPr>
           <a:xfrm xmlns:a="http://schemas.openxmlformats.org/drawingml/2006/main">
-            <a:off x="533400" y="6172200"/>
-            <a:ext cx="11125200" cy="276225"/>
+            <a:off x="533400" y="6096000"/>
+            <a:ext cx="11125200" cy="238125"/>
           </a:xfrm>
           <a:prstGeom xmlns:a="http://schemas.openxmlformats.org/drawingml/2006/main" prst="rect">
             <a:avLst/>
@@ -5203,9 +5271,9 @@
           </a:bodyPr>
           <a:lstStyle xmlns:a="http://schemas.openxmlformats.org/drawingml/2006/main">
             <a:defPPr>
-              <a:defRPr sz="1500" b="1">
-                <a:solidFill>
-                  <a:srgbClr val="92BFFF"/>
+              <a:defRPr sz="1350" b="0">
+                <a:solidFill>
+                  <a:srgbClr val="70DEC9"/>
                 </a:solidFill>
                 <a:latin typeface="Arial"/>
                 <a:ea typeface="Arial"/>
@@ -5215,9 +5283,9 @@
           </a:lstStyle>
           <a:p xmlns:a="http://schemas.openxmlformats.org/drawingml/2006/main">
             <a:pPr>
-              <a:defRPr sz="1500" b="1">
-                <a:solidFill>
-                  <a:srgbClr val="92BFFF"/>
+              <a:defRPr sz="1350" b="0">
+                <a:solidFill>
+                  <a:srgbClr val="70DEC9"/>
                 </a:solidFill>
                 <a:latin typeface="Arial"/>
                 <a:ea typeface="Arial"/>
@@ -5225,25 +5293,25 @@
               </a:defRPr>
             </a:pPr>
             <a:r>
-              <a:rPr sz="1500" b="1">
-                <a:solidFill>
-                  <a:srgbClr val="92BFFF"/>
+              <a:rPr sz="1350" b="0">
+                <a:solidFill>
+                  <a:srgbClr val="70DEC9"/>
                 </a:solidFill>
                 <a:latin typeface="Arial"/>
                 <a:ea typeface="Arial"/>
                 <a:cs typeface="Arial"/>
               </a:rPr>
-              <a:t>Espera no cenário: 2h/dia → 0h/dia · potencial de 10h/semana ou 44h/mês</a:t>
+              <a:t>Equivalência de API: R$ 10,80/dia, R$ 54/semana e R$ 237,60/mês, a R$ 36/milhão hipotéticos.</a:t>
             </a:r>
           </a:p>
         </p:txBody>
       </p:sp>
       <p:sp>
         <p:nvSpPr>
-          <p:cNvPr id="22" name="">
+          <p:cNvPr id="23" name="">
             <a:extLst xmlns:a="http://schemas.openxmlformats.org/drawingml/2006/main">
               <a:ext uri="{FF2B5EF4-FFF2-40B4-BE49-F238E27FC236}">
-                <a16:creationId xmlns:a16="http://schemas.microsoft.com/office/drawing/2014/main" id="{F96AE0B4-374B-41D1-863B-686D60DBB204}"/>
+                <a16:creationId xmlns:a16="http://schemas.microsoft.com/office/drawing/2014/main" id="{22C544F0-F3F1-4B8C-8779-F777E88F1D16}"/>
               </a:ext>
             </a:extLst>
           </p:cNvPr>
@@ -5254,8 +5322,8 @@
         </p:nvSpPr>
         <p:spPr>
           <a:xfrm xmlns:a="http://schemas.openxmlformats.org/drawingml/2006/main">
-            <a:off x="533400" y="6515100"/>
-            <a:ext cx="11125200" cy="323850"/>
+            <a:off x="533400" y="6362700"/>
+            <a:ext cx="11125200" cy="238125"/>
           </a:xfrm>
           <a:prstGeom xmlns:a="http://schemas.openxmlformats.org/drawingml/2006/main" prst="rect">
             <a:avLst/>
@@ -5271,9 +5339,9 @@
           </a:bodyPr>
           <a:lstStyle xmlns:a="http://schemas.openxmlformats.org/drawingml/2006/main">
             <a:defPPr>
-              <a:defRPr sz="1013" b="0">
-                <a:solidFill>
-                  <a:srgbClr val="AAB8C5"/>
+              <a:defRPr sz="1350" b="0">
+                <a:solidFill>
+                  <a:srgbClr val="F5F6F0"/>
                 </a:solidFill>
                 <a:latin typeface="Arial"/>
                 <a:ea typeface="Arial"/>
@@ -5283,9 +5351,9 @@
           </a:lstStyle>
           <a:p xmlns:a="http://schemas.openxmlformats.org/drawingml/2006/main">
             <a:pPr>
-              <a:defRPr sz="1013" b="0">
-                <a:solidFill>
-                  <a:srgbClr val="AAB8C5"/>
+              <a:defRPr sz="1350" b="0">
+                <a:solidFill>
+                  <a:srgbClr val="F5F6F0"/>
                 </a:solidFill>
                 <a:latin typeface="Arial"/>
                 <a:ea typeface="Arial"/>
@@ -5293,20 +5361,65 @@
               </a:defRPr>
             </a:pPr>
             <a:r>
-              <a:rPr sz="1013" b="0">
-                <a:solidFill>
-                  <a:srgbClr val="AAB8C5"/>
+              <a:rPr sz="1350" b="0">
+                <a:solidFill>
+                  <a:srgbClr val="F5F6F0"/>
                 </a:solidFill>
                 <a:latin typeface="Arial"/>
                 <a:ea typeface="Arial"/>
                 <a:cs typeface="Arial"/>
               </a:rPr>
-              <a:t>Hipóteses: 8h/dia; 5 dias/semana; 22 dias/mês; cota antes durava 6h; auxiliares disponíveis. Ganhos ainda não medidos.</a:t>
+              <a:t>Equivalência na mensalidade: R$ 0 de desconto. Ganho potencial: mais entregas e menos espera.</a:t>
             </a:r>
           </a:p>
+        </p:txBody>
+      </p:sp>
+      <p:sp>
+        <p:nvSpPr>
+          <p:cNvPr id="24" name="">
+            <a:extLst xmlns:a="http://schemas.openxmlformats.org/drawingml/2006/main">
+              <a:ext uri="{FF2B5EF4-FFF2-40B4-BE49-F238E27FC236}">
+                <a16:creationId xmlns:a16="http://schemas.microsoft.com/office/drawing/2014/main" id="{E88916E3-D514-4D87-97D1-FE2D34CC16A5}"/>
+              </a:ext>
+            </a:extLst>
+          </p:cNvPr>
+          <p:cNvSpPr>
+            <a:spLocks xmlns:a="http://schemas.openxmlformats.org/drawingml/2006/main" noGrp="1"/>
+          </p:cNvSpPr>
+          <p:nvPr/>
+        </p:nvSpPr>
+        <p:spPr>
+          <a:xfrm xmlns:a="http://schemas.openxmlformats.org/drawingml/2006/main">
+            <a:off x="533400" y="6667500"/>
+            <a:ext cx="11125200" cy="152400"/>
+          </a:xfrm>
+          <a:prstGeom xmlns:a="http://schemas.openxmlformats.org/drawingml/2006/main" prst="rect">
+            <a:avLst/>
+          </a:prstGeom>
+          <a:noFill xmlns:a="http://schemas.openxmlformats.org/drawingml/2006/main"/>
+          <a:ln xmlns:a="http://schemas.openxmlformats.org/drawingml/2006/main" w="0">
+            <a:noFill/>
+          </a:ln>
+        </p:spPr>
+        <p:txBody>
+          <a:bodyPr xmlns:a="http://schemas.openxmlformats.org/drawingml/2006/main" wrap="square" lIns="0" tIns="0" rIns="0" bIns="0" anchor="t">
+            <a:noAutofit/>
+          </a:bodyPr>
+          <a:lstStyle xmlns:a="http://schemas.openxmlformats.org/drawingml/2006/main">
+            <a:defPPr>
+              <a:defRPr sz="825" b="0">
+                <a:solidFill>
+                  <a:srgbClr val="AAB8C5"/>
+                </a:solidFill>
+                <a:latin typeface="Arial"/>
+                <a:ea typeface="Arial"/>
+                <a:cs typeface="Arial"/>
+              </a:defRPr>
+            </a:defPPr>
+          </a:lstStyle>
           <a:p xmlns:a="http://schemas.openxmlformats.org/drawingml/2006/main">
             <a:pPr>
-              <a:defRPr sz="1013" b="0">
+              <a:defRPr sz="825" b="0">
                 <a:solidFill>
                   <a:srgbClr val="AAB8C5"/>
                 </a:solidFill>
@@ -5316,7 +5429,7 @@
               </a:defRPr>
             </a:pPr>
             <a:r>
-              <a:rPr sz="1013" b="0">
+              <a:rPr sz="825" b="0">
                 <a:solidFill>
                   <a:srgbClr val="AAB8C5"/>
                 </a:solidFill>
@@ -5324,7 +5437,7 @@
                 <a:ea typeface="Arial"/>
                 <a:cs typeface="Arial"/>
               </a:rPr>
-              <a:t>R$ 36/milhão é uma referência hipotética de API. A mensalidade fica igual; tokens auxiliares e energia não foram precificados.</a:t>
+              <a:t>Simulação, não medição. 8h/dia, 5 dias/semana, 22 dias/mês e cota antes de 6h. Limites reais variam. Energia e tokens auxiliares fora do cálculo.</a:t>
             </a:r>
           </a:p>
         </p:txBody>
@@ -5332,7 +5445,7 @@
     </p:spTree>
     <p:extLst>
       <p:ext uri="{BB962C8B-B14F-4D97-AF65-F5344CB8AC3E}">
-        <p14:creationId xmlns:p14="http://schemas.microsoft.com/office/powerpoint/2010/main" val="2140008147"/>
+        <p14:creationId xmlns:p14="http://schemas.microsoft.com/office/powerpoint/2010/main" val="576253058"/>
       </p:ext>
     </p:extLst>
   </p:cSld>

</xml_diff>

<commit_message>
Atualiza infográfico para a medição de 60,9% e destaca vídeo
</commit_message>
<xml_diff>
--- a/media/one-pager.pptx
+++ b/media/one-pager.pptx
@@ -2,13 +2,13 @@
 <file path=ppt/presentation.xml><?xml version="1.0" encoding="utf-8"?>
 <p:presentation xmlns:p="http://schemas.openxmlformats.org/presentationml/2006/main">
   <p:sldMasterIdLst>
-    <p:sldMasterId xmlns:r="http://schemas.openxmlformats.org/officeDocument/2006/relationships" id="2147483648" r:id="R7fd23f08cd594c93"/>
+    <p:sldMasterId xmlns:r="http://schemas.openxmlformats.org/officeDocument/2006/relationships" id="2147483648" r:id="Rc7eb4ecff8a7416c"/>
   </p:sldMasterIdLst>
   <p:notesMasterIdLst>
-    <p:notesMasterId xmlns:r="http://schemas.openxmlformats.org/officeDocument/2006/relationships" r:id="Rbc9c9e03c80c4e29"/>
+    <p:notesMasterId xmlns:r="http://schemas.openxmlformats.org/officeDocument/2006/relationships" r:id="R02349d5d80804f78"/>
   </p:notesMasterIdLst>
   <p:sldIdLst>
-    <p:sldId xmlns:r="http://schemas.openxmlformats.org/officeDocument/2006/relationships" id="256" r:id="R841bca4cad034949"/>
+    <p:sldId xmlns:r="http://schemas.openxmlformats.org/officeDocument/2006/relationships" id="256" r:id="R9db6d1d4a2fa4f88"/>
   </p:sldIdLst>
   <p:sldSz cx="12192000" cy="6858000"/>
   <p:notesSz cx="6858000" cy="9144000"/>
@@ -442,7 +442,7 @@
           <a:lstStyle xmlns:a="http://schemas.openxmlformats.org/drawingml/2006/main"/>
           <a:p xmlns:a="http://schemas.openxmlformats.org/drawingml/2006/main">
             <a:r>
-              <a:t>Cenário ilustrativo solicitado pelo usuário; não é benchmark histórico e não representa redução medida.</a:t>
+              <a:t>Medição local em 16/10/2026, versão pública 663803e: comparação da mesma consulta no mesmo estado do cofre com cinco notas e orçamento de 12.000 caracteres. Saída inteira anterior: 11.961 caracteres; nova: 4.677; diferença: 7.284; redução arredondada: 60,9%. Os nomes das cinco notas e os trechos selecionados foram conferidos como idênticos; nomes de omissões e resumos não fazem parte dessa equivalência. Dados privados não acompanham a apresentação. Fonte pública do método e limites: https://github.com/nicholasbirochi/Cerebro/blob/main/docs/BENCHMARK.md.</a:t>
             </a:r>
           </a:p>
           <a:p xmlns:a="http://schemas.openxmlformats.org/drawingml/2006/main">
@@ -452,7 +452,7 @@
           </a:p>
           <a:p xmlns:a="http://schemas.openxmlformats.org/drawingml/2006/main">
             <a:r>
-              <a:t>1.000.000 − 400.000 + 100.000 = 700.000 tokens/dia do principal. 40% da execução é delegada e a preparação/revisão custa 10% do volume original. Economia líquida no principal: 300.000/dia, 1.500.000/semana (5 dias), 6.600.000/mês (22 dias). Entre todas as IAs o cenário pode somar 1.100.000 tokens/dia: a delegação preserva a franquia principal, sem afirmar redução do total global. Tokenizadores e contabilização dos provedores variam.</a:t>
+              <a:t>Cenário sintético distinto, reproduzível pelo script público tools/benchmark_busca.py: 40 notas relevantes, mesmas cinco notas e vinte trechos; 11.696 → 5.862 caracteres, redução de 49,9%. O padrão atual de duas notas retorna 2.495 caracteres neste cenário sintético e não compõe a comparação controlada de cinco notas.</a:t>
             </a:r>
           </a:p>
           <a:p xmlns:a="http://schemas.openxmlformats.org/drawingml/2006/main">
@@ -462,37 +462,7 @@
           </a:p>
           <a:p xmlns:a="http://schemas.openxmlformats.org/drawingml/2006/main">
             <a:r>
-              <a:t>Médias da mesma demanda distribuída em 8h/dia: antes 2.083,33 tokens/min e 125.000/h; depois 1.458,33/min e 87.500/h; diferença 625/min ou 37.500/h. Minutos arredondados apenas na apresentação. Semanas e meses são úteis, não calendário.</a:t>
-            </a:r>
-          </a:p>
-          <a:p xmlns:a="http://schemas.openxmlformats.org/drawingml/2006/main">
-            <a:r>
-              <a:t/>
-            </a:r>
-          </a:p>
-          <a:p xmlns:a="http://schemas.openxmlformats.org/drawingml/2006/main">
-            <a:r>
-              <a:t>R$36/milhão é premissa hipotética de processamento de API, mantida para comparar este exemplo; não afirma preço atual de um modelo, câmbio atual nem cobrança observada. Antes R$36/dia, agora R$25,20/dia, diferença R$10,80/dia, R$54/semana e R$237,60/mês. O usuário informou mensalidade igual: economia financeira na assinatura é R$0. Os R$237,60 são duzentos e trinta e sete reais e sessenta centavos de processamento equivalente de API, não desconto nem despesa observada. Com mais entregas pela mesma mensalidade, o custo médio por entrega pode cair. Exemplo meramente aritmético: mensalidade M / 10 entregas versus M / 14 entregas, redução de28,6% por entrega. Não há medição do número de entregas ou da espera real. O cenário assume acesso auxiliar incluído ou local, com margem disponível e sem cobrança avulsa; energia e tokens dos auxiliares não foram precificados.</a:t>
-            </a:r>
-          </a:p>
-          <a:p xmlns:a="http://schemas.openxmlformats.org/drawingml/2006/main">
-            <a:r>
-              <a:t/>
-            </a:r>
-          </a:p>
-          <a:p xmlns:a="http://schemas.openxmlformats.org/drawingml/2006/main">
-            <a:r>
-              <a:t>Ociosidade: se um orçamento modelado em tokens antes sustentava 6h da demanda de uma jornada de 8h, a demanda principal 30% menor sustentaria 6/0,7=8,57h. Nessas condições a espera poderia cair de2h/dia para0h/dia, liberando até10h/semana ou44h/mês. Esta é uma hipótese de continuidade, não medição de latência, bloqueios ou qualidade. Limites reais não são necessariamente cotas fixas de tokens.</a:t>
-            </a:r>
-          </a:p>
-          <a:p xmlns:a="http://schemas.openxmlformats.org/drawingml/2006/main">
-            <a:r>
-              <a:t/>
-            </a:r>
-          </a:p>
-          <a:p xmlns:a="http://schemas.openxmlformats.org/drawingml/2006/main">
-            <a:r>
-              <a:t>Exemplos representam capacidades textuais sob demanda: Ollama resume texto local; Copilot sugere testes a partir de função fornecida; OpenCode/Nemotron analisa trecho público de erro. Principal escolhe contexto permitido, passa a delegação pelo roteador, revisa e aplica. Copilot, Ollama e OpenCode/Nemotron são destinos na mesma camada, com elegibilidade distinta por tarefa, cota e recursos. Integração de Copilot no helper aplicada e validada em14/10/2026; detalhes da implantação devem ser relatados separadamente, sem tratar esta simulação como prova de economia.</a:t>
+              <a:t>Não foram medidos tokens de entrada, saída, raciocínio, cache, consumo global de IAs, latência, produtividade ou desconto financeiro. A mensalidade permanece a mesma: R$0 de desconto. A imagem anterior apresentava uma simulação de 30% menos tokens no principal, com projeções hipotéticas de tempo e equivalência de API; foi substituída por resultados de saída da busca, sem converter caracteres em tokens ou dinheiro. O vídeo ilustrativo da arquitetura permanece inalterado.</a:t>
             </a:r>
           </a:p>
         </p:txBody>
@@ -590,6 +560,7 @@
                 <a:spcPts val="0"/>
               </a:spcAft>
               <a:buNone/>
+              <a:defRPr/>
             </a:lvl1pPr>
             <a:lvl2pPr marL="0" indent="0">
               <a:lnSpc>
@@ -602,6 +573,7 @@
                 <a:spcPts val="0"/>
               </a:spcAft>
               <a:buNone/>
+              <a:defRPr/>
             </a:lvl2pPr>
             <a:lvl3pPr marL="0" indent="0">
               <a:lnSpc>
@@ -614,6 +586,7 @@
                 <a:spcPts val="0"/>
               </a:spcAft>
               <a:buNone/>
+              <a:defRPr/>
             </a:lvl3pPr>
             <a:lvl4pPr marL="0" indent="0">
               <a:lnSpc>
@@ -626,6 +599,7 @@
                 <a:spcPts val="0"/>
               </a:spcAft>
               <a:buNone/>
+              <a:defRPr/>
             </a:lvl4pPr>
             <a:lvl5pPr marL="0" indent="0">
               <a:lnSpc>
@@ -638,6 +612,7 @@
                 <a:spcPts val="0"/>
               </a:spcAft>
               <a:buNone/>
+              <a:defRPr/>
             </a:lvl5pPr>
             <a:lvl6pPr marL="0" indent="0">
               <a:lnSpc>
@@ -650,6 +625,7 @@
                 <a:spcPts val="0"/>
               </a:spcAft>
               <a:buNone/>
+              <a:defRPr/>
             </a:lvl6pPr>
             <a:lvl7pPr marL="0" indent="0">
               <a:lnSpc>
@@ -662,6 +638,7 @@
                 <a:spcPts val="0"/>
               </a:spcAft>
               <a:buNone/>
+              <a:defRPr/>
             </a:lvl7pPr>
             <a:lvl8pPr marL="0" indent="0">
               <a:lnSpc>
@@ -674,6 +651,7 @@
                 <a:spcPts val="0"/>
               </a:spcAft>
               <a:buNone/>
+              <a:defRPr/>
             </a:lvl8pPr>
             <a:lvl9pPr marL="0" indent="0">
               <a:lnSpc>
@@ -686,6 +664,7 @@
                 <a:spcPts val="0"/>
               </a:spcAft>
               <a:buNone/>
+              <a:defRPr/>
             </a:lvl9pPr>
           </a:lstStyle>
           <a:p xmlns:a="http://schemas.openxmlformats.org/drawingml/2006/main"/>
@@ -747,6 +726,7 @@
                 <a:spcPts val="0"/>
               </a:spcAft>
               <a:buNone/>
+              <a:defRPr/>
             </a:lvl1pPr>
             <a:lvl2pPr marL="0" indent="0">
               <a:lnSpc>
@@ -759,6 +739,7 @@
                 <a:spcPts val="0"/>
               </a:spcAft>
               <a:buNone/>
+              <a:defRPr/>
             </a:lvl2pPr>
             <a:lvl3pPr marL="0" indent="0">
               <a:lnSpc>
@@ -771,6 +752,7 @@
                 <a:spcPts val="0"/>
               </a:spcAft>
               <a:buNone/>
+              <a:defRPr/>
             </a:lvl3pPr>
             <a:lvl4pPr marL="0" indent="0">
               <a:lnSpc>
@@ -783,6 +765,7 @@
                 <a:spcPts val="0"/>
               </a:spcAft>
               <a:buNone/>
+              <a:defRPr/>
             </a:lvl4pPr>
             <a:lvl5pPr marL="0" indent="0">
               <a:lnSpc>
@@ -795,6 +778,7 @@
                 <a:spcPts val="0"/>
               </a:spcAft>
               <a:buNone/>
+              <a:defRPr/>
             </a:lvl5pPr>
             <a:lvl6pPr marL="0" indent="0">
               <a:lnSpc>
@@ -807,6 +791,7 @@
                 <a:spcPts val="0"/>
               </a:spcAft>
               <a:buNone/>
+              <a:defRPr/>
             </a:lvl6pPr>
             <a:lvl7pPr marL="0" indent="0">
               <a:lnSpc>
@@ -819,6 +804,7 @@
                 <a:spcPts val="0"/>
               </a:spcAft>
               <a:buNone/>
+              <a:defRPr/>
             </a:lvl7pPr>
             <a:lvl8pPr marL="0" indent="0">
               <a:lnSpc>
@@ -831,6 +817,7 @@
                 <a:spcPts val="0"/>
               </a:spcAft>
               <a:buNone/>
+              <a:defRPr/>
             </a:lvl8pPr>
             <a:lvl9pPr marL="0" indent="0">
               <a:lnSpc>
@@ -843,6 +830,7 @@
                 <a:spcPts val="0"/>
               </a:spcAft>
               <a:buNone/>
+              <a:defRPr/>
             </a:lvl9pPr>
           </a:lstStyle>
           <a:p xmlns:a="http://schemas.openxmlformats.org/drawingml/2006/main"/>
@@ -921,6 +909,7 @@
                 <a:spcPts val="0"/>
               </a:spcAft>
               <a:buNone/>
+              <a:defRPr/>
             </a:lvl1pPr>
             <a:lvl2pPr marL="0" indent="0">
               <a:lnSpc>
@@ -933,6 +922,7 @@
                 <a:spcPts val="0"/>
               </a:spcAft>
               <a:buNone/>
+              <a:defRPr/>
             </a:lvl2pPr>
             <a:lvl3pPr marL="0" indent="0">
               <a:lnSpc>
@@ -945,6 +935,7 @@
                 <a:spcPts val="0"/>
               </a:spcAft>
               <a:buNone/>
+              <a:defRPr/>
             </a:lvl3pPr>
             <a:lvl4pPr marL="0" indent="0">
               <a:lnSpc>
@@ -957,6 +948,7 @@
                 <a:spcPts val="0"/>
               </a:spcAft>
               <a:buNone/>
+              <a:defRPr/>
             </a:lvl4pPr>
             <a:lvl5pPr marL="0" indent="0">
               <a:lnSpc>
@@ -969,6 +961,7 @@
                 <a:spcPts val="0"/>
               </a:spcAft>
               <a:buNone/>
+              <a:defRPr/>
             </a:lvl5pPr>
             <a:lvl6pPr marL="0" indent="0">
               <a:lnSpc>
@@ -981,6 +974,7 @@
                 <a:spcPts val="0"/>
               </a:spcAft>
               <a:buNone/>
+              <a:defRPr/>
             </a:lvl6pPr>
             <a:lvl7pPr marL="0" indent="0">
               <a:lnSpc>
@@ -993,6 +987,7 @@
                 <a:spcPts val="0"/>
               </a:spcAft>
               <a:buNone/>
+              <a:defRPr/>
             </a:lvl7pPr>
             <a:lvl8pPr marL="0" indent="0">
               <a:lnSpc>
@@ -1005,6 +1000,7 @@
                 <a:spcPts val="0"/>
               </a:spcAft>
               <a:buNone/>
+              <a:defRPr/>
             </a:lvl8pPr>
             <a:lvl9pPr marL="0" indent="0">
               <a:lnSpc>
@@ -1017,6 +1013,7 @@
                 <a:spcPts val="0"/>
               </a:spcAft>
               <a:buNone/>
+              <a:defRPr/>
             </a:lvl9pPr>
           </a:lstStyle>
           <a:p xmlns:a="http://schemas.openxmlformats.org/drawingml/2006/main"/>
@@ -1095,6 +1092,7 @@
                 <a:spcPts val="0"/>
               </a:spcAft>
               <a:buNone/>
+              <a:defRPr/>
             </a:lvl1pPr>
             <a:lvl2pPr marL="0" indent="0">
               <a:lnSpc>
@@ -1107,6 +1105,7 @@
                 <a:spcPts val="0"/>
               </a:spcAft>
               <a:buNone/>
+              <a:defRPr/>
             </a:lvl2pPr>
             <a:lvl3pPr marL="0" indent="0">
               <a:lnSpc>
@@ -1119,6 +1118,7 @@
                 <a:spcPts val="0"/>
               </a:spcAft>
               <a:buNone/>
+              <a:defRPr/>
             </a:lvl3pPr>
             <a:lvl4pPr marL="0" indent="0">
               <a:lnSpc>
@@ -1131,6 +1131,7 @@
                 <a:spcPts val="0"/>
               </a:spcAft>
               <a:buNone/>
+              <a:defRPr/>
             </a:lvl4pPr>
             <a:lvl5pPr marL="0" indent="0">
               <a:lnSpc>
@@ -1143,6 +1144,7 @@
                 <a:spcPts val="0"/>
               </a:spcAft>
               <a:buNone/>
+              <a:defRPr/>
             </a:lvl5pPr>
             <a:lvl6pPr marL="0" indent="0">
               <a:lnSpc>
@@ -1155,6 +1157,7 @@
                 <a:spcPts val="0"/>
               </a:spcAft>
               <a:buNone/>
+              <a:defRPr/>
             </a:lvl6pPr>
             <a:lvl7pPr marL="0" indent="0">
               <a:lnSpc>
@@ -1167,6 +1170,7 @@
                 <a:spcPts val="0"/>
               </a:spcAft>
               <a:buNone/>
+              <a:defRPr/>
             </a:lvl7pPr>
             <a:lvl8pPr marL="0" indent="0">
               <a:lnSpc>
@@ -1179,6 +1183,7 @@
                 <a:spcPts val="0"/>
               </a:spcAft>
               <a:buNone/>
+              <a:defRPr/>
             </a:lvl8pPr>
             <a:lvl9pPr marL="0" indent="0">
               <a:lnSpc>
@@ -1191,6 +1196,7 @@
                 <a:spcPts val="0"/>
               </a:spcAft>
               <a:buNone/>
+              <a:defRPr/>
             </a:lvl9pPr>
           </a:lstStyle>
           <a:p xmlns:a="http://schemas.openxmlformats.org/drawingml/2006/main"/>
@@ -1252,6 +1258,7 @@
                 <a:spcPts val="1200"/>
               </a:spcAft>
               <a:buChar char="•"/>
+              <a:defRPr/>
             </a:lvl1pPr>
             <a:lvl2pPr marL="533400" indent="-228600">
               <a:lnSpc>
@@ -1264,6 +1271,7 @@
                 <a:spcPts val="1200"/>
               </a:spcAft>
               <a:buChar char="•"/>
+              <a:defRPr/>
             </a:lvl2pPr>
             <a:lvl3pPr marL="838200" indent="-228600">
               <a:lnSpc>
@@ -1276,6 +1284,7 @@
                 <a:spcPts val="1200"/>
               </a:spcAft>
               <a:buChar char="•"/>
+              <a:defRPr/>
             </a:lvl3pPr>
             <a:lvl4pPr marL="1143000" indent="-228600">
               <a:lnSpc>
@@ -1288,6 +1297,7 @@
                 <a:spcPts val="1200"/>
               </a:spcAft>
               <a:buChar char="•"/>
+              <a:defRPr/>
             </a:lvl4pPr>
             <a:lvl5pPr marL="1447800" indent="-228600">
               <a:lnSpc>
@@ -1300,6 +1310,7 @@
                 <a:spcPts val="1200"/>
               </a:spcAft>
               <a:buChar char="•"/>
+              <a:defRPr/>
             </a:lvl5pPr>
             <a:lvl6pPr marL="1752600" indent="-228600">
               <a:lnSpc>
@@ -1312,6 +1323,7 @@
                 <a:spcPts val="1200"/>
               </a:spcAft>
               <a:buChar char="•"/>
+              <a:defRPr/>
             </a:lvl6pPr>
             <a:lvl7pPr marL="2057400" indent="-228600">
               <a:lnSpc>
@@ -1324,6 +1336,7 @@
                 <a:spcPts val="1200"/>
               </a:spcAft>
               <a:buChar char="•"/>
+              <a:defRPr/>
             </a:lvl7pPr>
             <a:lvl8pPr marL="2362200" indent="-228600">
               <a:lnSpc>
@@ -1336,6 +1349,7 @@
                 <a:spcPts val="1200"/>
               </a:spcAft>
               <a:buChar char="•"/>
+              <a:defRPr/>
             </a:lvl8pPr>
             <a:lvl9pPr marL="2667000" indent="-228600">
               <a:lnSpc>
@@ -1348,6 +1362,7 @@
                 <a:spcPts val="1200"/>
               </a:spcAft>
               <a:buChar char="•"/>
+              <a:defRPr/>
             </a:lvl9pPr>
           </a:lstStyle>
           <a:p xmlns:a="http://schemas.openxmlformats.org/drawingml/2006/main"/>
@@ -1426,6 +1441,7 @@
                 <a:spcPts val="0"/>
               </a:spcAft>
               <a:buNone/>
+              <a:defRPr/>
             </a:lvl1pPr>
             <a:lvl2pPr marL="0" indent="0">
               <a:lnSpc>
@@ -1438,6 +1454,7 @@
                 <a:spcPts val="0"/>
               </a:spcAft>
               <a:buNone/>
+              <a:defRPr/>
             </a:lvl2pPr>
             <a:lvl3pPr marL="0" indent="0">
               <a:lnSpc>
@@ -1450,6 +1467,7 @@
                 <a:spcPts val="0"/>
               </a:spcAft>
               <a:buNone/>
+              <a:defRPr/>
             </a:lvl3pPr>
             <a:lvl4pPr marL="0" indent="0">
               <a:lnSpc>
@@ -1462,6 +1480,7 @@
                 <a:spcPts val="0"/>
               </a:spcAft>
               <a:buNone/>
+              <a:defRPr/>
             </a:lvl4pPr>
             <a:lvl5pPr marL="0" indent="0">
               <a:lnSpc>
@@ -1474,6 +1493,7 @@
                 <a:spcPts val="0"/>
               </a:spcAft>
               <a:buNone/>
+              <a:defRPr/>
             </a:lvl5pPr>
             <a:lvl6pPr marL="0" indent="0">
               <a:lnSpc>
@@ -1486,6 +1506,7 @@
                 <a:spcPts val="0"/>
               </a:spcAft>
               <a:buNone/>
+              <a:defRPr/>
             </a:lvl6pPr>
             <a:lvl7pPr marL="0" indent="0">
               <a:lnSpc>
@@ -1498,6 +1519,7 @@
                 <a:spcPts val="0"/>
               </a:spcAft>
               <a:buNone/>
+              <a:defRPr/>
             </a:lvl7pPr>
             <a:lvl8pPr marL="0" indent="0">
               <a:lnSpc>
@@ -1510,6 +1532,7 @@
                 <a:spcPts val="0"/>
               </a:spcAft>
               <a:buNone/>
+              <a:defRPr/>
             </a:lvl8pPr>
             <a:lvl9pPr marL="0" indent="0">
               <a:lnSpc>
@@ -1522,6 +1545,7 @@
                 <a:spcPts val="0"/>
               </a:spcAft>
               <a:buNone/>
+              <a:defRPr/>
             </a:lvl9pPr>
           </a:lstStyle>
           <a:p xmlns:a="http://schemas.openxmlformats.org/drawingml/2006/main"/>
@@ -1583,6 +1607,7 @@
                 <a:spcPts val="1200"/>
               </a:spcAft>
               <a:buChar char="•"/>
+              <a:defRPr/>
             </a:lvl1pPr>
             <a:lvl2pPr marL="533400" indent="-228600">
               <a:lnSpc>
@@ -1595,6 +1620,7 @@
                 <a:spcPts val="1200"/>
               </a:spcAft>
               <a:buChar char="•"/>
+              <a:defRPr/>
             </a:lvl2pPr>
             <a:lvl3pPr marL="838200" indent="-228600">
               <a:lnSpc>
@@ -1607,6 +1633,7 @@
                 <a:spcPts val="1200"/>
               </a:spcAft>
               <a:buChar char="•"/>
+              <a:defRPr/>
             </a:lvl3pPr>
             <a:lvl4pPr marL="1143000" indent="-228600">
               <a:lnSpc>
@@ -1619,6 +1646,7 @@
                 <a:spcPts val="1200"/>
               </a:spcAft>
               <a:buChar char="•"/>
+              <a:defRPr/>
             </a:lvl4pPr>
             <a:lvl5pPr marL="1447800" indent="-228600">
               <a:lnSpc>
@@ -1631,6 +1659,7 @@
                 <a:spcPts val="1200"/>
               </a:spcAft>
               <a:buChar char="•"/>
+              <a:defRPr/>
             </a:lvl5pPr>
             <a:lvl6pPr marL="1752600" indent="-228600">
               <a:lnSpc>
@@ -1643,6 +1672,7 @@
                 <a:spcPts val="1200"/>
               </a:spcAft>
               <a:buChar char="•"/>
+              <a:defRPr/>
             </a:lvl6pPr>
             <a:lvl7pPr marL="2057400" indent="-228600">
               <a:lnSpc>
@@ -1655,6 +1685,7 @@
                 <a:spcPts val="1200"/>
               </a:spcAft>
               <a:buChar char="•"/>
+              <a:defRPr/>
             </a:lvl7pPr>
             <a:lvl8pPr marL="2362200" indent="-228600">
               <a:lnSpc>
@@ -1667,6 +1698,7 @@
                 <a:spcPts val="1200"/>
               </a:spcAft>
               <a:buChar char="•"/>
+              <a:defRPr/>
             </a:lvl8pPr>
             <a:lvl9pPr marL="2667000" indent="-228600">
               <a:lnSpc>
@@ -1679,6 +1711,7 @@
                 <a:spcPts val="1200"/>
               </a:spcAft>
               <a:buChar char="•"/>
+              <a:defRPr/>
             </a:lvl9pPr>
           </a:lstStyle>
           <a:p xmlns:a="http://schemas.openxmlformats.org/drawingml/2006/main"/>
@@ -1740,6 +1773,7 @@
                 <a:spcPts val="1200"/>
               </a:spcAft>
               <a:buChar char="•"/>
+              <a:defRPr/>
             </a:lvl1pPr>
             <a:lvl2pPr marL="533400" indent="-228600">
               <a:lnSpc>
@@ -1752,6 +1786,7 @@
                 <a:spcPts val="1200"/>
               </a:spcAft>
               <a:buChar char="•"/>
+              <a:defRPr/>
             </a:lvl2pPr>
             <a:lvl3pPr marL="838200" indent="-228600">
               <a:lnSpc>
@@ -1764,6 +1799,7 @@
                 <a:spcPts val="1200"/>
               </a:spcAft>
               <a:buChar char="•"/>
+              <a:defRPr/>
             </a:lvl3pPr>
             <a:lvl4pPr marL="1143000" indent="-228600">
               <a:lnSpc>
@@ -1776,6 +1812,7 @@
                 <a:spcPts val="1200"/>
               </a:spcAft>
               <a:buChar char="•"/>
+              <a:defRPr/>
             </a:lvl4pPr>
             <a:lvl5pPr marL="1447800" indent="-228600">
               <a:lnSpc>
@@ -1788,6 +1825,7 @@
                 <a:spcPts val="1200"/>
               </a:spcAft>
               <a:buChar char="•"/>
+              <a:defRPr/>
             </a:lvl5pPr>
             <a:lvl6pPr marL="1752600" indent="-228600">
               <a:lnSpc>
@@ -1800,6 +1838,7 @@
                 <a:spcPts val="1200"/>
               </a:spcAft>
               <a:buChar char="•"/>
+              <a:defRPr/>
             </a:lvl6pPr>
             <a:lvl7pPr marL="2057400" indent="-228600">
               <a:lnSpc>
@@ -1812,6 +1851,7 @@
                 <a:spcPts val="1200"/>
               </a:spcAft>
               <a:buChar char="•"/>
+              <a:defRPr/>
             </a:lvl7pPr>
             <a:lvl8pPr marL="2362200" indent="-228600">
               <a:lnSpc>
@@ -1824,6 +1864,7 @@
                 <a:spcPts val="1200"/>
               </a:spcAft>
               <a:buChar char="•"/>
+              <a:defRPr/>
             </a:lvl8pPr>
             <a:lvl9pPr marL="2667000" indent="-228600">
               <a:lnSpc>
@@ -1836,6 +1877,7 @@
                 <a:spcPts val="1200"/>
               </a:spcAft>
               <a:buChar char="•"/>
+              <a:defRPr/>
             </a:lvl9pPr>
           </a:lstStyle>
           <a:p xmlns:a="http://schemas.openxmlformats.org/drawingml/2006/main"/>
@@ -1914,6 +1956,7 @@
                 <a:spcPts val="0"/>
               </a:spcAft>
               <a:buNone/>
+              <a:defRPr/>
             </a:lvl1pPr>
             <a:lvl2pPr marL="0" indent="0">
               <a:lnSpc>
@@ -1926,6 +1969,7 @@
                 <a:spcPts val="0"/>
               </a:spcAft>
               <a:buNone/>
+              <a:defRPr/>
             </a:lvl2pPr>
             <a:lvl3pPr marL="0" indent="0">
               <a:lnSpc>
@@ -1938,6 +1982,7 @@
                 <a:spcPts val="0"/>
               </a:spcAft>
               <a:buNone/>
+              <a:defRPr/>
             </a:lvl3pPr>
             <a:lvl4pPr marL="0" indent="0">
               <a:lnSpc>
@@ -1950,6 +1995,7 @@
                 <a:spcPts val="0"/>
               </a:spcAft>
               <a:buNone/>
+              <a:defRPr/>
             </a:lvl4pPr>
             <a:lvl5pPr marL="0" indent="0">
               <a:lnSpc>
@@ -1962,6 +2008,7 @@
                 <a:spcPts val="0"/>
               </a:spcAft>
               <a:buNone/>
+              <a:defRPr/>
             </a:lvl5pPr>
             <a:lvl6pPr marL="0" indent="0">
               <a:lnSpc>
@@ -1974,6 +2021,7 @@
                 <a:spcPts val="0"/>
               </a:spcAft>
               <a:buNone/>
+              <a:defRPr/>
             </a:lvl6pPr>
             <a:lvl7pPr marL="0" indent="0">
               <a:lnSpc>
@@ -1986,6 +2034,7 @@
                 <a:spcPts val="0"/>
               </a:spcAft>
               <a:buNone/>
+              <a:defRPr/>
             </a:lvl7pPr>
             <a:lvl8pPr marL="0" indent="0">
               <a:lnSpc>
@@ -1998,6 +2047,7 @@
                 <a:spcPts val="0"/>
               </a:spcAft>
               <a:buNone/>
+              <a:defRPr/>
             </a:lvl8pPr>
             <a:lvl9pPr marL="0" indent="0">
               <a:lnSpc>
@@ -2010,6 +2060,7 @@
                 <a:spcPts val="0"/>
               </a:spcAft>
               <a:buNone/>
+              <a:defRPr/>
             </a:lvl9pPr>
           </a:lstStyle>
           <a:p xmlns:a="http://schemas.openxmlformats.org/drawingml/2006/main"/>
@@ -2071,6 +2122,7 @@
                 <a:spcPts val="1200"/>
               </a:spcAft>
               <a:buChar char="•"/>
+              <a:defRPr/>
             </a:lvl1pPr>
             <a:lvl2pPr marL="533400" indent="-228600">
               <a:lnSpc>
@@ -2083,6 +2135,7 @@
                 <a:spcPts val="1200"/>
               </a:spcAft>
               <a:buChar char="•"/>
+              <a:defRPr/>
             </a:lvl2pPr>
             <a:lvl3pPr marL="838200" indent="-228600">
               <a:lnSpc>
@@ -2095,6 +2148,7 @@
                 <a:spcPts val="1200"/>
               </a:spcAft>
               <a:buChar char="•"/>
+              <a:defRPr/>
             </a:lvl3pPr>
             <a:lvl4pPr marL="1143000" indent="-228600">
               <a:lnSpc>
@@ -2107,6 +2161,7 @@
                 <a:spcPts val="1200"/>
               </a:spcAft>
               <a:buChar char="•"/>
+              <a:defRPr/>
             </a:lvl4pPr>
             <a:lvl5pPr marL="1447800" indent="-228600">
               <a:lnSpc>
@@ -2119,6 +2174,7 @@
                 <a:spcPts val="1200"/>
               </a:spcAft>
               <a:buChar char="•"/>
+              <a:defRPr/>
             </a:lvl5pPr>
             <a:lvl6pPr marL="1752600" indent="-228600">
               <a:lnSpc>
@@ -2131,6 +2187,7 @@
                 <a:spcPts val="1200"/>
               </a:spcAft>
               <a:buChar char="•"/>
+              <a:defRPr/>
             </a:lvl6pPr>
             <a:lvl7pPr marL="2057400" indent="-228600">
               <a:lnSpc>
@@ -2143,6 +2200,7 @@
                 <a:spcPts val="1200"/>
               </a:spcAft>
               <a:buChar char="•"/>
+              <a:defRPr/>
             </a:lvl7pPr>
             <a:lvl8pPr marL="2362200" indent="-228600">
               <a:lnSpc>
@@ -2155,6 +2213,7 @@
                 <a:spcPts val="1200"/>
               </a:spcAft>
               <a:buChar char="•"/>
+              <a:defRPr/>
             </a:lvl8pPr>
             <a:lvl9pPr marL="2667000" indent="-228600">
               <a:lnSpc>
@@ -2167,6 +2226,7 @@
                 <a:spcPts val="1200"/>
               </a:spcAft>
               <a:buChar char="•"/>
+              <a:defRPr/>
             </a:lvl9pPr>
           </a:lstStyle>
           <a:p xmlns:a="http://schemas.openxmlformats.org/drawingml/2006/main"/>
@@ -2215,12 +2275,12 @@
   </p:cSld>
   <p:clrMap bg1="lt1" tx1="dk1" bg2="lt2" tx2="dk2" accent1="accent1" accent2="accent2" accent3="accent3" accent4="accent4" accent5="accent5" accent6="accent6" hlink="hlink" folHlink="folHlink"/>
   <p:sldLayoutIdLst>
-    <p:sldLayoutId xmlns:r="http://schemas.openxmlformats.org/officeDocument/2006/relationships" id="2147483649" r:id="Rc1801f6a62b744cc"/>
-    <p:sldLayoutId xmlns:r="http://schemas.openxmlformats.org/officeDocument/2006/relationships" id="2147483650" r:id="R5a9e5649e86548af"/>
-    <p:sldLayoutId xmlns:r="http://schemas.openxmlformats.org/officeDocument/2006/relationships" id="2147483651" r:id="R7e8f3d7c888e4e9b"/>
-    <p:sldLayoutId xmlns:r="http://schemas.openxmlformats.org/officeDocument/2006/relationships" id="2147483652" r:id="Rc8df512d408c48c8"/>
-    <p:sldLayoutId xmlns:r="http://schemas.openxmlformats.org/officeDocument/2006/relationships" id="2147483653" r:id="R6687e298e21d47c1"/>
-    <p:sldLayoutId xmlns:r="http://schemas.openxmlformats.org/officeDocument/2006/relationships" id="2147483654" r:id="Ra42f588b204d4feb"/>
+    <p:sldLayoutId xmlns:r="http://schemas.openxmlformats.org/officeDocument/2006/relationships" id="2147483649" r:id="Rda0e6a14c069476a"/>
+    <p:sldLayoutId xmlns:r="http://schemas.openxmlformats.org/officeDocument/2006/relationships" id="2147483650" r:id="Rc62d934f8afd4486"/>
+    <p:sldLayoutId xmlns:r="http://schemas.openxmlformats.org/officeDocument/2006/relationships" id="2147483651" r:id="R9e3063e969d94e3a"/>
+    <p:sldLayoutId xmlns:r="http://schemas.openxmlformats.org/officeDocument/2006/relationships" id="2147483652" r:id="Ra749fceaebd34d42"/>
+    <p:sldLayoutId xmlns:r="http://schemas.openxmlformats.org/officeDocument/2006/relationships" id="2147483653" r:id="Rddd0c500499f42e8"/>
+    <p:sldLayoutId xmlns:r="http://schemas.openxmlformats.org/officeDocument/2006/relationships" id="2147483654" r:id="R6c437044ab764494"/>
   </p:sldLayoutIdLst>
   <p:txStyles>
     <p:titleStyle>
@@ -2748,274 +2808,281 @@
 </file>
 
 <file path=ppt/slides/charts/chart1.xml><?xml version="1.0" encoding="utf-8"?>
-<c:chartSpace xmlns:c="http://schemas.openxmlformats.org/drawingml/2006/chart" xmlns:r="http://schemas.openxmlformats.org/officeDocument/2006/relationships">
-  <c:lang val="en-US"/>
-  <c:chart>
-    <c:plotArea>
-      <c:barChart>
-        <c:barDir val="bar"/>
-        <c:grouping val="clustered"/>
-        <c:varyColors val="1"/>
-        <c:ser>
-          <c:idx val="0"/>
-          <c:order val="0"/>
-          <c:tx>
-            <c:v>Tokens do principal por dia</c:v>
-          </c:tx>
-          <c:invertIfNegative val="0"/>
-          <c:dPt>
-            <c:idx val="0"/>
-            <c:invertIfNegative val="0"/>
-            <c:spPr>
-              <a:solidFill xmlns:a="http://schemas.openxmlformats.org/drawingml/2006/main">
-                <a:srgbClr val="70DEC9"/>
-              </a:solidFill>
-            </c:spPr>
-          </c:dPt>
-          <c:dPt>
-            <c:idx val="1"/>
-            <c:invertIfNegative val="0"/>
-            <c:spPr>
-              <a:solidFill xmlns:a="http://schemas.openxmlformats.org/drawingml/2006/main">
-                <a:srgbClr val="607487"/>
-              </a:solidFill>
-            </c:spPr>
-          </c:dPt>
-          <c:dLbls>
-            <c:dLbl>
-              <c:idx val="0"/>
-              <c:tx>
-                <c:rich>
-                  <a:bodyPr xmlns:a="http://schemas.openxmlformats.org/drawingml/2006/main"/>
-                  <a:lstStyle xmlns:a="http://schemas.openxmlformats.org/drawingml/2006/main"/>
-                  <a:p xmlns:a="http://schemas.openxmlformats.org/drawingml/2006/main">
-                    <a:r>
-                      <a:rPr sz="1800" b="1">
-                        <a:solidFill>
-                          <a:srgbClr val="101923"/>
-                        </a:solidFill>
-                        <a:latin typeface="Arial"/>
-                        <a:ea typeface="Arial"/>
-                        <a:cs typeface="Arial"/>
-                      </a:rPr>
-                      <a:t>700 mil</a:t>
-                    </a:r>
-                  </a:p>
-                </c:rich>
-              </c:tx>
-              <c:txPr>
-                <a:bodyPr xmlns:a="http://schemas.openxmlformats.org/drawingml/2006/main" anchorCtr="1"/>
-                <a:lstStyle xmlns:a="http://schemas.openxmlformats.org/drawingml/2006/main"/>
-                <a:p xmlns:a="http://schemas.openxmlformats.org/drawingml/2006/main">
-                  <a:pPr>
-                    <a:defRPr sz="1800" b="1">
-                      <a:solidFill>
-                        <a:srgbClr val="101923"/>
-                      </a:solidFill>
-                      <a:latin typeface="Arial"/>
-                      <a:ea typeface="Arial"/>
-                      <a:cs typeface="Arial"/>
-                    </a:defRPr>
-                  </a:pPr>
-                </a:p>
-              </c:txPr>
-              <c:dLblPos val="inEnd"/>
-              <c:showVal val="0"/>
-            </c:dLbl>
-            <c:dLbl>
-              <c:idx val="1"/>
-              <c:tx>
-                <c:rich>
-                  <a:bodyPr xmlns:a="http://schemas.openxmlformats.org/drawingml/2006/main"/>
-                  <a:lstStyle xmlns:a="http://schemas.openxmlformats.org/drawingml/2006/main"/>
-                  <a:p xmlns:a="http://schemas.openxmlformats.org/drawingml/2006/main">
-                    <a:r>
-                      <a:rPr sz="1800" b="1">
-                        <a:solidFill>
-                          <a:srgbClr val="F5F6F0"/>
-                        </a:solidFill>
-                        <a:latin typeface="Arial"/>
-                        <a:ea typeface="Arial"/>
-                        <a:cs typeface="Arial"/>
-                      </a:rPr>
-                      <a:t>1 milhão</a:t>
-                    </a:r>
-                  </a:p>
-                </c:rich>
-              </c:tx>
-              <c:txPr>
-                <a:bodyPr xmlns:a="http://schemas.openxmlformats.org/drawingml/2006/main" anchorCtr="1"/>
-                <a:lstStyle xmlns:a="http://schemas.openxmlformats.org/drawingml/2006/main"/>
-                <a:p xmlns:a="http://schemas.openxmlformats.org/drawingml/2006/main">
-                  <a:pPr>
-                    <a:defRPr sz="1800" b="1">
-                      <a:solidFill>
-                        <a:srgbClr val="F5F6F0"/>
-                      </a:solidFill>
-                      <a:latin typeface="Arial"/>
-                      <a:ea typeface="Arial"/>
-                      <a:cs typeface="Arial"/>
-                    </a:defRPr>
-                  </a:pPr>
-                </a:p>
-              </c:txPr>
-              <c:dLblPos val="inEnd"/>
-              <c:showVal val="0"/>
-            </c:dLbl>
-          </c:dLbls>
-          <c:cat>
-            <c:strRef>
-              <c:f>'Chart Data'!$A$2:$A$3</c:f>
-              <c:strCache>
-                <c:ptCount val="2"/>
-                <c:pt idx="0">
-                  <c:v>Agora</c:v>
-                </c:pt>
-                <c:pt idx="1">
-                  <c:v>Antes</c:v>
-                </c:pt>
-              </c:strCache>
-            </c:strRef>
-          </c:cat>
-          <c:val>
-            <c:numRef>
-              <c:f>'Chart Data'!$B$2:$B$3</c:f>
-              <c:numCache>
-                <c:formatCode>General</c:formatCode>
-                <c:ptCount val="2"/>
-                <c:pt idx="0">
-                  <c:v>700000</c:v>
-                </c:pt>
-                <c:pt idx="1">
-                  <c:v>1000000</c:v>
-                </c:pt>
-              </c:numCache>
-            </c:numRef>
-          </c:val>
-        </c:ser>
-        <c:dLbls>
-          <c:delete val="0"/>
-          <c:txPr>
-            <a:bodyPr xmlns:a="http://schemas.openxmlformats.org/drawingml/2006/main" anchorCtr="1"/>
-            <a:lstStyle xmlns:a="http://schemas.openxmlformats.org/drawingml/2006/main"/>
-            <a:p xmlns:a="http://schemas.openxmlformats.org/drawingml/2006/main">
-              <a:pPr>
-                <a:defRPr>
-                  <a:latin typeface="Arial"/>
-                  <a:ea typeface="Arial"/>
-                  <a:cs typeface="Arial"/>
-                </a:defRPr>
-              </a:pPr>
-            </a:p>
-          </c:txPr>
-          <c:dLblPos val="inEnd"/>
-          <c:showLegendKey val="0"/>
-          <c:showVal val="1"/>
-          <c:showCatName val="0"/>
-          <c:showSerName val="0"/>
-          <c:showPercent val="0"/>
-          <c:showBubbleSize val="0"/>
-          <c:showLeaderLines val="0"/>
-        </c:dLbls>
-        <c:gapWidth val="60"/>
-        <c:axId val="48650112"/>
-        <c:axId val="48672768"/>
-      </c:barChart>
-      <c:catAx>
-        <c:axId val="48650112"/>
-        <c:scaling>
-          <c:orientation val="minMax"/>
-        </c:scaling>
-        <c:delete val="0"/>
-        <c:axPos val="l"/>
-        <c:numFmt formatCode="General"/>
-        <c:majorTickMark val="none"/>
-        <c:minorTickMark val="none"/>
-        <c:spPr>
-          <a:ln xmlns:a="http://schemas.openxmlformats.org/drawingml/2006/main" w="0">
-            <a:noFill/>
-          </a:ln>
-        </c:spPr>
-        <c:txPr>
-          <a:bodyPr xmlns:a="http://schemas.openxmlformats.org/drawingml/2006/main" anchorCtr="1"/>
-          <a:lstStyle xmlns:a="http://schemas.openxmlformats.org/drawingml/2006/main"/>
-          <a:p xmlns:a="http://schemas.openxmlformats.org/drawingml/2006/main">
-            <a:pPr>
-              <a:defRPr sz="1575" b="1">
-                <a:solidFill>
-                  <a:srgbClr val="F5F6F0"/>
-                </a:solidFill>
-                <a:latin typeface="Arial"/>
-                <a:ea typeface="Arial"/>
-                <a:cs typeface="Arial"/>
-              </a:defRPr>
-            </a:pPr>
-          </a:p>
-        </c:txPr>
-        <c:crossAx val="48672768"/>
-      </c:catAx>
-      <c:valAx>
-        <c:axId val="48672768"/>
-        <c:scaling>
-          <c:orientation val="minMax"/>
-          <c:max val="1100000"/>
-          <c:min val="0"/>
-        </c:scaling>
-        <c:delete val="1"/>
-        <c:axPos val="b"/>
-        <c:numFmt formatCode="General"/>
-        <c:majorTickMark val="none"/>
-        <c:minorTickMark val="none"/>
-        <c:spPr>
-          <a:ln xmlns:a="http://schemas.openxmlformats.org/drawingml/2006/main" w="9525">
-            <a:solidFill>
-              <a:srgbClr val="D4D4D4"/>
-            </a:solidFill>
-            <a:prstDash val="solid"/>
-          </a:ln>
-        </c:spPr>
-        <c:txPr>
-          <a:bodyPr xmlns:a="http://schemas.openxmlformats.org/drawingml/2006/main" anchorCtr="1"/>
-          <a:lstStyle xmlns:a="http://schemas.openxmlformats.org/drawingml/2006/main"/>
-          <a:p xmlns:a="http://schemas.openxmlformats.org/drawingml/2006/main">
-            <a:pPr>
-              <a:defRPr>
-                <a:solidFill>
-                  <a:srgbClr val="666666"/>
-                </a:solidFill>
-                <a:latin typeface="Arial"/>
-                <a:ea typeface="Arial"/>
-                <a:cs typeface="Arial"/>
-              </a:defRPr>
-            </a:pPr>
-          </a:p>
-        </c:txPr>
-        <c:crossAx val="48650112"/>
-        <c:crossBetween val="between"/>
-      </c:valAx>
-      <c:spPr>
-        <a:solidFill xmlns:a="http://schemas.openxmlformats.org/drawingml/2006/main">
-          <a:srgbClr val="101923"/>
-        </a:solidFill>
-        <a:ln xmlns:a="http://schemas.openxmlformats.org/drawingml/2006/main" w="0">
-          <a:noFill/>
-        </a:ln>
-      </c:spPr>
-    </c:plotArea>
-    <c:plotVisOnly val="1"/>
-  </c:chart>
-  <c:spPr>
-    <a:solidFill xmlns:a="http://schemas.openxmlformats.org/drawingml/2006/main">
-      <a:srgbClr val="101923"/>
-    </a:solidFill>
-    <a:ln xmlns:a="http://schemas.openxmlformats.org/drawingml/2006/main" w="0">
-      <a:noFill/>
-    </a:ln>
-  </c:spPr>
-  <c:externalData r:id="rIdChartSnapshot1">
-    <c:autoUpdate val="0"/>
-  </c:externalData>
-</c:chartSpace>
+<ns0:chartSpace xmlns:ns0="http://schemas.openxmlformats.org/drawingml/2006/chart" xmlns:ns1="http://schemas.openxmlformats.org/drawingml/2006/main" xmlns:ns2="http://schemas.openxmlformats.org/officeDocument/2006/relationships">
+  <ns0:lang val="en-US"/>
+  <ns0:chart>
+    <ns0:plotArea>
+      <ns0:barChart>
+        <ns0:barDir val="bar"/>
+        <ns0:grouping val="clustered"/>
+        <ns0:varyColors val="1"/>
+        <ns0:ser>
+          <ns0:idx val="0"/>
+          <ns0:order val="0"/>
+          <ns0:tx>
+            <ns0:v>Caracteres retornados pela busca</ns0:v>
+          </ns0:tx>
+          <ns0:invertIfNegative val="0"/>
+          <ns0:dPt>
+            <ns0:idx val="0"/>
+            <ns0:invertIfNegative val="0"/>
+            <ns0:spPr>
+              <ns1:solidFill>
+                <ns1:srgbClr val="70DEC9"/>
+              </ns1:solidFill>
+            </ns0:spPr>
+          </ns0:dPt>
+          <ns0:dPt>
+            <ns0:idx val="1"/>
+            <ns0:invertIfNegative val="0"/>
+            <ns0:spPr>
+              <ns1:solidFill>
+                <ns1:srgbClr val="607487"/>
+              </ns1:solidFill>
+            </ns0:spPr>
+          </ns0:dPt>
+          <ns0:dLbls>
+            <ns0:dLbl>
+              <ns0:idx val="0"/>
+              <ns0:tx>
+                <ns0:rich>
+                  <ns1:bodyPr/>
+                  <ns1:lstStyle/>
+                  <ns1:p>
+                    <ns1:r>
+                      <ns1:rPr sz="1800" b="1">
+                        <ns1:solidFill>
+                          <ns1:srgbClr val="101923"/>
+                        </ns1:solidFill>
+                        <ns1:latin typeface="Arial"/>
+                        <ns1:ea typeface="Arial"/>
+                        <ns1:cs typeface="Arial"/>
+                      </ns1:rPr>
+                      <ns1:t>4.677</ns1:t>
+                    </ns1:r>
+                  </ns1:p>
+                </ns0:rich>
+              </ns0:tx>
+              <ns0:txPr>
+                <ns1:bodyPr anchorCtr="1"/>
+                <ns1:lstStyle/>
+                <ns1:p>
+                  <ns1:pPr>
+                    <ns1:defRPr sz="1800" b="1">
+                      <ns1:solidFill>
+                        <ns1:srgbClr val="101923"/>
+                      </ns1:solidFill>
+                      <ns1:latin typeface="Arial"/>
+                      <ns1:ea typeface="Arial"/>
+                      <ns1:cs typeface="Arial"/>
+                    </ns1:defRPr>
+                  </ns1:pPr>
+                </ns1:p>
+              </ns0:txPr>
+              <ns0:dLblPos val="inEnd"/>
+              <ns0:showVal val="0"/>
+            </ns0:dLbl>
+            <ns0:dLbl>
+              <ns0:idx val="1"/>
+              <ns0:tx>
+                <ns0:rich>
+                  <ns1:bodyPr/>
+                  <ns1:lstStyle/>
+                  <ns1:p>
+                    <ns1:r>
+                      <ns1:rPr sz="1800" b="1">
+                        <ns1:solidFill>
+                          <ns1:srgbClr val="F5F6F0"/>
+                        </ns1:solidFill>
+                        <ns1:latin typeface="Arial"/>
+                        <ns1:ea typeface="Arial"/>
+                        <ns1:cs typeface="Arial"/>
+                      </ns1:rPr>
+                      <ns1:t>11.961</ns1:t>
+                    </ns1:r>
+                  </ns1:p>
+                </ns0:rich>
+              </ns0:tx>
+              <ns0:txPr>
+                <ns1:bodyPr anchorCtr="1"/>
+                <ns1:lstStyle/>
+                <ns1:p>
+                  <ns1:pPr>
+                    <ns1:defRPr sz="1800" b="1">
+                      <ns1:solidFill>
+                        <ns1:srgbClr val="F5F6F0"/>
+                      </ns1:solidFill>
+                      <ns1:latin typeface="Arial"/>
+                      <ns1:ea typeface="Arial"/>
+                      <ns1:cs typeface="Arial"/>
+                    </ns1:defRPr>
+                  </ns1:pPr>
+                </ns1:p>
+              </ns0:txPr>
+              <ns0:dLblPos val="inEnd"/>
+              <ns0:showVal val="0"/>
+            </ns0:dLbl>
+            <ns0:showLegendKey val="0"/>
+            <ns0:showVal val="0"/>
+            <ns0:showCatName val="0"/>
+            <ns0:showSerName val="0"/>
+            <ns0:showPercent val="0"/>
+            <ns0:showBubbleSize val="0"/>
+            <ns0:showLeaderLines val="0"/>
+          </ns0:dLbls>
+          <ns0:cat>
+            <ns0:strRef>
+              <ns0:f>'Chart Data'!$A$2:$A$3</ns0:f>
+              <ns0:strCache>
+                <ns0:ptCount val="2"/>
+                <ns0:pt idx="0">
+                  <ns0:v>Agora</ns0:v>
+                </ns0:pt>
+                <ns0:pt idx="1">
+                  <ns0:v>Antes</ns0:v>
+                </ns0:pt>
+              </ns0:strCache>
+            </ns0:strRef>
+          </ns0:cat>
+          <ns0:val>
+            <ns0:numRef>
+              <ns0:f>'Chart Data'!$B$2:$B$3</ns0:f>
+              <ns0:numCache>
+                <ns0:formatCode>General</ns0:formatCode>
+                <ns0:ptCount val="2"/>
+                <ns0:pt idx="0">
+                  <ns0:v>4677</ns0:v>
+                </ns0:pt>
+                <ns0:pt idx="1">
+                  <ns0:v>11961</ns0:v>
+                </ns0:pt>
+              </ns0:numCache>
+            </ns0:numRef>
+          </ns0:val>
+        </ns0:ser>
+        <ns0:dLbls>
+          <ns0:delete val="0"/>
+          <ns0:txPr>
+            <ns1:bodyPr anchorCtr="1"/>
+            <ns1:lstStyle/>
+            <ns1:p>
+              <ns1:pPr>
+                <ns1:defRPr>
+                  <ns1:latin typeface="Arial"/>
+                  <ns1:ea typeface="Arial"/>
+                  <ns1:cs typeface="Arial"/>
+                </ns1:defRPr>
+              </ns1:pPr>
+            </ns1:p>
+          </ns0:txPr>
+          <ns0:dLblPos val="inEnd"/>
+          <ns0:showLegendKey val="0"/>
+          <ns0:showVal val="1"/>
+          <ns0:showCatName val="0"/>
+          <ns0:showSerName val="0"/>
+          <ns0:showPercent val="0"/>
+          <ns0:showBubbleSize val="0"/>
+          <ns0:showLeaderLines val="0"/>
+        </ns0:dLbls>
+        <ns0:gapWidth val="60"/>
+        <ns0:axId val="48650112"/>
+        <ns0:axId val="48672768"/>
+      </ns0:barChart>
+      <ns0:catAx>
+        <ns0:axId val="48650112"/>
+        <ns0:scaling>
+          <ns0:orientation val="minMax"/>
+        </ns0:scaling>
+        <ns0:delete val="0"/>
+        <ns0:axPos val="l"/>
+        <ns0:numFmt formatCode="General"/>
+        <ns0:majorTickMark val="none"/>
+        <ns0:minorTickMark val="none"/>
+        <ns0:spPr>
+          <ns1:ln w="0">
+            <ns1:noFill/>
+          </ns1:ln>
+        </ns0:spPr>
+        <ns0:txPr>
+          <ns1:bodyPr anchorCtr="1"/>
+          <ns1:lstStyle/>
+          <ns1:p>
+            <ns1:pPr>
+              <ns1:defRPr sz="1575" b="1">
+                <ns1:solidFill>
+                  <ns1:srgbClr val="F5F6F0"/>
+                </ns1:solidFill>
+                <ns1:latin typeface="Arial"/>
+                <ns1:ea typeface="Arial"/>
+                <ns1:cs typeface="Arial"/>
+              </ns1:defRPr>
+            </ns1:pPr>
+          </ns1:p>
+        </ns0:txPr>
+        <ns0:crossAx val="48672768"/>
+      </ns0:catAx>
+      <ns0:valAx>
+        <ns0:axId val="48672768"/>
+        <ns0:scaling>
+          <ns0:orientation val="minMax"/>
+          <ns0:max val="13157.1"/>
+          <ns0:min val="0"/>
+        </ns0:scaling>
+        <ns0:delete val="1"/>
+        <ns0:axPos val="b"/>
+        <ns0:numFmt formatCode="General"/>
+        <ns0:majorTickMark val="none"/>
+        <ns0:minorTickMark val="none"/>
+        <ns0:spPr>
+          <ns1:ln w="9525">
+            <ns1:solidFill>
+              <ns1:srgbClr val="D4D4D4"/>
+            </ns1:solidFill>
+            <ns1:prstDash val="solid"/>
+          </ns1:ln>
+        </ns0:spPr>
+        <ns0:txPr>
+          <ns1:bodyPr anchorCtr="1"/>
+          <ns1:lstStyle/>
+          <ns1:p>
+            <ns1:pPr>
+              <ns1:defRPr>
+                <ns1:solidFill>
+                  <ns1:srgbClr val="666666"/>
+                </ns1:solidFill>
+                <ns1:latin typeface="Arial"/>
+                <ns1:ea typeface="Arial"/>
+                <ns1:cs typeface="Arial"/>
+              </ns1:defRPr>
+            </ns1:pPr>
+          </ns1:p>
+        </ns0:txPr>
+        <ns0:crossAx val="48650112"/>
+        <ns0:crossBetween val="between"/>
+      </ns0:valAx>
+      <ns0:spPr>
+        <ns1:solidFill>
+          <ns1:srgbClr val="101923"/>
+        </ns1:solidFill>
+        <ns1:ln w="0">
+          <ns1:noFill/>
+        </ns1:ln>
+      </ns0:spPr>
+    </ns0:plotArea>
+    <ns0:plotVisOnly val="1"/>
+  </ns0:chart>
+  <ns0:spPr>
+    <ns1:solidFill>
+      <ns1:srgbClr val="101923"/>
+    </ns1:solidFill>
+    <ns1:ln w="0">
+      <ns1:noFill/>
+    </ns1:ln>
+  </ns0:spPr>
+  <ns0:externalData ns2:id="rIdChartSnapshot1">
+    <ns0:autoUpdate val="0"/>
+  </ns0:externalData>
+</ns0:chartSpace>
 </file>
 
 <file path=ppt/slides/slide1.xml><?xml version="1.0" encoding="utf-8"?>
@@ -3082,6 +3149,7 @@
           </a:lstStyle>
           <a:p xmlns:a="http://schemas.openxmlformats.org/drawingml/2006/main">
             <a:pPr>
+              <a:buNone/>
               <a:defRPr sz="1275" b="1">
                 <a:solidFill>
                   <a:srgbClr val="70DEC9"/>
@@ -3100,7 +3168,7 @@
                 <a:ea typeface="Arial"/>
                 <a:cs typeface="Arial"/>
               </a:rPr>
-              <a:t>SIMULAÇÃO · MESMO TRABALHO · MESMA MENSALIDADE</a:t>
+              <a:t>MEDIÇÃO LOCAL · MESMO CONTEXTO · MESMA MENSALIDADE</a:t>
             </a:r>
           </a:p>
         </p:txBody>
@@ -3150,6 +3218,7 @@
           </a:lstStyle>
           <a:p xmlns:a="http://schemas.openxmlformats.org/drawingml/2006/main">
             <a:pPr>
+              <a:buNone/>
               <a:defRPr sz="3375" b="1">
                 <a:solidFill>
                   <a:srgbClr val="F5F6F0"/>
@@ -3168,7 +3237,7 @@
                 <a:ea typeface="Arial"/>
                 <a:cs typeface="Arial"/>
               </a:rPr>
-              <a:t>30% menos tokens no principal</a:t>
+              <a:t>60,9% menos texto na busca</a:t>
             </a:r>
           </a:p>
         </p:txBody>
@@ -3218,6 +3287,7 @@
           </a:lstStyle>
           <a:p xmlns:a="http://schemas.openxmlformats.org/drawingml/2006/main">
             <a:pPr>
+              <a:buNone/>
               <a:defRPr sz="1425" b="0">
                 <a:solidFill>
                   <a:srgbClr val="AAB8C5"/>
@@ -3236,7 +3306,7 @@
                 <a:ea typeface="Arial"/>
                 <a:cs typeface="Arial"/>
               </a:rPr>
-              <a:t>Claude ou Codex coordena. O roteador distribui a execução e o principal revisa.</a:t>
+              <a:t>Mesma consulta, mesmo acervo, mesmas cinco notas e trechos.</a:t>
             </a:r>
           </a:p>
         </p:txBody>
@@ -3286,6 +3356,7 @@
           </a:lstStyle>
           <a:p xmlns:a="http://schemas.openxmlformats.org/drawingml/2006/main">
             <a:pPr>
+              <a:buNone/>
               <a:defRPr sz="1425" b="0">
                 <a:solidFill>
                   <a:srgbClr val="AAB8C5"/>
@@ -3304,7 +3375,7 @@
                 <a:ea typeface="Arial"/>
                 <a:cs typeface="Arial"/>
               </a:rPr>
-              <a:t>Consumo diário do principal</a:t>
+              <a:t>Texto retornado pela busca</a:t>
             </a:r>
           </a:p>
         </p:txBody>
@@ -3314,7 +3385,7 @@
           <p:cNvPr id="5" name="Chart">
             <a:extLst xmlns:a="http://schemas.openxmlformats.org/drawingml/2006/main">
               <a:ext uri="{FF2B5EF4-FFF2-40B4-BE49-F238E27FC236}">
-                <a16:creationId xmlns:a16="http://schemas.microsoft.com/office/drawing/2014/main" id="{0EE0A955-9C23-48E6-B390-09C900663FF2}"/>
+                <a16:creationId xmlns:a16="http://schemas.microsoft.com/office/drawing/2014/main" id="{4ECA498E-2511-4A0A-9952-3A6E0D2BC73B}"/>
               </a:ext>
             </a:extLst>
           </p:cNvPr>
@@ -3327,7 +3398,7 @@
         </p:xfrm>
         <a:graphic xmlns:a="http://schemas.openxmlformats.org/drawingml/2006/main">
           <a:graphicData uri="http://schemas.openxmlformats.org/drawingml/2006/chart">
-            <c:chart xmlns:r="http://schemas.openxmlformats.org/officeDocument/2006/relationships" xmlns:c="http://schemas.openxmlformats.org/drawingml/2006/chart" r:id="R51637a1f667b44a8"/>
+            <c:chart xmlns:r="http://schemas.openxmlformats.org/officeDocument/2006/relationships" xmlns:c="http://schemas.openxmlformats.org/drawingml/2006/chart" r:id="R0c7e625a0ffe4c48"/>
           </a:graphicData>
         </a:graphic>
       </p:graphicFrame>
@@ -3376,6 +3447,7 @@
           </a:lstStyle>
           <a:p xmlns:a="http://schemas.openxmlformats.org/drawingml/2006/main">
             <a:pPr>
+              <a:buNone/>
               <a:defRPr sz="1500" b="1">
                 <a:solidFill>
                   <a:srgbClr val="70DEC9"/>
@@ -3394,7 +3466,7 @@
                 <a:ea typeface="Arial"/>
                 <a:cs typeface="Arial"/>
               </a:rPr>
-              <a:t>300 mil tokens a menos por dia (30%)</a:t>
+              <a:t>7.284 caracteres a menos (60,9%)</a:t>
             </a:r>
           </a:p>
         </p:txBody>
@@ -3444,6 +3516,7 @@
           </a:lstStyle>
           <a:p xmlns:a="http://schemas.openxmlformats.org/drawingml/2006/main">
             <a:pPr>
+              <a:buNone/>
               <a:defRPr sz="1875" b="1">
                 <a:solidFill>
                   <a:srgbClr val="F5F6F0"/>
@@ -3462,7 +3535,7 @@
                 <a:ea typeface="Arial"/>
                 <a:cs typeface="Arial"/>
               </a:rPr>
-              <a:t>A conta, com o mesmo trabalho</a:t>
+              <a:t>A conta da redução medida</a:t>
             </a:r>
           </a:p>
         </p:txBody>
@@ -3512,6 +3585,7 @@
           </a:lstStyle>
           <a:p xmlns:a="http://schemas.openxmlformats.org/drawingml/2006/main">
             <a:pPr>
+              <a:buNone/>
               <a:defRPr sz="2250" b="1">
                 <a:solidFill>
                   <a:srgbClr val="70DEC9"/>
@@ -3530,7 +3604,7 @@
                 <a:ea typeface="Arial"/>
                 <a:cs typeface="Arial"/>
               </a:rPr>
-              <a:t>1.000.000 − 400.000 + 100.000 = 700.000</a:t>
+              <a:t>11.961 − 4.677 = 7.284</a:t>
             </a:r>
           </a:p>
         </p:txBody>
@@ -3580,6 +3654,7 @@
           </a:lstStyle>
           <a:p xmlns:a="http://schemas.openxmlformats.org/drawingml/2006/main">
             <a:pPr>
+              <a:buNone/>
               <a:defRPr sz="1425" b="0">
                 <a:solidFill>
                   <a:srgbClr val="F5F6F0"/>
@@ -3598,7 +3673,7 @@
                 <a:ea typeface="Arial"/>
                 <a:cs typeface="Arial"/>
               </a:rPr>
-              <a:t>400 mil tokens de execução vão aos auxiliares (40%).</a:t>
+              <a:t>7.284 caracteres deixam de ocupar a saída da busca.</a:t>
             </a:r>
           </a:p>
         </p:txBody>
@@ -3648,6 +3723,7 @@
           </a:lstStyle>
           <a:p xmlns:a="http://schemas.openxmlformats.org/drawingml/2006/main">
             <a:pPr>
+              <a:buNone/>
               <a:defRPr sz="1425" b="0">
                 <a:solidFill>
                   <a:srgbClr val="F5F6F0"/>
@@ -3666,7 +3742,7 @@
                 <a:ea typeface="Arial"/>
                 <a:cs typeface="Arial"/>
               </a:rPr>
-              <a:t>100 mil tokens ficam para preparar e revisar (10%).</a:t>
+              <a:t>O conteúdo dos trechos selecionados foi preservado.</a:t>
             </a:r>
           </a:p>
         </p:txBody>
@@ -3716,6 +3792,7 @@
           </a:lstStyle>
           <a:p xmlns:a="http://schemas.openxmlformats.org/drawingml/2006/main">
             <a:pPr>
+              <a:buNone/>
               <a:defRPr sz="1575" b="1">
                 <a:solidFill>
                   <a:srgbClr val="70DEC9"/>
@@ -3734,7 +3811,7 @@
                 <a:ea typeface="Arial"/>
                 <a:cs typeface="Arial"/>
               </a:rPr>
-              <a:t>300 mil tokens do principal preservados por dia</a:t>
+              <a:t>Redução: 7.284 ÷ 11.961 = 60,9%</a:t>
             </a:r>
           </a:p>
         </p:txBody>
@@ -3784,6 +3861,7 @@
           </a:lstStyle>
           <a:p xmlns:a="http://schemas.openxmlformats.org/drawingml/2006/main">
             <a:pPr>
+              <a:buNone/>
               <a:defRPr sz="1275" b="0">
                 <a:solidFill>
                   <a:srgbClr val="AAB8C5"/>
@@ -3802,7 +3880,7 @@
                 <a:ea typeface="Arial"/>
                 <a:cs typeface="Arial"/>
               </a:rPr>
-              <a:t>O total entre as IAs pode chegar a 1,1 milhão/dia neste exemplo.</a:t>
+              <a:t>O ganho vem de resumir a lista de notas omitidas.</a:t>
             </a:r>
           </a:p>
         </p:txBody>
@@ -3852,6 +3930,7 @@
           </a:lstStyle>
           <a:p xmlns:a="http://schemas.openxmlformats.org/drawingml/2006/main">
             <a:pPr>
+              <a:buNone/>
               <a:defRPr sz="1350" b="0">
                 <a:solidFill>
                   <a:srgbClr val="AAB8C5"/>
@@ -3870,7 +3949,7 @@
                 <a:ea typeface="Arial"/>
                 <a:cs typeface="Arial"/>
               </a:rPr>
-              <a:t>Tokens do principal · médias em 8h de trabalho</a:t>
+              <a:t>Controle da comparação local</a:t>
             </a:r>
           </a:p>
         </p:txBody>
@@ -3880,7 +3959,7 @@
           <p:cNvPr id="14" name="">
             <a:extLst xmlns:a="http://schemas.openxmlformats.org/drawingml/2006/main">
               <a:ext uri="{FF2B5EF4-FFF2-40B4-BE49-F238E27FC236}">
-                <a16:creationId xmlns:a16="http://schemas.microsoft.com/office/drawing/2014/main" id="{3E024B88-2632-438F-816D-99F40B4C2625}"/>
+                <a16:creationId xmlns:a16="http://schemas.microsoft.com/office/drawing/2014/main" id="{7E60879A-9846-47C3-B233-0D9BCF1C5A85}"/>
               </a:ext>
             </a:extLst>
           </p:cNvPr>
@@ -3909,7 +3988,9 @@
                     </a:bodyPr>
                     <a:lstStyle/>
                     <a:p>
-                      <a:pPr algn="l"/>
+                      <a:pPr algn="l">
+                        <a:buNone/>
+                      </a:pPr>
                       <a:r>
                         <a:rPr sz="1313" b="1">
                           <a:solidFill>
@@ -3919,7 +4000,7 @@
                           <a:ea typeface="Arial"/>
                           <a:cs typeface="Arial"/>
                         </a:rPr>
-                        <a:t>Período</a:t>
+                        <a:t>Controle</a:t>
                       </a:r>
                     </a:p>
                   </a:txBody>
@@ -3948,7 +4029,9 @@
                     </a:bodyPr>
                     <a:lstStyle/>
                     <a:p>
-                      <a:pPr algn="l"/>
+                      <a:pPr algn="l">
+                        <a:buNone/>
+                      </a:pPr>
                       <a:r>
                         <a:rPr sz="1313" b="1">
                           <a:solidFill>
@@ -3984,7 +4067,9 @@
                     </a:bodyPr>
                     <a:lstStyle/>
                     <a:p>
-                      <a:pPr algn="l"/>
+                      <a:pPr algn="l">
+                        <a:buNone/>
+                      </a:pPr>
                       <a:r>
                         <a:rPr sz="1313" b="1">
                           <a:solidFill>
@@ -4020,7 +4105,9 @@
                     </a:bodyPr>
                     <a:lstStyle/>
                     <a:p>
-                      <a:pPr algn="l"/>
+                      <a:pPr algn="l">
+                        <a:buNone/>
+                      </a:pPr>
                       <a:r>
                         <a:rPr sz="1313" b="1">
                           <a:solidFill>
@@ -4030,7 +4117,7 @@
                           <a:ea typeface="Arial"/>
                           <a:cs typeface="Arial"/>
                         </a:rPr>
-                        <a:t>A menos</a:t>
+                        <a:t>Diferença</a:t>
                       </a:r>
                     </a:p>
                   </a:txBody>
@@ -4058,7 +4145,9 @@
                     </a:bodyPr>
                     <a:lstStyle/>
                     <a:p>
-                      <a:pPr algn="l"/>
+                      <a:pPr algn="l">
+                        <a:buNone/>
+                      </a:pPr>
                       <a:r>
                         <a:rPr sz="1313" b="0">
                           <a:solidFill>
@@ -4068,7 +4157,7 @@
                           <a:ea typeface="Arial"/>
                           <a:cs typeface="Arial"/>
                         </a:rPr>
-                        <a:t>Minuto</a:t>
+                        <a:t>Notas</a:t>
                       </a:r>
                     </a:p>
                   </a:txBody>
@@ -4094,7 +4183,9 @@
                     </a:bodyPr>
                     <a:lstStyle/>
                     <a:p>
-                      <a:pPr algn="l"/>
+                      <a:pPr algn="l">
+                        <a:buNone/>
+                      </a:pPr>
                       <a:r>
                         <a:rPr sz="1313" b="0">
                           <a:solidFill>
@@ -4104,7 +4195,7 @@
                           <a:ea typeface="Arial"/>
                           <a:cs typeface="Arial"/>
                         </a:rPr>
-                        <a:t>2.083</a:t>
+                        <a:t>5</a:t>
                       </a:r>
                     </a:p>
                   </a:txBody>
@@ -4127,7 +4218,9 @@
                     </a:bodyPr>
                     <a:lstStyle/>
                     <a:p>
-                      <a:pPr algn="l"/>
+                      <a:pPr algn="l">
+                        <a:buNone/>
+                      </a:pPr>
                       <a:r>
                         <a:rPr sz="1313" b="0">
                           <a:solidFill>
@@ -4137,7 +4230,7 @@
                           <a:ea typeface="Arial"/>
                           <a:cs typeface="Arial"/>
                         </a:rPr>
-                        <a:t>1.458</a:t>
+                        <a:t>5</a:t>
                       </a:r>
                     </a:p>
                   </a:txBody>
@@ -4160,7 +4253,9 @@
                     </a:bodyPr>
                     <a:lstStyle/>
                     <a:p>
-                      <a:pPr algn="l"/>
+                      <a:pPr algn="l">
+                        <a:buNone/>
+                      </a:pPr>
                       <a:r>
                         <a:rPr sz="1313" b="0">
                           <a:solidFill>
@@ -4170,7 +4265,7 @@
                           <a:ea typeface="Arial"/>
                           <a:cs typeface="Arial"/>
                         </a:rPr>
-                        <a:t>625</a:t>
+                        <a:t>mesmas</a:t>
                       </a:r>
                     </a:p>
                   </a:txBody>
@@ -4195,7 +4290,9 @@
                     </a:bodyPr>
                     <a:lstStyle/>
                     <a:p>
-                      <a:pPr algn="l"/>
+                      <a:pPr algn="l">
+                        <a:buNone/>
+                      </a:pPr>
                       <a:r>
                         <a:rPr sz="1313" b="0">
                           <a:solidFill>
@@ -4205,7 +4302,7 @@
                           <a:ea typeface="Arial"/>
                           <a:cs typeface="Arial"/>
                         </a:rPr>
-                        <a:t>Hora</a:t>
+                        <a:t>Trechos</a:t>
                       </a:r>
                     </a:p>
                   </a:txBody>
@@ -4231,7 +4328,9 @@
                     </a:bodyPr>
                     <a:lstStyle/>
                     <a:p>
-                      <a:pPr algn="l"/>
+                      <a:pPr algn="l">
+                        <a:buNone/>
+                      </a:pPr>
                       <a:r>
                         <a:rPr sz="1313" b="0">
                           <a:solidFill>
@@ -4241,7 +4340,7 @@
                           <a:ea typeface="Arial"/>
                           <a:cs typeface="Arial"/>
                         </a:rPr>
-                        <a:t>125 mil</a:t>
+                        <a:t>originais</a:t>
                       </a:r>
                     </a:p>
                   </a:txBody>
@@ -4264,7 +4363,9 @@
                     </a:bodyPr>
                     <a:lstStyle/>
                     <a:p>
-                      <a:pPr algn="l"/>
+                      <a:pPr algn="l">
+                        <a:buNone/>
+                      </a:pPr>
                       <a:r>
                         <a:rPr sz="1313" b="0">
                           <a:solidFill>
@@ -4274,7 +4375,7 @@
                           <a:ea typeface="Arial"/>
                           <a:cs typeface="Arial"/>
                         </a:rPr>
-                        <a:t>87,5 mil</a:t>
+                        <a:t>idênticos</a:t>
                       </a:r>
                     </a:p>
                   </a:txBody>
@@ -4297,7 +4398,9 @@
                     </a:bodyPr>
                     <a:lstStyle/>
                     <a:p>
-                      <a:pPr algn="l"/>
+                      <a:pPr algn="l">
+                        <a:buNone/>
+                      </a:pPr>
                       <a:r>
                         <a:rPr sz="1313" b="0">
                           <a:solidFill>
@@ -4307,7 +4410,7 @@
                           <a:ea typeface="Arial"/>
                           <a:cs typeface="Arial"/>
                         </a:rPr>
-                        <a:t>37,5 mil</a:t>
+                        <a:t>preservados</a:t>
                       </a:r>
                     </a:p>
                   </a:txBody>
@@ -4332,7 +4435,9 @@
                     </a:bodyPr>
                     <a:lstStyle/>
                     <a:p>
-                      <a:pPr algn="l"/>
+                      <a:pPr algn="l">
+                        <a:buNone/>
+                      </a:pPr>
                       <a:r>
                         <a:rPr sz="1313" b="0">
                           <a:solidFill>
@@ -4342,7 +4447,7 @@
                           <a:ea typeface="Arial"/>
                           <a:cs typeface="Arial"/>
                         </a:rPr>
-                        <a:t>Dia</a:t>
+                        <a:t>Limite</a:t>
                       </a:r>
                     </a:p>
                   </a:txBody>
@@ -4368,7 +4473,9 @@
                     </a:bodyPr>
                     <a:lstStyle/>
                     <a:p>
-                      <a:pPr algn="l"/>
+                      <a:pPr algn="l">
+                        <a:buNone/>
+                      </a:pPr>
                       <a:r>
                         <a:rPr sz="1313" b="0">
                           <a:solidFill>
@@ -4378,7 +4485,7 @@
                           <a:ea typeface="Arial"/>
                           <a:cs typeface="Arial"/>
                         </a:rPr>
-                        <a:t>1 milhão</a:t>
+                        <a:t>5 notas</a:t>
                       </a:r>
                     </a:p>
                   </a:txBody>
@@ -4401,7 +4508,9 @@
                     </a:bodyPr>
                     <a:lstStyle/>
                     <a:p>
-                      <a:pPr algn="l"/>
+                      <a:pPr algn="l">
+                        <a:buNone/>
+                      </a:pPr>
                       <a:r>
                         <a:rPr sz="1313" b="0">
                           <a:solidFill>
@@ -4411,7 +4520,7 @@
                           <a:ea typeface="Arial"/>
                           <a:cs typeface="Arial"/>
                         </a:rPr>
-                        <a:t>700 mil</a:t>
+                        <a:t>5 notas</a:t>
                       </a:r>
                     </a:p>
                   </a:txBody>
@@ -4434,7 +4543,9 @@
                     </a:bodyPr>
                     <a:lstStyle/>
                     <a:p>
-                      <a:pPr algn="l"/>
+                      <a:pPr algn="l">
+                        <a:buNone/>
+                      </a:pPr>
                       <a:r>
                         <a:rPr sz="1313" b="0">
                           <a:solidFill>
@@ -4444,7 +4555,7 @@
                           <a:ea typeface="Arial"/>
                           <a:cs typeface="Arial"/>
                         </a:rPr>
-                        <a:t>300 mil</a:t>
+                        <a:t>igual</a:t>
                       </a:r>
                     </a:p>
                   </a:txBody>
@@ -4469,7 +4580,9 @@
                     </a:bodyPr>
                     <a:lstStyle/>
                     <a:p>
-                      <a:pPr algn="l"/>
+                      <a:pPr algn="l">
+                        <a:buNone/>
+                      </a:pPr>
                       <a:r>
                         <a:rPr sz="1313" b="0">
                           <a:solidFill>
@@ -4479,7 +4592,7 @@
                           <a:ea typeface="Arial"/>
                           <a:cs typeface="Arial"/>
                         </a:rPr>
-                        <a:t>Semana</a:t>
+                        <a:t>Orçamento</a:t>
                       </a:r>
                     </a:p>
                   </a:txBody>
@@ -4505,7 +4618,9 @@
                     </a:bodyPr>
                     <a:lstStyle/>
                     <a:p>
-                      <a:pPr algn="l"/>
+                      <a:pPr algn="l">
+                        <a:buNone/>
+                      </a:pPr>
                       <a:r>
                         <a:rPr sz="1313" b="0">
                           <a:solidFill>
@@ -4515,7 +4630,7 @@
                           <a:ea typeface="Arial"/>
                           <a:cs typeface="Arial"/>
                         </a:rPr>
-                        <a:t>5 milhões</a:t>
+                        <a:t>12.000</a:t>
                       </a:r>
                     </a:p>
                   </a:txBody>
@@ -4538,7 +4653,9 @@
                     </a:bodyPr>
                     <a:lstStyle/>
                     <a:p>
-                      <a:pPr algn="l"/>
+                      <a:pPr algn="l">
+                        <a:buNone/>
+                      </a:pPr>
                       <a:r>
                         <a:rPr sz="1313" b="0">
                           <a:solidFill>
@@ -4548,7 +4665,7 @@
                           <a:ea typeface="Arial"/>
                           <a:cs typeface="Arial"/>
                         </a:rPr>
-                        <a:t>3,5 milhões</a:t>
+                        <a:t>12.000</a:t>
                       </a:r>
                     </a:p>
                   </a:txBody>
@@ -4571,7 +4688,9 @@
                     </a:bodyPr>
                     <a:lstStyle/>
                     <a:p>
-                      <a:pPr algn="l"/>
+                      <a:pPr algn="l">
+                        <a:buNone/>
+                      </a:pPr>
                       <a:r>
                         <a:rPr sz="1313" b="0">
                           <a:solidFill>
@@ -4581,7 +4700,7 @@
                           <a:ea typeface="Arial"/>
                           <a:cs typeface="Arial"/>
                         </a:rPr>
-                        <a:t>1,5 milhão</a:t>
+                        <a:t>igual</a:t>
                       </a:r>
                     </a:p>
                   </a:txBody>
@@ -4606,7 +4725,9 @@
                     </a:bodyPr>
                     <a:lstStyle/>
                     <a:p>
-                      <a:pPr algn="l"/>
+                      <a:pPr algn="l">
+                        <a:buNone/>
+                      </a:pPr>
                       <a:r>
                         <a:rPr sz="1313" b="0">
                           <a:solidFill>
@@ -4616,7 +4737,7 @@
                           <a:ea typeface="Arial"/>
                           <a:cs typeface="Arial"/>
                         </a:rPr>
-                        <a:t>Mês</a:t>
+                        <a:t>Caracteres</a:t>
                       </a:r>
                     </a:p>
                   </a:txBody>
@@ -4642,7 +4763,9 @@
                     </a:bodyPr>
                     <a:lstStyle/>
                     <a:p>
-                      <a:pPr algn="l"/>
+                      <a:pPr algn="l">
+                        <a:buNone/>
+                      </a:pPr>
                       <a:r>
                         <a:rPr sz="1313" b="0">
                           <a:solidFill>
@@ -4652,7 +4775,7 @@
                           <a:ea typeface="Arial"/>
                           <a:cs typeface="Arial"/>
                         </a:rPr>
-                        <a:t>22 milhões</a:t>
+                        <a:t>11.961</a:t>
                       </a:r>
                     </a:p>
                   </a:txBody>
@@ -4675,7 +4798,9 @@
                     </a:bodyPr>
                     <a:lstStyle/>
                     <a:p>
-                      <a:pPr algn="l"/>
+                      <a:pPr algn="l">
+                        <a:buNone/>
+                      </a:pPr>
                       <a:r>
                         <a:rPr sz="1313" b="0">
                           <a:solidFill>
@@ -4685,7 +4810,7 @@
                           <a:ea typeface="Arial"/>
                           <a:cs typeface="Arial"/>
                         </a:rPr>
-                        <a:t>15,4 milhões</a:t>
+                        <a:t>4.677</a:t>
                       </a:r>
                     </a:p>
                   </a:txBody>
@@ -4708,7 +4833,9 @@
                     </a:bodyPr>
                     <a:lstStyle/>
                     <a:p>
-                      <a:pPr algn="l"/>
+                      <a:pPr algn="l">
+                        <a:buNone/>
+                      </a:pPr>
                       <a:r>
                         <a:rPr sz="1313" b="0">
                           <a:solidFill>
@@ -4718,7 +4845,7 @@
                           <a:ea typeface="Arial"/>
                           <a:cs typeface="Arial"/>
                         </a:rPr>
-                        <a:t>6,6 milhões</a:t>
+                        <a:t>−7.284</a:t>
                       </a:r>
                     </a:p>
                   </a:txBody>
@@ -4784,6 +4911,7 @@
           </a:lstStyle>
           <a:p xmlns:a="http://schemas.openxmlformats.org/drawingml/2006/main">
             <a:pPr>
+              <a:buNone/>
               <a:defRPr sz="1650" b="1">
                 <a:solidFill>
                   <a:srgbClr val="F5F6F0"/>
@@ -4802,7 +4930,7 @@
                 <a:ea typeface="Arial"/>
                 <a:cs typeface="Arial"/>
               </a:rPr>
-              <a:t>Exemplos de trabalho delegado</a:t>
+              <a:t>Benchmark público sintético</a:t>
             </a:r>
           </a:p>
         </p:txBody>
@@ -4852,6 +4980,7 @@
           </a:lstStyle>
           <a:p xmlns:a="http://schemas.openxmlformats.org/drawingml/2006/main">
             <a:pPr>
+              <a:buNone/>
               <a:defRPr sz="1425" b="0">
                 <a:solidFill>
                   <a:srgbClr val="70DEC9"/>
@@ -4870,7 +4999,7 @@
                 <a:ea typeface="Arial"/>
                 <a:cs typeface="Arial"/>
               </a:rPr>
-              <a:t>Ollama · resumir um texto local</a:t>
+              <a:t>40 notas · seleção de 5 notas e 20 trechos</a:t>
             </a:r>
           </a:p>
         </p:txBody>
@@ -4920,6 +5049,7 @@
           </a:lstStyle>
           <a:p xmlns:a="http://schemas.openxmlformats.org/drawingml/2006/main">
             <a:pPr>
+              <a:buNone/>
               <a:defRPr sz="1425" b="0">
                 <a:solidFill>
                   <a:srgbClr val="92BFFF"/>
@@ -4938,7 +5068,7 @@
                 <a:ea typeface="Arial"/>
                 <a:cs typeface="Arial"/>
               </a:rPr>
-              <a:t>Copilot · sugerir testes para uma função</a:t>
+              <a:t>11.696 → 5.862 caracteres (−49,9%)</a:t>
             </a:r>
           </a:p>
         </p:txBody>
@@ -4988,6 +5118,7 @@
           </a:lstStyle>
           <a:p xmlns:a="http://schemas.openxmlformats.org/drawingml/2006/main">
             <a:pPr>
+              <a:buNone/>
               <a:defRPr sz="1425" b="0">
                 <a:solidFill>
                   <a:srgbClr val="F5F6F0"/>
@@ -5006,11 +5137,12 @@
                 <a:ea typeface="Arial"/>
                 <a:cs typeface="Arial"/>
               </a:rPr>
-              <a:t>OpenCode/Nemotron · analisar um erro</a:t>
+              <a:t>Reproduza com dados de demonstração:</a:t>
             </a:r>
           </a:p>
           <a:p xmlns:a="http://schemas.openxmlformats.org/drawingml/2006/main">
             <a:pPr>
+              <a:buNone/>
               <a:defRPr sz="1425" b="0">
                 <a:solidFill>
                   <a:srgbClr val="F5F6F0"/>
@@ -5029,7 +5161,7 @@
                 <a:ea typeface="Arial"/>
                 <a:cs typeface="Arial"/>
               </a:rPr>
-              <a:t>com um trecho público</a:t>
+              <a:t>python3 tools/benchmark_busca.py</a:t>
             </a:r>
           </a:p>
         </p:txBody>
@@ -5079,6 +5211,7 @@
           </a:lstStyle>
           <a:p xmlns:a="http://schemas.openxmlformats.org/drawingml/2006/main">
             <a:pPr>
+              <a:buNone/>
               <a:defRPr sz="1313" b="0">
                 <a:solidFill>
                   <a:srgbClr val="AAB8C5"/>
@@ -5097,7 +5230,7 @@
                 <a:ea typeface="Arial"/>
                 <a:cs typeface="Arial"/>
               </a:rPr>
-              <a:t>O principal confere e aplica o resultado.</a:t>
+              <a:t>Cenário distinto da medição local de 60,9%.</a:t>
             </a:r>
           </a:p>
         </p:txBody>
@@ -5147,6 +5280,7 @@
           </a:lstStyle>
           <a:p xmlns:a="http://schemas.openxmlformats.org/drawingml/2006/main">
             <a:pPr>
+              <a:buNone/>
               <a:defRPr sz="1800" b="1">
                 <a:solidFill>
                   <a:srgbClr val="F5F6F0"/>
@@ -5165,7 +5299,7 @@
                 <a:ea typeface="Arial"/>
                 <a:cs typeface="Arial"/>
               </a:rPr>
-              <a:t>Cota preservada pode reduzir o tempo parado</a:t>
+              <a:t>Menos texto repetido para recuperar o mesmo contexto</a:t>
             </a:r>
           </a:p>
         </p:txBody>
@@ -5215,6 +5349,7 @@
           </a:lstStyle>
           <a:p xmlns:a="http://schemas.openxmlformats.org/drawingml/2006/main">
             <a:pPr>
+              <a:buNone/>
               <a:defRPr sz="1388" b="0">
                 <a:solidFill>
                   <a:srgbClr val="92BFFF"/>
@@ -5233,7 +5368,7 @@
                 <a:ea typeface="Arial"/>
                 <a:cs typeface="Arial"/>
               </a:rPr>
-              <a:t>Neste cenário: até 2h/dia, 10h/semana ou 44h/mês de espera evitada, com auxiliares disponíveis.</a:t>
+              <a:t>Medição da busca; tokens totais, latência e produtividade não foram medidos.</a:t>
             </a:r>
           </a:p>
         </p:txBody>
@@ -5283,6 +5418,7 @@
           </a:lstStyle>
           <a:p xmlns:a="http://schemas.openxmlformats.org/drawingml/2006/main">
             <a:pPr>
+              <a:buNone/>
               <a:defRPr sz="1350" b="0">
                 <a:solidFill>
                   <a:srgbClr val="70DEC9"/>
@@ -5301,7 +5437,7 @@
                 <a:ea typeface="Arial"/>
                 <a:cs typeface="Arial"/>
               </a:rPr>
-              <a:t>Equivalência de API: R$ 10,80/dia, R$ 54/semana e R$ 237,60/mês, a R$ 36/milhão hipotéticos.</a:t>
+              <a:t>Mensalidade: R$ 0 de desconto. A redução medida é de caracteres por consulta.</a:t>
             </a:r>
           </a:p>
         </p:txBody>
@@ -5351,6 +5487,7 @@
           </a:lstStyle>
           <a:p xmlns:a="http://schemas.openxmlformats.org/drawingml/2006/main">
             <a:pPr>
+              <a:buNone/>
               <a:defRPr sz="1350" b="0">
                 <a:solidFill>
                   <a:srgbClr val="F5F6F0"/>
@@ -5369,7 +5506,7 @@
                 <a:ea typeface="Arial"/>
                 <a:cs typeface="Arial"/>
               </a:rPr>
-              <a:t>Equivalência na mensalidade: R$ 0 de desconto. Ganho potencial: mais entregas e menos espera.</a:t>
+              <a:t>Consulta local em 16/10/2026 · versão 663803e · notas pessoais não publicadas.</a:t>
             </a:r>
           </a:p>
         </p:txBody>
@@ -5419,6 +5556,7 @@
           </a:lstStyle>
           <a:p xmlns:a="http://schemas.openxmlformats.org/drawingml/2006/main">
             <a:pPr>
+              <a:buNone/>
               <a:defRPr sz="825" b="0">
                 <a:solidFill>
                   <a:srgbClr val="AAB8C5"/>
@@ -5437,7 +5575,7 @@
                 <a:ea typeface="Arial"/>
                 <a:cs typeface="Arial"/>
               </a:rPr>
-              <a:t>Simulação, não medição. 8h/dia, 5 dias/semana, 22 dias/mês e cota antes de 6h. Limites reais variam. Energia e tokens auxiliares fora do cálculo.</a:t>
+              <a:t>Um cenário de consulta, não uma média das IAs. Método e reprodução: docs/BENCHMARK.md.</a:t>
             </a:r>
           </a:p>
         </p:txBody>

</xml_diff>

<commit_message>
chore: update the infographic to the 60.9% measurement and highlight the video
</commit_message>
<xml_diff>
--- a/media/one-pager.pptx
+++ b/media/one-pager.pptx
@@ -2,13 +2,13 @@
 <file path=ppt/presentation.xml><?xml version="1.0" encoding="utf-8"?>
 <p:presentation xmlns:p="http://schemas.openxmlformats.org/presentationml/2006/main">
   <p:sldMasterIdLst>
-    <p:sldMasterId xmlns:r="http://schemas.openxmlformats.org/officeDocument/2006/relationships" id="2147483648" r:id="R7fd23f08cd594c93"/>
+    <p:sldMasterId xmlns:r="http://schemas.openxmlformats.org/officeDocument/2006/relationships" id="2147483648" r:id="Rc7eb4ecff8a7416c"/>
   </p:sldMasterIdLst>
   <p:notesMasterIdLst>
-    <p:notesMasterId xmlns:r="http://schemas.openxmlformats.org/officeDocument/2006/relationships" r:id="Rbc9c9e03c80c4e29"/>
+    <p:notesMasterId xmlns:r="http://schemas.openxmlformats.org/officeDocument/2006/relationships" r:id="R02349d5d80804f78"/>
   </p:notesMasterIdLst>
   <p:sldIdLst>
-    <p:sldId xmlns:r="http://schemas.openxmlformats.org/officeDocument/2006/relationships" id="256" r:id="R841bca4cad034949"/>
+    <p:sldId xmlns:r="http://schemas.openxmlformats.org/officeDocument/2006/relationships" id="256" r:id="R9db6d1d4a2fa4f88"/>
   </p:sldIdLst>
   <p:sldSz cx="12192000" cy="6858000"/>
   <p:notesSz cx="6858000" cy="9144000"/>
@@ -442,7 +442,7 @@
           <a:lstStyle xmlns:a="http://schemas.openxmlformats.org/drawingml/2006/main"/>
           <a:p xmlns:a="http://schemas.openxmlformats.org/drawingml/2006/main">
             <a:r>
-              <a:t>Cenário ilustrativo solicitado pelo usuário; não é benchmark histórico e não representa redução medida.</a:t>
+              <a:t>Medição local em 16/10/2026, versão pública 663803e: comparação da mesma consulta no mesmo estado do cofre com cinco notas e orçamento de 12.000 caracteres. Saída inteira anterior: 11.961 caracteres; nova: 4.677; diferença: 7.284; redução arredondada: 60,9%. Os nomes das cinco notas e os trechos selecionados foram conferidos como idênticos; nomes de omissões e resumos não fazem parte dessa equivalência. Dados privados não acompanham a apresentação. Fonte pública do método e limites: https://github.com/nicholasbirochi/Cerebro/blob/main/docs/BENCHMARK.md.</a:t>
             </a:r>
           </a:p>
           <a:p xmlns:a="http://schemas.openxmlformats.org/drawingml/2006/main">
@@ -452,7 +452,7 @@
           </a:p>
           <a:p xmlns:a="http://schemas.openxmlformats.org/drawingml/2006/main">
             <a:r>
-              <a:t>1.000.000 − 400.000 + 100.000 = 700.000 tokens/dia do principal. 40% da execução é delegada e a preparação/revisão custa 10% do volume original. Economia líquida no principal: 300.000/dia, 1.500.000/semana (5 dias), 6.600.000/mês (22 dias). Entre todas as IAs o cenário pode somar 1.100.000 tokens/dia: a delegação preserva a franquia principal, sem afirmar redução do total global. Tokenizadores e contabilização dos provedores variam.</a:t>
+              <a:t>Cenário sintético distinto, reproduzível pelo script público tools/benchmark_busca.py: 40 notas relevantes, mesmas cinco notas e vinte trechos; 11.696 → 5.862 caracteres, redução de 49,9%. O padrão atual de duas notas retorna 2.495 caracteres neste cenário sintético e não compõe a comparação controlada de cinco notas.</a:t>
             </a:r>
           </a:p>
           <a:p xmlns:a="http://schemas.openxmlformats.org/drawingml/2006/main">
@@ -462,37 +462,7 @@
           </a:p>
           <a:p xmlns:a="http://schemas.openxmlformats.org/drawingml/2006/main">
             <a:r>
-              <a:t>Médias da mesma demanda distribuída em 8h/dia: antes 2.083,33 tokens/min e 125.000/h; depois 1.458,33/min e 87.500/h; diferença 625/min ou 37.500/h. Minutos arredondados apenas na apresentação. Semanas e meses são úteis, não calendário.</a:t>
-            </a:r>
-          </a:p>
-          <a:p xmlns:a="http://schemas.openxmlformats.org/drawingml/2006/main">
-            <a:r>
-              <a:t/>
-            </a:r>
-          </a:p>
-          <a:p xmlns:a="http://schemas.openxmlformats.org/drawingml/2006/main">
-            <a:r>
-              <a:t>R$36/milhão é premissa hipotética de processamento de API, mantida para comparar este exemplo; não afirma preço atual de um modelo, câmbio atual nem cobrança observada. Antes R$36/dia, agora R$25,20/dia, diferença R$10,80/dia, R$54/semana e R$237,60/mês. O usuário informou mensalidade igual: economia financeira na assinatura é R$0. Os R$237,60 são duzentos e trinta e sete reais e sessenta centavos de processamento equivalente de API, não desconto nem despesa observada. Com mais entregas pela mesma mensalidade, o custo médio por entrega pode cair. Exemplo meramente aritmético: mensalidade M / 10 entregas versus M / 14 entregas, redução de28,6% por entrega. Não há medição do número de entregas ou da espera real. O cenário assume acesso auxiliar incluído ou local, com margem disponível e sem cobrança avulsa; energia e tokens dos auxiliares não foram precificados.</a:t>
-            </a:r>
-          </a:p>
-          <a:p xmlns:a="http://schemas.openxmlformats.org/drawingml/2006/main">
-            <a:r>
-              <a:t/>
-            </a:r>
-          </a:p>
-          <a:p xmlns:a="http://schemas.openxmlformats.org/drawingml/2006/main">
-            <a:r>
-              <a:t>Ociosidade: se um orçamento modelado em tokens antes sustentava 6h da demanda de uma jornada de 8h, a demanda principal 30% menor sustentaria 6/0,7=8,57h. Nessas condições a espera poderia cair de2h/dia para0h/dia, liberando até10h/semana ou44h/mês. Esta é uma hipótese de continuidade, não medição de latência, bloqueios ou qualidade. Limites reais não são necessariamente cotas fixas de tokens.</a:t>
-            </a:r>
-          </a:p>
-          <a:p xmlns:a="http://schemas.openxmlformats.org/drawingml/2006/main">
-            <a:r>
-              <a:t/>
-            </a:r>
-          </a:p>
-          <a:p xmlns:a="http://schemas.openxmlformats.org/drawingml/2006/main">
-            <a:r>
-              <a:t>Exemplos representam capacidades textuais sob demanda: Ollama resume texto local; Copilot sugere testes a partir de função fornecida; OpenCode/Nemotron analisa trecho público de erro. Principal escolhe contexto permitido, passa a delegação pelo roteador, revisa e aplica. Copilot, Ollama e OpenCode/Nemotron são destinos na mesma camada, com elegibilidade distinta por tarefa, cota e recursos. Integração de Copilot no helper aplicada e validada em14/10/2026; detalhes da implantação devem ser relatados separadamente, sem tratar esta simulação como prova de economia.</a:t>
+              <a:t>Não foram medidos tokens de entrada, saída, raciocínio, cache, consumo global de IAs, latência, produtividade ou desconto financeiro. A mensalidade permanece a mesma: R$0 de desconto. A imagem anterior apresentava uma simulação de 30% menos tokens no principal, com projeções hipotéticas de tempo e equivalência de API; foi substituída por resultados de saída da busca, sem converter caracteres em tokens ou dinheiro. O vídeo ilustrativo da arquitetura permanece inalterado.</a:t>
             </a:r>
           </a:p>
         </p:txBody>
@@ -590,6 +560,7 @@
                 <a:spcPts val="0"/>
               </a:spcAft>
               <a:buNone/>
+              <a:defRPr/>
             </a:lvl1pPr>
             <a:lvl2pPr marL="0" indent="0">
               <a:lnSpc>
@@ -602,6 +573,7 @@
                 <a:spcPts val="0"/>
               </a:spcAft>
               <a:buNone/>
+              <a:defRPr/>
             </a:lvl2pPr>
             <a:lvl3pPr marL="0" indent="0">
               <a:lnSpc>
@@ -614,6 +586,7 @@
                 <a:spcPts val="0"/>
               </a:spcAft>
               <a:buNone/>
+              <a:defRPr/>
             </a:lvl3pPr>
             <a:lvl4pPr marL="0" indent="0">
               <a:lnSpc>
@@ -626,6 +599,7 @@
                 <a:spcPts val="0"/>
               </a:spcAft>
               <a:buNone/>
+              <a:defRPr/>
             </a:lvl4pPr>
             <a:lvl5pPr marL="0" indent="0">
               <a:lnSpc>
@@ -638,6 +612,7 @@
                 <a:spcPts val="0"/>
               </a:spcAft>
               <a:buNone/>
+              <a:defRPr/>
             </a:lvl5pPr>
             <a:lvl6pPr marL="0" indent="0">
               <a:lnSpc>
@@ -650,6 +625,7 @@
                 <a:spcPts val="0"/>
               </a:spcAft>
               <a:buNone/>
+              <a:defRPr/>
             </a:lvl6pPr>
             <a:lvl7pPr marL="0" indent="0">
               <a:lnSpc>
@@ -662,6 +638,7 @@
                 <a:spcPts val="0"/>
               </a:spcAft>
               <a:buNone/>
+              <a:defRPr/>
             </a:lvl7pPr>
             <a:lvl8pPr marL="0" indent="0">
               <a:lnSpc>
@@ -674,6 +651,7 @@
                 <a:spcPts val="0"/>
               </a:spcAft>
               <a:buNone/>
+              <a:defRPr/>
             </a:lvl8pPr>
             <a:lvl9pPr marL="0" indent="0">
               <a:lnSpc>
@@ -686,6 +664,7 @@
                 <a:spcPts val="0"/>
               </a:spcAft>
               <a:buNone/>
+              <a:defRPr/>
             </a:lvl9pPr>
           </a:lstStyle>
           <a:p xmlns:a="http://schemas.openxmlformats.org/drawingml/2006/main"/>
@@ -747,6 +726,7 @@
                 <a:spcPts val="0"/>
               </a:spcAft>
               <a:buNone/>
+              <a:defRPr/>
             </a:lvl1pPr>
             <a:lvl2pPr marL="0" indent="0">
               <a:lnSpc>
@@ -759,6 +739,7 @@
                 <a:spcPts val="0"/>
               </a:spcAft>
               <a:buNone/>
+              <a:defRPr/>
             </a:lvl2pPr>
             <a:lvl3pPr marL="0" indent="0">
               <a:lnSpc>
@@ -771,6 +752,7 @@
                 <a:spcPts val="0"/>
               </a:spcAft>
               <a:buNone/>
+              <a:defRPr/>
             </a:lvl3pPr>
             <a:lvl4pPr marL="0" indent="0">
               <a:lnSpc>
@@ -783,6 +765,7 @@
                 <a:spcPts val="0"/>
               </a:spcAft>
               <a:buNone/>
+              <a:defRPr/>
             </a:lvl4pPr>
             <a:lvl5pPr marL="0" indent="0">
               <a:lnSpc>
@@ -795,6 +778,7 @@
                 <a:spcPts val="0"/>
               </a:spcAft>
               <a:buNone/>
+              <a:defRPr/>
             </a:lvl5pPr>
             <a:lvl6pPr marL="0" indent="0">
               <a:lnSpc>
@@ -807,6 +791,7 @@
                 <a:spcPts val="0"/>
               </a:spcAft>
               <a:buNone/>
+              <a:defRPr/>
             </a:lvl6pPr>
             <a:lvl7pPr marL="0" indent="0">
               <a:lnSpc>
@@ -819,6 +804,7 @@
                 <a:spcPts val="0"/>
               </a:spcAft>
               <a:buNone/>
+              <a:defRPr/>
             </a:lvl7pPr>
             <a:lvl8pPr marL="0" indent="0">
               <a:lnSpc>
@@ -831,6 +817,7 @@
                 <a:spcPts val="0"/>
               </a:spcAft>
               <a:buNone/>
+              <a:defRPr/>
             </a:lvl8pPr>
             <a:lvl9pPr marL="0" indent="0">
               <a:lnSpc>
@@ -843,6 +830,7 @@
                 <a:spcPts val="0"/>
               </a:spcAft>
               <a:buNone/>
+              <a:defRPr/>
             </a:lvl9pPr>
           </a:lstStyle>
           <a:p xmlns:a="http://schemas.openxmlformats.org/drawingml/2006/main"/>
@@ -921,6 +909,7 @@
                 <a:spcPts val="0"/>
               </a:spcAft>
               <a:buNone/>
+              <a:defRPr/>
             </a:lvl1pPr>
             <a:lvl2pPr marL="0" indent="0">
               <a:lnSpc>
@@ -933,6 +922,7 @@
                 <a:spcPts val="0"/>
               </a:spcAft>
               <a:buNone/>
+              <a:defRPr/>
             </a:lvl2pPr>
             <a:lvl3pPr marL="0" indent="0">
               <a:lnSpc>
@@ -945,6 +935,7 @@
                 <a:spcPts val="0"/>
               </a:spcAft>
               <a:buNone/>
+              <a:defRPr/>
             </a:lvl3pPr>
             <a:lvl4pPr marL="0" indent="0">
               <a:lnSpc>
@@ -957,6 +948,7 @@
                 <a:spcPts val="0"/>
               </a:spcAft>
               <a:buNone/>
+              <a:defRPr/>
             </a:lvl4pPr>
             <a:lvl5pPr marL="0" indent="0">
               <a:lnSpc>
@@ -969,6 +961,7 @@
                 <a:spcPts val="0"/>
               </a:spcAft>
               <a:buNone/>
+              <a:defRPr/>
             </a:lvl5pPr>
             <a:lvl6pPr marL="0" indent="0">
               <a:lnSpc>
@@ -981,6 +974,7 @@
                 <a:spcPts val="0"/>
               </a:spcAft>
               <a:buNone/>
+              <a:defRPr/>
             </a:lvl6pPr>
             <a:lvl7pPr marL="0" indent="0">
               <a:lnSpc>
@@ -993,6 +987,7 @@
                 <a:spcPts val="0"/>
               </a:spcAft>
               <a:buNone/>
+              <a:defRPr/>
             </a:lvl7pPr>
             <a:lvl8pPr marL="0" indent="0">
               <a:lnSpc>
@@ -1005,6 +1000,7 @@
                 <a:spcPts val="0"/>
               </a:spcAft>
               <a:buNone/>
+              <a:defRPr/>
             </a:lvl8pPr>
             <a:lvl9pPr marL="0" indent="0">
               <a:lnSpc>
@@ -1017,6 +1013,7 @@
                 <a:spcPts val="0"/>
               </a:spcAft>
               <a:buNone/>
+              <a:defRPr/>
             </a:lvl9pPr>
           </a:lstStyle>
           <a:p xmlns:a="http://schemas.openxmlformats.org/drawingml/2006/main"/>
@@ -1095,6 +1092,7 @@
                 <a:spcPts val="0"/>
               </a:spcAft>
               <a:buNone/>
+              <a:defRPr/>
             </a:lvl1pPr>
             <a:lvl2pPr marL="0" indent="0">
               <a:lnSpc>
@@ -1107,6 +1105,7 @@
                 <a:spcPts val="0"/>
               </a:spcAft>
               <a:buNone/>
+              <a:defRPr/>
             </a:lvl2pPr>
             <a:lvl3pPr marL="0" indent="0">
               <a:lnSpc>
@@ -1119,6 +1118,7 @@
                 <a:spcPts val="0"/>
               </a:spcAft>
               <a:buNone/>
+              <a:defRPr/>
             </a:lvl3pPr>
             <a:lvl4pPr marL="0" indent="0">
               <a:lnSpc>
@@ -1131,6 +1131,7 @@
                 <a:spcPts val="0"/>
               </a:spcAft>
               <a:buNone/>
+              <a:defRPr/>
             </a:lvl4pPr>
             <a:lvl5pPr marL="0" indent="0">
               <a:lnSpc>
@@ -1143,6 +1144,7 @@
                 <a:spcPts val="0"/>
               </a:spcAft>
               <a:buNone/>
+              <a:defRPr/>
             </a:lvl5pPr>
             <a:lvl6pPr marL="0" indent="0">
               <a:lnSpc>
@@ -1155,6 +1157,7 @@
                 <a:spcPts val="0"/>
               </a:spcAft>
               <a:buNone/>
+              <a:defRPr/>
             </a:lvl6pPr>
             <a:lvl7pPr marL="0" indent="0">
               <a:lnSpc>
@@ -1167,6 +1170,7 @@
                 <a:spcPts val="0"/>
               </a:spcAft>
               <a:buNone/>
+              <a:defRPr/>
             </a:lvl7pPr>
             <a:lvl8pPr marL="0" indent="0">
               <a:lnSpc>
@@ -1179,6 +1183,7 @@
                 <a:spcPts val="0"/>
               </a:spcAft>
               <a:buNone/>
+              <a:defRPr/>
             </a:lvl8pPr>
             <a:lvl9pPr marL="0" indent="0">
               <a:lnSpc>
@@ -1191,6 +1196,7 @@
                 <a:spcPts val="0"/>
               </a:spcAft>
               <a:buNone/>
+              <a:defRPr/>
             </a:lvl9pPr>
           </a:lstStyle>
           <a:p xmlns:a="http://schemas.openxmlformats.org/drawingml/2006/main"/>
@@ -1252,6 +1258,7 @@
                 <a:spcPts val="1200"/>
               </a:spcAft>
               <a:buChar char="•"/>
+              <a:defRPr/>
             </a:lvl1pPr>
             <a:lvl2pPr marL="533400" indent="-228600">
               <a:lnSpc>
@@ -1264,6 +1271,7 @@
                 <a:spcPts val="1200"/>
               </a:spcAft>
               <a:buChar char="•"/>
+              <a:defRPr/>
             </a:lvl2pPr>
             <a:lvl3pPr marL="838200" indent="-228600">
               <a:lnSpc>
@@ -1276,6 +1284,7 @@
                 <a:spcPts val="1200"/>
               </a:spcAft>
               <a:buChar char="•"/>
+              <a:defRPr/>
             </a:lvl3pPr>
             <a:lvl4pPr marL="1143000" indent="-228600">
               <a:lnSpc>
@@ -1288,6 +1297,7 @@
                 <a:spcPts val="1200"/>
               </a:spcAft>
               <a:buChar char="•"/>
+              <a:defRPr/>
             </a:lvl4pPr>
             <a:lvl5pPr marL="1447800" indent="-228600">
               <a:lnSpc>
@@ -1300,6 +1310,7 @@
                 <a:spcPts val="1200"/>
               </a:spcAft>
               <a:buChar char="•"/>
+              <a:defRPr/>
             </a:lvl5pPr>
             <a:lvl6pPr marL="1752600" indent="-228600">
               <a:lnSpc>
@@ -1312,6 +1323,7 @@
                 <a:spcPts val="1200"/>
               </a:spcAft>
               <a:buChar char="•"/>
+              <a:defRPr/>
             </a:lvl6pPr>
             <a:lvl7pPr marL="2057400" indent="-228600">
               <a:lnSpc>
@@ -1324,6 +1336,7 @@
                 <a:spcPts val="1200"/>
               </a:spcAft>
               <a:buChar char="•"/>
+              <a:defRPr/>
             </a:lvl7pPr>
             <a:lvl8pPr marL="2362200" indent="-228600">
               <a:lnSpc>
@@ -1336,6 +1349,7 @@
                 <a:spcPts val="1200"/>
               </a:spcAft>
               <a:buChar char="•"/>
+              <a:defRPr/>
             </a:lvl8pPr>
             <a:lvl9pPr marL="2667000" indent="-228600">
               <a:lnSpc>
@@ -1348,6 +1362,7 @@
                 <a:spcPts val="1200"/>
               </a:spcAft>
               <a:buChar char="•"/>
+              <a:defRPr/>
             </a:lvl9pPr>
           </a:lstStyle>
           <a:p xmlns:a="http://schemas.openxmlformats.org/drawingml/2006/main"/>
@@ -1426,6 +1441,7 @@
                 <a:spcPts val="0"/>
               </a:spcAft>
               <a:buNone/>
+              <a:defRPr/>
             </a:lvl1pPr>
             <a:lvl2pPr marL="0" indent="0">
               <a:lnSpc>
@@ -1438,6 +1454,7 @@
                 <a:spcPts val="0"/>
               </a:spcAft>
               <a:buNone/>
+              <a:defRPr/>
             </a:lvl2pPr>
             <a:lvl3pPr marL="0" indent="0">
               <a:lnSpc>
@@ -1450,6 +1467,7 @@
                 <a:spcPts val="0"/>
               </a:spcAft>
               <a:buNone/>
+              <a:defRPr/>
             </a:lvl3pPr>
             <a:lvl4pPr marL="0" indent="0">
               <a:lnSpc>
@@ -1462,6 +1480,7 @@
                 <a:spcPts val="0"/>
               </a:spcAft>
               <a:buNone/>
+              <a:defRPr/>
             </a:lvl4pPr>
             <a:lvl5pPr marL="0" indent="0">
               <a:lnSpc>
@@ -1474,6 +1493,7 @@
                 <a:spcPts val="0"/>
               </a:spcAft>
               <a:buNone/>
+              <a:defRPr/>
             </a:lvl5pPr>
             <a:lvl6pPr marL="0" indent="0">
               <a:lnSpc>
@@ -1486,6 +1506,7 @@
                 <a:spcPts val="0"/>
               </a:spcAft>
               <a:buNone/>
+              <a:defRPr/>
             </a:lvl6pPr>
             <a:lvl7pPr marL="0" indent="0">
               <a:lnSpc>
@@ -1498,6 +1519,7 @@
                 <a:spcPts val="0"/>
               </a:spcAft>
               <a:buNone/>
+              <a:defRPr/>
             </a:lvl7pPr>
             <a:lvl8pPr marL="0" indent="0">
               <a:lnSpc>
@@ -1510,6 +1532,7 @@
                 <a:spcPts val="0"/>
               </a:spcAft>
               <a:buNone/>
+              <a:defRPr/>
             </a:lvl8pPr>
             <a:lvl9pPr marL="0" indent="0">
               <a:lnSpc>
@@ -1522,6 +1545,7 @@
                 <a:spcPts val="0"/>
               </a:spcAft>
               <a:buNone/>
+              <a:defRPr/>
             </a:lvl9pPr>
           </a:lstStyle>
           <a:p xmlns:a="http://schemas.openxmlformats.org/drawingml/2006/main"/>
@@ -1583,6 +1607,7 @@
                 <a:spcPts val="1200"/>
               </a:spcAft>
               <a:buChar char="•"/>
+              <a:defRPr/>
             </a:lvl1pPr>
             <a:lvl2pPr marL="533400" indent="-228600">
               <a:lnSpc>
@@ -1595,6 +1620,7 @@
                 <a:spcPts val="1200"/>
               </a:spcAft>
               <a:buChar char="•"/>
+              <a:defRPr/>
             </a:lvl2pPr>
             <a:lvl3pPr marL="838200" indent="-228600">
               <a:lnSpc>
@@ -1607,6 +1633,7 @@
                 <a:spcPts val="1200"/>
               </a:spcAft>
               <a:buChar char="•"/>
+              <a:defRPr/>
             </a:lvl3pPr>
             <a:lvl4pPr marL="1143000" indent="-228600">
               <a:lnSpc>
@@ -1619,6 +1646,7 @@
                 <a:spcPts val="1200"/>
               </a:spcAft>
               <a:buChar char="•"/>
+              <a:defRPr/>
             </a:lvl4pPr>
             <a:lvl5pPr marL="1447800" indent="-228600">
               <a:lnSpc>
@@ -1631,6 +1659,7 @@
                 <a:spcPts val="1200"/>
               </a:spcAft>
               <a:buChar char="•"/>
+              <a:defRPr/>
             </a:lvl5pPr>
             <a:lvl6pPr marL="1752600" indent="-228600">
               <a:lnSpc>
@@ -1643,6 +1672,7 @@
                 <a:spcPts val="1200"/>
               </a:spcAft>
               <a:buChar char="•"/>
+              <a:defRPr/>
             </a:lvl6pPr>
             <a:lvl7pPr marL="2057400" indent="-228600">
               <a:lnSpc>
@@ -1655,6 +1685,7 @@
                 <a:spcPts val="1200"/>
               </a:spcAft>
               <a:buChar char="•"/>
+              <a:defRPr/>
             </a:lvl7pPr>
             <a:lvl8pPr marL="2362200" indent="-228600">
               <a:lnSpc>
@@ -1667,6 +1698,7 @@
                 <a:spcPts val="1200"/>
               </a:spcAft>
               <a:buChar char="•"/>
+              <a:defRPr/>
             </a:lvl8pPr>
             <a:lvl9pPr marL="2667000" indent="-228600">
               <a:lnSpc>
@@ -1679,6 +1711,7 @@
                 <a:spcPts val="1200"/>
               </a:spcAft>
               <a:buChar char="•"/>
+              <a:defRPr/>
             </a:lvl9pPr>
           </a:lstStyle>
           <a:p xmlns:a="http://schemas.openxmlformats.org/drawingml/2006/main"/>
@@ -1740,6 +1773,7 @@
                 <a:spcPts val="1200"/>
               </a:spcAft>
               <a:buChar char="•"/>
+              <a:defRPr/>
             </a:lvl1pPr>
             <a:lvl2pPr marL="533400" indent="-228600">
               <a:lnSpc>
@@ -1752,6 +1786,7 @@
                 <a:spcPts val="1200"/>
               </a:spcAft>
               <a:buChar char="•"/>
+              <a:defRPr/>
             </a:lvl2pPr>
             <a:lvl3pPr marL="838200" indent="-228600">
               <a:lnSpc>
@@ -1764,6 +1799,7 @@
                 <a:spcPts val="1200"/>
               </a:spcAft>
               <a:buChar char="•"/>
+              <a:defRPr/>
             </a:lvl3pPr>
             <a:lvl4pPr marL="1143000" indent="-228600">
               <a:lnSpc>
@@ -1776,6 +1812,7 @@
                 <a:spcPts val="1200"/>
               </a:spcAft>
               <a:buChar char="•"/>
+              <a:defRPr/>
             </a:lvl4pPr>
             <a:lvl5pPr marL="1447800" indent="-228600">
               <a:lnSpc>
@@ -1788,6 +1825,7 @@
                 <a:spcPts val="1200"/>
               </a:spcAft>
               <a:buChar char="•"/>
+              <a:defRPr/>
             </a:lvl5pPr>
             <a:lvl6pPr marL="1752600" indent="-228600">
               <a:lnSpc>
@@ -1800,6 +1838,7 @@
                 <a:spcPts val="1200"/>
               </a:spcAft>
               <a:buChar char="•"/>
+              <a:defRPr/>
             </a:lvl6pPr>
             <a:lvl7pPr marL="2057400" indent="-228600">
               <a:lnSpc>
@@ -1812,6 +1851,7 @@
                 <a:spcPts val="1200"/>
               </a:spcAft>
               <a:buChar char="•"/>
+              <a:defRPr/>
             </a:lvl7pPr>
             <a:lvl8pPr marL="2362200" indent="-228600">
               <a:lnSpc>
@@ -1824,6 +1864,7 @@
                 <a:spcPts val="1200"/>
               </a:spcAft>
               <a:buChar char="•"/>
+              <a:defRPr/>
             </a:lvl8pPr>
             <a:lvl9pPr marL="2667000" indent="-228600">
               <a:lnSpc>
@@ -1836,6 +1877,7 @@
                 <a:spcPts val="1200"/>
               </a:spcAft>
               <a:buChar char="•"/>
+              <a:defRPr/>
             </a:lvl9pPr>
           </a:lstStyle>
           <a:p xmlns:a="http://schemas.openxmlformats.org/drawingml/2006/main"/>
@@ -1914,6 +1956,7 @@
                 <a:spcPts val="0"/>
               </a:spcAft>
               <a:buNone/>
+              <a:defRPr/>
             </a:lvl1pPr>
             <a:lvl2pPr marL="0" indent="0">
               <a:lnSpc>
@@ -1926,6 +1969,7 @@
                 <a:spcPts val="0"/>
               </a:spcAft>
               <a:buNone/>
+              <a:defRPr/>
             </a:lvl2pPr>
             <a:lvl3pPr marL="0" indent="0">
               <a:lnSpc>
@@ -1938,6 +1982,7 @@
                 <a:spcPts val="0"/>
               </a:spcAft>
               <a:buNone/>
+              <a:defRPr/>
             </a:lvl3pPr>
             <a:lvl4pPr marL="0" indent="0">
               <a:lnSpc>
@@ -1950,6 +1995,7 @@
                 <a:spcPts val="0"/>
               </a:spcAft>
               <a:buNone/>
+              <a:defRPr/>
             </a:lvl4pPr>
             <a:lvl5pPr marL="0" indent="0">
               <a:lnSpc>
@@ -1962,6 +2008,7 @@
                 <a:spcPts val="0"/>
               </a:spcAft>
               <a:buNone/>
+              <a:defRPr/>
             </a:lvl5pPr>
             <a:lvl6pPr marL="0" indent="0">
               <a:lnSpc>
@@ -1974,6 +2021,7 @@
                 <a:spcPts val="0"/>
               </a:spcAft>
               <a:buNone/>
+              <a:defRPr/>
             </a:lvl6pPr>
             <a:lvl7pPr marL="0" indent="0">
               <a:lnSpc>
@@ -1986,6 +2034,7 @@
                 <a:spcPts val="0"/>
               </a:spcAft>
               <a:buNone/>
+              <a:defRPr/>
             </a:lvl7pPr>
             <a:lvl8pPr marL="0" indent="0">
               <a:lnSpc>
@@ -1998,6 +2047,7 @@
                 <a:spcPts val="0"/>
               </a:spcAft>
               <a:buNone/>
+              <a:defRPr/>
             </a:lvl8pPr>
             <a:lvl9pPr marL="0" indent="0">
               <a:lnSpc>
@@ -2010,6 +2060,7 @@
                 <a:spcPts val="0"/>
               </a:spcAft>
               <a:buNone/>
+              <a:defRPr/>
             </a:lvl9pPr>
           </a:lstStyle>
           <a:p xmlns:a="http://schemas.openxmlformats.org/drawingml/2006/main"/>
@@ -2071,6 +2122,7 @@
                 <a:spcPts val="1200"/>
               </a:spcAft>
               <a:buChar char="•"/>
+              <a:defRPr/>
             </a:lvl1pPr>
             <a:lvl2pPr marL="533400" indent="-228600">
               <a:lnSpc>
@@ -2083,6 +2135,7 @@
                 <a:spcPts val="1200"/>
               </a:spcAft>
               <a:buChar char="•"/>
+              <a:defRPr/>
             </a:lvl2pPr>
             <a:lvl3pPr marL="838200" indent="-228600">
               <a:lnSpc>
@@ -2095,6 +2148,7 @@
                 <a:spcPts val="1200"/>
               </a:spcAft>
               <a:buChar char="•"/>
+              <a:defRPr/>
             </a:lvl3pPr>
             <a:lvl4pPr marL="1143000" indent="-228600">
               <a:lnSpc>
@@ -2107,6 +2161,7 @@
                 <a:spcPts val="1200"/>
               </a:spcAft>
               <a:buChar char="•"/>
+              <a:defRPr/>
             </a:lvl4pPr>
             <a:lvl5pPr marL="1447800" indent="-228600">
               <a:lnSpc>
@@ -2119,6 +2174,7 @@
                 <a:spcPts val="1200"/>
               </a:spcAft>
               <a:buChar char="•"/>
+              <a:defRPr/>
             </a:lvl5pPr>
             <a:lvl6pPr marL="1752600" indent="-228600">
               <a:lnSpc>
@@ -2131,6 +2187,7 @@
                 <a:spcPts val="1200"/>
               </a:spcAft>
               <a:buChar char="•"/>
+              <a:defRPr/>
             </a:lvl6pPr>
             <a:lvl7pPr marL="2057400" indent="-228600">
               <a:lnSpc>
@@ -2143,6 +2200,7 @@
                 <a:spcPts val="1200"/>
               </a:spcAft>
               <a:buChar char="•"/>
+              <a:defRPr/>
             </a:lvl7pPr>
             <a:lvl8pPr marL="2362200" indent="-228600">
               <a:lnSpc>
@@ -2155,6 +2213,7 @@
                 <a:spcPts val="1200"/>
               </a:spcAft>
               <a:buChar char="•"/>
+              <a:defRPr/>
             </a:lvl8pPr>
             <a:lvl9pPr marL="2667000" indent="-228600">
               <a:lnSpc>
@@ -2167,6 +2226,7 @@
                 <a:spcPts val="1200"/>
               </a:spcAft>
               <a:buChar char="•"/>
+              <a:defRPr/>
             </a:lvl9pPr>
           </a:lstStyle>
           <a:p xmlns:a="http://schemas.openxmlformats.org/drawingml/2006/main"/>
@@ -2215,12 +2275,12 @@
   </p:cSld>
   <p:clrMap bg1="lt1" tx1="dk1" bg2="lt2" tx2="dk2" accent1="accent1" accent2="accent2" accent3="accent3" accent4="accent4" accent5="accent5" accent6="accent6" hlink="hlink" folHlink="folHlink"/>
   <p:sldLayoutIdLst>
-    <p:sldLayoutId xmlns:r="http://schemas.openxmlformats.org/officeDocument/2006/relationships" id="2147483649" r:id="Rc1801f6a62b744cc"/>
-    <p:sldLayoutId xmlns:r="http://schemas.openxmlformats.org/officeDocument/2006/relationships" id="2147483650" r:id="R5a9e5649e86548af"/>
-    <p:sldLayoutId xmlns:r="http://schemas.openxmlformats.org/officeDocument/2006/relationships" id="2147483651" r:id="R7e8f3d7c888e4e9b"/>
-    <p:sldLayoutId xmlns:r="http://schemas.openxmlformats.org/officeDocument/2006/relationships" id="2147483652" r:id="Rc8df512d408c48c8"/>
-    <p:sldLayoutId xmlns:r="http://schemas.openxmlformats.org/officeDocument/2006/relationships" id="2147483653" r:id="R6687e298e21d47c1"/>
-    <p:sldLayoutId xmlns:r="http://schemas.openxmlformats.org/officeDocument/2006/relationships" id="2147483654" r:id="Ra42f588b204d4feb"/>
+    <p:sldLayoutId xmlns:r="http://schemas.openxmlformats.org/officeDocument/2006/relationships" id="2147483649" r:id="Rda0e6a14c069476a"/>
+    <p:sldLayoutId xmlns:r="http://schemas.openxmlformats.org/officeDocument/2006/relationships" id="2147483650" r:id="Rc62d934f8afd4486"/>
+    <p:sldLayoutId xmlns:r="http://schemas.openxmlformats.org/officeDocument/2006/relationships" id="2147483651" r:id="R9e3063e969d94e3a"/>
+    <p:sldLayoutId xmlns:r="http://schemas.openxmlformats.org/officeDocument/2006/relationships" id="2147483652" r:id="Ra749fceaebd34d42"/>
+    <p:sldLayoutId xmlns:r="http://schemas.openxmlformats.org/officeDocument/2006/relationships" id="2147483653" r:id="Rddd0c500499f42e8"/>
+    <p:sldLayoutId xmlns:r="http://schemas.openxmlformats.org/officeDocument/2006/relationships" id="2147483654" r:id="R6c437044ab764494"/>
   </p:sldLayoutIdLst>
   <p:txStyles>
     <p:titleStyle>
@@ -2748,274 +2808,281 @@
 </file>
 
 <file path=ppt/slides/charts/chart1.xml><?xml version="1.0" encoding="utf-8"?>
-<c:chartSpace xmlns:c="http://schemas.openxmlformats.org/drawingml/2006/chart" xmlns:r="http://schemas.openxmlformats.org/officeDocument/2006/relationships">
-  <c:lang val="en-US"/>
-  <c:chart>
-    <c:plotArea>
-      <c:barChart>
-        <c:barDir val="bar"/>
-        <c:grouping val="clustered"/>
-        <c:varyColors val="1"/>
-        <c:ser>
-          <c:idx val="0"/>
-          <c:order val="0"/>
-          <c:tx>
-            <c:v>Tokens do principal por dia</c:v>
-          </c:tx>
-          <c:invertIfNegative val="0"/>
-          <c:dPt>
-            <c:idx val="0"/>
-            <c:invertIfNegative val="0"/>
-            <c:spPr>
-              <a:solidFill xmlns:a="http://schemas.openxmlformats.org/drawingml/2006/main">
-                <a:srgbClr val="70DEC9"/>
-              </a:solidFill>
-            </c:spPr>
-          </c:dPt>
-          <c:dPt>
-            <c:idx val="1"/>
-            <c:invertIfNegative val="0"/>
-            <c:spPr>
-              <a:solidFill xmlns:a="http://schemas.openxmlformats.org/drawingml/2006/main">
-                <a:srgbClr val="607487"/>
-              </a:solidFill>
-            </c:spPr>
-          </c:dPt>
-          <c:dLbls>
-            <c:dLbl>
-              <c:idx val="0"/>
-              <c:tx>
-                <c:rich>
-                  <a:bodyPr xmlns:a="http://schemas.openxmlformats.org/drawingml/2006/main"/>
-                  <a:lstStyle xmlns:a="http://schemas.openxmlformats.org/drawingml/2006/main"/>
-                  <a:p xmlns:a="http://schemas.openxmlformats.org/drawingml/2006/main">
-                    <a:r>
-                      <a:rPr sz="1800" b="1">
-                        <a:solidFill>
-                          <a:srgbClr val="101923"/>
-                        </a:solidFill>
-                        <a:latin typeface="Arial"/>
-                        <a:ea typeface="Arial"/>
-                        <a:cs typeface="Arial"/>
-                      </a:rPr>
-                      <a:t>700 mil</a:t>
-                    </a:r>
-                  </a:p>
-                </c:rich>
-              </c:tx>
-              <c:txPr>
-                <a:bodyPr xmlns:a="http://schemas.openxmlformats.org/drawingml/2006/main" anchorCtr="1"/>
-                <a:lstStyle xmlns:a="http://schemas.openxmlformats.org/drawingml/2006/main"/>
-                <a:p xmlns:a="http://schemas.openxmlformats.org/drawingml/2006/main">
-                  <a:pPr>
-                    <a:defRPr sz="1800" b="1">
-                      <a:solidFill>
-                        <a:srgbClr val="101923"/>
-                      </a:solidFill>
-                      <a:latin typeface="Arial"/>
-                      <a:ea typeface="Arial"/>
-                      <a:cs typeface="Arial"/>
-                    </a:defRPr>
-                  </a:pPr>
-                </a:p>
-              </c:txPr>
-              <c:dLblPos val="inEnd"/>
-              <c:showVal val="0"/>
-            </c:dLbl>
-            <c:dLbl>
-              <c:idx val="1"/>
-              <c:tx>
-                <c:rich>
-                  <a:bodyPr xmlns:a="http://schemas.openxmlformats.org/drawingml/2006/main"/>
-                  <a:lstStyle xmlns:a="http://schemas.openxmlformats.org/drawingml/2006/main"/>
-                  <a:p xmlns:a="http://schemas.openxmlformats.org/drawingml/2006/main">
-                    <a:r>
-                      <a:rPr sz="1800" b="1">
-                        <a:solidFill>
-                          <a:srgbClr val="F5F6F0"/>
-                        </a:solidFill>
-                        <a:latin typeface="Arial"/>
-                        <a:ea typeface="Arial"/>
-                        <a:cs typeface="Arial"/>
-                      </a:rPr>
-                      <a:t>1 milhão</a:t>
-                    </a:r>
-                  </a:p>
-                </c:rich>
-              </c:tx>
-              <c:txPr>
-                <a:bodyPr xmlns:a="http://schemas.openxmlformats.org/drawingml/2006/main" anchorCtr="1"/>
-                <a:lstStyle xmlns:a="http://schemas.openxmlformats.org/drawingml/2006/main"/>
-                <a:p xmlns:a="http://schemas.openxmlformats.org/drawingml/2006/main">
-                  <a:pPr>
-                    <a:defRPr sz="1800" b="1">
-                      <a:solidFill>
-                        <a:srgbClr val="F5F6F0"/>
-                      </a:solidFill>
-                      <a:latin typeface="Arial"/>
-                      <a:ea typeface="Arial"/>
-                      <a:cs typeface="Arial"/>
-                    </a:defRPr>
-                  </a:pPr>
-                </a:p>
-              </c:txPr>
-              <c:dLblPos val="inEnd"/>
-              <c:showVal val="0"/>
-            </c:dLbl>
-          </c:dLbls>
-          <c:cat>
-            <c:strRef>
-              <c:f>'Chart Data'!$A$2:$A$3</c:f>
-              <c:strCache>
-                <c:ptCount val="2"/>
-                <c:pt idx="0">
-                  <c:v>Agora</c:v>
-                </c:pt>
-                <c:pt idx="1">
-                  <c:v>Antes</c:v>
-                </c:pt>
-              </c:strCache>
-            </c:strRef>
-          </c:cat>
-          <c:val>
-            <c:numRef>
-              <c:f>'Chart Data'!$B$2:$B$3</c:f>
-              <c:numCache>
-                <c:formatCode>General</c:formatCode>
-                <c:ptCount val="2"/>
-                <c:pt idx="0">
-                  <c:v>700000</c:v>
-                </c:pt>
-                <c:pt idx="1">
-                  <c:v>1000000</c:v>
-                </c:pt>
-              </c:numCache>
-            </c:numRef>
-          </c:val>
-        </c:ser>
-        <c:dLbls>
-          <c:delete val="0"/>
-          <c:txPr>
-            <a:bodyPr xmlns:a="http://schemas.openxmlformats.org/drawingml/2006/main" anchorCtr="1"/>
-            <a:lstStyle xmlns:a="http://schemas.openxmlformats.org/drawingml/2006/main"/>
-            <a:p xmlns:a="http://schemas.openxmlformats.org/drawingml/2006/main">
-              <a:pPr>
-                <a:defRPr>
-                  <a:latin typeface="Arial"/>
-                  <a:ea typeface="Arial"/>
-                  <a:cs typeface="Arial"/>
-                </a:defRPr>
-              </a:pPr>
-            </a:p>
-          </c:txPr>
-          <c:dLblPos val="inEnd"/>
-          <c:showLegendKey val="0"/>
-          <c:showVal val="1"/>
-          <c:showCatName val="0"/>
-          <c:showSerName val="0"/>
-          <c:showPercent val="0"/>
-          <c:showBubbleSize val="0"/>
-          <c:showLeaderLines val="0"/>
-        </c:dLbls>
-        <c:gapWidth val="60"/>
-        <c:axId val="48650112"/>
-        <c:axId val="48672768"/>
-      </c:barChart>
-      <c:catAx>
-        <c:axId val="48650112"/>
-        <c:scaling>
-          <c:orientation val="minMax"/>
-        </c:scaling>
-        <c:delete val="0"/>
-        <c:axPos val="l"/>
-        <c:numFmt formatCode="General"/>
-        <c:majorTickMark val="none"/>
-        <c:minorTickMark val="none"/>
-        <c:spPr>
-          <a:ln xmlns:a="http://schemas.openxmlformats.org/drawingml/2006/main" w="0">
-            <a:noFill/>
-          </a:ln>
-        </c:spPr>
-        <c:txPr>
-          <a:bodyPr xmlns:a="http://schemas.openxmlformats.org/drawingml/2006/main" anchorCtr="1"/>
-          <a:lstStyle xmlns:a="http://schemas.openxmlformats.org/drawingml/2006/main"/>
-          <a:p xmlns:a="http://schemas.openxmlformats.org/drawingml/2006/main">
-            <a:pPr>
-              <a:defRPr sz="1575" b="1">
-                <a:solidFill>
-                  <a:srgbClr val="F5F6F0"/>
-                </a:solidFill>
-                <a:latin typeface="Arial"/>
-                <a:ea typeface="Arial"/>
-                <a:cs typeface="Arial"/>
-              </a:defRPr>
-            </a:pPr>
-          </a:p>
-        </c:txPr>
-        <c:crossAx val="48672768"/>
-      </c:catAx>
-      <c:valAx>
-        <c:axId val="48672768"/>
-        <c:scaling>
-          <c:orientation val="minMax"/>
-          <c:max val="1100000"/>
-          <c:min val="0"/>
-        </c:scaling>
-        <c:delete val="1"/>
-        <c:axPos val="b"/>
-        <c:numFmt formatCode="General"/>
-        <c:majorTickMark val="none"/>
-        <c:minorTickMark val="none"/>
-        <c:spPr>
-          <a:ln xmlns:a="http://schemas.openxmlformats.org/drawingml/2006/main" w="9525">
-            <a:solidFill>
-              <a:srgbClr val="D4D4D4"/>
-            </a:solidFill>
-            <a:prstDash val="solid"/>
-          </a:ln>
-        </c:spPr>
-        <c:txPr>
-          <a:bodyPr xmlns:a="http://schemas.openxmlformats.org/drawingml/2006/main" anchorCtr="1"/>
-          <a:lstStyle xmlns:a="http://schemas.openxmlformats.org/drawingml/2006/main"/>
-          <a:p xmlns:a="http://schemas.openxmlformats.org/drawingml/2006/main">
-            <a:pPr>
-              <a:defRPr>
-                <a:solidFill>
-                  <a:srgbClr val="666666"/>
-                </a:solidFill>
-                <a:latin typeface="Arial"/>
-                <a:ea typeface="Arial"/>
-                <a:cs typeface="Arial"/>
-              </a:defRPr>
-            </a:pPr>
-          </a:p>
-        </c:txPr>
-        <c:crossAx val="48650112"/>
-        <c:crossBetween val="between"/>
-      </c:valAx>
-      <c:spPr>
-        <a:solidFill xmlns:a="http://schemas.openxmlformats.org/drawingml/2006/main">
-          <a:srgbClr val="101923"/>
-        </a:solidFill>
-        <a:ln xmlns:a="http://schemas.openxmlformats.org/drawingml/2006/main" w="0">
-          <a:noFill/>
-        </a:ln>
-      </c:spPr>
-    </c:plotArea>
-    <c:plotVisOnly val="1"/>
-  </c:chart>
-  <c:spPr>
-    <a:solidFill xmlns:a="http://schemas.openxmlformats.org/drawingml/2006/main">
-      <a:srgbClr val="101923"/>
-    </a:solidFill>
-    <a:ln xmlns:a="http://schemas.openxmlformats.org/drawingml/2006/main" w="0">
-      <a:noFill/>
-    </a:ln>
-  </c:spPr>
-  <c:externalData r:id="rIdChartSnapshot1">
-    <c:autoUpdate val="0"/>
-  </c:externalData>
-</c:chartSpace>
+<ns0:chartSpace xmlns:ns0="http://schemas.openxmlformats.org/drawingml/2006/chart" xmlns:ns1="http://schemas.openxmlformats.org/drawingml/2006/main" xmlns:ns2="http://schemas.openxmlformats.org/officeDocument/2006/relationships">
+  <ns0:lang val="en-US"/>
+  <ns0:chart>
+    <ns0:plotArea>
+      <ns0:barChart>
+        <ns0:barDir val="bar"/>
+        <ns0:grouping val="clustered"/>
+        <ns0:varyColors val="1"/>
+        <ns0:ser>
+          <ns0:idx val="0"/>
+          <ns0:order val="0"/>
+          <ns0:tx>
+            <ns0:v>Caracteres retornados pela busca</ns0:v>
+          </ns0:tx>
+          <ns0:invertIfNegative val="0"/>
+          <ns0:dPt>
+            <ns0:idx val="0"/>
+            <ns0:invertIfNegative val="0"/>
+            <ns0:spPr>
+              <ns1:solidFill>
+                <ns1:srgbClr val="70DEC9"/>
+              </ns1:solidFill>
+            </ns0:spPr>
+          </ns0:dPt>
+          <ns0:dPt>
+            <ns0:idx val="1"/>
+            <ns0:invertIfNegative val="0"/>
+            <ns0:spPr>
+              <ns1:solidFill>
+                <ns1:srgbClr val="607487"/>
+              </ns1:solidFill>
+            </ns0:spPr>
+          </ns0:dPt>
+          <ns0:dLbls>
+            <ns0:dLbl>
+              <ns0:idx val="0"/>
+              <ns0:tx>
+                <ns0:rich>
+                  <ns1:bodyPr/>
+                  <ns1:lstStyle/>
+                  <ns1:p>
+                    <ns1:r>
+                      <ns1:rPr sz="1800" b="1">
+                        <ns1:solidFill>
+                          <ns1:srgbClr val="101923"/>
+                        </ns1:solidFill>
+                        <ns1:latin typeface="Arial"/>
+                        <ns1:ea typeface="Arial"/>
+                        <ns1:cs typeface="Arial"/>
+                      </ns1:rPr>
+                      <ns1:t>4.677</ns1:t>
+                    </ns1:r>
+                  </ns1:p>
+                </ns0:rich>
+              </ns0:tx>
+              <ns0:txPr>
+                <ns1:bodyPr anchorCtr="1"/>
+                <ns1:lstStyle/>
+                <ns1:p>
+                  <ns1:pPr>
+                    <ns1:defRPr sz="1800" b="1">
+                      <ns1:solidFill>
+                        <ns1:srgbClr val="101923"/>
+                      </ns1:solidFill>
+                      <ns1:latin typeface="Arial"/>
+                      <ns1:ea typeface="Arial"/>
+                      <ns1:cs typeface="Arial"/>
+                    </ns1:defRPr>
+                  </ns1:pPr>
+                </ns1:p>
+              </ns0:txPr>
+              <ns0:dLblPos val="inEnd"/>
+              <ns0:showVal val="0"/>
+            </ns0:dLbl>
+            <ns0:dLbl>
+              <ns0:idx val="1"/>
+              <ns0:tx>
+                <ns0:rich>
+                  <ns1:bodyPr/>
+                  <ns1:lstStyle/>
+                  <ns1:p>
+                    <ns1:r>
+                      <ns1:rPr sz="1800" b="1">
+                        <ns1:solidFill>
+                          <ns1:srgbClr val="F5F6F0"/>
+                        </ns1:solidFill>
+                        <ns1:latin typeface="Arial"/>
+                        <ns1:ea typeface="Arial"/>
+                        <ns1:cs typeface="Arial"/>
+                      </ns1:rPr>
+                      <ns1:t>11.961</ns1:t>
+                    </ns1:r>
+                  </ns1:p>
+                </ns0:rich>
+              </ns0:tx>
+              <ns0:txPr>
+                <ns1:bodyPr anchorCtr="1"/>
+                <ns1:lstStyle/>
+                <ns1:p>
+                  <ns1:pPr>
+                    <ns1:defRPr sz="1800" b="1">
+                      <ns1:solidFill>
+                        <ns1:srgbClr val="F5F6F0"/>
+                      </ns1:solidFill>
+                      <ns1:latin typeface="Arial"/>
+                      <ns1:ea typeface="Arial"/>
+                      <ns1:cs typeface="Arial"/>
+                    </ns1:defRPr>
+                  </ns1:pPr>
+                </ns1:p>
+              </ns0:txPr>
+              <ns0:dLblPos val="inEnd"/>
+              <ns0:showVal val="0"/>
+            </ns0:dLbl>
+            <ns0:showLegendKey val="0"/>
+            <ns0:showVal val="0"/>
+            <ns0:showCatName val="0"/>
+            <ns0:showSerName val="0"/>
+            <ns0:showPercent val="0"/>
+            <ns0:showBubbleSize val="0"/>
+            <ns0:showLeaderLines val="0"/>
+          </ns0:dLbls>
+          <ns0:cat>
+            <ns0:strRef>
+              <ns0:f>'Chart Data'!$A$2:$A$3</ns0:f>
+              <ns0:strCache>
+                <ns0:ptCount val="2"/>
+                <ns0:pt idx="0">
+                  <ns0:v>Agora</ns0:v>
+                </ns0:pt>
+                <ns0:pt idx="1">
+                  <ns0:v>Antes</ns0:v>
+                </ns0:pt>
+              </ns0:strCache>
+            </ns0:strRef>
+          </ns0:cat>
+          <ns0:val>
+            <ns0:numRef>
+              <ns0:f>'Chart Data'!$B$2:$B$3</ns0:f>
+              <ns0:numCache>
+                <ns0:formatCode>General</ns0:formatCode>
+                <ns0:ptCount val="2"/>
+                <ns0:pt idx="0">
+                  <ns0:v>4677</ns0:v>
+                </ns0:pt>
+                <ns0:pt idx="1">
+                  <ns0:v>11961</ns0:v>
+                </ns0:pt>
+              </ns0:numCache>
+            </ns0:numRef>
+          </ns0:val>
+        </ns0:ser>
+        <ns0:dLbls>
+          <ns0:delete val="0"/>
+          <ns0:txPr>
+            <ns1:bodyPr anchorCtr="1"/>
+            <ns1:lstStyle/>
+            <ns1:p>
+              <ns1:pPr>
+                <ns1:defRPr>
+                  <ns1:latin typeface="Arial"/>
+                  <ns1:ea typeface="Arial"/>
+                  <ns1:cs typeface="Arial"/>
+                </ns1:defRPr>
+              </ns1:pPr>
+            </ns1:p>
+          </ns0:txPr>
+          <ns0:dLblPos val="inEnd"/>
+          <ns0:showLegendKey val="0"/>
+          <ns0:showVal val="1"/>
+          <ns0:showCatName val="0"/>
+          <ns0:showSerName val="0"/>
+          <ns0:showPercent val="0"/>
+          <ns0:showBubbleSize val="0"/>
+          <ns0:showLeaderLines val="0"/>
+        </ns0:dLbls>
+        <ns0:gapWidth val="60"/>
+        <ns0:axId val="48650112"/>
+        <ns0:axId val="48672768"/>
+      </ns0:barChart>
+      <ns0:catAx>
+        <ns0:axId val="48650112"/>
+        <ns0:scaling>
+          <ns0:orientation val="minMax"/>
+        </ns0:scaling>
+        <ns0:delete val="0"/>
+        <ns0:axPos val="l"/>
+        <ns0:numFmt formatCode="General"/>
+        <ns0:majorTickMark val="none"/>
+        <ns0:minorTickMark val="none"/>
+        <ns0:spPr>
+          <ns1:ln w="0">
+            <ns1:noFill/>
+          </ns1:ln>
+        </ns0:spPr>
+        <ns0:txPr>
+          <ns1:bodyPr anchorCtr="1"/>
+          <ns1:lstStyle/>
+          <ns1:p>
+            <ns1:pPr>
+              <ns1:defRPr sz="1575" b="1">
+                <ns1:solidFill>
+                  <ns1:srgbClr val="F5F6F0"/>
+                </ns1:solidFill>
+                <ns1:latin typeface="Arial"/>
+                <ns1:ea typeface="Arial"/>
+                <ns1:cs typeface="Arial"/>
+              </ns1:defRPr>
+            </ns1:pPr>
+          </ns1:p>
+        </ns0:txPr>
+        <ns0:crossAx val="48672768"/>
+      </ns0:catAx>
+      <ns0:valAx>
+        <ns0:axId val="48672768"/>
+        <ns0:scaling>
+          <ns0:orientation val="minMax"/>
+          <ns0:max val="13157.1"/>
+          <ns0:min val="0"/>
+        </ns0:scaling>
+        <ns0:delete val="1"/>
+        <ns0:axPos val="b"/>
+        <ns0:numFmt formatCode="General"/>
+        <ns0:majorTickMark val="none"/>
+        <ns0:minorTickMark val="none"/>
+        <ns0:spPr>
+          <ns1:ln w="9525">
+            <ns1:solidFill>
+              <ns1:srgbClr val="D4D4D4"/>
+            </ns1:solidFill>
+            <ns1:prstDash val="solid"/>
+          </ns1:ln>
+        </ns0:spPr>
+        <ns0:txPr>
+          <ns1:bodyPr anchorCtr="1"/>
+          <ns1:lstStyle/>
+          <ns1:p>
+            <ns1:pPr>
+              <ns1:defRPr>
+                <ns1:solidFill>
+                  <ns1:srgbClr val="666666"/>
+                </ns1:solidFill>
+                <ns1:latin typeface="Arial"/>
+                <ns1:ea typeface="Arial"/>
+                <ns1:cs typeface="Arial"/>
+              </ns1:defRPr>
+            </ns1:pPr>
+          </ns1:p>
+        </ns0:txPr>
+        <ns0:crossAx val="48650112"/>
+        <ns0:crossBetween val="between"/>
+      </ns0:valAx>
+      <ns0:spPr>
+        <ns1:solidFill>
+          <ns1:srgbClr val="101923"/>
+        </ns1:solidFill>
+        <ns1:ln w="0">
+          <ns1:noFill/>
+        </ns1:ln>
+      </ns0:spPr>
+    </ns0:plotArea>
+    <ns0:plotVisOnly val="1"/>
+  </ns0:chart>
+  <ns0:spPr>
+    <ns1:solidFill>
+      <ns1:srgbClr val="101923"/>
+    </ns1:solidFill>
+    <ns1:ln w="0">
+      <ns1:noFill/>
+    </ns1:ln>
+  </ns0:spPr>
+  <ns0:externalData ns2:id="rIdChartSnapshot1">
+    <ns0:autoUpdate val="0"/>
+  </ns0:externalData>
+</ns0:chartSpace>
 </file>
 
 <file path=ppt/slides/slide1.xml><?xml version="1.0" encoding="utf-8"?>
@@ -3082,6 +3149,7 @@
           </a:lstStyle>
           <a:p xmlns:a="http://schemas.openxmlformats.org/drawingml/2006/main">
             <a:pPr>
+              <a:buNone/>
               <a:defRPr sz="1275" b="1">
                 <a:solidFill>
                   <a:srgbClr val="70DEC9"/>
@@ -3100,7 +3168,7 @@
                 <a:ea typeface="Arial"/>
                 <a:cs typeface="Arial"/>
               </a:rPr>
-              <a:t>SIMULAÇÃO · MESMO TRABALHO · MESMA MENSALIDADE</a:t>
+              <a:t>MEDIÇÃO LOCAL · MESMO CONTEXTO · MESMA MENSALIDADE</a:t>
             </a:r>
           </a:p>
         </p:txBody>
@@ -3150,6 +3218,7 @@
           </a:lstStyle>
           <a:p xmlns:a="http://schemas.openxmlformats.org/drawingml/2006/main">
             <a:pPr>
+              <a:buNone/>
               <a:defRPr sz="3375" b="1">
                 <a:solidFill>
                   <a:srgbClr val="F5F6F0"/>
@@ -3168,7 +3237,7 @@
                 <a:ea typeface="Arial"/>
                 <a:cs typeface="Arial"/>
               </a:rPr>
-              <a:t>30% menos tokens no principal</a:t>
+              <a:t>60,9% menos texto na busca</a:t>
             </a:r>
           </a:p>
         </p:txBody>
@@ -3218,6 +3287,7 @@
           </a:lstStyle>
           <a:p xmlns:a="http://schemas.openxmlformats.org/drawingml/2006/main">
             <a:pPr>
+              <a:buNone/>
               <a:defRPr sz="1425" b="0">
                 <a:solidFill>
                   <a:srgbClr val="AAB8C5"/>
@@ -3236,7 +3306,7 @@
                 <a:ea typeface="Arial"/>
                 <a:cs typeface="Arial"/>
               </a:rPr>
-              <a:t>Claude ou Codex coordena. O roteador distribui a execução e o principal revisa.</a:t>
+              <a:t>Mesma consulta, mesmo acervo, mesmas cinco notas e trechos.</a:t>
             </a:r>
           </a:p>
         </p:txBody>
@@ -3286,6 +3356,7 @@
           </a:lstStyle>
           <a:p xmlns:a="http://schemas.openxmlformats.org/drawingml/2006/main">
             <a:pPr>
+              <a:buNone/>
               <a:defRPr sz="1425" b="0">
                 <a:solidFill>
                   <a:srgbClr val="AAB8C5"/>
@@ -3304,7 +3375,7 @@
                 <a:ea typeface="Arial"/>
                 <a:cs typeface="Arial"/>
               </a:rPr>
-              <a:t>Consumo diário do principal</a:t>
+              <a:t>Texto retornado pela busca</a:t>
             </a:r>
           </a:p>
         </p:txBody>
@@ -3314,7 +3385,7 @@
           <p:cNvPr id="5" name="Chart">
             <a:extLst xmlns:a="http://schemas.openxmlformats.org/drawingml/2006/main">
               <a:ext uri="{FF2B5EF4-FFF2-40B4-BE49-F238E27FC236}">
-                <a16:creationId xmlns:a16="http://schemas.microsoft.com/office/drawing/2014/main" id="{0EE0A955-9C23-48E6-B390-09C900663FF2}"/>
+                <a16:creationId xmlns:a16="http://schemas.microsoft.com/office/drawing/2014/main" id="{4ECA498E-2511-4A0A-9952-3A6E0D2BC73B}"/>
               </a:ext>
             </a:extLst>
           </p:cNvPr>
@@ -3327,7 +3398,7 @@
         </p:xfrm>
         <a:graphic xmlns:a="http://schemas.openxmlformats.org/drawingml/2006/main">
           <a:graphicData uri="http://schemas.openxmlformats.org/drawingml/2006/chart">
-            <c:chart xmlns:r="http://schemas.openxmlformats.org/officeDocument/2006/relationships" xmlns:c="http://schemas.openxmlformats.org/drawingml/2006/chart" r:id="R51637a1f667b44a8"/>
+            <c:chart xmlns:r="http://schemas.openxmlformats.org/officeDocument/2006/relationships" xmlns:c="http://schemas.openxmlformats.org/drawingml/2006/chart" r:id="R0c7e625a0ffe4c48"/>
           </a:graphicData>
         </a:graphic>
       </p:graphicFrame>
@@ -3376,6 +3447,7 @@
           </a:lstStyle>
           <a:p xmlns:a="http://schemas.openxmlformats.org/drawingml/2006/main">
             <a:pPr>
+              <a:buNone/>
               <a:defRPr sz="1500" b="1">
                 <a:solidFill>
                   <a:srgbClr val="70DEC9"/>
@@ -3394,7 +3466,7 @@
                 <a:ea typeface="Arial"/>
                 <a:cs typeface="Arial"/>
               </a:rPr>
-              <a:t>300 mil tokens a menos por dia (30%)</a:t>
+              <a:t>7.284 caracteres a menos (60,9%)</a:t>
             </a:r>
           </a:p>
         </p:txBody>
@@ -3444,6 +3516,7 @@
           </a:lstStyle>
           <a:p xmlns:a="http://schemas.openxmlformats.org/drawingml/2006/main">
             <a:pPr>
+              <a:buNone/>
               <a:defRPr sz="1875" b="1">
                 <a:solidFill>
                   <a:srgbClr val="F5F6F0"/>
@@ -3462,7 +3535,7 @@
                 <a:ea typeface="Arial"/>
                 <a:cs typeface="Arial"/>
               </a:rPr>
-              <a:t>A conta, com o mesmo trabalho</a:t>
+              <a:t>A conta da redução medida</a:t>
             </a:r>
           </a:p>
         </p:txBody>
@@ -3512,6 +3585,7 @@
           </a:lstStyle>
           <a:p xmlns:a="http://schemas.openxmlformats.org/drawingml/2006/main">
             <a:pPr>
+              <a:buNone/>
               <a:defRPr sz="2250" b="1">
                 <a:solidFill>
                   <a:srgbClr val="70DEC9"/>
@@ -3530,7 +3604,7 @@
                 <a:ea typeface="Arial"/>
                 <a:cs typeface="Arial"/>
               </a:rPr>
-              <a:t>1.000.000 − 400.000 + 100.000 = 700.000</a:t>
+              <a:t>11.961 − 4.677 = 7.284</a:t>
             </a:r>
           </a:p>
         </p:txBody>
@@ -3580,6 +3654,7 @@
           </a:lstStyle>
           <a:p xmlns:a="http://schemas.openxmlformats.org/drawingml/2006/main">
             <a:pPr>
+              <a:buNone/>
               <a:defRPr sz="1425" b="0">
                 <a:solidFill>
                   <a:srgbClr val="F5F6F0"/>
@@ -3598,7 +3673,7 @@
                 <a:ea typeface="Arial"/>
                 <a:cs typeface="Arial"/>
               </a:rPr>
-              <a:t>400 mil tokens de execução vão aos auxiliares (40%).</a:t>
+              <a:t>7.284 caracteres deixam de ocupar a saída da busca.</a:t>
             </a:r>
           </a:p>
         </p:txBody>
@@ -3648,6 +3723,7 @@
           </a:lstStyle>
           <a:p xmlns:a="http://schemas.openxmlformats.org/drawingml/2006/main">
             <a:pPr>
+              <a:buNone/>
               <a:defRPr sz="1425" b="0">
                 <a:solidFill>
                   <a:srgbClr val="F5F6F0"/>
@@ -3666,7 +3742,7 @@
                 <a:ea typeface="Arial"/>
                 <a:cs typeface="Arial"/>
               </a:rPr>
-              <a:t>100 mil tokens ficam para preparar e revisar (10%).</a:t>
+              <a:t>O conteúdo dos trechos selecionados foi preservado.</a:t>
             </a:r>
           </a:p>
         </p:txBody>
@@ -3716,6 +3792,7 @@
           </a:lstStyle>
           <a:p xmlns:a="http://schemas.openxmlformats.org/drawingml/2006/main">
             <a:pPr>
+              <a:buNone/>
               <a:defRPr sz="1575" b="1">
                 <a:solidFill>
                   <a:srgbClr val="70DEC9"/>
@@ -3734,7 +3811,7 @@
                 <a:ea typeface="Arial"/>
                 <a:cs typeface="Arial"/>
               </a:rPr>
-              <a:t>300 mil tokens do principal preservados por dia</a:t>
+              <a:t>Redução: 7.284 ÷ 11.961 = 60,9%</a:t>
             </a:r>
           </a:p>
         </p:txBody>
@@ -3784,6 +3861,7 @@
           </a:lstStyle>
           <a:p xmlns:a="http://schemas.openxmlformats.org/drawingml/2006/main">
             <a:pPr>
+              <a:buNone/>
               <a:defRPr sz="1275" b="0">
                 <a:solidFill>
                   <a:srgbClr val="AAB8C5"/>
@@ -3802,7 +3880,7 @@
                 <a:ea typeface="Arial"/>
                 <a:cs typeface="Arial"/>
               </a:rPr>
-              <a:t>O total entre as IAs pode chegar a 1,1 milhão/dia neste exemplo.</a:t>
+              <a:t>O ganho vem de resumir a lista de notas omitidas.</a:t>
             </a:r>
           </a:p>
         </p:txBody>
@@ -3852,6 +3930,7 @@
           </a:lstStyle>
           <a:p xmlns:a="http://schemas.openxmlformats.org/drawingml/2006/main">
             <a:pPr>
+              <a:buNone/>
               <a:defRPr sz="1350" b="0">
                 <a:solidFill>
                   <a:srgbClr val="AAB8C5"/>
@@ -3870,7 +3949,7 @@
                 <a:ea typeface="Arial"/>
                 <a:cs typeface="Arial"/>
               </a:rPr>
-              <a:t>Tokens do principal · médias em 8h de trabalho</a:t>
+              <a:t>Controle da comparação local</a:t>
             </a:r>
           </a:p>
         </p:txBody>
@@ -3880,7 +3959,7 @@
           <p:cNvPr id="14" name="">
             <a:extLst xmlns:a="http://schemas.openxmlformats.org/drawingml/2006/main">
               <a:ext uri="{FF2B5EF4-FFF2-40B4-BE49-F238E27FC236}">
-                <a16:creationId xmlns:a16="http://schemas.microsoft.com/office/drawing/2014/main" id="{3E024B88-2632-438F-816D-99F40B4C2625}"/>
+                <a16:creationId xmlns:a16="http://schemas.microsoft.com/office/drawing/2014/main" id="{7E60879A-9846-47C3-B233-0D9BCF1C5A85}"/>
               </a:ext>
             </a:extLst>
           </p:cNvPr>
@@ -3909,7 +3988,9 @@
                     </a:bodyPr>
                     <a:lstStyle/>
                     <a:p>
-                      <a:pPr algn="l"/>
+                      <a:pPr algn="l">
+                        <a:buNone/>
+                      </a:pPr>
                       <a:r>
                         <a:rPr sz="1313" b="1">
                           <a:solidFill>
@@ -3919,7 +4000,7 @@
                           <a:ea typeface="Arial"/>
                           <a:cs typeface="Arial"/>
                         </a:rPr>
-                        <a:t>Período</a:t>
+                        <a:t>Controle</a:t>
                       </a:r>
                     </a:p>
                   </a:txBody>
@@ -3948,7 +4029,9 @@
                     </a:bodyPr>
                     <a:lstStyle/>
                     <a:p>
-                      <a:pPr algn="l"/>
+                      <a:pPr algn="l">
+                        <a:buNone/>
+                      </a:pPr>
                       <a:r>
                         <a:rPr sz="1313" b="1">
                           <a:solidFill>
@@ -3984,7 +4067,9 @@
                     </a:bodyPr>
                     <a:lstStyle/>
                     <a:p>
-                      <a:pPr algn="l"/>
+                      <a:pPr algn="l">
+                        <a:buNone/>
+                      </a:pPr>
                       <a:r>
                         <a:rPr sz="1313" b="1">
                           <a:solidFill>
@@ -4020,7 +4105,9 @@
                     </a:bodyPr>
                     <a:lstStyle/>
                     <a:p>
-                      <a:pPr algn="l"/>
+                      <a:pPr algn="l">
+                        <a:buNone/>
+                      </a:pPr>
                       <a:r>
                         <a:rPr sz="1313" b="1">
                           <a:solidFill>
@@ -4030,7 +4117,7 @@
                           <a:ea typeface="Arial"/>
                           <a:cs typeface="Arial"/>
                         </a:rPr>
-                        <a:t>A menos</a:t>
+                        <a:t>Diferença</a:t>
                       </a:r>
                     </a:p>
                   </a:txBody>
@@ -4058,7 +4145,9 @@
                     </a:bodyPr>
                     <a:lstStyle/>
                     <a:p>
-                      <a:pPr algn="l"/>
+                      <a:pPr algn="l">
+                        <a:buNone/>
+                      </a:pPr>
                       <a:r>
                         <a:rPr sz="1313" b="0">
                           <a:solidFill>
@@ -4068,7 +4157,7 @@
                           <a:ea typeface="Arial"/>
                           <a:cs typeface="Arial"/>
                         </a:rPr>
-                        <a:t>Minuto</a:t>
+                        <a:t>Notas</a:t>
                       </a:r>
                     </a:p>
                   </a:txBody>
@@ -4094,7 +4183,9 @@
                     </a:bodyPr>
                     <a:lstStyle/>
                     <a:p>
-                      <a:pPr algn="l"/>
+                      <a:pPr algn="l">
+                        <a:buNone/>
+                      </a:pPr>
                       <a:r>
                         <a:rPr sz="1313" b="0">
                           <a:solidFill>
@@ -4104,7 +4195,7 @@
                           <a:ea typeface="Arial"/>
                           <a:cs typeface="Arial"/>
                         </a:rPr>
-                        <a:t>2.083</a:t>
+                        <a:t>5</a:t>
                       </a:r>
                     </a:p>
                   </a:txBody>
@@ -4127,7 +4218,9 @@
                     </a:bodyPr>
                     <a:lstStyle/>
                     <a:p>
-                      <a:pPr algn="l"/>
+                      <a:pPr algn="l">
+                        <a:buNone/>
+                      </a:pPr>
                       <a:r>
                         <a:rPr sz="1313" b="0">
                           <a:solidFill>
@@ -4137,7 +4230,7 @@
                           <a:ea typeface="Arial"/>
                           <a:cs typeface="Arial"/>
                         </a:rPr>
-                        <a:t>1.458</a:t>
+                        <a:t>5</a:t>
                       </a:r>
                     </a:p>
                   </a:txBody>
@@ -4160,7 +4253,9 @@
                     </a:bodyPr>
                     <a:lstStyle/>
                     <a:p>
-                      <a:pPr algn="l"/>
+                      <a:pPr algn="l">
+                        <a:buNone/>
+                      </a:pPr>
                       <a:r>
                         <a:rPr sz="1313" b="0">
                           <a:solidFill>
@@ -4170,7 +4265,7 @@
                           <a:ea typeface="Arial"/>
                           <a:cs typeface="Arial"/>
                         </a:rPr>
-                        <a:t>625</a:t>
+                        <a:t>mesmas</a:t>
                       </a:r>
                     </a:p>
                   </a:txBody>
@@ -4195,7 +4290,9 @@
                     </a:bodyPr>
                     <a:lstStyle/>
                     <a:p>
-                      <a:pPr algn="l"/>
+                      <a:pPr algn="l">
+                        <a:buNone/>
+                      </a:pPr>
                       <a:r>
                         <a:rPr sz="1313" b="0">
                           <a:solidFill>
@@ -4205,7 +4302,7 @@
                           <a:ea typeface="Arial"/>
                           <a:cs typeface="Arial"/>
                         </a:rPr>
-                        <a:t>Hora</a:t>
+                        <a:t>Trechos</a:t>
                       </a:r>
                     </a:p>
                   </a:txBody>
@@ -4231,7 +4328,9 @@
                     </a:bodyPr>
                     <a:lstStyle/>
                     <a:p>
-                      <a:pPr algn="l"/>
+                      <a:pPr algn="l">
+                        <a:buNone/>
+                      </a:pPr>
                       <a:r>
                         <a:rPr sz="1313" b="0">
                           <a:solidFill>
@@ -4241,7 +4340,7 @@
                           <a:ea typeface="Arial"/>
                           <a:cs typeface="Arial"/>
                         </a:rPr>
-                        <a:t>125 mil</a:t>
+                        <a:t>originais</a:t>
                       </a:r>
                     </a:p>
                   </a:txBody>
@@ -4264,7 +4363,9 @@
                     </a:bodyPr>
                     <a:lstStyle/>
                     <a:p>
-                      <a:pPr algn="l"/>
+                      <a:pPr algn="l">
+                        <a:buNone/>
+                      </a:pPr>
                       <a:r>
                         <a:rPr sz="1313" b="0">
                           <a:solidFill>
@@ -4274,7 +4375,7 @@
                           <a:ea typeface="Arial"/>
                           <a:cs typeface="Arial"/>
                         </a:rPr>
-                        <a:t>87,5 mil</a:t>
+                        <a:t>idênticos</a:t>
                       </a:r>
                     </a:p>
                   </a:txBody>
@@ -4297,7 +4398,9 @@
                     </a:bodyPr>
                     <a:lstStyle/>
                     <a:p>
-                      <a:pPr algn="l"/>
+                      <a:pPr algn="l">
+                        <a:buNone/>
+                      </a:pPr>
                       <a:r>
                         <a:rPr sz="1313" b="0">
                           <a:solidFill>
@@ -4307,7 +4410,7 @@
                           <a:ea typeface="Arial"/>
                           <a:cs typeface="Arial"/>
                         </a:rPr>
-                        <a:t>37,5 mil</a:t>
+                        <a:t>preservados</a:t>
                       </a:r>
                     </a:p>
                   </a:txBody>
@@ -4332,7 +4435,9 @@
                     </a:bodyPr>
                     <a:lstStyle/>
                     <a:p>
-                      <a:pPr algn="l"/>
+                      <a:pPr algn="l">
+                        <a:buNone/>
+                      </a:pPr>
                       <a:r>
                         <a:rPr sz="1313" b="0">
                           <a:solidFill>
@@ -4342,7 +4447,7 @@
                           <a:ea typeface="Arial"/>
                           <a:cs typeface="Arial"/>
                         </a:rPr>
-                        <a:t>Dia</a:t>
+                        <a:t>Limite</a:t>
                       </a:r>
                     </a:p>
                   </a:txBody>
@@ -4368,7 +4473,9 @@
                     </a:bodyPr>
                     <a:lstStyle/>
                     <a:p>
-                      <a:pPr algn="l"/>
+                      <a:pPr algn="l">
+                        <a:buNone/>
+                      </a:pPr>
                       <a:r>
                         <a:rPr sz="1313" b="0">
                           <a:solidFill>
@@ -4378,7 +4485,7 @@
                           <a:ea typeface="Arial"/>
                           <a:cs typeface="Arial"/>
                         </a:rPr>
-                        <a:t>1 milhão</a:t>
+                        <a:t>5 notas</a:t>
                       </a:r>
                     </a:p>
                   </a:txBody>
@@ -4401,7 +4508,9 @@
                     </a:bodyPr>
                     <a:lstStyle/>
                     <a:p>
-                      <a:pPr algn="l"/>
+                      <a:pPr algn="l">
+                        <a:buNone/>
+                      </a:pPr>
                       <a:r>
                         <a:rPr sz="1313" b="0">
                           <a:solidFill>
@@ -4411,7 +4520,7 @@
                           <a:ea typeface="Arial"/>
                           <a:cs typeface="Arial"/>
                         </a:rPr>
-                        <a:t>700 mil</a:t>
+                        <a:t>5 notas</a:t>
                       </a:r>
                     </a:p>
                   </a:txBody>
@@ -4434,7 +4543,9 @@
                     </a:bodyPr>
                     <a:lstStyle/>
                     <a:p>
-                      <a:pPr algn="l"/>
+                      <a:pPr algn="l">
+                        <a:buNone/>
+                      </a:pPr>
                       <a:r>
                         <a:rPr sz="1313" b="0">
                           <a:solidFill>
@@ -4444,7 +4555,7 @@
                           <a:ea typeface="Arial"/>
                           <a:cs typeface="Arial"/>
                         </a:rPr>
-                        <a:t>300 mil</a:t>
+                        <a:t>igual</a:t>
                       </a:r>
                     </a:p>
                   </a:txBody>
@@ -4469,7 +4580,9 @@
                     </a:bodyPr>
                     <a:lstStyle/>
                     <a:p>
-                      <a:pPr algn="l"/>
+                      <a:pPr algn="l">
+                        <a:buNone/>
+                      </a:pPr>
                       <a:r>
                         <a:rPr sz="1313" b="0">
                           <a:solidFill>
@@ -4479,7 +4592,7 @@
                           <a:ea typeface="Arial"/>
                           <a:cs typeface="Arial"/>
                         </a:rPr>
-                        <a:t>Semana</a:t>
+                        <a:t>Orçamento</a:t>
                       </a:r>
                     </a:p>
                   </a:txBody>
@@ -4505,7 +4618,9 @@
                     </a:bodyPr>
                     <a:lstStyle/>
                     <a:p>
-                      <a:pPr algn="l"/>
+                      <a:pPr algn="l">
+                        <a:buNone/>
+                      </a:pPr>
                       <a:r>
                         <a:rPr sz="1313" b="0">
                           <a:solidFill>
@@ -4515,7 +4630,7 @@
                           <a:ea typeface="Arial"/>
                           <a:cs typeface="Arial"/>
                         </a:rPr>
-                        <a:t>5 milhões</a:t>
+                        <a:t>12.000</a:t>
                       </a:r>
                     </a:p>
                   </a:txBody>
@@ -4538,7 +4653,9 @@
                     </a:bodyPr>
                     <a:lstStyle/>
                     <a:p>
-                      <a:pPr algn="l"/>
+                      <a:pPr algn="l">
+                        <a:buNone/>
+                      </a:pPr>
                       <a:r>
                         <a:rPr sz="1313" b="0">
                           <a:solidFill>
@@ -4548,7 +4665,7 @@
                           <a:ea typeface="Arial"/>
                           <a:cs typeface="Arial"/>
                         </a:rPr>
-                        <a:t>3,5 milhões</a:t>
+                        <a:t>12.000</a:t>
                       </a:r>
                     </a:p>
                   </a:txBody>
@@ -4571,7 +4688,9 @@
                     </a:bodyPr>
                     <a:lstStyle/>
                     <a:p>
-                      <a:pPr algn="l"/>
+                      <a:pPr algn="l">
+                        <a:buNone/>
+                      </a:pPr>
                       <a:r>
                         <a:rPr sz="1313" b="0">
                           <a:solidFill>
@@ -4581,7 +4700,7 @@
                           <a:ea typeface="Arial"/>
                           <a:cs typeface="Arial"/>
                         </a:rPr>
-                        <a:t>1,5 milhão</a:t>
+                        <a:t>igual</a:t>
                       </a:r>
                     </a:p>
                   </a:txBody>
@@ -4606,7 +4725,9 @@
                     </a:bodyPr>
                     <a:lstStyle/>
                     <a:p>
-                      <a:pPr algn="l"/>
+                      <a:pPr algn="l">
+                        <a:buNone/>
+                      </a:pPr>
                       <a:r>
                         <a:rPr sz="1313" b="0">
                           <a:solidFill>
@@ -4616,7 +4737,7 @@
                           <a:ea typeface="Arial"/>
                           <a:cs typeface="Arial"/>
                         </a:rPr>
-                        <a:t>Mês</a:t>
+                        <a:t>Caracteres</a:t>
                       </a:r>
                     </a:p>
                   </a:txBody>
@@ -4642,7 +4763,9 @@
                     </a:bodyPr>
                     <a:lstStyle/>
                     <a:p>
-                      <a:pPr algn="l"/>
+                      <a:pPr algn="l">
+                        <a:buNone/>
+                      </a:pPr>
                       <a:r>
                         <a:rPr sz="1313" b="0">
                           <a:solidFill>
@@ -4652,7 +4775,7 @@
                           <a:ea typeface="Arial"/>
                           <a:cs typeface="Arial"/>
                         </a:rPr>
-                        <a:t>22 milhões</a:t>
+                        <a:t>11.961</a:t>
                       </a:r>
                     </a:p>
                   </a:txBody>
@@ -4675,7 +4798,9 @@
                     </a:bodyPr>
                     <a:lstStyle/>
                     <a:p>
-                      <a:pPr algn="l"/>
+                      <a:pPr algn="l">
+                        <a:buNone/>
+                      </a:pPr>
                       <a:r>
                         <a:rPr sz="1313" b="0">
                           <a:solidFill>
@@ -4685,7 +4810,7 @@
                           <a:ea typeface="Arial"/>
                           <a:cs typeface="Arial"/>
                         </a:rPr>
-                        <a:t>15,4 milhões</a:t>
+                        <a:t>4.677</a:t>
                       </a:r>
                     </a:p>
                   </a:txBody>
@@ -4708,7 +4833,9 @@
                     </a:bodyPr>
                     <a:lstStyle/>
                     <a:p>
-                      <a:pPr algn="l"/>
+                      <a:pPr algn="l">
+                        <a:buNone/>
+                      </a:pPr>
                       <a:r>
                         <a:rPr sz="1313" b="0">
                           <a:solidFill>
@@ -4718,7 +4845,7 @@
                           <a:ea typeface="Arial"/>
                           <a:cs typeface="Arial"/>
                         </a:rPr>
-                        <a:t>6,6 milhões</a:t>
+                        <a:t>−7.284</a:t>
                       </a:r>
                     </a:p>
                   </a:txBody>
@@ -4784,6 +4911,7 @@
           </a:lstStyle>
           <a:p xmlns:a="http://schemas.openxmlformats.org/drawingml/2006/main">
             <a:pPr>
+              <a:buNone/>
               <a:defRPr sz="1650" b="1">
                 <a:solidFill>
                   <a:srgbClr val="F5F6F0"/>
@@ -4802,7 +4930,7 @@
                 <a:ea typeface="Arial"/>
                 <a:cs typeface="Arial"/>
               </a:rPr>
-              <a:t>Exemplos de trabalho delegado</a:t>
+              <a:t>Benchmark público sintético</a:t>
             </a:r>
           </a:p>
         </p:txBody>
@@ -4852,6 +4980,7 @@
           </a:lstStyle>
           <a:p xmlns:a="http://schemas.openxmlformats.org/drawingml/2006/main">
             <a:pPr>
+              <a:buNone/>
               <a:defRPr sz="1425" b="0">
                 <a:solidFill>
                   <a:srgbClr val="70DEC9"/>
@@ -4870,7 +4999,7 @@
                 <a:ea typeface="Arial"/>
                 <a:cs typeface="Arial"/>
               </a:rPr>
-              <a:t>Ollama · resumir um texto local</a:t>
+              <a:t>40 notas · seleção de 5 notas e 20 trechos</a:t>
             </a:r>
           </a:p>
         </p:txBody>
@@ -4920,6 +5049,7 @@
           </a:lstStyle>
           <a:p xmlns:a="http://schemas.openxmlformats.org/drawingml/2006/main">
             <a:pPr>
+              <a:buNone/>
               <a:defRPr sz="1425" b="0">
                 <a:solidFill>
                   <a:srgbClr val="92BFFF"/>
@@ -4938,7 +5068,7 @@
                 <a:ea typeface="Arial"/>
                 <a:cs typeface="Arial"/>
               </a:rPr>
-              <a:t>Copilot · sugerir testes para uma função</a:t>
+              <a:t>11.696 → 5.862 caracteres (−49,9%)</a:t>
             </a:r>
           </a:p>
         </p:txBody>
@@ -4988,6 +5118,7 @@
           </a:lstStyle>
           <a:p xmlns:a="http://schemas.openxmlformats.org/drawingml/2006/main">
             <a:pPr>
+              <a:buNone/>
               <a:defRPr sz="1425" b="0">
                 <a:solidFill>
                   <a:srgbClr val="F5F6F0"/>
@@ -5006,11 +5137,12 @@
                 <a:ea typeface="Arial"/>
                 <a:cs typeface="Arial"/>
               </a:rPr>
-              <a:t>OpenCode/Nemotron · analisar um erro</a:t>
+              <a:t>Reproduza com dados de demonstração:</a:t>
             </a:r>
           </a:p>
           <a:p xmlns:a="http://schemas.openxmlformats.org/drawingml/2006/main">
             <a:pPr>
+              <a:buNone/>
               <a:defRPr sz="1425" b="0">
                 <a:solidFill>
                   <a:srgbClr val="F5F6F0"/>
@@ -5029,7 +5161,7 @@
                 <a:ea typeface="Arial"/>
                 <a:cs typeface="Arial"/>
               </a:rPr>
-              <a:t>com um trecho público</a:t>
+              <a:t>python3 tools/benchmark_busca.py</a:t>
             </a:r>
           </a:p>
         </p:txBody>
@@ -5079,6 +5211,7 @@
           </a:lstStyle>
           <a:p xmlns:a="http://schemas.openxmlformats.org/drawingml/2006/main">
             <a:pPr>
+              <a:buNone/>
               <a:defRPr sz="1313" b="0">
                 <a:solidFill>
                   <a:srgbClr val="AAB8C5"/>
@@ -5097,7 +5230,7 @@
                 <a:ea typeface="Arial"/>
                 <a:cs typeface="Arial"/>
               </a:rPr>
-              <a:t>O principal confere e aplica o resultado.</a:t>
+              <a:t>Cenário distinto da medição local de 60,9%.</a:t>
             </a:r>
           </a:p>
         </p:txBody>
@@ -5147,6 +5280,7 @@
           </a:lstStyle>
           <a:p xmlns:a="http://schemas.openxmlformats.org/drawingml/2006/main">
             <a:pPr>
+              <a:buNone/>
               <a:defRPr sz="1800" b="1">
                 <a:solidFill>
                   <a:srgbClr val="F5F6F0"/>
@@ -5165,7 +5299,7 @@
                 <a:ea typeface="Arial"/>
                 <a:cs typeface="Arial"/>
               </a:rPr>
-              <a:t>Cota preservada pode reduzir o tempo parado</a:t>
+              <a:t>Menos texto repetido para recuperar o mesmo contexto</a:t>
             </a:r>
           </a:p>
         </p:txBody>
@@ -5215,6 +5349,7 @@
           </a:lstStyle>
           <a:p xmlns:a="http://schemas.openxmlformats.org/drawingml/2006/main">
             <a:pPr>
+              <a:buNone/>
               <a:defRPr sz="1388" b="0">
                 <a:solidFill>
                   <a:srgbClr val="92BFFF"/>
@@ -5233,7 +5368,7 @@
                 <a:ea typeface="Arial"/>
                 <a:cs typeface="Arial"/>
               </a:rPr>
-              <a:t>Neste cenário: até 2h/dia, 10h/semana ou 44h/mês de espera evitada, com auxiliares disponíveis.</a:t>
+              <a:t>Medição da busca; tokens totais, latência e produtividade não foram medidos.</a:t>
             </a:r>
           </a:p>
         </p:txBody>
@@ -5283,6 +5418,7 @@
           </a:lstStyle>
           <a:p xmlns:a="http://schemas.openxmlformats.org/drawingml/2006/main">
             <a:pPr>
+              <a:buNone/>
               <a:defRPr sz="1350" b="0">
                 <a:solidFill>
                   <a:srgbClr val="70DEC9"/>
@@ -5301,7 +5437,7 @@
                 <a:ea typeface="Arial"/>
                 <a:cs typeface="Arial"/>
               </a:rPr>
-              <a:t>Equivalência de API: R$ 10,80/dia, R$ 54/semana e R$ 237,60/mês, a R$ 36/milhão hipotéticos.</a:t>
+              <a:t>Mensalidade: R$ 0 de desconto. A redução medida é de caracteres por consulta.</a:t>
             </a:r>
           </a:p>
         </p:txBody>
@@ -5351,6 +5487,7 @@
           </a:lstStyle>
           <a:p xmlns:a="http://schemas.openxmlformats.org/drawingml/2006/main">
             <a:pPr>
+              <a:buNone/>
               <a:defRPr sz="1350" b="0">
                 <a:solidFill>
                   <a:srgbClr val="F5F6F0"/>
@@ -5369,7 +5506,7 @@
                 <a:ea typeface="Arial"/>
                 <a:cs typeface="Arial"/>
               </a:rPr>
-              <a:t>Equivalência na mensalidade: R$ 0 de desconto. Ganho potencial: mais entregas e menos espera.</a:t>
+              <a:t>Consulta local em 16/10/2026 · versão 663803e · notas pessoais não publicadas.</a:t>
             </a:r>
           </a:p>
         </p:txBody>
@@ -5419,6 +5556,7 @@
           </a:lstStyle>
           <a:p xmlns:a="http://schemas.openxmlformats.org/drawingml/2006/main">
             <a:pPr>
+              <a:buNone/>
               <a:defRPr sz="825" b="0">
                 <a:solidFill>
                   <a:srgbClr val="AAB8C5"/>
@@ -5437,7 +5575,7 @@
                 <a:ea typeface="Arial"/>
                 <a:cs typeface="Arial"/>
               </a:rPr>
-              <a:t>Simulação, não medição. 8h/dia, 5 dias/semana, 22 dias/mês e cota antes de 6h. Limites reais variam. Energia e tokens auxiliares fora do cálculo.</a:t>
+              <a:t>Um cenário de consulta, não uma média das IAs. Método e reprodução: docs/BENCHMARK.md.</a:t>
             </a:r>
           </a:p>
         </p:txBody>

</xml_diff>

<commit_message>
Amplia benchmark e adiciona player com reprodução manual
</commit_message>
<xml_diff>
--- a/media/one-pager.pptx
+++ b/media/one-pager.pptx
@@ -2,13 +2,13 @@
 <file path=ppt/presentation.xml><?xml version="1.0" encoding="utf-8"?>
 <p:presentation xmlns:p="http://schemas.openxmlformats.org/presentationml/2006/main">
   <p:sldMasterIdLst>
-    <p:sldMasterId xmlns:r="http://schemas.openxmlformats.org/officeDocument/2006/relationships" id="2147483648" r:id="Rc7eb4ecff8a7416c"/>
+    <p:sldMasterId xmlns:r="http://schemas.openxmlformats.org/officeDocument/2006/relationships" id="2147483648" r:id="R28aa5915d7744153"/>
   </p:sldMasterIdLst>
   <p:notesMasterIdLst>
-    <p:notesMasterId xmlns:r="http://schemas.openxmlformats.org/officeDocument/2006/relationships" r:id="R02349d5d80804f78"/>
+    <p:notesMasterId xmlns:r="http://schemas.openxmlformats.org/officeDocument/2006/relationships" r:id="Rb3cd4b7293d44e2a"/>
   </p:notesMasterIdLst>
   <p:sldIdLst>
-    <p:sldId xmlns:r="http://schemas.openxmlformats.org/officeDocument/2006/relationships" id="256" r:id="R9db6d1d4a2fa4f88"/>
+    <p:sldId xmlns:r="http://schemas.openxmlformats.org/officeDocument/2006/relationships" id="256" r:id="R976e9abcf9db43a5"/>
   </p:sldIdLst>
   <p:sldSz cx="12192000" cy="6858000"/>
   <p:notesSz cx="6858000" cy="9144000"/>
@@ -442,27 +442,7 @@
           <a:lstStyle xmlns:a="http://schemas.openxmlformats.org/drawingml/2006/main"/>
           <a:p xmlns:a="http://schemas.openxmlformats.org/drawingml/2006/main">
             <a:r>
-              <a:t>Medição local em 16/10/2026, versão pública 663803e: comparação da mesma consulta no mesmo estado do cofre com cinco notas e orçamento de 12.000 caracteres. Saída inteira anterior: 11.961 caracteres; nova: 4.677; diferença: 7.284; redução arredondada: 60,9%. Os nomes das cinco notas e os trechos selecionados foram conferidos como idênticos; nomes de omissões e resumos não fazem parte dessa equivalência. Dados privados não acompanham a apresentação. Fonte pública do método e limites: https://github.com/nicholasbirochi/Cerebro/blob/main/docs/BENCHMARK.md.</a:t>
-            </a:r>
-          </a:p>
-          <a:p xmlns:a="http://schemas.openxmlformats.org/drawingml/2006/main">
-            <a:r>
-              <a:t/>
-            </a:r>
-          </a:p>
-          <a:p xmlns:a="http://schemas.openxmlformats.org/drawingml/2006/main">
-            <a:r>
-              <a:t>Cenário sintético distinto, reproduzível pelo script público tools/benchmark_busca.py: 40 notas relevantes, mesmas cinco notas e vinte trechos; 11.696 → 5.862 caracteres, redução de 49,9%. O padrão atual de duas notas retorna 2.495 caracteres neste cenário sintético e não compõe a comparação controlada de cinco notas.</a:t>
-            </a:r>
-          </a:p>
-          <a:p xmlns:a="http://schemas.openxmlformats.org/drawingml/2006/main">
-            <a:r>
-              <a:t/>
-            </a:r>
-          </a:p>
-          <a:p xmlns:a="http://schemas.openxmlformats.org/drawingml/2006/main">
-            <a:r>
-              <a:t>Não foram medidos tokens de entrada, saída, raciocínio, cache, consumo global de IAs, latência, produtividade ou desconto financeiro. A mensalidade permanece a mesma: R$0 de desconto. A imagem anterior apresentava uma simulação de 30% menos tokens no principal, com projeções hipotéticas de tempo e equivalência de API; foi substituída por resultados de saída da busca, sem converter caracteres em tokens ou dinheiro. O vídeo ilustrativo da arquitetura permanece inalterado.</a:t>
+              <a:t>Benchmark ampliado executado em 16/10/2026: três corpus sintéticos de40,1000e10000notas de conteúdo, mais um protocolo mínimo em cada. Maior corpus:26.918.974caracteresUnicode,28.208.929bytesUTF8, sem multiplicar por consultas ou somar prefixos repetidos. Oito consultas distintas por escala, com temas, múltiplos termos, filtro de projeto e ausência de resultado:24pares,48execuções. Mesmos limites --max5 --orcamento12000. Saída acumulada anterior210.965caracteres, atual118.299, diferença92.666, redução43,9%. Notas e trechos selecionados conferidos como idênticos em todos os pares. Reduções por escala:16,6%,50,9%,51,6%. Versão de referência40569e851506e3cd027004960f4b7d217bd0cb32. Dados, hashes e tempos observados em https://github.com/nicholasbirochi/Cerebro/blob/main/docs/benchmark-ampliado.json; método em docs/BENCHMARK.md. Tempos de uma passagem por caso, sem cache controlado ou inferência de ganho de velocidade. Não mede tokens de IA, qualidade geral, produtividade ou economia financeira. Medição local anterior60,9%em uma consulta permanece histórica, sem ser extrapolada para esta bateria. Nenhum cofre pessoal, credencial ou dado privado foi usado.</a:t>
             </a:r>
           </a:p>
         </p:txBody>
@@ -549,7 +529,7 @@
                 <a:cs typeface="+mj-lt"/>
               </a:defRPr>
             </a:defPPr>
-            <a:lvl1pPr marL="0" indent="0">
+            <a:lvl1pPr marL="0" indent="0" algn="ctr">
               <a:lnSpc>
                 <a:spcPct val="110000"/>
               </a:lnSpc>
@@ -560,9 +540,16 @@
                 <a:spcPts val="0"/>
               </a:spcAft>
               <a:buNone/>
-              <a:defRPr/>
+              <a:defRPr sz="4800" b="1">
+                <a:solidFill>
+                  <a:schemeClr val="tx1"/>
+                </a:solidFill>
+                <a:latin typeface="+mj-lt"/>
+                <a:ea typeface="+mj-lt"/>
+                <a:cs typeface="+mj-lt"/>
+              </a:defRPr>
             </a:lvl1pPr>
-            <a:lvl2pPr marL="0" indent="0">
+            <a:lvl2pPr marL="0" indent="0" algn="ctr">
               <a:lnSpc>
                 <a:spcPct val="110000"/>
               </a:lnSpc>
@@ -573,9 +560,16 @@
                 <a:spcPts val="0"/>
               </a:spcAft>
               <a:buNone/>
-              <a:defRPr/>
+              <a:defRPr sz="4800" b="1">
+                <a:solidFill>
+                  <a:schemeClr val="tx1"/>
+                </a:solidFill>
+                <a:latin typeface="+mj-lt"/>
+                <a:ea typeface="+mj-lt"/>
+                <a:cs typeface="+mj-lt"/>
+              </a:defRPr>
             </a:lvl2pPr>
-            <a:lvl3pPr marL="0" indent="0">
+            <a:lvl3pPr marL="0" indent="0" algn="ctr">
               <a:lnSpc>
                 <a:spcPct val="110000"/>
               </a:lnSpc>
@@ -586,9 +580,16 @@
                 <a:spcPts val="0"/>
               </a:spcAft>
               <a:buNone/>
-              <a:defRPr/>
+              <a:defRPr sz="4800" b="1">
+                <a:solidFill>
+                  <a:schemeClr val="tx1"/>
+                </a:solidFill>
+                <a:latin typeface="+mj-lt"/>
+                <a:ea typeface="+mj-lt"/>
+                <a:cs typeface="+mj-lt"/>
+              </a:defRPr>
             </a:lvl3pPr>
-            <a:lvl4pPr marL="0" indent="0">
+            <a:lvl4pPr marL="0" indent="0" algn="ctr">
               <a:lnSpc>
                 <a:spcPct val="110000"/>
               </a:lnSpc>
@@ -599,9 +600,16 @@
                 <a:spcPts val="0"/>
               </a:spcAft>
               <a:buNone/>
-              <a:defRPr/>
+              <a:defRPr sz="4800" b="1">
+                <a:solidFill>
+                  <a:schemeClr val="tx1"/>
+                </a:solidFill>
+                <a:latin typeface="+mj-lt"/>
+                <a:ea typeface="+mj-lt"/>
+                <a:cs typeface="+mj-lt"/>
+              </a:defRPr>
             </a:lvl4pPr>
-            <a:lvl5pPr marL="0" indent="0">
+            <a:lvl5pPr marL="0" indent="0" algn="ctr">
               <a:lnSpc>
                 <a:spcPct val="110000"/>
               </a:lnSpc>
@@ -612,9 +620,16 @@
                 <a:spcPts val="0"/>
               </a:spcAft>
               <a:buNone/>
-              <a:defRPr/>
+              <a:defRPr sz="4800" b="1">
+                <a:solidFill>
+                  <a:schemeClr val="tx1"/>
+                </a:solidFill>
+                <a:latin typeface="+mj-lt"/>
+                <a:ea typeface="+mj-lt"/>
+                <a:cs typeface="+mj-lt"/>
+              </a:defRPr>
             </a:lvl5pPr>
-            <a:lvl6pPr marL="0" indent="0">
+            <a:lvl6pPr marL="0" indent="0" algn="ctr">
               <a:lnSpc>
                 <a:spcPct val="110000"/>
               </a:lnSpc>
@@ -625,9 +640,16 @@
                 <a:spcPts val="0"/>
               </a:spcAft>
               <a:buNone/>
-              <a:defRPr/>
+              <a:defRPr sz="4800" b="1">
+                <a:solidFill>
+                  <a:schemeClr val="tx1"/>
+                </a:solidFill>
+                <a:latin typeface="+mj-lt"/>
+                <a:ea typeface="+mj-lt"/>
+                <a:cs typeface="+mj-lt"/>
+              </a:defRPr>
             </a:lvl6pPr>
-            <a:lvl7pPr marL="0" indent="0">
+            <a:lvl7pPr marL="0" indent="0" algn="ctr">
               <a:lnSpc>
                 <a:spcPct val="110000"/>
               </a:lnSpc>
@@ -638,9 +660,16 @@
                 <a:spcPts val="0"/>
               </a:spcAft>
               <a:buNone/>
-              <a:defRPr/>
+              <a:defRPr sz="4800" b="1">
+                <a:solidFill>
+                  <a:schemeClr val="tx1"/>
+                </a:solidFill>
+                <a:latin typeface="+mj-lt"/>
+                <a:ea typeface="+mj-lt"/>
+                <a:cs typeface="+mj-lt"/>
+              </a:defRPr>
             </a:lvl7pPr>
-            <a:lvl8pPr marL="0" indent="0">
+            <a:lvl8pPr marL="0" indent="0" algn="ctr">
               <a:lnSpc>
                 <a:spcPct val="110000"/>
               </a:lnSpc>
@@ -651,9 +680,16 @@
                 <a:spcPts val="0"/>
               </a:spcAft>
               <a:buNone/>
-              <a:defRPr/>
+              <a:defRPr sz="4800" b="1">
+                <a:solidFill>
+                  <a:schemeClr val="tx1"/>
+                </a:solidFill>
+                <a:latin typeface="+mj-lt"/>
+                <a:ea typeface="+mj-lt"/>
+                <a:cs typeface="+mj-lt"/>
+              </a:defRPr>
             </a:lvl8pPr>
-            <a:lvl9pPr marL="0" indent="0">
+            <a:lvl9pPr marL="0" indent="0" algn="ctr">
               <a:lnSpc>
                 <a:spcPct val="110000"/>
               </a:lnSpc>
@@ -664,7 +700,14 @@
                 <a:spcPts val="0"/>
               </a:spcAft>
               <a:buNone/>
-              <a:defRPr/>
+              <a:defRPr sz="4800" b="1">
+                <a:solidFill>
+                  <a:schemeClr val="tx1"/>
+                </a:solidFill>
+                <a:latin typeface="+mj-lt"/>
+                <a:ea typeface="+mj-lt"/>
+                <a:cs typeface="+mj-lt"/>
+              </a:defRPr>
             </a:lvl9pPr>
           </a:lstStyle>
           <a:p xmlns:a="http://schemas.openxmlformats.org/drawingml/2006/main"/>
@@ -715,7 +758,7 @@
                 <a:cs typeface="+mn-lt"/>
               </a:defRPr>
             </a:defPPr>
-            <a:lvl1pPr marL="0" indent="0">
+            <a:lvl1pPr marL="0" indent="0" algn="ctr">
               <a:lnSpc>
                 <a:spcPct val="110000"/>
               </a:lnSpc>
@@ -726,9 +769,16 @@
                 <a:spcPts val="0"/>
               </a:spcAft>
               <a:buNone/>
-              <a:defRPr/>
+              <a:defRPr sz="2100" b="0">
+                <a:solidFill>
+                  <a:schemeClr val="tx1"/>
+                </a:solidFill>
+                <a:latin typeface="+mn-lt"/>
+                <a:ea typeface="+mn-lt"/>
+                <a:cs typeface="+mn-lt"/>
+              </a:defRPr>
             </a:lvl1pPr>
-            <a:lvl2pPr marL="0" indent="0">
+            <a:lvl2pPr marL="0" indent="0" algn="ctr">
               <a:lnSpc>
                 <a:spcPct val="110000"/>
               </a:lnSpc>
@@ -739,9 +789,16 @@
                 <a:spcPts val="0"/>
               </a:spcAft>
               <a:buNone/>
-              <a:defRPr/>
+              <a:defRPr sz="2100" b="0">
+                <a:solidFill>
+                  <a:schemeClr val="tx1"/>
+                </a:solidFill>
+                <a:latin typeface="+mn-lt"/>
+                <a:ea typeface="+mn-lt"/>
+                <a:cs typeface="+mn-lt"/>
+              </a:defRPr>
             </a:lvl2pPr>
-            <a:lvl3pPr marL="0" indent="0">
+            <a:lvl3pPr marL="0" indent="0" algn="ctr">
               <a:lnSpc>
                 <a:spcPct val="110000"/>
               </a:lnSpc>
@@ -752,9 +809,16 @@
                 <a:spcPts val="0"/>
               </a:spcAft>
               <a:buNone/>
-              <a:defRPr/>
+              <a:defRPr sz="2100" b="0">
+                <a:solidFill>
+                  <a:schemeClr val="tx1"/>
+                </a:solidFill>
+                <a:latin typeface="+mn-lt"/>
+                <a:ea typeface="+mn-lt"/>
+                <a:cs typeface="+mn-lt"/>
+              </a:defRPr>
             </a:lvl3pPr>
-            <a:lvl4pPr marL="0" indent="0">
+            <a:lvl4pPr marL="0" indent="0" algn="ctr">
               <a:lnSpc>
                 <a:spcPct val="110000"/>
               </a:lnSpc>
@@ -765,9 +829,16 @@
                 <a:spcPts val="0"/>
               </a:spcAft>
               <a:buNone/>
-              <a:defRPr/>
+              <a:defRPr sz="2100" b="0">
+                <a:solidFill>
+                  <a:schemeClr val="tx1"/>
+                </a:solidFill>
+                <a:latin typeface="+mn-lt"/>
+                <a:ea typeface="+mn-lt"/>
+                <a:cs typeface="+mn-lt"/>
+              </a:defRPr>
             </a:lvl4pPr>
-            <a:lvl5pPr marL="0" indent="0">
+            <a:lvl5pPr marL="0" indent="0" algn="ctr">
               <a:lnSpc>
                 <a:spcPct val="110000"/>
               </a:lnSpc>
@@ -778,9 +849,16 @@
                 <a:spcPts val="0"/>
               </a:spcAft>
               <a:buNone/>
-              <a:defRPr/>
+              <a:defRPr sz="2100" b="0">
+                <a:solidFill>
+                  <a:schemeClr val="tx1"/>
+                </a:solidFill>
+                <a:latin typeface="+mn-lt"/>
+                <a:ea typeface="+mn-lt"/>
+                <a:cs typeface="+mn-lt"/>
+              </a:defRPr>
             </a:lvl5pPr>
-            <a:lvl6pPr marL="0" indent="0">
+            <a:lvl6pPr marL="0" indent="0" algn="ctr">
               <a:lnSpc>
                 <a:spcPct val="110000"/>
               </a:lnSpc>
@@ -791,9 +869,16 @@
                 <a:spcPts val="0"/>
               </a:spcAft>
               <a:buNone/>
-              <a:defRPr/>
+              <a:defRPr sz="2100" b="0">
+                <a:solidFill>
+                  <a:schemeClr val="tx1"/>
+                </a:solidFill>
+                <a:latin typeface="+mn-lt"/>
+                <a:ea typeface="+mn-lt"/>
+                <a:cs typeface="+mn-lt"/>
+              </a:defRPr>
             </a:lvl6pPr>
-            <a:lvl7pPr marL="0" indent="0">
+            <a:lvl7pPr marL="0" indent="0" algn="ctr">
               <a:lnSpc>
                 <a:spcPct val="110000"/>
               </a:lnSpc>
@@ -804,9 +889,16 @@
                 <a:spcPts val="0"/>
               </a:spcAft>
               <a:buNone/>
-              <a:defRPr/>
+              <a:defRPr sz="2100" b="0">
+                <a:solidFill>
+                  <a:schemeClr val="tx1"/>
+                </a:solidFill>
+                <a:latin typeface="+mn-lt"/>
+                <a:ea typeface="+mn-lt"/>
+                <a:cs typeface="+mn-lt"/>
+              </a:defRPr>
             </a:lvl7pPr>
-            <a:lvl8pPr marL="0" indent="0">
+            <a:lvl8pPr marL="0" indent="0" algn="ctr">
               <a:lnSpc>
                 <a:spcPct val="110000"/>
               </a:lnSpc>
@@ -817,9 +909,16 @@
                 <a:spcPts val="0"/>
               </a:spcAft>
               <a:buNone/>
-              <a:defRPr/>
+              <a:defRPr sz="2100" b="0">
+                <a:solidFill>
+                  <a:schemeClr val="tx1"/>
+                </a:solidFill>
+                <a:latin typeface="+mn-lt"/>
+                <a:ea typeface="+mn-lt"/>
+                <a:cs typeface="+mn-lt"/>
+              </a:defRPr>
             </a:lvl8pPr>
-            <a:lvl9pPr marL="0" indent="0">
+            <a:lvl9pPr marL="0" indent="0" algn="ctr">
               <a:lnSpc>
                 <a:spcPct val="110000"/>
               </a:lnSpc>
@@ -830,7 +929,14 @@
                 <a:spcPts val="0"/>
               </a:spcAft>
               <a:buNone/>
-              <a:defRPr/>
+              <a:defRPr sz="2100" b="0">
+                <a:solidFill>
+                  <a:schemeClr val="tx1"/>
+                </a:solidFill>
+                <a:latin typeface="+mn-lt"/>
+                <a:ea typeface="+mn-lt"/>
+                <a:cs typeface="+mn-lt"/>
+              </a:defRPr>
             </a:lvl9pPr>
           </a:lstStyle>
           <a:p xmlns:a="http://schemas.openxmlformats.org/drawingml/2006/main"/>
@@ -898,7 +1004,7 @@
                 <a:cs typeface="+mj-lt"/>
               </a:defRPr>
             </a:defPPr>
-            <a:lvl1pPr marL="0" indent="0">
+            <a:lvl1pPr marL="0" indent="0" algn="ctr">
               <a:lnSpc>
                 <a:spcPct val="110000"/>
               </a:lnSpc>
@@ -909,9 +1015,16 @@
                 <a:spcPts val="0"/>
               </a:spcAft>
               <a:buNone/>
-              <a:defRPr/>
+              <a:defRPr sz="4200" b="1">
+                <a:solidFill>
+                  <a:schemeClr val="tx1"/>
+                </a:solidFill>
+                <a:latin typeface="+mj-lt"/>
+                <a:ea typeface="+mj-lt"/>
+                <a:cs typeface="+mj-lt"/>
+              </a:defRPr>
             </a:lvl1pPr>
-            <a:lvl2pPr marL="0" indent="0">
+            <a:lvl2pPr marL="0" indent="0" algn="ctr">
               <a:lnSpc>
                 <a:spcPct val="110000"/>
               </a:lnSpc>
@@ -922,9 +1035,16 @@
                 <a:spcPts val="0"/>
               </a:spcAft>
               <a:buNone/>
-              <a:defRPr/>
+              <a:defRPr sz="4200" b="1">
+                <a:solidFill>
+                  <a:schemeClr val="tx1"/>
+                </a:solidFill>
+                <a:latin typeface="+mj-lt"/>
+                <a:ea typeface="+mj-lt"/>
+                <a:cs typeface="+mj-lt"/>
+              </a:defRPr>
             </a:lvl2pPr>
-            <a:lvl3pPr marL="0" indent="0">
+            <a:lvl3pPr marL="0" indent="0" algn="ctr">
               <a:lnSpc>
                 <a:spcPct val="110000"/>
               </a:lnSpc>
@@ -935,9 +1055,16 @@
                 <a:spcPts val="0"/>
               </a:spcAft>
               <a:buNone/>
-              <a:defRPr/>
+              <a:defRPr sz="4200" b="1">
+                <a:solidFill>
+                  <a:schemeClr val="tx1"/>
+                </a:solidFill>
+                <a:latin typeface="+mj-lt"/>
+                <a:ea typeface="+mj-lt"/>
+                <a:cs typeface="+mj-lt"/>
+              </a:defRPr>
             </a:lvl3pPr>
-            <a:lvl4pPr marL="0" indent="0">
+            <a:lvl4pPr marL="0" indent="0" algn="ctr">
               <a:lnSpc>
                 <a:spcPct val="110000"/>
               </a:lnSpc>
@@ -948,9 +1075,16 @@
                 <a:spcPts val="0"/>
               </a:spcAft>
               <a:buNone/>
-              <a:defRPr/>
+              <a:defRPr sz="4200" b="1">
+                <a:solidFill>
+                  <a:schemeClr val="tx1"/>
+                </a:solidFill>
+                <a:latin typeface="+mj-lt"/>
+                <a:ea typeface="+mj-lt"/>
+                <a:cs typeface="+mj-lt"/>
+              </a:defRPr>
             </a:lvl4pPr>
-            <a:lvl5pPr marL="0" indent="0">
+            <a:lvl5pPr marL="0" indent="0" algn="ctr">
               <a:lnSpc>
                 <a:spcPct val="110000"/>
               </a:lnSpc>
@@ -961,9 +1095,16 @@
                 <a:spcPts val="0"/>
               </a:spcAft>
               <a:buNone/>
-              <a:defRPr/>
+              <a:defRPr sz="4200" b="1">
+                <a:solidFill>
+                  <a:schemeClr val="tx1"/>
+                </a:solidFill>
+                <a:latin typeface="+mj-lt"/>
+                <a:ea typeface="+mj-lt"/>
+                <a:cs typeface="+mj-lt"/>
+              </a:defRPr>
             </a:lvl5pPr>
-            <a:lvl6pPr marL="0" indent="0">
+            <a:lvl6pPr marL="0" indent="0" algn="ctr">
               <a:lnSpc>
                 <a:spcPct val="110000"/>
               </a:lnSpc>
@@ -974,9 +1115,16 @@
                 <a:spcPts val="0"/>
               </a:spcAft>
               <a:buNone/>
-              <a:defRPr/>
+              <a:defRPr sz="4200" b="1">
+                <a:solidFill>
+                  <a:schemeClr val="tx1"/>
+                </a:solidFill>
+                <a:latin typeface="+mj-lt"/>
+                <a:ea typeface="+mj-lt"/>
+                <a:cs typeface="+mj-lt"/>
+              </a:defRPr>
             </a:lvl6pPr>
-            <a:lvl7pPr marL="0" indent="0">
+            <a:lvl7pPr marL="0" indent="0" algn="ctr">
               <a:lnSpc>
                 <a:spcPct val="110000"/>
               </a:lnSpc>
@@ -987,9 +1135,16 @@
                 <a:spcPts val="0"/>
               </a:spcAft>
               <a:buNone/>
-              <a:defRPr/>
+              <a:defRPr sz="4200" b="1">
+                <a:solidFill>
+                  <a:schemeClr val="tx1"/>
+                </a:solidFill>
+                <a:latin typeface="+mj-lt"/>
+                <a:ea typeface="+mj-lt"/>
+                <a:cs typeface="+mj-lt"/>
+              </a:defRPr>
             </a:lvl7pPr>
-            <a:lvl8pPr marL="0" indent="0">
+            <a:lvl8pPr marL="0" indent="0" algn="ctr">
               <a:lnSpc>
                 <a:spcPct val="110000"/>
               </a:lnSpc>
@@ -1000,9 +1155,16 @@
                 <a:spcPts val="0"/>
               </a:spcAft>
               <a:buNone/>
-              <a:defRPr/>
+              <a:defRPr sz="4200" b="1">
+                <a:solidFill>
+                  <a:schemeClr val="tx1"/>
+                </a:solidFill>
+                <a:latin typeface="+mj-lt"/>
+                <a:ea typeface="+mj-lt"/>
+                <a:cs typeface="+mj-lt"/>
+              </a:defRPr>
             </a:lvl8pPr>
-            <a:lvl9pPr marL="0" indent="0">
+            <a:lvl9pPr marL="0" indent="0" algn="ctr">
               <a:lnSpc>
                 <a:spcPct val="110000"/>
               </a:lnSpc>
@@ -1013,7 +1175,14 @@
                 <a:spcPts val="0"/>
               </a:spcAft>
               <a:buNone/>
-              <a:defRPr/>
+              <a:defRPr sz="4200" b="1">
+                <a:solidFill>
+                  <a:schemeClr val="tx1"/>
+                </a:solidFill>
+                <a:latin typeface="+mj-lt"/>
+                <a:ea typeface="+mj-lt"/>
+                <a:cs typeface="+mj-lt"/>
+              </a:defRPr>
             </a:lvl9pPr>
           </a:lstStyle>
           <a:p xmlns:a="http://schemas.openxmlformats.org/drawingml/2006/main"/>
@@ -1081,7 +1250,7 @@
                 <a:cs typeface="+mj-lt"/>
               </a:defRPr>
             </a:defPPr>
-            <a:lvl1pPr marL="0" indent="0">
+            <a:lvl1pPr marL="0" indent="0" algn="l">
               <a:lnSpc>
                 <a:spcPct val="110000"/>
               </a:lnSpc>
@@ -1092,9 +1261,16 @@
                 <a:spcPts val="0"/>
               </a:spcAft>
               <a:buNone/>
-              <a:defRPr/>
+              <a:defRPr sz="3300" b="1">
+                <a:solidFill>
+                  <a:schemeClr val="tx1"/>
+                </a:solidFill>
+                <a:latin typeface="+mj-lt"/>
+                <a:ea typeface="+mj-lt"/>
+                <a:cs typeface="+mj-lt"/>
+              </a:defRPr>
             </a:lvl1pPr>
-            <a:lvl2pPr marL="0" indent="0">
+            <a:lvl2pPr marL="0" indent="0" algn="l">
               <a:lnSpc>
                 <a:spcPct val="110000"/>
               </a:lnSpc>
@@ -1105,9 +1281,16 @@
                 <a:spcPts val="0"/>
               </a:spcAft>
               <a:buNone/>
-              <a:defRPr/>
+              <a:defRPr sz="3300" b="1">
+                <a:solidFill>
+                  <a:schemeClr val="tx1"/>
+                </a:solidFill>
+                <a:latin typeface="+mj-lt"/>
+                <a:ea typeface="+mj-lt"/>
+                <a:cs typeface="+mj-lt"/>
+              </a:defRPr>
             </a:lvl2pPr>
-            <a:lvl3pPr marL="0" indent="0">
+            <a:lvl3pPr marL="0" indent="0" algn="l">
               <a:lnSpc>
                 <a:spcPct val="110000"/>
               </a:lnSpc>
@@ -1118,9 +1301,16 @@
                 <a:spcPts val="0"/>
               </a:spcAft>
               <a:buNone/>
-              <a:defRPr/>
+              <a:defRPr sz="3300" b="1">
+                <a:solidFill>
+                  <a:schemeClr val="tx1"/>
+                </a:solidFill>
+                <a:latin typeface="+mj-lt"/>
+                <a:ea typeface="+mj-lt"/>
+                <a:cs typeface="+mj-lt"/>
+              </a:defRPr>
             </a:lvl3pPr>
-            <a:lvl4pPr marL="0" indent="0">
+            <a:lvl4pPr marL="0" indent="0" algn="l">
               <a:lnSpc>
                 <a:spcPct val="110000"/>
               </a:lnSpc>
@@ -1131,9 +1321,16 @@
                 <a:spcPts val="0"/>
               </a:spcAft>
               <a:buNone/>
-              <a:defRPr/>
+              <a:defRPr sz="3300" b="1">
+                <a:solidFill>
+                  <a:schemeClr val="tx1"/>
+                </a:solidFill>
+                <a:latin typeface="+mj-lt"/>
+                <a:ea typeface="+mj-lt"/>
+                <a:cs typeface="+mj-lt"/>
+              </a:defRPr>
             </a:lvl4pPr>
-            <a:lvl5pPr marL="0" indent="0">
+            <a:lvl5pPr marL="0" indent="0" algn="l">
               <a:lnSpc>
                 <a:spcPct val="110000"/>
               </a:lnSpc>
@@ -1144,9 +1341,16 @@
                 <a:spcPts val="0"/>
               </a:spcAft>
               <a:buNone/>
-              <a:defRPr/>
+              <a:defRPr sz="3300" b="1">
+                <a:solidFill>
+                  <a:schemeClr val="tx1"/>
+                </a:solidFill>
+                <a:latin typeface="+mj-lt"/>
+                <a:ea typeface="+mj-lt"/>
+                <a:cs typeface="+mj-lt"/>
+              </a:defRPr>
             </a:lvl5pPr>
-            <a:lvl6pPr marL="0" indent="0">
+            <a:lvl6pPr marL="0" indent="0" algn="l">
               <a:lnSpc>
                 <a:spcPct val="110000"/>
               </a:lnSpc>
@@ -1157,9 +1361,16 @@
                 <a:spcPts val="0"/>
               </a:spcAft>
               <a:buNone/>
-              <a:defRPr/>
+              <a:defRPr sz="3300" b="1">
+                <a:solidFill>
+                  <a:schemeClr val="tx1"/>
+                </a:solidFill>
+                <a:latin typeface="+mj-lt"/>
+                <a:ea typeface="+mj-lt"/>
+                <a:cs typeface="+mj-lt"/>
+              </a:defRPr>
             </a:lvl6pPr>
-            <a:lvl7pPr marL="0" indent="0">
+            <a:lvl7pPr marL="0" indent="0" algn="l">
               <a:lnSpc>
                 <a:spcPct val="110000"/>
               </a:lnSpc>
@@ -1170,9 +1381,16 @@
                 <a:spcPts val="0"/>
               </a:spcAft>
               <a:buNone/>
-              <a:defRPr/>
+              <a:defRPr sz="3300" b="1">
+                <a:solidFill>
+                  <a:schemeClr val="tx1"/>
+                </a:solidFill>
+                <a:latin typeface="+mj-lt"/>
+                <a:ea typeface="+mj-lt"/>
+                <a:cs typeface="+mj-lt"/>
+              </a:defRPr>
             </a:lvl7pPr>
-            <a:lvl8pPr marL="0" indent="0">
+            <a:lvl8pPr marL="0" indent="0" algn="l">
               <a:lnSpc>
                 <a:spcPct val="110000"/>
               </a:lnSpc>
@@ -1183,9 +1401,16 @@
                 <a:spcPts val="0"/>
               </a:spcAft>
               <a:buNone/>
-              <a:defRPr/>
+              <a:defRPr sz="3300" b="1">
+                <a:solidFill>
+                  <a:schemeClr val="tx1"/>
+                </a:solidFill>
+                <a:latin typeface="+mj-lt"/>
+                <a:ea typeface="+mj-lt"/>
+                <a:cs typeface="+mj-lt"/>
+              </a:defRPr>
             </a:lvl8pPr>
-            <a:lvl9pPr marL="0" indent="0">
+            <a:lvl9pPr marL="0" indent="0" algn="l">
               <a:lnSpc>
                 <a:spcPct val="110000"/>
               </a:lnSpc>
@@ -1196,7 +1421,14 @@
                 <a:spcPts val="0"/>
               </a:spcAft>
               <a:buNone/>
-              <a:defRPr/>
+              <a:defRPr sz="3300" b="1">
+                <a:solidFill>
+                  <a:schemeClr val="tx1"/>
+                </a:solidFill>
+                <a:latin typeface="+mj-lt"/>
+                <a:ea typeface="+mj-lt"/>
+                <a:cs typeface="+mj-lt"/>
+              </a:defRPr>
             </a:lvl9pPr>
           </a:lstStyle>
           <a:p xmlns:a="http://schemas.openxmlformats.org/drawingml/2006/main"/>
@@ -1247,7 +1479,7 @@
                 <a:cs typeface="+mn-lt"/>
               </a:defRPr>
             </a:defPPr>
-            <a:lvl1pPr marL="228600" indent="-228600">
+            <a:lvl1pPr marL="228600" indent="-228600" algn="l">
               <a:lnSpc>
                 <a:spcPct val="110000"/>
               </a:lnSpc>
@@ -1258,9 +1490,16 @@
                 <a:spcPts val="1200"/>
               </a:spcAft>
               <a:buChar char="•"/>
-              <a:defRPr/>
+              <a:defRPr sz="2250" b="0">
+                <a:solidFill>
+                  <a:schemeClr val="tx1"/>
+                </a:solidFill>
+                <a:latin typeface="+mn-lt"/>
+                <a:ea typeface="+mn-lt"/>
+                <a:cs typeface="+mn-lt"/>
+              </a:defRPr>
             </a:lvl1pPr>
-            <a:lvl2pPr marL="533400" indent="-228600">
+            <a:lvl2pPr marL="533400" indent="-228600" algn="l">
               <a:lnSpc>
                 <a:spcPct val="110000"/>
               </a:lnSpc>
@@ -1271,9 +1510,16 @@
                 <a:spcPts val="1200"/>
               </a:spcAft>
               <a:buChar char="•"/>
-              <a:defRPr/>
+              <a:defRPr sz="2250" b="0">
+                <a:solidFill>
+                  <a:schemeClr val="tx1"/>
+                </a:solidFill>
+                <a:latin typeface="+mn-lt"/>
+                <a:ea typeface="+mn-lt"/>
+                <a:cs typeface="+mn-lt"/>
+              </a:defRPr>
             </a:lvl2pPr>
-            <a:lvl3pPr marL="838200" indent="-228600">
+            <a:lvl3pPr marL="838200" indent="-228600" algn="l">
               <a:lnSpc>
                 <a:spcPct val="110000"/>
               </a:lnSpc>
@@ -1284,9 +1530,16 @@
                 <a:spcPts val="1200"/>
               </a:spcAft>
               <a:buChar char="•"/>
-              <a:defRPr/>
+              <a:defRPr sz="2250" b="0">
+                <a:solidFill>
+                  <a:schemeClr val="tx1"/>
+                </a:solidFill>
+                <a:latin typeface="+mn-lt"/>
+                <a:ea typeface="+mn-lt"/>
+                <a:cs typeface="+mn-lt"/>
+              </a:defRPr>
             </a:lvl3pPr>
-            <a:lvl4pPr marL="1143000" indent="-228600">
+            <a:lvl4pPr marL="1143000" indent="-228600" algn="l">
               <a:lnSpc>
                 <a:spcPct val="110000"/>
               </a:lnSpc>
@@ -1297,9 +1550,16 @@
                 <a:spcPts val="1200"/>
               </a:spcAft>
               <a:buChar char="•"/>
-              <a:defRPr/>
+              <a:defRPr sz="2250" b="0">
+                <a:solidFill>
+                  <a:schemeClr val="tx1"/>
+                </a:solidFill>
+                <a:latin typeface="+mn-lt"/>
+                <a:ea typeface="+mn-lt"/>
+                <a:cs typeface="+mn-lt"/>
+              </a:defRPr>
             </a:lvl4pPr>
-            <a:lvl5pPr marL="1447800" indent="-228600">
+            <a:lvl5pPr marL="1447800" indent="-228600" algn="l">
               <a:lnSpc>
                 <a:spcPct val="110000"/>
               </a:lnSpc>
@@ -1310,9 +1570,16 @@
                 <a:spcPts val="1200"/>
               </a:spcAft>
               <a:buChar char="•"/>
-              <a:defRPr/>
+              <a:defRPr sz="2250" b="0">
+                <a:solidFill>
+                  <a:schemeClr val="tx1"/>
+                </a:solidFill>
+                <a:latin typeface="+mn-lt"/>
+                <a:ea typeface="+mn-lt"/>
+                <a:cs typeface="+mn-lt"/>
+              </a:defRPr>
             </a:lvl5pPr>
-            <a:lvl6pPr marL="1752600" indent="-228600">
+            <a:lvl6pPr marL="1752600" indent="-228600" algn="l">
               <a:lnSpc>
                 <a:spcPct val="110000"/>
               </a:lnSpc>
@@ -1323,9 +1590,16 @@
                 <a:spcPts val="1200"/>
               </a:spcAft>
               <a:buChar char="•"/>
-              <a:defRPr/>
+              <a:defRPr sz="2250" b="0">
+                <a:solidFill>
+                  <a:schemeClr val="tx1"/>
+                </a:solidFill>
+                <a:latin typeface="+mn-lt"/>
+                <a:ea typeface="+mn-lt"/>
+                <a:cs typeface="+mn-lt"/>
+              </a:defRPr>
             </a:lvl6pPr>
-            <a:lvl7pPr marL="2057400" indent="-228600">
+            <a:lvl7pPr marL="2057400" indent="-228600" algn="l">
               <a:lnSpc>
                 <a:spcPct val="110000"/>
               </a:lnSpc>
@@ -1336,9 +1610,16 @@
                 <a:spcPts val="1200"/>
               </a:spcAft>
               <a:buChar char="•"/>
-              <a:defRPr/>
+              <a:defRPr sz="2250" b="0">
+                <a:solidFill>
+                  <a:schemeClr val="tx1"/>
+                </a:solidFill>
+                <a:latin typeface="+mn-lt"/>
+                <a:ea typeface="+mn-lt"/>
+                <a:cs typeface="+mn-lt"/>
+              </a:defRPr>
             </a:lvl7pPr>
-            <a:lvl8pPr marL="2362200" indent="-228600">
+            <a:lvl8pPr marL="2362200" indent="-228600" algn="l">
               <a:lnSpc>
                 <a:spcPct val="110000"/>
               </a:lnSpc>
@@ -1349,9 +1630,16 @@
                 <a:spcPts val="1200"/>
               </a:spcAft>
               <a:buChar char="•"/>
-              <a:defRPr/>
+              <a:defRPr sz="2250" b="0">
+                <a:solidFill>
+                  <a:schemeClr val="tx1"/>
+                </a:solidFill>
+                <a:latin typeface="+mn-lt"/>
+                <a:ea typeface="+mn-lt"/>
+                <a:cs typeface="+mn-lt"/>
+              </a:defRPr>
             </a:lvl8pPr>
-            <a:lvl9pPr marL="2667000" indent="-228600">
+            <a:lvl9pPr marL="2667000" indent="-228600" algn="l">
               <a:lnSpc>
                 <a:spcPct val="110000"/>
               </a:lnSpc>
@@ -1362,7 +1650,14 @@
                 <a:spcPts val="1200"/>
               </a:spcAft>
               <a:buChar char="•"/>
-              <a:defRPr/>
+              <a:defRPr sz="2250" b="0">
+                <a:solidFill>
+                  <a:schemeClr val="tx1"/>
+                </a:solidFill>
+                <a:latin typeface="+mn-lt"/>
+                <a:ea typeface="+mn-lt"/>
+                <a:cs typeface="+mn-lt"/>
+              </a:defRPr>
             </a:lvl9pPr>
           </a:lstStyle>
           <a:p xmlns:a="http://schemas.openxmlformats.org/drawingml/2006/main"/>
@@ -1430,7 +1725,7 @@
                 <a:cs typeface="+mj-lt"/>
               </a:defRPr>
             </a:defPPr>
-            <a:lvl1pPr marL="0" indent="0">
+            <a:lvl1pPr marL="0" indent="0" algn="l">
               <a:lnSpc>
                 <a:spcPct val="110000"/>
               </a:lnSpc>
@@ -1441,9 +1736,16 @@
                 <a:spcPts val="0"/>
               </a:spcAft>
               <a:buNone/>
-              <a:defRPr/>
+              <a:defRPr sz="3300" b="1">
+                <a:solidFill>
+                  <a:schemeClr val="tx1"/>
+                </a:solidFill>
+                <a:latin typeface="+mj-lt"/>
+                <a:ea typeface="+mj-lt"/>
+                <a:cs typeface="+mj-lt"/>
+              </a:defRPr>
             </a:lvl1pPr>
-            <a:lvl2pPr marL="0" indent="0">
+            <a:lvl2pPr marL="0" indent="0" algn="l">
               <a:lnSpc>
                 <a:spcPct val="110000"/>
               </a:lnSpc>
@@ -1454,9 +1756,16 @@
                 <a:spcPts val="0"/>
               </a:spcAft>
               <a:buNone/>
-              <a:defRPr/>
+              <a:defRPr sz="3300" b="1">
+                <a:solidFill>
+                  <a:schemeClr val="tx1"/>
+                </a:solidFill>
+                <a:latin typeface="+mj-lt"/>
+                <a:ea typeface="+mj-lt"/>
+                <a:cs typeface="+mj-lt"/>
+              </a:defRPr>
             </a:lvl2pPr>
-            <a:lvl3pPr marL="0" indent="0">
+            <a:lvl3pPr marL="0" indent="0" algn="l">
               <a:lnSpc>
                 <a:spcPct val="110000"/>
               </a:lnSpc>
@@ -1467,9 +1776,16 @@
                 <a:spcPts val="0"/>
               </a:spcAft>
               <a:buNone/>
-              <a:defRPr/>
+              <a:defRPr sz="3300" b="1">
+                <a:solidFill>
+                  <a:schemeClr val="tx1"/>
+                </a:solidFill>
+                <a:latin typeface="+mj-lt"/>
+                <a:ea typeface="+mj-lt"/>
+                <a:cs typeface="+mj-lt"/>
+              </a:defRPr>
             </a:lvl3pPr>
-            <a:lvl4pPr marL="0" indent="0">
+            <a:lvl4pPr marL="0" indent="0" algn="l">
               <a:lnSpc>
                 <a:spcPct val="110000"/>
               </a:lnSpc>
@@ -1480,9 +1796,16 @@
                 <a:spcPts val="0"/>
               </a:spcAft>
               <a:buNone/>
-              <a:defRPr/>
+              <a:defRPr sz="3300" b="1">
+                <a:solidFill>
+                  <a:schemeClr val="tx1"/>
+                </a:solidFill>
+                <a:latin typeface="+mj-lt"/>
+                <a:ea typeface="+mj-lt"/>
+                <a:cs typeface="+mj-lt"/>
+              </a:defRPr>
             </a:lvl4pPr>
-            <a:lvl5pPr marL="0" indent="0">
+            <a:lvl5pPr marL="0" indent="0" algn="l">
               <a:lnSpc>
                 <a:spcPct val="110000"/>
               </a:lnSpc>
@@ -1493,9 +1816,16 @@
                 <a:spcPts val="0"/>
               </a:spcAft>
               <a:buNone/>
-              <a:defRPr/>
+              <a:defRPr sz="3300" b="1">
+                <a:solidFill>
+                  <a:schemeClr val="tx1"/>
+                </a:solidFill>
+                <a:latin typeface="+mj-lt"/>
+                <a:ea typeface="+mj-lt"/>
+                <a:cs typeface="+mj-lt"/>
+              </a:defRPr>
             </a:lvl5pPr>
-            <a:lvl6pPr marL="0" indent="0">
+            <a:lvl6pPr marL="0" indent="0" algn="l">
               <a:lnSpc>
                 <a:spcPct val="110000"/>
               </a:lnSpc>
@@ -1506,9 +1836,16 @@
                 <a:spcPts val="0"/>
               </a:spcAft>
               <a:buNone/>
-              <a:defRPr/>
+              <a:defRPr sz="3300" b="1">
+                <a:solidFill>
+                  <a:schemeClr val="tx1"/>
+                </a:solidFill>
+                <a:latin typeface="+mj-lt"/>
+                <a:ea typeface="+mj-lt"/>
+                <a:cs typeface="+mj-lt"/>
+              </a:defRPr>
             </a:lvl6pPr>
-            <a:lvl7pPr marL="0" indent="0">
+            <a:lvl7pPr marL="0" indent="0" algn="l">
               <a:lnSpc>
                 <a:spcPct val="110000"/>
               </a:lnSpc>
@@ -1519,9 +1856,16 @@
                 <a:spcPts val="0"/>
               </a:spcAft>
               <a:buNone/>
-              <a:defRPr/>
+              <a:defRPr sz="3300" b="1">
+                <a:solidFill>
+                  <a:schemeClr val="tx1"/>
+                </a:solidFill>
+                <a:latin typeface="+mj-lt"/>
+                <a:ea typeface="+mj-lt"/>
+                <a:cs typeface="+mj-lt"/>
+              </a:defRPr>
             </a:lvl7pPr>
-            <a:lvl8pPr marL="0" indent="0">
+            <a:lvl8pPr marL="0" indent="0" algn="l">
               <a:lnSpc>
                 <a:spcPct val="110000"/>
               </a:lnSpc>
@@ -1532,9 +1876,16 @@
                 <a:spcPts val="0"/>
               </a:spcAft>
               <a:buNone/>
-              <a:defRPr/>
+              <a:defRPr sz="3300" b="1">
+                <a:solidFill>
+                  <a:schemeClr val="tx1"/>
+                </a:solidFill>
+                <a:latin typeface="+mj-lt"/>
+                <a:ea typeface="+mj-lt"/>
+                <a:cs typeface="+mj-lt"/>
+              </a:defRPr>
             </a:lvl8pPr>
-            <a:lvl9pPr marL="0" indent="0">
+            <a:lvl9pPr marL="0" indent="0" algn="l">
               <a:lnSpc>
                 <a:spcPct val="110000"/>
               </a:lnSpc>
@@ -1545,7 +1896,14 @@
                 <a:spcPts val="0"/>
               </a:spcAft>
               <a:buNone/>
-              <a:defRPr/>
+              <a:defRPr sz="3300" b="1">
+                <a:solidFill>
+                  <a:schemeClr val="tx1"/>
+                </a:solidFill>
+                <a:latin typeface="+mj-lt"/>
+                <a:ea typeface="+mj-lt"/>
+                <a:cs typeface="+mj-lt"/>
+              </a:defRPr>
             </a:lvl9pPr>
           </a:lstStyle>
           <a:p xmlns:a="http://schemas.openxmlformats.org/drawingml/2006/main"/>
@@ -1596,7 +1954,7 @@
                 <a:cs typeface="+mn-lt"/>
               </a:defRPr>
             </a:defPPr>
-            <a:lvl1pPr marL="228600" indent="-228600">
+            <a:lvl1pPr marL="228600" indent="-228600" algn="l">
               <a:lnSpc>
                 <a:spcPct val="110000"/>
               </a:lnSpc>
@@ -1607,9 +1965,16 @@
                 <a:spcPts val="1200"/>
               </a:spcAft>
               <a:buChar char="•"/>
-              <a:defRPr/>
+              <a:defRPr sz="2100" b="0">
+                <a:solidFill>
+                  <a:schemeClr val="tx1"/>
+                </a:solidFill>
+                <a:latin typeface="+mn-lt"/>
+                <a:ea typeface="+mn-lt"/>
+                <a:cs typeface="+mn-lt"/>
+              </a:defRPr>
             </a:lvl1pPr>
-            <a:lvl2pPr marL="533400" indent="-228600">
+            <a:lvl2pPr marL="533400" indent="-228600" algn="l">
               <a:lnSpc>
                 <a:spcPct val="110000"/>
               </a:lnSpc>
@@ -1620,9 +1985,16 @@
                 <a:spcPts val="1200"/>
               </a:spcAft>
               <a:buChar char="•"/>
-              <a:defRPr/>
+              <a:defRPr sz="2100" b="0">
+                <a:solidFill>
+                  <a:schemeClr val="tx1"/>
+                </a:solidFill>
+                <a:latin typeface="+mn-lt"/>
+                <a:ea typeface="+mn-lt"/>
+                <a:cs typeface="+mn-lt"/>
+              </a:defRPr>
             </a:lvl2pPr>
-            <a:lvl3pPr marL="838200" indent="-228600">
+            <a:lvl3pPr marL="838200" indent="-228600" algn="l">
               <a:lnSpc>
                 <a:spcPct val="110000"/>
               </a:lnSpc>
@@ -1633,9 +2005,16 @@
                 <a:spcPts val="1200"/>
               </a:spcAft>
               <a:buChar char="•"/>
-              <a:defRPr/>
+              <a:defRPr sz="2100" b="0">
+                <a:solidFill>
+                  <a:schemeClr val="tx1"/>
+                </a:solidFill>
+                <a:latin typeface="+mn-lt"/>
+                <a:ea typeface="+mn-lt"/>
+                <a:cs typeface="+mn-lt"/>
+              </a:defRPr>
             </a:lvl3pPr>
-            <a:lvl4pPr marL="1143000" indent="-228600">
+            <a:lvl4pPr marL="1143000" indent="-228600" algn="l">
               <a:lnSpc>
                 <a:spcPct val="110000"/>
               </a:lnSpc>
@@ -1646,9 +2025,16 @@
                 <a:spcPts val="1200"/>
               </a:spcAft>
               <a:buChar char="•"/>
-              <a:defRPr/>
+              <a:defRPr sz="2100" b="0">
+                <a:solidFill>
+                  <a:schemeClr val="tx1"/>
+                </a:solidFill>
+                <a:latin typeface="+mn-lt"/>
+                <a:ea typeface="+mn-lt"/>
+                <a:cs typeface="+mn-lt"/>
+              </a:defRPr>
             </a:lvl4pPr>
-            <a:lvl5pPr marL="1447800" indent="-228600">
+            <a:lvl5pPr marL="1447800" indent="-228600" algn="l">
               <a:lnSpc>
                 <a:spcPct val="110000"/>
               </a:lnSpc>
@@ -1659,9 +2045,16 @@
                 <a:spcPts val="1200"/>
               </a:spcAft>
               <a:buChar char="•"/>
-              <a:defRPr/>
+              <a:defRPr sz="2100" b="0">
+                <a:solidFill>
+                  <a:schemeClr val="tx1"/>
+                </a:solidFill>
+                <a:latin typeface="+mn-lt"/>
+                <a:ea typeface="+mn-lt"/>
+                <a:cs typeface="+mn-lt"/>
+              </a:defRPr>
             </a:lvl5pPr>
-            <a:lvl6pPr marL="1752600" indent="-228600">
+            <a:lvl6pPr marL="1752600" indent="-228600" algn="l">
               <a:lnSpc>
                 <a:spcPct val="110000"/>
               </a:lnSpc>
@@ -1672,9 +2065,16 @@
                 <a:spcPts val="1200"/>
               </a:spcAft>
               <a:buChar char="•"/>
-              <a:defRPr/>
+              <a:defRPr sz="2100" b="0">
+                <a:solidFill>
+                  <a:schemeClr val="tx1"/>
+                </a:solidFill>
+                <a:latin typeface="+mn-lt"/>
+                <a:ea typeface="+mn-lt"/>
+                <a:cs typeface="+mn-lt"/>
+              </a:defRPr>
             </a:lvl6pPr>
-            <a:lvl7pPr marL="2057400" indent="-228600">
+            <a:lvl7pPr marL="2057400" indent="-228600" algn="l">
               <a:lnSpc>
                 <a:spcPct val="110000"/>
               </a:lnSpc>
@@ -1685,9 +2085,16 @@
                 <a:spcPts val="1200"/>
               </a:spcAft>
               <a:buChar char="•"/>
-              <a:defRPr/>
+              <a:defRPr sz="2100" b="0">
+                <a:solidFill>
+                  <a:schemeClr val="tx1"/>
+                </a:solidFill>
+                <a:latin typeface="+mn-lt"/>
+                <a:ea typeface="+mn-lt"/>
+                <a:cs typeface="+mn-lt"/>
+              </a:defRPr>
             </a:lvl7pPr>
-            <a:lvl8pPr marL="2362200" indent="-228600">
+            <a:lvl8pPr marL="2362200" indent="-228600" algn="l">
               <a:lnSpc>
                 <a:spcPct val="110000"/>
               </a:lnSpc>
@@ -1698,9 +2105,16 @@
                 <a:spcPts val="1200"/>
               </a:spcAft>
               <a:buChar char="•"/>
-              <a:defRPr/>
+              <a:defRPr sz="2100" b="0">
+                <a:solidFill>
+                  <a:schemeClr val="tx1"/>
+                </a:solidFill>
+                <a:latin typeface="+mn-lt"/>
+                <a:ea typeface="+mn-lt"/>
+                <a:cs typeface="+mn-lt"/>
+              </a:defRPr>
             </a:lvl8pPr>
-            <a:lvl9pPr marL="2667000" indent="-228600">
+            <a:lvl9pPr marL="2667000" indent="-228600" algn="l">
               <a:lnSpc>
                 <a:spcPct val="110000"/>
               </a:lnSpc>
@@ -1711,7 +2125,14 @@
                 <a:spcPts val="1200"/>
               </a:spcAft>
               <a:buChar char="•"/>
-              <a:defRPr/>
+              <a:defRPr sz="2100" b="0">
+                <a:solidFill>
+                  <a:schemeClr val="tx1"/>
+                </a:solidFill>
+                <a:latin typeface="+mn-lt"/>
+                <a:ea typeface="+mn-lt"/>
+                <a:cs typeface="+mn-lt"/>
+              </a:defRPr>
             </a:lvl9pPr>
           </a:lstStyle>
           <a:p xmlns:a="http://schemas.openxmlformats.org/drawingml/2006/main"/>
@@ -1762,7 +2183,7 @@
                 <a:cs typeface="+mn-lt"/>
               </a:defRPr>
             </a:defPPr>
-            <a:lvl1pPr marL="228600" indent="-228600">
+            <a:lvl1pPr marL="228600" indent="-228600" algn="l">
               <a:lnSpc>
                 <a:spcPct val="110000"/>
               </a:lnSpc>
@@ -1773,9 +2194,16 @@
                 <a:spcPts val="1200"/>
               </a:spcAft>
               <a:buChar char="•"/>
-              <a:defRPr/>
+              <a:defRPr sz="2100" b="0">
+                <a:solidFill>
+                  <a:schemeClr val="tx1"/>
+                </a:solidFill>
+                <a:latin typeface="+mn-lt"/>
+                <a:ea typeface="+mn-lt"/>
+                <a:cs typeface="+mn-lt"/>
+              </a:defRPr>
             </a:lvl1pPr>
-            <a:lvl2pPr marL="533400" indent="-228600">
+            <a:lvl2pPr marL="533400" indent="-228600" algn="l">
               <a:lnSpc>
                 <a:spcPct val="110000"/>
               </a:lnSpc>
@@ -1786,9 +2214,16 @@
                 <a:spcPts val="1200"/>
               </a:spcAft>
               <a:buChar char="•"/>
-              <a:defRPr/>
+              <a:defRPr sz="2100" b="0">
+                <a:solidFill>
+                  <a:schemeClr val="tx1"/>
+                </a:solidFill>
+                <a:latin typeface="+mn-lt"/>
+                <a:ea typeface="+mn-lt"/>
+                <a:cs typeface="+mn-lt"/>
+              </a:defRPr>
             </a:lvl2pPr>
-            <a:lvl3pPr marL="838200" indent="-228600">
+            <a:lvl3pPr marL="838200" indent="-228600" algn="l">
               <a:lnSpc>
                 <a:spcPct val="110000"/>
               </a:lnSpc>
@@ -1799,9 +2234,16 @@
                 <a:spcPts val="1200"/>
               </a:spcAft>
               <a:buChar char="•"/>
-              <a:defRPr/>
+              <a:defRPr sz="2100" b="0">
+                <a:solidFill>
+                  <a:schemeClr val="tx1"/>
+                </a:solidFill>
+                <a:latin typeface="+mn-lt"/>
+                <a:ea typeface="+mn-lt"/>
+                <a:cs typeface="+mn-lt"/>
+              </a:defRPr>
             </a:lvl3pPr>
-            <a:lvl4pPr marL="1143000" indent="-228600">
+            <a:lvl4pPr marL="1143000" indent="-228600" algn="l">
               <a:lnSpc>
                 <a:spcPct val="110000"/>
               </a:lnSpc>
@@ -1812,9 +2254,16 @@
                 <a:spcPts val="1200"/>
               </a:spcAft>
               <a:buChar char="•"/>
-              <a:defRPr/>
+              <a:defRPr sz="2100" b="0">
+                <a:solidFill>
+                  <a:schemeClr val="tx1"/>
+                </a:solidFill>
+                <a:latin typeface="+mn-lt"/>
+                <a:ea typeface="+mn-lt"/>
+                <a:cs typeface="+mn-lt"/>
+              </a:defRPr>
             </a:lvl4pPr>
-            <a:lvl5pPr marL="1447800" indent="-228600">
+            <a:lvl5pPr marL="1447800" indent="-228600" algn="l">
               <a:lnSpc>
                 <a:spcPct val="110000"/>
               </a:lnSpc>
@@ -1825,9 +2274,16 @@
                 <a:spcPts val="1200"/>
               </a:spcAft>
               <a:buChar char="•"/>
-              <a:defRPr/>
+              <a:defRPr sz="2100" b="0">
+                <a:solidFill>
+                  <a:schemeClr val="tx1"/>
+                </a:solidFill>
+                <a:latin typeface="+mn-lt"/>
+                <a:ea typeface="+mn-lt"/>
+                <a:cs typeface="+mn-lt"/>
+              </a:defRPr>
             </a:lvl5pPr>
-            <a:lvl6pPr marL="1752600" indent="-228600">
+            <a:lvl6pPr marL="1752600" indent="-228600" algn="l">
               <a:lnSpc>
                 <a:spcPct val="110000"/>
               </a:lnSpc>
@@ -1838,9 +2294,16 @@
                 <a:spcPts val="1200"/>
               </a:spcAft>
               <a:buChar char="•"/>
-              <a:defRPr/>
+              <a:defRPr sz="2100" b="0">
+                <a:solidFill>
+                  <a:schemeClr val="tx1"/>
+                </a:solidFill>
+                <a:latin typeface="+mn-lt"/>
+                <a:ea typeface="+mn-lt"/>
+                <a:cs typeface="+mn-lt"/>
+              </a:defRPr>
             </a:lvl6pPr>
-            <a:lvl7pPr marL="2057400" indent="-228600">
+            <a:lvl7pPr marL="2057400" indent="-228600" algn="l">
               <a:lnSpc>
                 <a:spcPct val="110000"/>
               </a:lnSpc>
@@ -1851,9 +2314,16 @@
                 <a:spcPts val="1200"/>
               </a:spcAft>
               <a:buChar char="•"/>
-              <a:defRPr/>
+              <a:defRPr sz="2100" b="0">
+                <a:solidFill>
+                  <a:schemeClr val="tx1"/>
+                </a:solidFill>
+                <a:latin typeface="+mn-lt"/>
+                <a:ea typeface="+mn-lt"/>
+                <a:cs typeface="+mn-lt"/>
+              </a:defRPr>
             </a:lvl7pPr>
-            <a:lvl8pPr marL="2362200" indent="-228600">
+            <a:lvl8pPr marL="2362200" indent="-228600" algn="l">
               <a:lnSpc>
                 <a:spcPct val="110000"/>
               </a:lnSpc>
@@ -1864,9 +2334,16 @@
                 <a:spcPts val="1200"/>
               </a:spcAft>
               <a:buChar char="•"/>
-              <a:defRPr/>
+              <a:defRPr sz="2100" b="0">
+                <a:solidFill>
+                  <a:schemeClr val="tx1"/>
+                </a:solidFill>
+                <a:latin typeface="+mn-lt"/>
+                <a:ea typeface="+mn-lt"/>
+                <a:cs typeface="+mn-lt"/>
+              </a:defRPr>
             </a:lvl8pPr>
-            <a:lvl9pPr marL="2667000" indent="-228600">
+            <a:lvl9pPr marL="2667000" indent="-228600" algn="l">
               <a:lnSpc>
                 <a:spcPct val="110000"/>
               </a:lnSpc>
@@ -1877,7 +2354,14 @@
                 <a:spcPts val="1200"/>
               </a:spcAft>
               <a:buChar char="•"/>
-              <a:defRPr/>
+              <a:defRPr sz="2100" b="0">
+                <a:solidFill>
+                  <a:schemeClr val="tx1"/>
+                </a:solidFill>
+                <a:latin typeface="+mn-lt"/>
+                <a:ea typeface="+mn-lt"/>
+                <a:cs typeface="+mn-lt"/>
+              </a:defRPr>
             </a:lvl9pPr>
           </a:lstStyle>
           <a:p xmlns:a="http://schemas.openxmlformats.org/drawingml/2006/main"/>
@@ -1945,7 +2429,7 @@
                 <a:cs typeface="+mj-lt"/>
               </a:defRPr>
             </a:defPPr>
-            <a:lvl1pPr marL="0" indent="0">
+            <a:lvl1pPr marL="0" indent="0" algn="l">
               <a:lnSpc>
                 <a:spcPct val="110000"/>
               </a:lnSpc>
@@ -1956,9 +2440,16 @@
                 <a:spcPts val="0"/>
               </a:spcAft>
               <a:buNone/>
-              <a:defRPr/>
+              <a:defRPr sz="3300" b="1">
+                <a:solidFill>
+                  <a:schemeClr val="tx1"/>
+                </a:solidFill>
+                <a:latin typeface="+mj-lt"/>
+                <a:ea typeface="+mj-lt"/>
+                <a:cs typeface="+mj-lt"/>
+              </a:defRPr>
             </a:lvl1pPr>
-            <a:lvl2pPr marL="0" indent="0">
+            <a:lvl2pPr marL="0" indent="0" algn="l">
               <a:lnSpc>
                 <a:spcPct val="110000"/>
               </a:lnSpc>
@@ -1969,9 +2460,16 @@
                 <a:spcPts val="0"/>
               </a:spcAft>
               <a:buNone/>
-              <a:defRPr/>
+              <a:defRPr sz="3300" b="1">
+                <a:solidFill>
+                  <a:schemeClr val="tx1"/>
+                </a:solidFill>
+                <a:latin typeface="+mj-lt"/>
+                <a:ea typeface="+mj-lt"/>
+                <a:cs typeface="+mj-lt"/>
+              </a:defRPr>
             </a:lvl2pPr>
-            <a:lvl3pPr marL="0" indent="0">
+            <a:lvl3pPr marL="0" indent="0" algn="l">
               <a:lnSpc>
                 <a:spcPct val="110000"/>
               </a:lnSpc>
@@ -1982,9 +2480,16 @@
                 <a:spcPts val="0"/>
               </a:spcAft>
               <a:buNone/>
-              <a:defRPr/>
+              <a:defRPr sz="3300" b="1">
+                <a:solidFill>
+                  <a:schemeClr val="tx1"/>
+                </a:solidFill>
+                <a:latin typeface="+mj-lt"/>
+                <a:ea typeface="+mj-lt"/>
+                <a:cs typeface="+mj-lt"/>
+              </a:defRPr>
             </a:lvl3pPr>
-            <a:lvl4pPr marL="0" indent="0">
+            <a:lvl4pPr marL="0" indent="0" algn="l">
               <a:lnSpc>
                 <a:spcPct val="110000"/>
               </a:lnSpc>
@@ -1995,9 +2500,16 @@
                 <a:spcPts val="0"/>
               </a:spcAft>
               <a:buNone/>
-              <a:defRPr/>
+              <a:defRPr sz="3300" b="1">
+                <a:solidFill>
+                  <a:schemeClr val="tx1"/>
+                </a:solidFill>
+                <a:latin typeface="+mj-lt"/>
+                <a:ea typeface="+mj-lt"/>
+                <a:cs typeface="+mj-lt"/>
+              </a:defRPr>
             </a:lvl4pPr>
-            <a:lvl5pPr marL="0" indent="0">
+            <a:lvl5pPr marL="0" indent="0" algn="l">
               <a:lnSpc>
                 <a:spcPct val="110000"/>
               </a:lnSpc>
@@ -2008,9 +2520,16 @@
                 <a:spcPts val="0"/>
               </a:spcAft>
               <a:buNone/>
-              <a:defRPr/>
+              <a:defRPr sz="3300" b="1">
+                <a:solidFill>
+                  <a:schemeClr val="tx1"/>
+                </a:solidFill>
+                <a:latin typeface="+mj-lt"/>
+                <a:ea typeface="+mj-lt"/>
+                <a:cs typeface="+mj-lt"/>
+              </a:defRPr>
             </a:lvl5pPr>
-            <a:lvl6pPr marL="0" indent="0">
+            <a:lvl6pPr marL="0" indent="0" algn="l">
               <a:lnSpc>
                 <a:spcPct val="110000"/>
               </a:lnSpc>
@@ -2021,9 +2540,16 @@
                 <a:spcPts val="0"/>
               </a:spcAft>
               <a:buNone/>
-              <a:defRPr/>
+              <a:defRPr sz="3300" b="1">
+                <a:solidFill>
+                  <a:schemeClr val="tx1"/>
+                </a:solidFill>
+                <a:latin typeface="+mj-lt"/>
+                <a:ea typeface="+mj-lt"/>
+                <a:cs typeface="+mj-lt"/>
+              </a:defRPr>
             </a:lvl6pPr>
-            <a:lvl7pPr marL="0" indent="0">
+            <a:lvl7pPr marL="0" indent="0" algn="l">
               <a:lnSpc>
                 <a:spcPct val="110000"/>
               </a:lnSpc>
@@ -2034,9 +2560,16 @@
                 <a:spcPts val="0"/>
               </a:spcAft>
               <a:buNone/>
-              <a:defRPr/>
+              <a:defRPr sz="3300" b="1">
+                <a:solidFill>
+                  <a:schemeClr val="tx1"/>
+                </a:solidFill>
+                <a:latin typeface="+mj-lt"/>
+                <a:ea typeface="+mj-lt"/>
+                <a:cs typeface="+mj-lt"/>
+              </a:defRPr>
             </a:lvl7pPr>
-            <a:lvl8pPr marL="0" indent="0">
+            <a:lvl8pPr marL="0" indent="0" algn="l">
               <a:lnSpc>
                 <a:spcPct val="110000"/>
               </a:lnSpc>
@@ -2047,9 +2580,16 @@
                 <a:spcPts val="0"/>
               </a:spcAft>
               <a:buNone/>
-              <a:defRPr/>
+              <a:defRPr sz="3300" b="1">
+                <a:solidFill>
+                  <a:schemeClr val="tx1"/>
+                </a:solidFill>
+                <a:latin typeface="+mj-lt"/>
+                <a:ea typeface="+mj-lt"/>
+                <a:cs typeface="+mj-lt"/>
+              </a:defRPr>
             </a:lvl8pPr>
-            <a:lvl9pPr marL="0" indent="0">
+            <a:lvl9pPr marL="0" indent="0" algn="l">
               <a:lnSpc>
                 <a:spcPct val="110000"/>
               </a:lnSpc>
@@ -2060,7 +2600,14 @@
                 <a:spcPts val="0"/>
               </a:spcAft>
               <a:buNone/>
-              <a:defRPr/>
+              <a:defRPr sz="3300" b="1">
+                <a:solidFill>
+                  <a:schemeClr val="tx1"/>
+                </a:solidFill>
+                <a:latin typeface="+mj-lt"/>
+                <a:ea typeface="+mj-lt"/>
+                <a:cs typeface="+mj-lt"/>
+              </a:defRPr>
             </a:lvl9pPr>
           </a:lstStyle>
           <a:p xmlns:a="http://schemas.openxmlformats.org/drawingml/2006/main"/>
@@ -2111,7 +2658,7 @@
                 <a:cs typeface="+mn-lt"/>
               </a:defRPr>
             </a:defPPr>
-            <a:lvl1pPr marL="228600" indent="-228600">
+            <a:lvl1pPr marL="228600" indent="-228600" algn="l">
               <a:lnSpc>
                 <a:spcPct val="110000"/>
               </a:lnSpc>
@@ -2122,9 +2669,16 @@
                 <a:spcPts val="1200"/>
               </a:spcAft>
               <a:buChar char="•"/>
-              <a:defRPr/>
+              <a:defRPr sz="2250" b="0">
+                <a:solidFill>
+                  <a:schemeClr val="tx1"/>
+                </a:solidFill>
+                <a:latin typeface="+mn-lt"/>
+                <a:ea typeface="+mn-lt"/>
+                <a:cs typeface="+mn-lt"/>
+              </a:defRPr>
             </a:lvl1pPr>
-            <a:lvl2pPr marL="533400" indent="-228600">
+            <a:lvl2pPr marL="533400" indent="-228600" algn="l">
               <a:lnSpc>
                 <a:spcPct val="110000"/>
               </a:lnSpc>
@@ -2135,9 +2689,16 @@
                 <a:spcPts val="1200"/>
               </a:spcAft>
               <a:buChar char="•"/>
-              <a:defRPr/>
+              <a:defRPr sz="2250" b="0">
+                <a:solidFill>
+                  <a:schemeClr val="tx1"/>
+                </a:solidFill>
+                <a:latin typeface="+mn-lt"/>
+                <a:ea typeface="+mn-lt"/>
+                <a:cs typeface="+mn-lt"/>
+              </a:defRPr>
             </a:lvl2pPr>
-            <a:lvl3pPr marL="838200" indent="-228600">
+            <a:lvl3pPr marL="838200" indent="-228600" algn="l">
               <a:lnSpc>
                 <a:spcPct val="110000"/>
               </a:lnSpc>
@@ -2148,9 +2709,16 @@
                 <a:spcPts val="1200"/>
               </a:spcAft>
               <a:buChar char="•"/>
-              <a:defRPr/>
+              <a:defRPr sz="2250" b="0">
+                <a:solidFill>
+                  <a:schemeClr val="tx1"/>
+                </a:solidFill>
+                <a:latin typeface="+mn-lt"/>
+                <a:ea typeface="+mn-lt"/>
+                <a:cs typeface="+mn-lt"/>
+              </a:defRPr>
             </a:lvl3pPr>
-            <a:lvl4pPr marL="1143000" indent="-228600">
+            <a:lvl4pPr marL="1143000" indent="-228600" algn="l">
               <a:lnSpc>
                 <a:spcPct val="110000"/>
               </a:lnSpc>
@@ -2161,9 +2729,16 @@
                 <a:spcPts val="1200"/>
               </a:spcAft>
               <a:buChar char="•"/>
-              <a:defRPr/>
+              <a:defRPr sz="2250" b="0">
+                <a:solidFill>
+                  <a:schemeClr val="tx1"/>
+                </a:solidFill>
+                <a:latin typeface="+mn-lt"/>
+                <a:ea typeface="+mn-lt"/>
+                <a:cs typeface="+mn-lt"/>
+              </a:defRPr>
             </a:lvl4pPr>
-            <a:lvl5pPr marL="1447800" indent="-228600">
+            <a:lvl5pPr marL="1447800" indent="-228600" algn="l">
               <a:lnSpc>
                 <a:spcPct val="110000"/>
               </a:lnSpc>
@@ -2174,9 +2749,16 @@
                 <a:spcPts val="1200"/>
               </a:spcAft>
               <a:buChar char="•"/>
-              <a:defRPr/>
+              <a:defRPr sz="2250" b="0">
+                <a:solidFill>
+                  <a:schemeClr val="tx1"/>
+                </a:solidFill>
+                <a:latin typeface="+mn-lt"/>
+                <a:ea typeface="+mn-lt"/>
+                <a:cs typeface="+mn-lt"/>
+              </a:defRPr>
             </a:lvl5pPr>
-            <a:lvl6pPr marL="1752600" indent="-228600">
+            <a:lvl6pPr marL="1752600" indent="-228600" algn="l">
               <a:lnSpc>
                 <a:spcPct val="110000"/>
               </a:lnSpc>
@@ -2187,9 +2769,16 @@
                 <a:spcPts val="1200"/>
               </a:spcAft>
               <a:buChar char="•"/>
-              <a:defRPr/>
+              <a:defRPr sz="2250" b="0">
+                <a:solidFill>
+                  <a:schemeClr val="tx1"/>
+                </a:solidFill>
+                <a:latin typeface="+mn-lt"/>
+                <a:ea typeface="+mn-lt"/>
+                <a:cs typeface="+mn-lt"/>
+              </a:defRPr>
             </a:lvl6pPr>
-            <a:lvl7pPr marL="2057400" indent="-228600">
+            <a:lvl7pPr marL="2057400" indent="-228600" algn="l">
               <a:lnSpc>
                 <a:spcPct val="110000"/>
               </a:lnSpc>
@@ -2200,9 +2789,16 @@
                 <a:spcPts val="1200"/>
               </a:spcAft>
               <a:buChar char="•"/>
-              <a:defRPr/>
+              <a:defRPr sz="2250" b="0">
+                <a:solidFill>
+                  <a:schemeClr val="tx1"/>
+                </a:solidFill>
+                <a:latin typeface="+mn-lt"/>
+                <a:ea typeface="+mn-lt"/>
+                <a:cs typeface="+mn-lt"/>
+              </a:defRPr>
             </a:lvl7pPr>
-            <a:lvl8pPr marL="2362200" indent="-228600">
+            <a:lvl8pPr marL="2362200" indent="-228600" algn="l">
               <a:lnSpc>
                 <a:spcPct val="110000"/>
               </a:lnSpc>
@@ -2213,9 +2809,16 @@
                 <a:spcPts val="1200"/>
               </a:spcAft>
               <a:buChar char="•"/>
-              <a:defRPr/>
+              <a:defRPr sz="2250" b="0">
+                <a:solidFill>
+                  <a:schemeClr val="tx1"/>
+                </a:solidFill>
+                <a:latin typeface="+mn-lt"/>
+                <a:ea typeface="+mn-lt"/>
+                <a:cs typeface="+mn-lt"/>
+              </a:defRPr>
             </a:lvl8pPr>
-            <a:lvl9pPr marL="2667000" indent="-228600">
+            <a:lvl9pPr marL="2667000" indent="-228600" algn="l">
               <a:lnSpc>
                 <a:spcPct val="110000"/>
               </a:lnSpc>
@@ -2226,7 +2829,14 @@
                 <a:spcPts val="1200"/>
               </a:spcAft>
               <a:buChar char="•"/>
-              <a:defRPr/>
+              <a:defRPr sz="2250" b="0">
+                <a:solidFill>
+                  <a:schemeClr val="tx1"/>
+                </a:solidFill>
+                <a:latin typeface="+mn-lt"/>
+                <a:ea typeface="+mn-lt"/>
+                <a:cs typeface="+mn-lt"/>
+              </a:defRPr>
             </a:lvl9pPr>
           </a:lstStyle>
           <a:p xmlns:a="http://schemas.openxmlformats.org/drawingml/2006/main"/>
@@ -2275,12 +2885,12 @@
   </p:cSld>
   <p:clrMap bg1="lt1" tx1="dk1" bg2="lt2" tx2="dk2" accent1="accent1" accent2="accent2" accent3="accent3" accent4="accent4" accent5="accent5" accent6="accent6" hlink="hlink" folHlink="folHlink"/>
   <p:sldLayoutIdLst>
-    <p:sldLayoutId xmlns:r="http://schemas.openxmlformats.org/officeDocument/2006/relationships" id="2147483649" r:id="Rda0e6a14c069476a"/>
-    <p:sldLayoutId xmlns:r="http://schemas.openxmlformats.org/officeDocument/2006/relationships" id="2147483650" r:id="Rc62d934f8afd4486"/>
-    <p:sldLayoutId xmlns:r="http://schemas.openxmlformats.org/officeDocument/2006/relationships" id="2147483651" r:id="R9e3063e969d94e3a"/>
-    <p:sldLayoutId xmlns:r="http://schemas.openxmlformats.org/officeDocument/2006/relationships" id="2147483652" r:id="Ra749fceaebd34d42"/>
-    <p:sldLayoutId xmlns:r="http://schemas.openxmlformats.org/officeDocument/2006/relationships" id="2147483653" r:id="Rddd0c500499f42e8"/>
-    <p:sldLayoutId xmlns:r="http://schemas.openxmlformats.org/officeDocument/2006/relationships" id="2147483654" r:id="R6c437044ab764494"/>
+    <p:sldLayoutId xmlns:r="http://schemas.openxmlformats.org/officeDocument/2006/relationships" id="2147483649" r:id="R1a4b66f2f332432e"/>
+    <p:sldLayoutId xmlns:r="http://schemas.openxmlformats.org/officeDocument/2006/relationships" id="2147483650" r:id="Rc8d760b05e4a47fe"/>
+    <p:sldLayoutId xmlns:r="http://schemas.openxmlformats.org/officeDocument/2006/relationships" id="2147483651" r:id="Rb686a57d33e24f75"/>
+    <p:sldLayoutId xmlns:r="http://schemas.openxmlformats.org/officeDocument/2006/relationships" id="2147483652" r:id="R6da9458a0eb646f9"/>
+    <p:sldLayoutId xmlns:r="http://schemas.openxmlformats.org/officeDocument/2006/relationships" id="2147483653" r:id="R338afb10facd4411"/>
+    <p:sldLayoutId xmlns:r="http://schemas.openxmlformats.org/officeDocument/2006/relationships" id="2147483654" r:id="R9d39626c544e4733"/>
   </p:sldLayoutIdLst>
   <p:txStyles>
     <p:titleStyle>
@@ -2858,7 +3468,7 @@
                         <ns1:ea typeface="Arial"/>
                         <ns1:cs typeface="Arial"/>
                       </ns1:rPr>
-                      <ns1:t>4.677</ns1:t>
+                      <ns1:t>118.299</ns1:t>
                     </ns1:r>
                   </ns1:p>
                 </ns0:rich>
@@ -2898,7 +3508,7 @@
                         <ns1:ea typeface="Arial"/>
                         <ns1:cs typeface="Arial"/>
                       </ns1:rPr>
-                      <ns1:t>11.961</ns1:t>
+                      <ns1:t>210.965</ns1:t>
                     </ns1:r>
                   </ns1:p>
                 </ns0:rich>
@@ -2951,10 +3561,10 @@
                 <ns0:formatCode>General</ns0:formatCode>
                 <ns0:ptCount val="2"/>
                 <ns0:pt idx="0">
-                  <ns0:v>4677</ns0:v>
+                  <ns0:v>118299</ns0:v>
                 </ns0:pt>
                 <ns0:pt idx="1">
-                  <ns0:v>11961</ns0:v>
+                  <ns0:v>210965</ns0:v>
                 </ns0:pt>
               </ns0:numCache>
             </ns0:numRef>
@@ -3025,7 +3635,7 @@
         <ns0:axId val="48672768"/>
         <ns0:scaling>
           <ns0:orientation val="minMax"/>
-          <ns0:max val="13157.1"/>
+          <ns0:max val="232061.50000000003"/>
           <ns0:min val="0"/>
         </ns0:scaling>
         <ns0:delete val="1"/>
@@ -3146,6 +3756,96 @@
                 <a:cs typeface="Arial"/>
               </a:defRPr>
             </a:defPPr>
+            <a:lvl1pPr>
+              <a:defRPr sz="1275" b="1">
+                <a:solidFill>
+                  <a:srgbClr val="70DEC9"/>
+                </a:solidFill>
+                <a:latin typeface="Arial"/>
+                <a:ea typeface="Arial"/>
+                <a:cs typeface="Arial"/>
+              </a:defRPr>
+            </a:lvl1pPr>
+            <a:lvl2pPr>
+              <a:defRPr sz="1275" b="1">
+                <a:solidFill>
+                  <a:srgbClr val="70DEC9"/>
+                </a:solidFill>
+                <a:latin typeface="Arial"/>
+                <a:ea typeface="Arial"/>
+                <a:cs typeface="Arial"/>
+              </a:defRPr>
+            </a:lvl2pPr>
+            <a:lvl3pPr>
+              <a:defRPr sz="1275" b="1">
+                <a:solidFill>
+                  <a:srgbClr val="70DEC9"/>
+                </a:solidFill>
+                <a:latin typeface="Arial"/>
+                <a:ea typeface="Arial"/>
+                <a:cs typeface="Arial"/>
+              </a:defRPr>
+            </a:lvl3pPr>
+            <a:lvl4pPr>
+              <a:defRPr sz="1275" b="1">
+                <a:solidFill>
+                  <a:srgbClr val="70DEC9"/>
+                </a:solidFill>
+                <a:latin typeface="Arial"/>
+                <a:ea typeface="Arial"/>
+                <a:cs typeface="Arial"/>
+              </a:defRPr>
+            </a:lvl4pPr>
+            <a:lvl5pPr>
+              <a:defRPr sz="1275" b="1">
+                <a:solidFill>
+                  <a:srgbClr val="70DEC9"/>
+                </a:solidFill>
+                <a:latin typeface="Arial"/>
+                <a:ea typeface="Arial"/>
+                <a:cs typeface="Arial"/>
+              </a:defRPr>
+            </a:lvl5pPr>
+            <a:lvl6pPr>
+              <a:defRPr sz="1275" b="1">
+                <a:solidFill>
+                  <a:srgbClr val="70DEC9"/>
+                </a:solidFill>
+                <a:latin typeface="Arial"/>
+                <a:ea typeface="Arial"/>
+                <a:cs typeface="Arial"/>
+              </a:defRPr>
+            </a:lvl6pPr>
+            <a:lvl7pPr>
+              <a:defRPr sz="1275" b="1">
+                <a:solidFill>
+                  <a:srgbClr val="70DEC9"/>
+                </a:solidFill>
+                <a:latin typeface="Arial"/>
+                <a:ea typeface="Arial"/>
+                <a:cs typeface="Arial"/>
+              </a:defRPr>
+            </a:lvl7pPr>
+            <a:lvl8pPr>
+              <a:defRPr sz="1275" b="1">
+                <a:solidFill>
+                  <a:srgbClr val="70DEC9"/>
+                </a:solidFill>
+                <a:latin typeface="Arial"/>
+                <a:ea typeface="Arial"/>
+                <a:cs typeface="Arial"/>
+              </a:defRPr>
+            </a:lvl8pPr>
+            <a:lvl9pPr>
+              <a:defRPr sz="1275" b="1">
+                <a:solidFill>
+                  <a:srgbClr val="70DEC9"/>
+                </a:solidFill>
+                <a:latin typeface="Arial"/>
+                <a:ea typeface="Arial"/>
+                <a:cs typeface="Arial"/>
+              </a:defRPr>
+            </a:lvl9pPr>
           </a:lstStyle>
           <a:p xmlns:a="http://schemas.openxmlformats.org/drawingml/2006/main">
             <a:pPr>
@@ -3168,7 +3868,7 @@
                 <a:ea typeface="Arial"/>
                 <a:cs typeface="Arial"/>
               </a:rPr>
-              <a:t>MEDIÇÃO LOCAL · MESMO CONTEXTO · MESMA MENSALIDADE</a:t>
+              <a:t>BENCHMARK AMPLIADO · 3 ESCALAS · 24 CONSULTAS PAREADAS</a:t>
             </a:r>
           </a:p>
         </p:txBody>
@@ -3215,6 +3915,96 @@
                 <a:cs typeface="Arial"/>
               </a:defRPr>
             </a:defPPr>
+            <a:lvl1pPr>
+              <a:defRPr sz="3375" b="1">
+                <a:solidFill>
+                  <a:srgbClr val="F5F6F0"/>
+                </a:solidFill>
+                <a:latin typeface="Arial"/>
+                <a:ea typeface="Arial"/>
+                <a:cs typeface="Arial"/>
+              </a:defRPr>
+            </a:lvl1pPr>
+            <a:lvl2pPr>
+              <a:defRPr sz="3375" b="1">
+                <a:solidFill>
+                  <a:srgbClr val="F5F6F0"/>
+                </a:solidFill>
+                <a:latin typeface="Arial"/>
+                <a:ea typeface="Arial"/>
+                <a:cs typeface="Arial"/>
+              </a:defRPr>
+            </a:lvl2pPr>
+            <a:lvl3pPr>
+              <a:defRPr sz="3375" b="1">
+                <a:solidFill>
+                  <a:srgbClr val="F5F6F0"/>
+                </a:solidFill>
+                <a:latin typeface="Arial"/>
+                <a:ea typeface="Arial"/>
+                <a:cs typeface="Arial"/>
+              </a:defRPr>
+            </a:lvl3pPr>
+            <a:lvl4pPr>
+              <a:defRPr sz="3375" b="1">
+                <a:solidFill>
+                  <a:srgbClr val="F5F6F0"/>
+                </a:solidFill>
+                <a:latin typeface="Arial"/>
+                <a:ea typeface="Arial"/>
+                <a:cs typeface="Arial"/>
+              </a:defRPr>
+            </a:lvl4pPr>
+            <a:lvl5pPr>
+              <a:defRPr sz="3375" b="1">
+                <a:solidFill>
+                  <a:srgbClr val="F5F6F0"/>
+                </a:solidFill>
+                <a:latin typeface="Arial"/>
+                <a:ea typeface="Arial"/>
+                <a:cs typeface="Arial"/>
+              </a:defRPr>
+            </a:lvl5pPr>
+            <a:lvl6pPr>
+              <a:defRPr sz="3375" b="1">
+                <a:solidFill>
+                  <a:srgbClr val="F5F6F0"/>
+                </a:solidFill>
+                <a:latin typeface="Arial"/>
+                <a:ea typeface="Arial"/>
+                <a:cs typeface="Arial"/>
+              </a:defRPr>
+            </a:lvl6pPr>
+            <a:lvl7pPr>
+              <a:defRPr sz="3375" b="1">
+                <a:solidFill>
+                  <a:srgbClr val="F5F6F0"/>
+                </a:solidFill>
+                <a:latin typeface="Arial"/>
+                <a:ea typeface="Arial"/>
+                <a:cs typeface="Arial"/>
+              </a:defRPr>
+            </a:lvl7pPr>
+            <a:lvl8pPr>
+              <a:defRPr sz="3375" b="1">
+                <a:solidFill>
+                  <a:srgbClr val="F5F6F0"/>
+                </a:solidFill>
+                <a:latin typeface="Arial"/>
+                <a:ea typeface="Arial"/>
+                <a:cs typeface="Arial"/>
+              </a:defRPr>
+            </a:lvl8pPr>
+            <a:lvl9pPr>
+              <a:defRPr sz="3375" b="1">
+                <a:solidFill>
+                  <a:srgbClr val="F5F6F0"/>
+                </a:solidFill>
+                <a:latin typeface="Arial"/>
+                <a:ea typeface="Arial"/>
+                <a:cs typeface="Arial"/>
+              </a:defRPr>
+            </a:lvl9pPr>
           </a:lstStyle>
           <a:p xmlns:a="http://schemas.openxmlformats.org/drawingml/2006/main">
             <a:pPr>
@@ -3237,7 +4027,7 @@
                 <a:ea typeface="Arial"/>
                 <a:cs typeface="Arial"/>
               </a:rPr>
-              <a:t>60,9% menos texto na busca</a:t>
+              <a:t>10.000 notas na análise</a:t>
             </a:r>
           </a:p>
         </p:txBody>
@@ -3284,6 +4074,96 @@
                 <a:cs typeface="Arial"/>
               </a:defRPr>
             </a:defPPr>
+            <a:lvl1pPr>
+              <a:defRPr sz="1425" b="0">
+                <a:solidFill>
+                  <a:srgbClr val="AAB8C5"/>
+                </a:solidFill>
+                <a:latin typeface="Arial"/>
+                <a:ea typeface="Arial"/>
+                <a:cs typeface="Arial"/>
+              </a:defRPr>
+            </a:lvl1pPr>
+            <a:lvl2pPr>
+              <a:defRPr sz="1425" b="0">
+                <a:solidFill>
+                  <a:srgbClr val="AAB8C5"/>
+                </a:solidFill>
+                <a:latin typeface="Arial"/>
+                <a:ea typeface="Arial"/>
+                <a:cs typeface="Arial"/>
+              </a:defRPr>
+            </a:lvl2pPr>
+            <a:lvl3pPr>
+              <a:defRPr sz="1425" b="0">
+                <a:solidFill>
+                  <a:srgbClr val="AAB8C5"/>
+                </a:solidFill>
+                <a:latin typeface="Arial"/>
+                <a:ea typeface="Arial"/>
+                <a:cs typeface="Arial"/>
+              </a:defRPr>
+            </a:lvl3pPr>
+            <a:lvl4pPr>
+              <a:defRPr sz="1425" b="0">
+                <a:solidFill>
+                  <a:srgbClr val="AAB8C5"/>
+                </a:solidFill>
+                <a:latin typeface="Arial"/>
+                <a:ea typeface="Arial"/>
+                <a:cs typeface="Arial"/>
+              </a:defRPr>
+            </a:lvl4pPr>
+            <a:lvl5pPr>
+              <a:defRPr sz="1425" b="0">
+                <a:solidFill>
+                  <a:srgbClr val="AAB8C5"/>
+                </a:solidFill>
+                <a:latin typeface="Arial"/>
+                <a:ea typeface="Arial"/>
+                <a:cs typeface="Arial"/>
+              </a:defRPr>
+            </a:lvl5pPr>
+            <a:lvl6pPr>
+              <a:defRPr sz="1425" b="0">
+                <a:solidFill>
+                  <a:srgbClr val="AAB8C5"/>
+                </a:solidFill>
+                <a:latin typeface="Arial"/>
+                <a:ea typeface="Arial"/>
+                <a:cs typeface="Arial"/>
+              </a:defRPr>
+            </a:lvl6pPr>
+            <a:lvl7pPr>
+              <a:defRPr sz="1425" b="0">
+                <a:solidFill>
+                  <a:srgbClr val="AAB8C5"/>
+                </a:solidFill>
+                <a:latin typeface="Arial"/>
+                <a:ea typeface="Arial"/>
+                <a:cs typeface="Arial"/>
+              </a:defRPr>
+            </a:lvl7pPr>
+            <a:lvl8pPr>
+              <a:defRPr sz="1425" b="0">
+                <a:solidFill>
+                  <a:srgbClr val="AAB8C5"/>
+                </a:solidFill>
+                <a:latin typeface="Arial"/>
+                <a:ea typeface="Arial"/>
+                <a:cs typeface="Arial"/>
+              </a:defRPr>
+            </a:lvl8pPr>
+            <a:lvl9pPr>
+              <a:defRPr sz="1425" b="0">
+                <a:solidFill>
+                  <a:srgbClr val="AAB8C5"/>
+                </a:solidFill>
+                <a:latin typeface="Arial"/>
+                <a:ea typeface="Arial"/>
+                <a:cs typeface="Arial"/>
+              </a:defRPr>
+            </a:lvl9pPr>
           </a:lstStyle>
           <a:p xmlns:a="http://schemas.openxmlformats.org/drawingml/2006/main">
             <a:pPr>
@@ -3306,7 +4186,7 @@
                 <a:ea typeface="Arial"/>
                 <a:cs typeface="Arial"/>
               </a:rPr>
-              <a:t>Mesma consulta, mesmo acervo, mesmas cinco notas e trechos.</a:t>
+              <a:t>Maior acervo com 26.918.974 caracteres sintéticos. Sem usar o cofre pessoal.</a:t>
             </a:r>
           </a:p>
         </p:txBody>
@@ -3353,6 +4233,96 @@
                 <a:cs typeface="Arial"/>
               </a:defRPr>
             </a:defPPr>
+            <a:lvl1pPr>
+              <a:defRPr sz="1425" b="0">
+                <a:solidFill>
+                  <a:srgbClr val="AAB8C5"/>
+                </a:solidFill>
+                <a:latin typeface="Arial"/>
+                <a:ea typeface="Arial"/>
+                <a:cs typeface="Arial"/>
+              </a:defRPr>
+            </a:lvl1pPr>
+            <a:lvl2pPr>
+              <a:defRPr sz="1425" b="0">
+                <a:solidFill>
+                  <a:srgbClr val="AAB8C5"/>
+                </a:solidFill>
+                <a:latin typeface="Arial"/>
+                <a:ea typeface="Arial"/>
+                <a:cs typeface="Arial"/>
+              </a:defRPr>
+            </a:lvl2pPr>
+            <a:lvl3pPr>
+              <a:defRPr sz="1425" b="0">
+                <a:solidFill>
+                  <a:srgbClr val="AAB8C5"/>
+                </a:solidFill>
+                <a:latin typeface="Arial"/>
+                <a:ea typeface="Arial"/>
+                <a:cs typeface="Arial"/>
+              </a:defRPr>
+            </a:lvl3pPr>
+            <a:lvl4pPr>
+              <a:defRPr sz="1425" b="0">
+                <a:solidFill>
+                  <a:srgbClr val="AAB8C5"/>
+                </a:solidFill>
+                <a:latin typeface="Arial"/>
+                <a:ea typeface="Arial"/>
+                <a:cs typeface="Arial"/>
+              </a:defRPr>
+            </a:lvl4pPr>
+            <a:lvl5pPr>
+              <a:defRPr sz="1425" b="0">
+                <a:solidFill>
+                  <a:srgbClr val="AAB8C5"/>
+                </a:solidFill>
+                <a:latin typeface="Arial"/>
+                <a:ea typeface="Arial"/>
+                <a:cs typeface="Arial"/>
+              </a:defRPr>
+            </a:lvl5pPr>
+            <a:lvl6pPr>
+              <a:defRPr sz="1425" b="0">
+                <a:solidFill>
+                  <a:srgbClr val="AAB8C5"/>
+                </a:solidFill>
+                <a:latin typeface="Arial"/>
+                <a:ea typeface="Arial"/>
+                <a:cs typeface="Arial"/>
+              </a:defRPr>
+            </a:lvl6pPr>
+            <a:lvl7pPr>
+              <a:defRPr sz="1425" b="0">
+                <a:solidFill>
+                  <a:srgbClr val="AAB8C5"/>
+                </a:solidFill>
+                <a:latin typeface="Arial"/>
+                <a:ea typeface="Arial"/>
+                <a:cs typeface="Arial"/>
+              </a:defRPr>
+            </a:lvl7pPr>
+            <a:lvl8pPr>
+              <a:defRPr sz="1425" b="0">
+                <a:solidFill>
+                  <a:srgbClr val="AAB8C5"/>
+                </a:solidFill>
+                <a:latin typeface="Arial"/>
+                <a:ea typeface="Arial"/>
+                <a:cs typeface="Arial"/>
+              </a:defRPr>
+            </a:lvl8pPr>
+            <a:lvl9pPr>
+              <a:defRPr sz="1425" b="0">
+                <a:solidFill>
+                  <a:srgbClr val="AAB8C5"/>
+                </a:solidFill>
+                <a:latin typeface="Arial"/>
+                <a:ea typeface="Arial"/>
+                <a:cs typeface="Arial"/>
+              </a:defRPr>
+            </a:lvl9pPr>
           </a:lstStyle>
           <a:p xmlns:a="http://schemas.openxmlformats.org/drawingml/2006/main">
             <a:pPr>
@@ -3375,7 +4345,7 @@
                 <a:ea typeface="Arial"/>
                 <a:cs typeface="Arial"/>
               </a:rPr>
-              <a:t>Texto retornado pela busca</a:t>
+              <a:t>Texto retornado nas 24 consultas</a:t>
             </a:r>
           </a:p>
         </p:txBody>
@@ -3385,7 +4355,7 @@
           <p:cNvPr id="5" name="Chart">
             <a:extLst xmlns:a="http://schemas.openxmlformats.org/drawingml/2006/main">
               <a:ext uri="{FF2B5EF4-FFF2-40B4-BE49-F238E27FC236}">
-                <a16:creationId xmlns:a16="http://schemas.microsoft.com/office/drawing/2014/main" id="{4ECA498E-2511-4A0A-9952-3A6E0D2BC73B}"/>
+                <a16:creationId xmlns:a16="http://schemas.microsoft.com/office/drawing/2014/main" id="{D03C8957-75CA-440C-AC5C-A51258EE9DDA}"/>
               </a:ext>
             </a:extLst>
           </p:cNvPr>
@@ -3398,7 +4368,7 @@
         </p:xfrm>
         <a:graphic xmlns:a="http://schemas.openxmlformats.org/drawingml/2006/main">
           <a:graphicData uri="http://schemas.openxmlformats.org/drawingml/2006/chart">
-            <c:chart xmlns:r="http://schemas.openxmlformats.org/officeDocument/2006/relationships" xmlns:c="http://schemas.openxmlformats.org/drawingml/2006/chart" r:id="R0c7e625a0ffe4c48"/>
+            <c:chart xmlns:r="http://schemas.openxmlformats.org/officeDocument/2006/relationships" xmlns:c="http://schemas.openxmlformats.org/drawingml/2006/chart" r:id="R5abb7b4a460e4e12"/>
           </a:graphicData>
         </a:graphic>
       </p:graphicFrame>
@@ -3444,6 +4414,96 @@
                 <a:cs typeface="Arial"/>
               </a:defRPr>
             </a:defPPr>
+            <a:lvl1pPr>
+              <a:defRPr sz="1500" b="1">
+                <a:solidFill>
+                  <a:srgbClr val="70DEC9"/>
+                </a:solidFill>
+                <a:latin typeface="Arial"/>
+                <a:ea typeface="Arial"/>
+                <a:cs typeface="Arial"/>
+              </a:defRPr>
+            </a:lvl1pPr>
+            <a:lvl2pPr>
+              <a:defRPr sz="1500" b="1">
+                <a:solidFill>
+                  <a:srgbClr val="70DEC9"/>
+                </a:solidFill>
+                <a:latin typeface="Arial"/>
+                <a:ea typeface="Arial"/>
+                <a:cs typeface="Arial"/>
+              </a:defRPr>
+            </a:lvl2pPr>
+            <a:lvl3pPr>
+              <a:defRPr sz="1500" b="1">
+                <a:solidFill>
+                  <a:srgbClr val="70DEC9"/>
+                </a:solidFill>
+                <a:latin typeface="Arial"/>
+                <a:ea typeface="Arial"/>
+                <a:cs typeface="Arial"/>
+              </a:defRPr>
+            </a:lvl3pPr>
+            <a:lvl4pPr>
+              <a:defRPr sz="1500" b="1">
+                <a:solidFill>
+                  <a:srgbClr val="70DEC9"/>
+                </a:solidFill>
+                <a:latin typeface="Arial"/>
+                <a:ea typeface="Arial"/>
+                <a:cs typeface="Arial"/>
+              </a:defRPr>
+            </a:lvl4pPr>
+            <a:lvl5pPr>
+              <a:defRPr sz="1500" b="1">
+                <a:solidFill>
+                  <a:srgbClr val="70DEC9"/>
+                </a:solidFill>
+                <a:latin typeface="Arial"/>
+                <a:ea typeface="Arial"/>
+                <a:cs typeface="Arial"/>
+              </a:defRPr>
+            </a:lvl5pPr>
+            <a:lvl6pPr>
+              <a:defRPr sz="1500" b="1">
+                <a:solidFill>
+                  <a:srgbClr val="70DEC9"/>
+                </a:solidFill>
+                <a:latin typeface="Arial"/>
+                <a:ea typeface="Arial"/>
+                <a:cs typeface="Arial"/>
+              </a:defRPr>
+            </a:lvl6pPr>
+            <a:lvl7pPr>
+              <a:defRPr sz="1500" b="1">
+                <a:solidFill>
+                  <a:srgbClr val="70DEC9"/>
+                </a:solidFill>
+                <a:latin typeface="Arial"/>
+                <a:ea typeface="Arial"/>
+                <a:cs typeface="Arial"/>
+              </a:defRPr>
+            </a:lvl7pPr>
+            <a:lvl8pPr>
+              <a:defRPr sz="1500" b="1">
+                <a:solidFill>
+                  <a:srgbClr val="70DEC9"/>
+                </a:solidFill>
+                <a:latin typeface="Arial"/>
+                <a:ea typeface="Arial"/>
+                <a:cs typeface="Arial"/>
+              </a:defRPr>
+            </a:lvl8pPr>
+            <a:lvl9pPr>
+              <a:defRPr sz="1500" b="1">
+                <a:solidFill>
+                  <a:srgbClr val="70DEC9"/>
+                </a:solidFill>
+                <a:latin typeface="Arial"/>
+                <a:ea typeface="Arial"/>
+                <a:cs typeface="Arial"/>
+              </a:defRPr>
+            </a:lvl9pPr>
           </a:lstStyle>
           <a:p xmlns:a="http://schemas.openxmlformats.org/drawingml/2006/main">
             <a:pPr>
@@ -3466,7 +4526,7 @@
                 <a:ea typeface="Arial"/>
                 <a:cs typeface="Arial"/>
               </a:rPr>
-              <a:t>7.284 caracteres a menos (60,9%)</a:t>
+              <a:t>92.666 caracteres a menos (43,9%)</a:t>
             </a:r>
           </a:p>
         </p:txBody>
@@ -3513,6 +4573,96 @@
                 <a:cs typeface="Arial"/>
               </a:defRPr>
             </a:defPPr>
+            <a:lvl1pPr>
+              <a:defRPr sz="1875" b="1">
+                <a:solidFill>
+                  <a:srgbClr val="F5F6F0"/>
+                </a:solidFill>
+                <a:latin typeface="Arial"/>
+                <a:ea typeface="Arial"/>
+                <a:cs typeface="Arial"/>
+              </a:defRPr>
+            </a:lvl1pPr>
+            <a:lvl2pPr>
+              <a:defRPr sz="1875" b="1">
+                <a:solidFill>
+                  <a:srgbClr val="F5F6F0"/>
+                </a:solidFill>
+                <a:latin typeface="Arial"/>
+                <a:ea typeface="Arial"/>
+                <a:cs typeface="Arial"/>
+              </a:defRPr>
+            </a:lvl2pPr>
+            <a:lvl3pPr>
+              <a:defRPr sz="1875" b="1">
+                <a:solidFill>
+                  <a:srgbClr val="F5F6F0"/>
+                </a:solidFill>
+                <a:latin typeface="Arial"/>
+                <a:ea typeface="Arial"/>
+                <a:cs typeface="Arial"/>
+              </a:defRPr>
+            </a:lvl3pPr>
+            <a:lvl4pPr>
+              <a:defRPr sz="1875" b="1">
+                <a:solidFill>
+                  <a:srgbClr val="F5F6F0"/>
+                </a:solidFill>
+                <a:latin typeface="Arial"/>
+                <a:ea typeface="Arial"/>
+                <a:cs typeface="Arial"/>
+              </a:defRPr>
+            </a:lvl4pPr>
+            <a:lvl5pPr>
+              <a:defRPr sz="1875" b="1">
+                <a:solidFill>
+                  <a:srgbClr val="F5F6F0"/>
+                </a:solidFill>
+                <a:latin typeface="Arial"/>
+                <a:ea typeface="Arial"/>
+                <a:cs typeface="Arial"/>
+              </a:defRPr>
+            </a:lvl5pPr>
+            <a:lvl6pPr>
+              <a:defRPr sz="1875" b="1">
+                <a:solidFill>
+                  <a:srgbClr val="F5F6F0"/>
+                </a:solidFill>
+                <a:latin typeface="Arial"/>
+                <a:ea typeface="Arial"/>
+                <a:cs typeface="Arial"/>
+              </a:defRPr>
+            </a:lvl6pPr>
+            <a:lvl7pPr>
+              <a:defRPr sz="1875" b="1">
+                <a:solidFill>
+                  <a:srgbClr val="F5F6F0"/>
+                </a:solidFill>
+                <a:latin typeface="Arial"/>
+                <a:ea typeface="Arial"/>
+                <a:cs typeface="Arial"/>
+              </a:defRPr>
+            </a:lvl7pPr>
+            <a:lvl8pPr>
+              <a:defRPr sz="1875" b="1">
+                <a:solidFill>
+                  <a:srgbClr val="F5F6F0"/>
+                </a:solidFill>
+                <a:latin typeface="Arial"/>
+                <a:ea typeface="Arial"/>
+                <a:cs typeface="Arial"/>
+              </a:defRPr>
+            </a:lvl8pPr>
+            <a:lvl9pPr>
+              <a:defRPr sz="1875" b="1">
+                <a:solidFill>
+                  <a:srgbClr val="F5F6F0"/>
+                </a:solidFill>
+                <a:latin typeface="Arial"/>
+                <a:ea typeface="Arial"/>
+                <a:cs typeface="Arial"/>
+              </a:defRPr>
+            </a:lvl9pPr>
           </a:lstStyle>
           <a:p xmlns:a="http://schemas.openxmlformats.org/drawingml/2006/main">
             <a:pPr>
@@ -3535,7 +4685,7 @@
                 <a:ea typeface="Arial"/>
                 <a:cs typeface="Arial"/>
               </a:rPr>
-              <a:t>A conta da redução medida</a:t>
+              <a:t>Mesma seleção nas 24 comparações</a:t>
             </a:r>
           </a:p>
         </p:txBody>
@@ -3582,6 +4732,96 @@
                 <a:cs typeface="Arial"/>
               </a:defRPr>
             </a:defPPr>
+            <a:lvl1pPr>
+              <a:defRPr sz="2250" b="1">
+                <a:solidFill>
+                  <a:srgbClr val="70DEC9"/>
+                </a:solidFill>
+                <a:latin typeface="Arial"/>
+                <a:ea typeface="Arial"/>
+                <a:cs typeface="Arial"/>
+              </a:defRPr>
+            </a:lvl1pPr>
+            <a:lvl2pPr>
+              <a:defRPr sz="2250" b="1">
+                <a:solidFill>
+                  <a:srgbClr val="70DEC9"/>
+                </a:solidFill>
+                <a:latin typeface="Arial"/>
+                <a:ea typeface="Arial"/>
+                <a:cs typeface="Arial"/>
+              </a:defRPr>
+            </a:lvl2pPr>
+            <a:lvl3pPr>
+              <a:defRPr sz="2250" b="1">
+                <a:solidFill>
+                  <a:srgbClr val="70DEC9"/>
+                </a:solidFill>
+                <a:latin typeface="Arial"/>
+                <a:ea typeface="Arial"/>
+                <a:cs typeface="Arial"/>
+              </a:defRPr>
+            </a:lvl3pPr>
+            <a:lvl4pPr>
+              <a:defRPr sz="2250" b="1">
+                <a:solidFill>
+                  <a:srgbClr val="70DEC9"/>
+                </a:solidFill>
+                <a:latin typeface="Arial"/>
+                <a:ea typeface="Arial"/>
+                <a:cs typeface="Arial"/>
+              </a:defRPr>
+            </a:lvl4pPr>
+            <a:lvl5pPr>
+              <a:defRPr sz="2250" b="1">
+                <a:solidFill>
+                  <a:srgbClr val="70DEC9"/>
+                </a:solidFill>
+                <a:latin typeface="Arial"/>
+                <a:ea typeface="Arial"/>
+                <a:cs typeface="Arial"/>
+              </a:defRPr>
+            </a:lvl5pPr>
+            <a:lvl6pPr>
+              <a:defRPr sz="2250" b="1">
+                <a:solidFill>
+                  <a:srgbClr val="70DEC9"/>
+                </a:solidFill>
+                <a:latin typeface="Arial"/>
+                <a:ea typeface="Arial"/>
+                <a:cs typeface="Arial"/>
+              </a:defRPr>
+            </a:lvl6pPr>
+            <a:lvl7pPr>
+              <a:defRPr sz="2250" b="1">
+                <a:solidFill>
+                  <a:srgbClr val="70DEC9"/>
+                </a:solidFill>
+                <a:latin typeface="Arial"/>
+                <a:ea typeface="Arial"/>
+                <a:cs typeface="Arial"/>
+              </a:defRPr>
+            </a:lvl7pPr>
+            <a:lvl8pPr>
+              <a:defRPr sz="2250" b="1">
+                <a:solidFill>
+                  <a:srgbClr val="70DEC9"/>
+                </a:solidFill>
+                <a:latin typeface="Arial"/>
+                <a:ea typeface="Arial"/>
+                <a:cs typeface="Arial"/>
+              </a:defRPr>
+            </a:lvl8pPr>
+            <a:lvl9pPr>
+              <a:defRPr sz="2250" b="1">
+                <a:solidFill>
+                  <a:srgbClr val="70DEC9"/>
+                </a:solidFill>
+                <a:latin typeface="Arial"/>
+                <a:ea typeface="Arial"/>
+                <a:cs typeface="Arial"/>
+              </a:defRPr>
+            </a:lvl9pPr>
           </a:lstStyle>
           <a:p xmlns:a="http://schemas.openxmlformats.org/drawingml/2006/main">
             <a:pPr>
@@ -3604,7 +4844,7 @@
                 <a:ea typeface="Arial"/>
                 <a:cs typeface="Arial"/>
               </a:rPr>
-              <a:t>11.961 − 4.677 = 7.284</a:t>
+              <a:t>210.965 − 118.299 = 92.666</a:t>
             </a:r>
           </a:p>
         </p:txBody>
@@ -3651,6 +4891,96 @@
                 <a:cs typeface="Arial"/>
               </a:defRPr>
             </a:defPPr>
+            <a:lvl1pPr>
+              <a:defRPr sz="1425" b="0">
+                <a:solidFill>
+                  <a:srgbClr val="F5F6F0"/>
+                </a:solidFill>
+                <a:latin typeface="Arial"/>
+                <a:ea typeface="Arial"/>
+                <a:cs typeface="Arial"/>
+              </a:defRPr>
+            </a:lvl1pPr>
+            <a:lvl2pPr>
+              <a:defRPr sz="1425" b="0">
+                <a:solidFill>
+                  <a:srgbClr val="F5F6F0"/>
+                </a:solidFill>
+                <a:latin typeface="Arial"/>
+                <a:ea typeface="Arial"/>
+                <a:cs typeface="Arial"/>
+              </a:defRPr>
+            </a:lvl2pPr>
+            <a:lvl3pPr>
+              <a:defRPr sz="1425" b="0">
+                <a:solidFill>
+                  <a:srgbClr val="F5F6F0"/>
+                </a:solidFill>
+                <a:latin typeface="Arial"/>
+                <a:ea typeface="Arial"/>
+                <a:cs typeface="Arial"/>
+              </a:defRPr>
+            </a:lvl3pPr>
+            <a:lvl4pPr>
+              <a:defRPr sz="1425" b="0">
+                <a:solidFill>
+                  <a:srgbClr val="F5F6F0"/>
+                </a:solidFill>
+                <a:latin typeface="Arial"/>
+                <a:ea typeface="Arial"/>
+                <a:cs typeface="Arial"/>
+              </a:defRPr>
+            </a:lvl4pPr>
+            <a:lvl5pPr>
+              <a:defRPr sz="1425" b="0">
+                <a:solidFill>
+                  <a:srgbClr val="F5F6F0"/>
+                </a:solidFill>
+                <a:latin typeface="Arial"/>
+                <a:ea typeface="Arial"/>
+                <a:cs typeface="Arial"/>
+              </a:defRPr>
+            </a:lvl5pPr>
+            <a:lvl6pPr>
+              <a:defRPr sz="1425" b="0">
+                <a:solidFill>
+                  <a:srgbClr val="F5F6F0"/>
+                </a:solidFill>
+                <a:latin typeface="Arial"/>
+                <a:ea typeface="Arial"/>
+                <a:cs typeface="Arial"/>
+              </a:defRPr>
+            </a:lvl6pPr>
+            <a:lvl7pPr>
+              <a:defRPr sz="1425" b="0">
+                <a:solidFill>
+                  <a:srgbClr val="F5F6F0"/>
+                </a:solidFill>
+                <a:latin typeface="Arial"/>
+                <a:ea typeface="Arial"/>
+                <a:cs typeface="Arial"/>
+              </a:defRPr>
+            </a:lvl7pPr>
+            <a:lvl8pPr>
+              <a:defRPr sz="1425" b="0">
+                <a:solidFill>
+                  <a:srgbClr val="F5F6F0"/>
+                </a:solidFill>
+                <a:latin typeface="Arial"/>
+                <a:ea typeface="Arial"/>
+                <a:cs typeface="Arial"/>
+              </a:defRPr>
+            </a:lvl8pPr>
+            <a:lvl9pPr>
+              <a:defRPr sz="1425" b="0">
+                <a:solidFill>
+                  <a:srgbClr val="F5F6F0"/>
+                </a:solidFill>
+                <a:latin typeface="Arial"/>
+                <a:ea typeface="Arial"/>
+                <a:cs typeface="Arial"/>
+              </a:defRPr>
+            </a:lvl9pPr>
           </a:lstStyle>
           <a:p xmlns:a="http://schemas.openxmlformats.org/drawingml/2006/main">
             <a:pPr>
@@ -3673,7 +5003,7 @@
                 <a:ea typeface="Arial"/>
                 <a:cs typeface="Arial"/>
               </a:rPr>
-              <a:t>7.284 caracteres deixam de ocupar a saída da busca.</a:t>
+              <a:t>48 execuções, antes e depois de cada consulta.</a:t>
             </a:r>
           </a:p>
         </p:txBody>
@@ -3720,6 +5050,96 @@
                 <a:cs typeface="Arial"/>
               </a:defRPr>
             </a:defPPr>
+            <a:lvl1pPr>
+              <a:defRPr sz="1425" b="0">
+                <a:solidFill>
+                  <a:srgbClr val="F5F6F0"/>
+                </a:solidFill>
+                <a:latin typeface="Arial"/>
+                <a:ea typeface="Arial"/>
+                <a:cs typeface="Arial"/>
+              </a:defRPr>
+            </a:lvl1pPr>
+            <a:lvl2pPr>
+              <a:defRPr sz="1425" b="0">
+                <a:solidFill>
+                  <a:srgbClr val="F5F6F0"/>
+                </a:solidFill>
+                <a:latin typeface="Arial"/>
+                <a:ea typeface="Arial"/>
+                <a:cs typeface="Arial"/>
+              </a:defRPr>
+            </a:lvl2pPr>
+            <a:lvl3pPr>
+              <a:defRPr sz="1425" b="0">
+                <a:solidFill>
+                  <a:srgbClr val="F5F6F0"/>
+                </a:solidFill>
+                <a:latin typeface="Arial"/>
+                <a:ea typeface="Arial"/>
+                <a:cs typeface="Arial"/>
+              </a:defRPr>
+            </a:lvl3pPr>
+            <a:lvl4pPr>
+              <a:defRPr sz="1425" b="0">
+                <a:solidFill>
+                  <a:srgbClr val="F5F6F0"/>
+                </a:solidFill>
+                <a:latin typeface="Arial"/>
+                <a:ea typeface="Arial"/>
+                <a:cs typeface="Arial"/>
+              </a:defRPr>
+            </a:lvl4pPr>
+            <a:lvl5pPr>
+              <a:defRPr sz="1425" b="0">
+                <a:solidFill>
+                  <a:srgbClr val="F5F6F0"/>
+                </a:solidFill>
+                <a:latin typeface="Arial"/>
+                <a:ea typeface="Arial"/>
+                <a:cs typeface="Arial"/>
+              </a:defRPr>
+            </a:lvl5pPr>
+            <a:lvl6pPr>
+              <a:defRPr sz="1425" b="0">
+                <a:solidFill>
+                  <a:srgbClr val="F5F6F0"/>
+                </a:solidFill>
+                <a:latin typeface="Arial"/>
+                <a:ea typeface="Arial"/>
+                <a:cs typeface="Arial"/>
+              </a:defRPr>
+            </a:lvl6pPr>
+            <a:lvl7pPr>
+              <a:defRPr sz="1425" b="0">
+                <a:solidFill>
+                  <a:srgbClr val="F5F6F0"/>
+                </a:solidFill>
+                <a:latin typeface="Arial"/>
+                <a:ea typeface="Arial"/>
+                <a:cs typeface="Arial"/>
+              </a:defRPr>
+            </a:lvl7pPr>
+            <a:lvl8pPr>
+              <a:defRPr sz="1425" b="0">
+                <a:solidFill>
+                  <a:srgbClr val="F5F6F0"/>
+                </a:solidFill>
+                <a:latin typeface="Arial"/>
+                <a:ea typeface="Arial"/>
+                <a:cs typeface="Arial"/>
+              </a:defRPr>
+            </a:lvl8pPr>
+            <a:lvl9pPr>
+              <a:defRPr sz="1425" b="0">
+                <a:solidFill>
+                  <a:srgbClr val="F5F6F0"/>
+                </a:solidFill>
+                <a:latin typeface="Arial"/>
+                <a:ea typeface="Arial"/>
+                <a:cs typeface="Arial"/>
+              </a:defRPr>
+            </a:lvl9pPr>
           </a:lstStyle>
           <a:p xmlns:a="http://schemas.openxmlformats.org/drawingml/2006/main">
             <a:pPr>
@@ -3742,7 +5162,7 @@
                 <a:ea typeface="Arial"/>
                 <a:cs typeface="Arial"/>
               </a:rPr>
-              <a:t>O conteúdo dos trechos selecionados foi preservado.</a:t>
+              <a:t>Temas, múltiplos termos, projeto e ausência de resultado.</a:t>
             </a:r>
           </a:p>
         </p:txBody>
@@ -3789,6 +5209,96 @@
                 <a:cs typeface="Arial"/>
               </a:defRPr>
             </a:defPPr>
+            <a:lvl1pPr>
+              <a:defRPr sz="1575" b="1">
+                <a:solidFill>
+                  <a:srgbClr val="70DEC9"/>
+                </a:solidFill>
+                <a:latin typeface="Arial"/>
+                <a:ea typeface="Arial"/>
+                <a:cs typeface="Arial"/>
+              </a:defRPr>
+            </a:lvl1pPr>
+            <a:lvl2pPr>
+              <a:defRPr sz="1575" b="1">
+                <a:solidFill>
+                  <a:srgbClr val="70DEC9"/>
+                </a:solidFill>
+                <a:latin typeface="Arial"/>
+                <a:ea typeface="Arial"/>
+                <a:cs typeface="Arial"/>
+              </a:defRPr>
+            </a:lvl2pPr>
+            <a:lvl3pPr>
+              <a:defRPr sz="1575" b="1">
+                <a:solidFill>
+                  <a:srgbClr val="70DEC9"/>
+                </a:solidFill>
+                <a:latin typeface="Arial"/>
+                <a:ea typeface="Arial"/>
+                <a:cs typeface="Arial"/>
+              </a:defRPr>
+            </a:lvl3pPr>
+            <a:lvl4pPr>
+              <a:defRPr sz="1575" b="1">
+                <a:solidFill>
+                  <a:srgbClr val="70DEC9"/>
+                </a:solidFill>
+                <a:latin typeface="Arial"/>
+                <a:ea typeface="Arial"/>
+                <a:cs typeface="Arial"/>
+              </a:defRPr>
+            </a:lvl4pPr>
+            <a:lvl5pPr>
+              <a:defRPr sz="1575" b="1">
+                <a:solidFill>
+                  <a:srgbClr val="70DEC9"/>
+                </a:solidFill>
+                <a:latin typeface="Arial"/>
+                <a:ea typeface="Arial"/>
+                <a:cs typeface="Arial"/>
+              </a:defRPr>
+            </a:lvl5pPr>
+            <a:lvl6pPr>
+              <a:defRPr sz="1575" b="1">
+                <a:solidFill>
+                  <a:srgbClr val="70DEC9"/>
+                </a:solidFill>
+                <a:latin typeface="Arial"/>
+                <a:ea typeface="Arial"/>
+                <a:cs typeface="Arial"/>
+              </a:defRPr>
+            </a:lvl6pPr>
+            <a:lvl7pPr>
+              <a:defRPr sz="1575" b="1">
+                <a:solidFill>
+                  <a:srgbClr val="70DEC9"/>
+                </a:solidFill>
+                <a:latin typeface="Arial"/>
+                <a:ea typeface="Arial"/>
+                <a:cs typeface="Arial"/>
+              </a:defRPr>
+            </a:lvl7pPr>
+            <a:lvl8pPr>
+              <a:defRPr sz="1575" b="1">
+                <a:solidFill>
+                  <a:srgbClr val="70DEC9"/>
+                </a:solidFill>
+                <a:latin typeface="Arial"/>
+                <a:ea typeface="Arial"/>
+                <a:cs typeface="Arial"/>
+              </a:defRPr>
+            </a:lvl8pPr>
+            <a:lvl9pPr>
+              <a:defRPr sz="1575" b="1">
+                <a:solidFill>
+                  <a:srgbClr val="70DEC9"/>
+                </a:solidFill>
+                <a:latin typeface="Arial"/>
+                <a:ea typeface="Arial"/>
+                <a:cs typeface="Arial"/>
+              </a:defRPr>
+            </a:lvl9pPr>
           </a:lstStyle>
           <a:p xmlns:a="http://schemas.openxmlformats.org/drawingml/2006/main">
             <a:pPr>
@@ -3811,7 +5321,7 @@
                 <a:ea typeface="Arial"/>
                 <a:cs typeface="Arial"/>
               </a:rPr>
-              <a:t>Redução: 7.284 ÷ 11.961 = 60,9%</a:t>
+              <a:t>Notas e trechos equivalentes em todos os casos</a:t>
             </a:r>
           </a:p>
         </p:txBody>
@@ -3858,6 +5368,96 @@
                 <a:cs typeface="Arial"/>
               </a:defRPr>
             </a:defPPr>
+            <a:lvl1pPr>
+              <a:defRPr sz="1275" b="0">
+                <a:solidFill>
+                  <a:srgbClr val="AAB8C5"/>
+                </a:solidFill>
+                <a:latin typeface="Arial"/>
+                <a:ea typeface="Arial"/>
+                <a:cs typeface="Arial"/>
+              </a:defRPr>
+            </a:lvl1pPr>
+            <a:lvl2pPr>
+              <a:defRPr sz="1275" b="0">
+                <a:solidFill>
+                  <a:srgbClr val="AAB8C5"/>
+                </a:solidFill>
+                <a:latin typeface="Arial"/>
+                <a:ea typeface="Arial"/>
+                <a:cs typeface="Arial"/>
+              </a:defRPr>
+            </a:lvl2pPr>
+            <a:lvl3pPr>
+              <a:defRPr sz="1275" b="0">
+                <a:solidFill>
+                  <a:srgbClr val="AAB8C5"/>
+                </a:solidFill>
+                <a:latin typeface="Arial"/>
+                <a:ea typeface="Arial"/>
+                <a:cs typeface="Arial"/>
+              </a:defRPr>
+            </a:lvl3pPr>
+            <a:lvl4pPr>
+              <a:defRPr sz="1275" b="0">
+                <a:solidFill>
+                  <a:srgbClr val="AAB8C5"/>
+                </a:solidFill>
+                <a:latin typeface="Arial"/>
+                <a:ea typeface="Arial"/>
+                <a:cs typeface="Arial"/>
+              </a:defRPr>
+            </a:lvl4pPr>
+            <a:lvl5pPr>
+              <a:defRPr sz="1275" b="0">
+                <a:solidFill>
+                  <a:srgbClr val="AAB8C5"/>
+                </a:solidFill>
+                <a:latin typeface="Arial"/>
+                <a:ea typeface="Arial"/>
+                <a:cs typeface="Arial"/>
+              </a:defRPr>
+            </a:lvl5pPr>
+            <a:lvl6pPr>
+              <a:defRPr sz="1275" b="0">
+                <a:solidFill>
+                  <a:srgbClr val="AAB8C5"/>
+                </a:solidFill>
+                <a:latin typeface="Arial"/>
+                <a:ea typeface="Arial"/>
+                <a:cs typeface="Arial"/>
+              </a:defRPr>
+            </a:lvl6pPr>
+            <a:lvl7pPr>
+              <a:defRPr sz="1275" b="0">
+                <a:solidFill>
+                  <a:srgbClr val="AAB8C5"/>
+                </a:solidFill>
+                <a:latin typeface="Arial"/>
+                <a:ea typeface="Arial"/>
+                <a:cs typeface="Arial"/>
+              </a:defRPr>
+            </a:lvl7pPr>
+            <a:lvl8pPr>
+              <a:defRPr sz="1275" b="0">
+                <a:solidFill>
+                  <a:srgbClr val="AAB8C5"/>
+                </a:solidFill>
+                <a:latin typeface="Arial"/>
+                <a:ea typeface="Arial"/>
+                <a:cs typeface="Arial"/>
+              </a:defRPr>
+            </a:lvl8pPr>
+            <a:lvl9pPr>
+              <a:defRPr sz="1275" b="0">
+                <a:solidFill>
+                  <a:srgbClr val="AAB8C5"/>
+                </a:solidFill>
+                <a:latin typeface="Arial"/>
+                <a:ea typeface="Arial"/>
+                <a:cs typeface="Arial"/>
+              </a:defRPr>
+            </a:lvl9pPr>
           </a:lstStyle>
           <a:p xmlns:a="http://schemas.openxmlformats.org/drawingml/2006/main">
             <a:pPr>
@@ -3880,7 +5480,7 @@
                 <a:ea typeface="Arial"/>
                 <a:cs typeface="Arial"/>
               </a:rPr>
-              <a:t>O ganho vem de resumir a lista de notas omitidas.</a:t>
+              <a:t>Mesmo limite: 5 notas e 12.000 caracteres por consulta.</a:t>
             </a:r>
           </a:p>
         </p:txBody>
@@ -3927,6 +5527,96 @@
                 <a:cs typeface="Arial"/>
               </a:defRPr>
             </a:defPPr>
+            <a:lvl1pPr>
+              <a:defRPr sz="1350" b="0">
+                <a:solidFill>
+                  <a:srgbClr val="AAB8C5"/>
+                </a:solidFill>
+                <a:latin typeface="Arial"/>
+                <a:ea typeface="Arial"/>
+                <a:cs typeface="Arial"/>
+              </a:defRPr>
+            </a:lvl1pPr>
+            <a:lvl2pPr>
+              <a:defRPr sz="1350" b="0">
+                <a:solidFill>
+                  <a:srgbClr val="AAB8C5"/>
+                </a:solidFill>
+                <a:latin typeface="Arial"/>
+                <a:ea typeface="Arial"/>
+                <a:cs typeface="Arial"/>
+              </a:defRPr>
+            </a:lvl2pPr>
+            <a:lvl3pPr>
+              <a:defRPr sz="1350" b="0">
+                <a:solidFill>
+                  <a:srgbClr val="AAB8C5"/>
+                </a:solidFill>
+                <a:latin typeface="Arial"/>
+                <a:ea typeface="Arial"/>
+                <a:cs typeface="Arial"/>
+              </a:defRPr>
+            </a:lvl3pPr>
+            <a:lvl4pPr>
+              <a:defRPr sz="1350" b="0">
+                <a:solidFill>
+                  <a:srgbClr val="AAB8C5"/>
+                </a:solidFill>
+                <a:latin typeface="Arial"/>
+                <a:ea typeface="Arial"/>
+                <a:cs typeface="Arial"/>
+              </a:defRPr>
+            </a:lvl4pPr>
+            <a:lvl5pPr>
+              <a:defRPr sz="1350" b="0">
+                <a:solidFill>
+                  <a:srgbClr val="AAB8C5"/>
+                </a:solidFill>
+                <a:latin typeface="Arial"/>
+                <a:ea typeface="Arial"/>
+                <a:cs typeface="Arial"/>
+              </a:defRPr>
+            </a:lvl5pPr>
+            <a:lvl6pPr>
+              <a:defRPr sz="1350" b="0">
+                <a:solidFill>
+                  <a:srgbClr val="AAB8C5"/>
+                </a:solidFill>
+                <a:latin typeface="Arial"/>
+                <a:ea typeface="Arial"/>
+                <a:cs typeface="Arial"/>
+              </a:defRPr>
+            </a:lvl6pPr>
+            <a:lvl7pPr>
+              <a:defRPr sz="1350" b="0">
+                <a:solidFill>
+                  <a:srgbClr val="AAB8C5"/>
+                </a:solidFill>
+                <a:latin typeface="Arial"/>
+                <a:ea typeface="Arial"/>
+                <a:cs typeface="Arial"/>
+              </a:defRPr>
+            </a:lvl7pPr>
+            <a:lvl8pPr>
+              <a:defRPr sz="1350" b="0">
+                <a:solidFill>
+                  <a:srgbClr val="AAB8C5"/>
+                </a:solidFill>
+                <a:latin typeface="Arial"/>
+                <a:ea typeface="Arial"/>
+                <a:cs typeface="Arial"/>
+              </a:defRPr>
+            </a:lvl8pPr>
+            <a:lvl9pPr>
+              <a:defRPr sz="1350" b="0">
+                <a:solidFill>
+                  <a:srgbClr val="AAB8C5"/>
+                </a:solidFill>
+                <a:latin typeface="Arial"/>
+                <a:ea typeface="Arial"/>
+                <a:cs typeface="Arial"/>
+              </a:defRPr>
+            </a:lvl9pPr>
           </a:lstStyle>
           <a:p xmlns:a="http://schemas.openxmlformats.org/drawingml/2006/main">
             <a:pPr>
@@ -3949,7 +5639,7 @@
                 <a:ea typeface="Arial"/>
                 <a:cs typeface="Arial"/>
               </a:rPr>
-              <a:t>Controle da comparação local</a:t>
+              <a:t>Resultados por escala · saídas em caracteres</a:t>
             </a:r>
           </a:p>
         </p:txBody>
@@ -3959,7 +5649,7 @@
           <p:cNvPr id="14" name="">
             <a:extLst xmlns:a="http://schemas.openxmlformats.org/drawingml/2006/main">
               <a:ext uri="{FF2B5EF4-FFF2-40B4-BE49-F238E27FC236}">
-                <a16:creationId xmlns:a16="http://schemas.microsoft.com/office/drawing/2014/main" id="{7E60879A-9846-47C3-B233-0D9BCF1C5A85}"/>
+                <a16:creationId xmlns:a16="http://schemas.microsoft.com/office/drawing/2014/main" id="{A436ED1F-28F4-44CC-800E-A3FD1406E7FD}"/>
               </a:ext>
             </a:extLst>
           </p:cNvPr>
@@ -4000,7 +5690,7 @@
                           <a:ea typeface="Arial"/>
                           <a:cs typeface="Arial"/>
                         </a:rPr>
-                        <a:t>Controle</a:t>
+                        <a:t>Escala</a:t>
                       </a:r>
                     </a:p>
                   </a:txBody>
@@ -4041,7 +5731,7 @@
                           <a:ea typeface="Arial"/>
                           <a:cs typeface="Arial"/>
                         </a:rPr>
-                        <a:t>Antes</a:t>
+                        <a:t>40 notas</a:t>
                       </a:r>
                     </a:p>
                   </a:txBody>
@@ -4079,7 +5769,7 @@
                           <a:ea typeface="Arial"/>
                           <a:cs typeface="Arial"/>
                         </a:rPr>
-                        <a:t>Agora</a:t>
+                        <a:t>1.000 notas</a:t>
                       </a:r>
                     </a:p>
                   </a:txBody>
@@ -4117,7 +5807,7 @@
                           <a:ea typeface="Arial"/>
                           <a:cs typeface="Arial"/>
                         </a:rPr>
-                        <a:t>Diferença</a:t>
+                        <a:t>10.000 notas</a:t>
                       </a:r>
                     </a:p>
                   </a:txBody>
@@ -4157,7 +5847,7 @@
                           <a:ea typeface="Arial"/>
                           <a:cs typeface="Arial"/>
                         </a:rPr>
-                        <a:t>Notas</a:t>
+                        <a:t>Acervo (car.)</a:t>
                       </a:r>
                     </a:p>
                   </a:txBody>
@@ -4195,7 +5885,7 @@
                           <a:ea typeface="Arial"/>
                           <a:cs typeface="Arial"/>
                         </a:rPr>
-                        <a:t>5</a:t>
+                        <a:t>105.046</a:t>
                       </a:r>
                     </a:p>
                   </a:txBody>
@@ -4230,7 +5920,7 @@
                           <a:ea typeface="Arial"/>
                           <a:cs typeface="Arial"/>
                         </a:rPr>
-                        <a:t>5</a:t>
+                        <a:t>2.690.974</a:t>
                       </a:r>
                     </a:p>
                   </a:txBody>
@@ -4265,7 +5955,7 @@
                           <a:ea typeface="Arial"/>
                           <a:cs typeface="Arial"/>
                         </a:rPr>
-                        <a:t>mesmas</a:t>
+                        <a:t>26.918.974</a:t>
                       </a:r>
                     </a:p>
                   </a:txBody>
@@ -4302,7 +5992,7 @@
                           <a:ea typeface="Arial"/>
                           <a:cs typeface="Arial"/>
                         </a:rPr>
-                        <a:t>Trechos</a:t>
+                        <a:t>Consultas</a:t>
                       </a:r>
                     </a:p>
                   </a:txBody>
@@ -4340,7 +6030,7 @@
                           <a:ea typeface="Arial"/>
                           <a:cs typeface="Arial"/>
                         </a:rPr>
-                        <a:t>originais</a:t>
+                        <a:t>8</a:t>
                       </a:r>
                     </a:p>
                   </a:txBody>
@@ -4375,7 +6065,7 @@
                           <a:ea typeface="Arial"/>
                           <a:cs typeface="Arial"/>
                         </a:rPr>
-                        <a:t>idênticos</a:t>
+                        <a:t>8</a:t>
                       </a:r>
                     </a:p>
                   </a:txBody>
@@ -4410,7 +6100,7 @@
                           <a:ea typeface="Arial"/>
                           <a:cs typeface="Arial"/>
                         </a:rPr>
-                        <a:t>preservados</a:t>
+                        <a:t>8</a:t>
                       </a:r>
                     </a:p>
                   </a:txBody>
@@ -4447,7 +6137,7 @@
                           <a:ea typeface="Arial"/>
                           <a:cs typeface="Arial"/>
                         </a:rPr>
-                        <a:t>Limite</a:t>
+                        <a:t>Saída antes</a:t>
                       </a:r>
                     </a:p>
                   </a:txBody>
@@ -4485,7 +6175,7 @@
                           <a:ea typeface="Arial"/>
                           <a:cs typeface="Arial"/>
                         </a:rPr>
-                        <a:t>5 notas</a:t>
+                        <a:t>44.547</a:t>
                       </a:r>
                     </a:p>
                   </a:txBody>
@@ -4520,7 +6210,7 @@
                           <a:ea typeface="Arial"/>
                           <a:cs typeface="Arial"/>
                         </a:rPr>
-                        <a:t>5 notas</a:t>
+                        <a:t>82.546</a:t>
                       </a:r>
                     </a:p>
                   </a:txBody>
@@ -4555,7 +6245,7 @@
                           <a:ea typeface="Arial"/>
                           <a:cs typeface="Arial"/>
                         </a:rPr>
-                        <a:t>igual</a:t>
+                        <a:t>83.872</a:t>
                       </a:r>
                     </a:p>
                   </a:txBody>
@@ -4592,7 +6282,7 @@
                           <a:ea typeface="Arial"/>
                           <a:cs typeface="Arial"/>
                         </a:rPr>
-                        <a:t>Orçamento</a:t>
+                        <a:t>Saída atual</a:t>
                       </a:r>
                     </a:p>
                   </a:txBody>
@@ -4630,7 +6320,7 @@
                           <a:ea typeface="Arial"/>
                           <a:cs typeface="Arial"/>
                         </a:rPr>
-                        <a:t>12.000</a:t>
+                        <a:t>37.155</a:t>
                       </a:r>
                     </a:p>
                   </a:txBody>
@@ -4665,7 +6355,7 @@
                           <a:ea typeface="Arial"/>
                           <a:cs typeface="Arial"/>
                         </a:rPr>
-                        <a:t>12.000</a:t>
+                        <a:t>40.565</a:t>
                       </a:r>
                     </a:p>
                   </a:txBody>
@@ -4700,7 +6390,7 @@
                           <a:ea typeface="Arial"/>
                           <a:cs typeface="Arial"/>
                         </a:rPr>
-                        <a:t>igual</a:t>
+                        <a:t>40.579</a:t>
                       </a:r>
                     </a:p>
                   </a:txBody>
@@ -4737,7 +6427,7 @@
                           <a:ea typeface="Arial"/>
                           <a:cs typeface="Arial"/>
                         </a:rPr>
-                        <a:t>Caracteres</a:t>
+                        <a:t>Redução</a:t>
                       </a:r>
                     </a:p>
                   </a:txBody>
@@ -4775,7 +6465,7 @@
                           <a:ea typeface="Arial"/>
                           <a:cs typeface="Arial"/>
                         </a:rPr>
-                        <a:t>11.961</a:t>
+                        <a:t>16,6%</a:t>
                       </a:r>
                     </a:p>
                   </a:txBody>
@@ -4810,7 +6500,7 @@
                           <a:ea typeface="Arial"/>
                           <a:cs typeface="Arial"/>
                         </a:rPr>
-                        <a:t>4.677</a:t>
+                        <a:t>50,9%</a:t>
                       </a:r>
                     </a:p>
                   </a:txBody>
@@ -4845,7 +6535,7 @@
                           <a:ea typeface="Arial"/>
                           <a:cs typeface="Arial"/>
                         </a:rPr>
-                        <a:t>−7.284</a:t>
+                        <a:t>51,6%</a:t>
                       </a:r>
                     </a:p>
                   </a:txBody>
@@ -4908,6 +6598,96 @@
                 <a:cs typeface="Arial"/>
               </a:defRPr>
             </a:defPPr>
+            <a:lvl1pPr>
+              <a:defRPr sz="1650" b="1">
+                <a:solidFill>
+                  <a:srgbClr val="F5F6F0"/>
+                </a:solidFill>
+                <a:latin typeface="Arial"/>
+                <a:ea typeface="Arial"/>
+                <a:cs typeface="Arial"/>
+              </a:defRPr>
+            </a:lvl1pPr>
+            <a:lvl2pPr>
+              <a:defRPr sz="1650" b="1">
+                <a:solidFill>
+                  <a:srgbClr val="F5F6F0"/>
+                </a:solidFill>
+                <a:latin typeface="Arial"/>
+                <a:ea typeface="Arial"/>
+                <a:cs typeface="Arial"/>
+              </a:defRPr>
+            </a:lvl2pPr>
+            <a:lvl3pPr>
+              <a:defRPr sz="1650" b="1">
+                <a:solidFill>
+                  <a:srgbClr val="F5F6F0"/>
+                </a:solidFill>
+                <a:latin typeface="Arial"/>
+                <a:ea typeface="Arial"/>
+                <a:cs typeface="Arial"/>
+              </a:defRPr>
+            </a:lvl3pPr>
+            <a:lvl4pPr>
+              <a:defRPr sz="1650" b="1">
+                <a:solidFill>
+                  <a:srgbClr val="F5F6F0"/>
+                </a:solidFill>
+                <a:latin typeface="Arial"/>
+                <a:ea typeface="Arial"/>
+                <a:cs typeface="Arial"/>
+              </a:defRPr>
+            </a:lvl4pPr>
+            <a:lvl5pPr>
+              <a:defRPr sz="1650" b="1">
+                <a:solidFill>
+                  <a:srgbClr val="F5F6F0"/>
+                </a:solidFill>
+                <a:latin typeface="Arial"/>
+                <a:ea typeface="Arial"/>
+                <a:cs typeface="Arial"/>
+              </a:defRPr>
+            </a:lvl5pPr>
+            <a:lvl6pPr>
+              <a:defRPr sz="1650" b="1">
+                <a:solidFill>
+                  <a:srgbClr val="F5F6F0"/>
+                </a:solidFill>
+                <a:latin typeface="Arial"/>
+                <a:ea typeface="Arial"/>
+                <a:cs typeface="Arial"/>
+              </a:defRPr>
+            </a:lvl6pPr>
+            <a:lvl7pPr>
+              <a:defRPr sz="1650" b="1">
+                <a:solidFill>
+                  <a:srgbClr val="F5F6F0"/>
+                </a:solidFill>
+                <a:latin typeface="Arial"/>
+                <a:ea typeface="Arial"/>
+                <a:cs typeface="Arial"/>
+              </a:defRPr>
+            </a:lvl7pPr>
+            <a:lvl8pPr>
+              <a:defRPr sz="1650" b="1">
+                <a:solidFill>
+                  <a:srgbClr val="F5F6F0"/>
+                </a:solidFill>
+                <a:latin typeface="Arial"/>
+                <a:ea typeface="Arial"/>
+                <a:cs typeface="Arial"/>
+              </a:defRPr>
+            </a:lvl8pPr>
+            <a:lvl9pPr>
+              <a:defRPr sz="1650" b="1">
+                <a:solidFill>
+                  <a:srgbClr val="F5F6F0"/>
+                </a:solidFill>
+                <a:latin typeface="Arial"/>
+                <a:ea typeface="Arial"/>
+                <a:cs typeface="Arial"/>
+              </a:defRPr>
+            </a:lvl9pPr>
           </a:lstStyle>
           <a:p xmlns:a="http://schemas.openxmlformats.org/drawingml/2006/main">
             <a:pPr>
@@ -4930,7 +6710,7 @@
                 <a:ea typeface="Arial"/>
                 <a:cs typeface="Arial"/>
               </a:rPr>
-              <a:t>Benchmark público sintético</a:t>
+              <a:t>Reproduza a análise ampliada</a:t>
             </a:r>
           </a:p>
         </p:txBody>
@@ -4977,6 +6757,96 @@
                 <a:cs typeface="Arial"/>
               </a:defRPr>
             </a:defPPr>
+            <a:lvl1pPr>
+              <a:defRPr sz="1425" b="0">
+                <a:solidFill>
+                  <a:srgbClr val="70DEC9"/>
+                </a:solidFill>
+                <a:latin typeface="Arial"/>
+                <a:ea typeface="Arial"/>
+                <a:cs typeface="Arial"/>
+              </a:defRPr>
+            </a:lvl1pPr>
+            <a:lvl2pPr>
+              <a:defRPr sz="1425" b="0">
+                <a:solidFill>
+                  <a:srgbClr val="70DEC9"/>
+                </a:solidFill>
+                <a:latin typeface="Arial"/>
+                <a:ea typeface="Arial"/>
+                <a:cs typeface="Arial"/>
+              </a:defRPr>
+            </a:lvl2pPr>
+            <a:lvl3pPr>
+              <a:defRPr sz="1425" b="0">
+                <a:solidFill>
+                  <a:srgbClr val="70DEC9"/>
+                </a:solidFill>
+                <a:latin typeface="Arial"/>
+                <a:ea typeface="Arial"/>
+                <a:cs typeface="Arial"/>
+              </a:defRPr>
+            </a:lvl3pPr>
+            <a:lvl4pPr>
+              <a:defRPr sz="1425" b="0">
+                <a:solidFill>
+                  <a:srgbClr val="70DEC9"/>
+                </a:solidFill>
+                <a:latin typeface="Arial"/>
+                <a:ea typeface="Arial"/>
+                <a:cs typeface="Arial"/>
+              </a:defRPr>
+            </a:lvl4pPr>
+            <a:lvl5pPr>
+              <a:defRPr sz="1425" b="0">
+                <a:solidFill>
+                  <a:srgbClr val="70DEC9"/>
+                </a:solidFill>
+                <a:latin typeface="Arial"/>
+                <a:ea typeface="Arial"/>
+                <a:cs typeface="Arial"/>
+              </a:defRPr>
+            </a:lvl5pPr>
+            <a:lvl6pPr>
+              <a:defRPr sz="1425" b="0">
+                <a:solidFill>
+                  <a:srgbClr val="70DEC9"/>
+                </a:solidFill>
+                <a:latin typeface="Arial"/>
+                <a:ea typeface="Arial"/>
+                <a:cs typeface="Arial"/>
+              </a:defRPr>
+            </a:lvl6pPr>
+            <a:lvl7pPr>
+              <a:defRPr sz="1425" b="0">
+                <a:solidFill>
+                  <a:srgbClr val="70DEC9"/>
+                </a:solidFill>
+                <a:latin typeface="Arial"/>
+                <a:ea typeface="Arial"/>
+                <a:cs typeface="Arial"/>
+              </a:defRPr>
+            </a:lvl7pPr>
+            <a:lvl8pPr>
+              <a:defRPr sz="1425" b="0">
+                <a:solidFill>
+                  <a:srgbClr val="70DEC9"/>
+                </a:solidFill>
+                <a:latin typeface="Arial"/>
+                <a:ea typeface="Arial"/>
+                <a:cs typeface="Arial"/>
+              </a:defRPr>
+            </a:lvl8pPr>
+            <a:lvl9pPr>
+              <a:defRPr sz="1425" b="0">
+                <a:solidFill>
+                  <a:srgbClr val="70DEC9"/>
+                </a:solidFill>
+                <a:latin typeface="Arial"/>
+                <a:ea typeface="Arial"/>
+                <a:cs typeface="Arial"/>
+              </a:defRPr>
+            </a:lvl9pPr>
           </a:lstStyle>
           <a:p xmlns:a="http://schemas.openxmlformats.org/drawingml/2006/main">
             <a:pPr>
@@ -4999,7 +6869,7 @@
                 <a:ea typeface="Arial"/>
                 <a:cs typeface="Arial"/>
               </a:rPr>
-              <a:t>40 notas · seleção de 5 notas e 20 trechos</a:t>
+              <a:t>python3 tools/benchmark_busca.py</a:t>
             </a:r>
           </a:p>
         </p:txBody>
@@ -5046,6 +6916,96 @@
                 <a:cs typeface="Arial"/>
               </a:defRPr>
             </a:defPPr>
+            <a:lvl1pPr>
+              <a:defRPr sz="1425" b="0">
+                <a:solidFill>
+                  <a:srgbClr val="92BFFF"/>
+                </a:solidFill>
+                <a:latin typeface="Arial"/>
+                <a:ea typeface="Arial"/>
+                <a:cs typeface="Arial"/>
+              </a:defRPr>
+            </a:lvl1pPr>
+            <a:lvl2pPr>
+              <a:defRPr sz="1425" b="0">
+                <a:solidFill>
+                  <a:srgbClr val="92BFFF"/>
+                </a:solidFill>
+                <a:latin typeface="Arial"/>
+                <a:ea typeface="Arial"/>
+                <a:cs typeface="Arial"/>
+              </a:defRPr>
+            </a:lvl2pPr>
+            <a:lvl3pPr>
+              <a:defRPr sz="1425" b="0">
+                <a:solidFill>
+                  <a:srgbClr val="92BFFF"/>
+                </a:solidFill>
+                <a:latin typeface="Arial"/>
+                <a:ea typeface="Arial"/>
+                <a:cs typeface="Arial"/>
+              </a:defRPr>
+            </a:lvl3pPr>
+            <a:lvl4pPr>
+              <a:defRPr sz="1425" b="0">
+                <a:solidFill>
+                  <a:srgbClr val="92BFFF"/>
+                </a:solidFill>
+                <a:latin typeface="Arial"/>
+                <a:ea typeface="Arial"/>
+                <a:cs typeface="Arial"/>
+              </a:defRPr>
+            </a:lvl4pPr>
+            <a:lvl5pPr>
+              <a:defRPr sz="1425" b="0">
+                <a:solidFill>
+                  <a:srgbClr val="92BFFF"/>
+                </a:solidFill>
+                <a:latin typeface="Arial"/>
+                <a:ea typeface="Arial"/>
+                <a:cs typeface="Arial"/>
+              </a:defRPr>
+            </a:lvl5pPr>
+            <a:lvl6pPr>
+              <a:defRPr sz="1425" b="0">
+                <a:solidFill>
+                  <a:srgbClr val="92BFFF"/>
+                </a:solidFill>
+                <a:latin typeface="Arial"/>
+                <a:ea typeface="Arial"/>
+                <a:cs typeface="Arial"/>
+              </a:defRPr>
+            </a:lvl6pPr>
+            <a:lvl7pPr>
+              <a:defRPr sz="1425" b="0">
+                <a:solidFill>
+                  <a:srgbClr val="92BFFF"/>
+                </a:solidFill>
+                <a:latin typeface="Arial"/>
+                <a:ea typeface="Arial"/>
+                <a:cs typeface="Arial"/>
+              </a:defRPr>
+            </a:lvl7pPr>
+            <a:lvl8pPr>
+              <a:defRPr sz="1425" b="0">
+                <a:solidFill>
+                  <a:srgbClr val="92BFFF"/>
+                </a:solidFill>
+                <a:latin typeface="Arial"/>
+                <a:ea typeface="Arial"/>
+                <a:cs typeface="Arial"/>
+              </a:defRPr>
+            </a:lvl8pPr>
+            <a:lvl9pPr>
+              <a:defRPr sz="1425" b="0">
+                <a:solidFill>
+                  <a:srgbClr val="92BFFF"/>
+                </a:solidFill>
+                <a:latin typeface="Arial"/>
+                <a:ea typeface="Arial"/>
+                <a:cs typeface="Arial"/>
+              </a:defRPr>
+            </a:lvl9pPr>
           </a:lstStyle>
           <a:p xmlns:a="http://schemas.openxmlformats.org/drawingml/2006/main">
             <a:pPr>
@@ -5068,7 +7028,7 @@
                 <a:ea typeface="Arial"/>
                 <a:cs typeface="Arial"/>
               </a:rPr>
-              <a:t>11.696 → 5.862 caracteres (−49,9%)</a:t>
+              <a:t>--ampliado</a:t>
             </a:r>
           </a:p>
         </p:txBody>
@@ -5115,6 +7075,96 @@
                 <a:cs typeface="Arial"/>
               </a:defRPr>
             </a:defPPr>
+            <a:lvl1pPr>
+              <a:defRPr sz="1425" b="0">
+                <a:solidFill>
+                  <a:srgbClr val="F5F6F0"/>
+                </a:solidFill>
+                <a:latin typeface="Arial"/>
+                <a:ea typeface="Arial"/>
+                <a:cs typeface="Arial"/>
+              </a:defRPr>
+            </a:lvl1pPr>
+            <a:lvl2pPr>
+              <a:defRPr sz="1425" b="0">
+                <a:solidFill>
+                  <a:srgbClr val="F5F6F0"/>
+                </a:solidFill>
+                <a:latin typeface="Arial"/>
+                <a:ea typeface="Arial"/>
+                <a:cs typeface="Arial"/>
+              </a:defRPr>
+            </a:lvl2pPr>
+            <a:lvl3pPr>
+              <a:defRPr sz="1425" b="0">
+                <a:solidFill>
+                  <a:srgbClr val="F5F6F0"/>
+                </a:solidFill>
+                <a:latin typeface="Arial"/>
+                <a:ea typeface="Arial"/>
+                <a:cs typeface="Arial"/>
+              </a:defRPr>
+            </a:lvl3pPr>
+            <a:lvl4pPr>
+              <a:defRPr sz="1425" b="0">
+                <a:solidFill>
+                  <a:srgbClr val="F5F6F0"/>
+                </a:solidFill>
+                <a:latin typeface="Arial"/>
+                <a:ea typeface="Arial"/>
+                <a:cs typeface="Arial"/>
+              </a:defRPr>
+            </a:lvl4pPr>
+            <a:lvl5pPr>
+              <a:defRPr sz="1425" b="0">
+                <a:solidFill>
+                  <a:srgbClr val="F5F6F0"/>
+                </a:solidFill>
+                <a:latin typeface="Arial"/>
+                <a:ea typeface="Arial"/>
+                <a:cs typeface="Arial"/>
+              </a:defRPr>
+            </a:lvl5pPr>
+            <a:lvl6pPr>
+              <a:defRPr sz="1425" b="0">
+                <a:solidFill>
+                  <a:srgbClr val="F5F6F0"/>
+                </a:solidFill>
+                <a:latin typeface="Arial"/>
+                <a:ea typeface="Arial"/>
+                <a:cs typeface="Arial"/>
+              </a:defRPr>
+            </a:lvl6pPr>
+            <a:lvl7pPr>
+              <a:defRPr sz="1425" b="0">
+                <a:solidFill>
+                  <a:srgbClr val="F5F6F0"/>
+                </a:solidFill>
+                <a:latin typeface="Arial"/>
+                <a:ea typeface="Arial"/>
+                <a:cs typeface="Arial"/>
+              </a:defRPr>
+            </a:lvl7pPr>
+            <a:lvl8pPr>
+              <a:defRPr sz="1425" b="0">
+                <a:solidFill>
+                  <a:srgbClr val="F5F6F0"/>
+                </a:solidFill>
+                <a:latin typeface="Arial"/>
+                <a:ea typeface="Arial"/>
+                <a:cs typeface="Arial"/>
+              </a:defRPr>
+            </a:lvl8pPr>
+            <a:lvl9pPr>
+              <a:defRPr sz="1425" b="0">
+                <a:solidFill>
+                  <a:srgbClr val="F5F6F0"/>
+                </a:solidFill>
+                <a:latin typeface="Arial"/>
+                <a:ea typeface="Arial"/>
+                <a:cs typeface="Arial"/>
+              </a:defRPr>
+            </a:lvl9pPr>
           </a:lstStyle>
           <a:p xmlns:a="http://schemas.openxmlformats.org/drawingml/2006/main">
             <a:pPr>
@@ -5137,7 +7187,7 @@
                 <a:ea typeface="Arial"/>
                 <a:cs typeface="Arial"/>
               </a:rPr>
-              <a:t>Reproduza com dados de demonstração:</a:t>
+              <a:t>Maior corpus: 26.918.974 caracteres</a:t>
             </a:r>
           </a:p>
           <a:p xmlns:a="http://schemas.openxmlformats.org/drawingml/2006/main">
@@ -5161,7 +7211,7 @@
                 <a:ea typeface="Arial"/>
                 <a:cs typeface="Arial"/>
               </a:rPr>
-              <a:t>python3 tools/benchmark_busca.py</a:t>
+              <a:t>10.000 notas sintéticas + protocolo mínimo</a:t>
             </a:r>
           </a:p>
         </p:txBody>
@@ -5208,6 +7258,96 @@
                 <a:cs typeface="Arial"/>
               </a:defRPr>
             </a:defPPr>
+            <a:lvl1pPr>
+              <a:defRPr sz="1313" b="0">
+                <a:solidFill>
+                  <a:srgbClr val="AAB8C5"/>
+                </a:solidFill>
+                <a:latin typeface="Arial"/>
+                <a:ea typeface="Arial"/>
+                <a:cs typeface="Arial"/>
+              </a:defRPr>
+            </a:lvl1pPr>
+            <a:lvl2pPr>
+              <a:defRPr sz="1313" b="0">
+                <a:solidFill>
+                  <a:srgbClr val="AAB8C5"/>
+                </a:solidFill>
+                <a:latin typeface="Arial"/>
+                <a:ea typeface="Arial"/>
+                <a:cs typeface="Arial"/>
+              </a:defRPr>
+            </a:lvl2pPr>
+            <a:lvl3pPr>
+              <a:defRPr sz="1313" b="0">
+                <a:solidFill>
+                  <a:srgbClr val="AAB8C5"/>
+                </a:solidFill>
+                <a:latin typeface="Arial"/>
+                <a:ea typeface="Arial"/>
+                <a:cs typeface="Arial"/>
+              </a:defRPr>
+            </a:lvl3pPr>
+            <a:lvl4pPr>
+              <a:defRPr sz="1313" b="0">
+                <a:solidFill>
+                  <a:srgbClr val="AAB8C5"/>
+                </a:solidFill>
+                <a:latin typeface="Arial"/>
+                <a:ea typeface="Arial"/>
+                <a:cs typeface="Arial"/>
+              </a:defRPr>
+            </a:lvl4pPr>
+            <a:lvl5pPr>
+              <a:defRPr sz="1313" b="0">
+                <a:solidFill>
+                  <a:srgbClr val="AAB8C5"/>
+                </a:solidFill>
+                <a:latin typeface="Arial"/>
+                <a:ea typeface="Arial"/>
+                <a:cs typeface="Arial"/>
+              </a:defRPr>
+            </a:lvl5pPr>
+            <a:lvl6pPr>
+              <a:defRPr sz="1313" b="0">
+                <a:solidFill>
+                  <a:srgbClr val="AAB8C5"/>
+                </a:solidFill>
+                <a:latin typeface="Arial"/>
+                <a:ea typeface="Arial"/>
+                <a:cs typeface="Arial"/>
+              </a:defRPr>
+            </a:lvl6pPr>
+            <a:lvl7pPr>
+              <a:defRPr sz="1313" b="0">
+                <a:solidFill>
+                  <a:srgbClr val="AAB8C5"/>
+                </a:solidFill>
+                <a:latin typeface="Arial"/>
+                <a:ea typeface="Arial"/>
+                <a:cs typeface="Arial"/>
+              </a:defRPr>
+            </a:lvl7pPr>
+            <a:lvl8pPr>
+              <a:defRPr sz="1313" b="0">
+                <a:solidFill>
+                  <a:srgbClr val="AAB8C5"/>
+                </a:solidFill>
+                <a:latin typeface="Arial"/>
+                <a:ea typeface="Arial"/>
+                <a:cs typeface="Arial"/>
+              </a:defRPr>
+            </a:lvl8pPr>
+            <a:lvl9pPr>
+              <a:defRPr sz="1313" b="0">
+                <a:solidFill>
+                  <a:srgbClr val="AAB8C5"/>
+                </a:solidFill>
+                <a:latin typeface="Arial"/>
+                <a:ea typeface="Arial"/>
+                <a:cs typeface="Arial"/>
+              </a:defRPr>
+            </a:lvl9pPr>
           </a:lstStyle>
           <a:p xmlns:a="http://schemas.openxmlformats.org/drawingml/2006/main">
             <a:pPr>
@@ -5230,7 +7370,7 @@
                 <a:ea typeface="Arial"/>
                 <a:cs typeface="Arial"/>
               </a:rPr>
-              <a:t>Cenário distinto da medição local de 60,9%.</a:t>
+              <a:t>Medição local anterior: 60,9% em uma consulta.</a:t>
             </a:r>
           </a:p>
         </p:txBody>
@@ -5277,6 +7417,96 @@
                 <a:cs typeface="Arial"/>
               </a:defRPr>
             </a:defPPr>
+            <a:lvl1pPr>
+              <a:defRPr sz="1800" b="1">
+                <a:solidFill>
+                  <a:srgbClr val="F5F6F0"/>
+                </a:solidFill>
+                <a:latin typeface="Arial"/>
+                <a:ea typeface="Arial"/>
+                <a:cs typeface="Arial"/>
+              </a:defRPr>
+            </a:lvl1pPr>
+            <a:lvl2pPr>
+              <a:defRPr sz="1800" b="1">
+                <a:solidFill>
+                  <a:srgbClr val="F5F6F0"/>
+                </a:solidFill>
+                <a:latin typeface="Arial"/>
+                <a:ea typeface="Arial"/>
+                <a:cs typeface="Arial"/>
+              </a:defRPr>
+            </a:lvl2pPr>
+            <a:lvl3pPr>
+              <a:defRPr sz="1800" b="1">
+                <a:solidFill>
+                  <a:srgbClr val="F5F6F0"/>
+                </a:solidFill>
+                <a:latin typeface="Arial"/>
+                <a:ea typeface="Arial"/>
+                <a:cs typeface="Arial"/>
+              </a:defRPr>
+            </a:lvl3pPr>
+            <a:lvl4pPr>
+              <a:defRPr sz="1800" b="1">
+                <a:solidFill>
+                  <a:srgbClr val="F5F6F0"/>
+                </a:solidFill>
+                <a:latin typeface="Arial"/>
+                <a:ea typeface="Arial"/>
+                <a:cs typeface="Arial"/>
+              </a:defRPr>
+            </a:lvl4pPr>
+            <a:lvl5pPr>
+              <a:defRPr sz="1800" b="1">
+                <a:solidFill>
+                  <a:srgbClr val="F5F6F0"/>
+                </a:solidFill>
+                <a:latin typeface="Arial"/>
+                <a:ea typeface="Arial"/>
+                <a:cs typeface="Arial"/>
+              </a:defRPr>
+            </a:lvl5pPr>
+            <a:lvl6pPr>
+              <a:defRPr sz="1800" b="1">
+                <a:solidFill>
+                  <a:srgbClr val="F5F6F0"/>
+                </a:solidFill>
+                <a:latin typeface="Arial"/>
+                <a:ea typeface="Arial"/>
+                <a:cs typeface="Arial"/>
+              </a:defRPr>
+            </a:lvl6pPr>
+            <a:lvl7pPr>
+              <a:defRPr sz="1800" b="1">
+                <a:solidFill>
+                  <a:srgbClr val="F5F6F0"/>
+                </a:solidFill>
+                <a:latin typeface="Arial"/>
+                <a:ea typeface="Arial"/>
+                <a:cs typeface="Arial"/>
+              </a:defRPr>
+            </a:lvl7pPr>
+            <a:lvl8pPr>
+              <a:defRPr sz="1800" b="1">
+                <a:solidFill>
+                  <a:srgbClr val="F5F6F0"/>
+                </a:solidFill>
+                <a:latin typeface="Arial"/>
+                <a:ea typeface="Arial"/>
+                <a:cs typeface="Arial"/>
+              </a:defRPr>
+            </a:lvl8pPr>
+            <a:lvl9pPr>
+              <a:defRPr sz="1800" b="1">
+                <a:solidFill>
+                  <a:srgbClr val="F5F6F0"/>
+                </a:solidFill>
+                <a:latin typeface="Arial"/>
+                <a:ea typeface="Arial"/>
+                <a:cs typeface="Arial"/>
+              </a:defRPr>
+            </a:lvl9pPr>
           </a:lstStyle>
           <a:p xmlns:a="http://schemas.openxmlformats.org/drawingml/2006/main">
             <a:pPr>
@@ -5299,7 +7529,7 @@
                 <a:ea typeface="Arial"/>
                 <a:cs typeface="Arial"/>
               </a:rPr>
-              <a:t>Menos texto repetido para recuperar o mesmo contexto</a:t>
+              <a:t>O acervo cresce; o contexto retornado tem orçamento</a:t>
             </a:r>
           </a:p>
         </p:txBody>
@@ -5346,6 +7576,96 @@
                 <a:cs typeface="Arial"/>
               </a:defRPr>
             </a:defPPr>
+            <a:lvl1pPr>
+              <a:defRPr sz="1388" b="0">
+                <a:solidFill>
+                  <a:srgbClr val="92BFFF"/>
+                </a:solidFill>
+                <a:latin typeface="Arial"/>
+                <a:ea typeface="Arial"/>
+                <a:cs typeface="Arial"/>
+              </a:defRPr>
+            </a:lvl1pPr>
+            <a:lvl2pPr>
+              <a:defRPr sz="1388" b="0">
+                <a:solidFill>
+                  <a:srgbClr val="92BFFF"/>
+                </a:solidFill>
+                <a:latin typeface="Arial"/>
+                <a:ea typeface="Arial"/>
+                <a:cs typeface="Arial"/>
+              </a:defRPr>
+            </a:lvl2pPr>
+            <a:lvl3pPr>
+              <a:defRPr sz="1388" b="0">
+                <a:solidFill>
+                  <a:srgbClr val="92BFFF"/>
+                </a:solidFill>
+                <a:latin typeface="Arial"/>
+                <a:ea typeface="Arial"/>
+                <a:cs typeface="Arial"/>
+              </a:defRPr>
+            </a:lvl3pPr>
+            <a:lvl4pPr>
+              <a:defRPr sz="1388" b="0">
+                <a:solidFill>
+                  <a:srgbClr val="92BFFF"/>
+                </a:solidFill>
+                <a:latin typeface="Arial"/>
+                <a:ea typeface="Arial"/>
+                <a:cs typeface="Arial"/>
+              </a:defRPr>
+            </a:lvl4pPr>
+            <a:lvl5pPr>
+              <a:defRPr sz="1388" b="0">
+                <a:solidFill>
+                  <a:srgbClr val="92BFFF"/>
+                </a:solidFill>
+                <a:latin typeface="Arial"/>
+                <a:ea typeface="Arial"/>
+                <a:cs typeface="Arial"/>
+              </a:defRPr>
+            </a:lvl5pPr>
+            <a:lvl6pPr>
+              <a:defRPr sz="1388" b="0">
+                <a:solidFill>
+                  <a:srgbClr val="92BFFF"/>
+                </a:solidFill>
+                <a:latin typeface="Arial"/>
+                <a:ea typeface="Arial"/>
+                <a:cs typeface="Arial"/>
+              </a:defRPr>
+            </a:lvl6pPr>
+            <a:lvl7pPr>
+              <a:defRPr sz="1388" b="0">
+                <a:solidFill>
+                  <a:srgbClr val="92BFFF"/>
+                </a:solidFill>
+                <a:latin typeface="Arial"/>
+                <a:ea typeface="Arial"/>
+                <a:cs typeface="Arial"/>
+              </a:defRPr>
+            </a:lvl7pPr>
+            <a:lvl8pPr>
+              <a:defRPr sz="1388" b="0">
+                <a:solidFill>
+                  <a:srgbClr val="92BFFF"/>
+                </a:solidFill>
+                <a:latin typeface="Arial"/>
+                <a:ea typeface="Arial"/>
+                <a:cs typeface="Arial"/>
+              </a:defRPr>
+            </a:lvl8pPr>
+            <a:lvl9pPr>
+              <a:defRPr sz="1388" b="0">
+                <a:solidFill>
+                  <a:srgbClr val="92BFFF"/>
+                </a:solidFill>
+                <a:latin typeface="Arial"/>
+                <a:ea typeface="Arial"/>
+                <a:cs typeface="Arial"/>
+              </a:defRPr>
+            </a:lvl9pPr>
           </a:lstStyle>
           <a:p xmlns:a="http://schemas.openxmlformats.org/drawingml/2006/main">
             <a:pPr>
@@ -5368,7 +7688,7 @@
                 <a:ea typeface="Arial"/>
                 <a:cs typeface="Arial"/>
               </a:rPr>
-              <a:t>Medição da busca; tokens totais, latência e produtividade não foram medidos.</a:t>
+              <a:t>210.965 → 118.299 soma 24 consultas distintas; não é o volume de uma única resposta.</a:t>
             </a:r>
           </a:p>
         </p:txBody>
@@ -5415,6 +7735,96 @@
                 <a:cs typeface="Arial"/>
               </a:defRPr>
             </a:defPPr>
+            <a:lvl1pPr>
+              <a:defRPr sz="1350" b="0">
+                <a:solidFill>
+                  <a:srgbClr val="70DEC9"/>
+                </a:solidFill>
+                <a:latin typeface="Arial"/>
+                <a:ea typeface="Arial"/>
+                <a:cs typeface="Arial"/>
+              </a:defRPr>
+            </a:lvl1pPr>
+            <a:lvl2pPr>
+              <a:defRPr sz="1350" b="0">
+                <a:solidFill>
+                  <a:srgbClr val="70DEC9"/>
+                </a:solidFill>
+                <a:latin typeface="Arial"/>
+                <a:ea typeface="Arial"/>
+                <a:cs typeface="Arial"/>
+              </a:defRPr>
+            </a:lvl2pPr>
+            <a:lvl3pPr>
+              <a:defRPr sz="1350" b="0">
+                <a:solidFill>
+                  <a:srgbClr val="70DEC9"/>
+                </a:solidFill>
+                <a:latin typeface="Arial"/>
+                <a:ea typeface="Arial"/>
+                <a:cs typeface="Arial"/>
+              </a:defRPr>
+            </a:lvl3pPr>
+            <a:lvl4pPr>
+              <a:defRPr sz="1350" b="0">
+                <a:solidFill>
+                  <a:srgbClr val="70DEC9"/>
+                </a:solidFill>
+                <a:latin typeface="Arial"/>
+                <a:ea typeface="Arial"/>
+                <a:cs typeface="Arial"/>
+              </a:defRPr>
+            </a:lvl4pPr>
+            <a:lvl5pPr>
+              <a:defRPr sz="1350" b="0">
+                <a:solidFill>
+                  <a:srgbClr val="70DEC9"/>
+                </a:solidFill>
+                <a:latin typeface="Arial"/>
+                <a:ea typeface="Arial"/>
+                <a:cs typeface="Arial"/>
+              </a:defRPr>
+            </a:lvl5pPr>
+            <a:lvl6pPr>
+              <a:defRPr sz="1350" b="0">
+                <a:solidFill>
+                  <a:srgbClr val="70DEC9"/>
+                </a:solidFill>
+                <a:latin typeface="Arial"/>
+                <a:ea typeface="Arial"/>
+                <a:cs typeface="Arial"/>
+              </a:defRPr>
+            </a:lvl6pPr>
+            <a:lvl7pPr>
+              <a:defRPr sz="1350" b="0">
+                <a:solidFill>
+                  <a:srgbClr val="70DEC9"/>
+                </a:solidFill>
+                <a:latin typeface="Arial"/>
+                <a:ea typeface="Arial"/>
+                <a:cs typeface="Arial"/>
+              </a:defRPr>
+            </a:lvl7pPr>
+            <a:lvl8pPr>
+              <a:defRPr sz="1350" b="0">
+                <a:solidFill>
+                  <a:srgbClr val="70DEC9"/>
+                </a:solidFill>
+                <a:latin typeface="Arial"/>
+                <a:ea typeface="Arial"/>
+                <a:cs typeface="Arial"/>
+              </a:defRPr>
+            </a:lvl8pPr>
+            <a:lvl9pPr>
+              <a:defRPr sz="1350" b="0">
+                <a:solidFill>
+                  <a:srgbClr val="70DEC9"/>
+                </a:solidFill>
+                <a:latin typeface="Arial"/>
+                <a:ea typeface="Arial"/>
+                <a:cs typeface="Arial"/>
+              </a:defRPr>
+            </a:lvl9pPr>
           </a:lstStyle>
           <a:p xmlns:a="http://schemas.openxmlformats.org/drawingml/2006/main">
             <a:pPr>
@@ -5437,7 +7847,7 @@
                 <a:ea typeface="Arial"/>
                 <a:cs typeface="Arial"/>
               </a:rPr>
-              <a:t>Mensalidade: R$ 0 de desconto. A redução medida é de caracteres por consulta.</a:t>
+              <a:t>Dados sintéticos reproduzíveis. Nenhuma inferência de IA ou API paga foi executada.</a:t>
             </a:r>
           </a:p>
         </p:txBody>
@@ -5484,6 +7894,96 @@
                 <a:cs typeface="Arial"/>
               </a:defRPr>
             </a:defPPr>
+            <a:lvl1pPr>
+              <a:defRPr sz="1350" b="0">
+                <a:solidFill>
+                  <a:srgbClr val="F5F6F0"/>
+                </a:solidFill>
+                <a:latin typeface="Arial"/>
+                <a:ea typeface="Arial"/>
+                <a:cs typeface="Arial"/>
+              </a:defRPr>
+            </a:lvl1pPr>
+            <a:lvl2pPr>
+              <a:defRPr sz="1350" b="0">
+                <a:solidFill>
+                  <a:srgbClr val="F5F6F0"/>
+                </a:solidFill>
+                <a:latin typeface="Arial"/>
+                <a:ea typeface="Arial"/>
+                <a:cs typeface="Arial"/>
+              </a:defRPr>
+            </a:lvl2pPr>
+            <a:lvl3pPr>
+              <a:defRPr sz="1350" b="0">
+                <a:solidFill>
+                  <a:srgbClr val="F5F6F0"/>
+                </a:solidFill>
+                <a:latin typeface="Arial"/>
+                <a:ea typeface="Arial"/>
+                <a:cs typeface="Arial"/>
+              </a:defRPr>
+            </a:lvl3pPr>
+            <a:lvl4pPr>
+              <a:defRPr sz="1350" b="0">
+                <a:solidFill>
+                  <a:srgbClr val="F5F6F0"/>
+                </a:solidFill>
+                <a:latin typeface="Arial"/>
+                <a:ea typeface="Arial"/>
+                <a:cs typeface="Arial"/>
+              </a:defRPr>
+            </a:lvl4pPr>
+            <a:lvl5pPr>
+              <a:defRPr sz="1350" b="0">
+                <a:solidFill>
+                  <a:srgbClr val="F5F6F0"/>
+                </a:solidFill>
+                <a:latin typeface="Arial"/>
+                <a:ea typeface="Arial"/>
+                <a:cs typeface="Arial"/>
+              </a:defRPr>
+            </a:lvl5pPr>
+            <a:lvl6pPr>
+              <a:defRPr sz="1350" b="0">
+                <a:solidFill>
+                  <a:srgbClr val="F5F6F0"/>
+                </a:solidFill>
+                <a:latin typeface="Arial"/>
+                <a:ea typeface="Arial"/>
+                <a:cs typeface="Arial"/>
+              </a:defRPr>
+            </a:lvl6pPr>
+            <a:lvl7pPr>
+              <a:defRPr sz="1350" b="0">
+                <a:solidFill>
+                  <a:srgbClr val="F5F6F0"/>
+                </a:solidFill>
+                <a:latin typeface="Arial"/>
+                <a:ea typeface="Arial"/>
+                <a:cs typeface="Arial"/>
+              </a:defRPr>
+            </a:lvl7pPr>
+            <a:lvl8pPr>
+              <a:defRPr sz="1350" b="0">
+                <a:solidFill>
+                  <a:srgbClr val="F5F6F0"/>
+                </a:solidFill>
+                <a:latin typeface="Arial"/>
+                <a:ea typeface="Arial"/>
+                <a:cs typeface="Arial"/>
+              </a:defRPr>
+            </a:lvl8pPr>
+            <a:lvl9pPr>
+              <a:defRPr sz="1350" b="0">
+                <a:solidFill>
+                  <a:srgbClr val="F5F6F0"/>
+                </a:solidFill>
+                <a:latin typeface="Arial"/>
+                <a:ea typeface="Arial"/>
+                <a:cs typeface="Arial"/>
+              </a:defRPr>
+            </a:lvl9pPr>
           </a:lstStyle>
           <a:p xmlns:a="http://schemas.openxmlformats.org/drawingml/2006/main">
             <a:pPr>
@@ -5506,7 +8006,7 @@
                 <a:ea typeface="Arial"/>
                 <a:cs typeface="Arial"/>
               </a:rPr>
-              <a:t>Consulta local em 16/10/2026 · versão 663803e · notas pessoais não publicadas.</a:t>
+              <a:t>Saída em caracteres; tokens totais, produtividade e economia financeira não foram medidos.</a:t>
             </a:r>
           </a:p>
         </p:txBody>
@@ -5553,6 +8053,96 @@
                 <a:cs typeface="Arial"/>
               </a:defRPr>
             </a:defPPr>
+            <a:lvl1pPr>
+              <a:defRPr sz="825" b="0">
+                <a:solidFill>
+                  <a:srgbClr val="AAB8C5"/>
+                </a:solidFill>
+                <a:latin typeface="Arial"/>
+                <a:ea typeface="Arial"/>
+                <a:cs typeface="Arial"/>
+              </a:defRPr>
+            </a:lvl1pPr>
+            <a:lvl2pPr>
+              <a:defRPr sz="825" b="0">
+                <a:solidFill>
+                  <a:srgbClr val="AAB8C5"/>
+                </a:solidFill>
+                <a:latin typeface="Arial"/>
+                <a:ea typeface="Arial"/>
+                <a:cs typeface="Arial"/>
+              </a:defRPr>
+            </a:lvl2pPr>
+            <a:lvl3pPr>
+              <a:defRPr sz="825" b="0">
+                <a:solidFill>
+                  <a:srgbClr val="AAB8C5"/>
+                </a:solidFill>
+                <a:latin typeface="Arial"/>
+                <a:ea typeface="Arial"/>
+                <a:cs typeface="Arial"/>
+              </a:defRPr>
+            </a:lvl3pPr>
+            <a:lvl4pPr>
+              <a:defRPr sz="825" b="0">
+                <a:solidFill>
+                  <a:srgbClr val="AAB8C5"/>
+                </a:solidFill>
+                <a:latin typeface="Arial"/>
+                <a:ea typeface="Arial"/>
+                <a:cs typeface="Arial"/>
+              </a:defRPr>
+            </a:lvl4pPr>
+            <a:lvl5pPr>
+              <a:defRPr sz="825" b="0">
+                <a:solidFill>
+                  <a:srgbClr val="AAB8C5"/>
+                </a:solidFill>
+                <a:latin typeface="Arial"/>
+                <a:ea typeface="Arial"/>
+                <a:cs typeface="Arial"/>
+              </a:defRPr>
+            </a:lvl5pPr>
+            <a:lvl6pPr>
+              <a:defRPr sz="825" b="0">
+                <a:solidFill>
+                  <a:srgbClr val="AAB8C5"/>
+                </a:solidFill>
+                <a:latin typeface="Arial"/>
+                <a:ea typeface="Arial"/>
+                <a:cs typeface="Arial"/>
+              </a:defRPr>
+            </a:lvl6pPr>
+            <a:lvl7pPr>
+              <a:defRPr sz="825" b="0">
+                <a:solidFill>
+                  <a:srgbClr val="AAB8C5"/>
+                </a:solidFill>
+                <a:latin typeface="Arial"/>
+                <a:ea typeface="Arial"/>
+                <a:cs typeface="Arial"/>
+              </a:defRPr>
+            </a:lvl7pPr>
+            <a:lvl8pPr>
+              <a:defRPr sz="825" b="0">
+                <a:solidFill>
+                  <a:srgbClr val="AAB8C5"/>
+                </a:solidFill>
+                <a:latin typeface="Arial"/>
+                <a:ea typeface="Arial"/>
+                <a:cs typeface="Arial"/>
+              </a:defRPr>
+            </a:lvl8pPr>
+            <a:lvl9pPr>
+              <a:defRPr sz="825" b="0">
+                <a:solidFill>
+                  <a:srgbClr val="AAB8C5"/>
+                </a:solidFill>
+                <a:latin typeface="Arial"/>
+                <a:ea typeface="Arial"/>
+                <a:cs typeface="Arial"/>
+              </a:defRPr>
+            </a:lvl9pPr>
           </a:lstStyle>
           <a:p xmlns:a="http://schemas.openxmlformats.org/drawingml/2006/main">
             <a:pPr>
@@ -5575,7 +8165,7 @@
                 <a:ea typeface="Arial"/>
                 <a:cs typeface="Arial"/>
               </a:rPr>
-              <a:t>Um cenário de consulta, não uma média das IAs. Método e reprodução: docs/BENCHMARK.md.</a:t>
+              <a:t>16/10/2026 · Uma passagem por caso, sem controle de cache. Corpus e consultas completos: docs/benchmark-ampliado.json.</a:t>
             </a:r>
           </a:p>
         </p:txBody>

</xml_diff>

<commit_message>
chore: expand the benchmark and add a manual-playback player
</commit_message>
<xml_diff>
--- a/media/one-pager.pptx
+++ b/media/one-pager.pptx
@@ -2,13 +2,13 @@
 <file path=ppt/presentation.xml><?xml version="1.0" encoding="utf-8"?>
 <p:presentation xmlns:p="http://schemas.openxmlformats.org/presentationml/2006/main">
   <p:sldMasterIdLst>
-    <p:sldMasterId xmlns:r="http://schemas.openxmlformats.org/officeDocument/2006/relationships" id="2147483648" r:id="Rc7eb4ecff8a7416c"/>
+    <p:sldMasterId xmlns:r="http://schemas.openxmlformats.org/officeDocument/2006/relationships" id="2147483648" r:id="R28aa5915d7744153"/>
   </p:sldMasterIdLst>
   <p:notesMasterIdLst>
-    <p:notesMasterId xmlns:r="http://schemas.openxmlformats.org/officeDocument/2006/relationships" r:id="R02349d5d80804f78"/>
+    <p:notesMasterId xmlns:r="http://schemas.openxmlformats.org/officeDocument/2006/relationships" r:id="Rb3cd4b7293d44e2a"/>
   </p:notesMasterIdLst>
   <p:sldIdLst>
-    <p:sldId xmlns:r="http://schemas.openxmlformats.org/officeDocument/2006/relationships" id="256" r:id="R9db6d1d4a2fa4f88"/>
+    <p:sldId xmlns:r="http://schemas.openxmlformats.org/officeDocument/2006/relationships" id="256" r:id="R976e9abcf9db43a5"/>
   </p:sldIdLst>
   <p:sldSz cx="12192000" cy="6858000"/>
   <p:notesSz cx="6858000" cy="9144000"/>
@@ -442,27 +442,7 @@
           <a:lstStyle xmlns:a="http://schemas.openxmlformats.org/drawingml/2006/main"/>
           <a:p xmlns:a="http://schemas.openxmlformats.org/drawingml/2006/main">
             <a:r>
-              <a:t>Medição local em 16/10/2026, versão pública 663803e: comparação da mesma consulta no mesmo estado do cofre com cinco notas e orçamento de 12.000 caracteres. Saída inteira anterior: 11.961 caracteres; nova: 4.677; diferença: 7.284; redução arredondada: 60,9%. Os nomes das cinco notas e os trechos selecionados foram conferidos como idênticos; nomes de omissões e resumos não fazem parte dessa equivalência. Dados privados não acompanham a apresentação. Fonte pública do método e limites: https://github.com/nicholasbirochi/Cerebro/blob/main/docs/BENCHMARK.md.</a:t>
-            </a:r>
-          </a:p>
-          <a:p xmlns:a="http://schemas.openxmlformats.org/drawingml/2006/main">
-            <a:r>
-              <a:t/>
-            </a:r>
-          </a:p>
-          <a:p xmlns:a="http://schemas.openxmlformats.org/drawingml/2006/main">
-            <a:r>
-              <a:t>Cenário sintético distinto, reproduzível pelo script público tools/benchmark_busca.py: 40 notas relevantes, mesmas cinco notas e vinte trechos; 11.696 → 5.862 caracteres, redução de 49,9%. O padrão atual de duas notas retorna 2.495 caracteres neste cenário sintético e não compõe a comparação controlada de cinco notas.</a:t>
-            </a:r>
-          </a:p>
-          <a:p xmlns:a="http://schemas.openxmlformats.org/drawingml/2006/main">
-            <a:r>
-              <a:t/>
-            </a:r>
-          </a:p>
-          <a:p xmlns:a="http://schemas.openxmlformats.org/drawingml/2006/main">
-            <a:r>
-              <a:t>Não foram medidos tokens de entrada, saída, raciocínio, cache, consumo global de IAs, latência, produtividade ou desconto financeiro. A mensalidade permanece a mesma: R$0 de desconto. A imagem anterior apresentava uma simulação de 30% menos tokens no principal, com projeções hipotéticas de tempo e equivalência de API; foi substituída por resultados de saída da busca, sem converter caracteres em tokens ou dinheiro. O vídeo ilustrativo da arquitetura permanece inalterado.</a:t>
+              <a:t>Benchmark ampliado executado em 16/10/2026: três corpus sintéticos de40,1000e10000notas de conteúdo, mais um protocolo mínimo em cada. Maior corpus:26.918.974caracteresUnicode,28.208.929bytesUTF8, sem multiplicar por consultas ou somar prefixos repetidos. Oito consultas distintas por escala, com temas, múltiplos termos, filtro de projeto e ausência de resultado:24pares,48execuções. Mesmos limites --max5 --orcamento12000. Saída acumulada anterior210.965caracteres, atual118.299, diferença92.666, redução43,9%. Notas e trechos selecionados conferidos como idênticos em todos os pares. Reduções por escala:16,6%,50,9%,51,6%. Versão de referência40569e851506e3cd027004960f4b7d217bd0cb32. Dados, hashes e tempos observados em https://github.com/nicholasbirochi/Cerebro/blob/main/docs/benchmark-ampliado.json; método em docs/BENCHMARK.md. Tempos de uma passagem por caso, sem cache controlado ou inferência de ganho de velocidade. Não mede tokens de IA, qualidade geral, produtividade ou economia financeira. Medição local anterior60,9%em uma consulta permanece histórica, sem ser extrapolada para esta bateria. Nenhum cofre pessoal, credencial ou dado privado foi usado.</a:t>
             </a:r>
           </a:p>
         </p:txBody>
@@ -549,7 +529,7 @@
                 <a:cs typeface="+mj-lt"/>
               </a:defRPr>
             </a:defPPr>
-            <a:lvl1pPr marL="0" indent="0">
+            <a:lvl1pPr marL="0" indent="0" algn="ctr">
               <a:lnSpc>
                 <a:spcPct val="110000"/>
               </a:lnSpc>
@@ -560,9 +540,16 @@
                 <a:spcPts val="0"/>
               </a:spcAft>
               <a:buNone/>
-              <a:defRPr/>
+              <a:defRPr sz="4800" b="1">
+                <a:solidFill>
+                  <a:schemeClr val="tx1"/>
+                </a:solidFill>
+                <a:latin typeface="+mj-lt"/>
+                <a:ea typeface="+mj-lt"/>
+                <a:cs typeface="+mj-lt"/>
+              </a:defRPr>
             </a:lvl1pPr>
-            <a:lvl2pPr marL="0" indent="0">
+            <a:lvl2pPr marL="0" indent="0" algn="ctr">
               <a:lnSpc>
                 <a:spcPct val="110000"/>
               </a:lnSpc>
@@ -573,9 +560,16 @@
                 <a:spcPts val="0"/>
               </a:spcAft>
               <a:buNone/>
-              <a:defRPr/>
+              <a:defRPr sz="4800" b="1">
+                <a:solidFill>
+                  <a:schemeClr val="tx1"/>
+                </a:solidFill>
+                <a:latin typeface="+mj-lt"/>
+                <a:ea typeface="+mj-lt"/>
+                <a:cs typeface="+mj-lt"/>
+              </a:defRPr>
             </a:lvl2pPr>
-            <a:lvl3pPr marL="0" indent="0">
+            <a:lvl3pPr marL="0" indent="0" algn="ctr">
               <a:lnSpc>
                 <a:spcPct val="110000"/>
               </a:lnSpc>
@@ -586,9 +580,16 @@
                 <a:spcPts val="0"/>
               </a:spcAft>
               <a:buNone/>
-              <a:defRPr/>
+              <a:defRPr sz="4800" b="1">
+                <a:solidFill>
+                  <a:schemeClr val="tx1"/>
+                </a:solidFill>
+                <a:latin typeface="+mj-lt"/>
+                <a:ea typeface="+mj-lt"/>
+                <a:cs typeface="+mj-lt"/>
+              </a:defRPr>
             </a:lvl3pPr>
-            <a:lvl4pPr marL="0" indent="0">
+            <a:lvl4pPr marL="0" indent="0" algn="ctr">
               <a:lnSpc>
                 <a:spcPct val="110000"/>
               </a:lnSpc>
@@ -599,9 +600,16 @@
                 <a:spcPts val="0"/>
               </a:spcAft>
               <a:buNone/>
-              <a:defRPr/>
+              <a:defRPr sz="4800" b="1">
+                <a:solidFill>
+                  <a:schemeClr val="tx1"/>
+                </a:solidFill>
+                <a:latin typeface="+mj-lt"/>
+                <a:ea typeface="+mj-lt"/>
+                <a:cs typeface="+mj-lt"/>
+              </a:defRPr>
             </a:lvl4pPr>
-            <a:lvl5pPr marL="0" indent="0">
+            <a:lvl5pPr marL="0" indent="0" algn="ctr">
               <a:lnSpc>
                 <a:spcPct val="110000"/>
               </a:lnSpc>
@@ -612,9 +620,16 @@
                 <a:spcPts val="0"/>
               </a:spcAft>
               <a:buNone/>
-              <a:defRPr/>
+              <a:defRPr sz="4800" b="1">
+                <a:solidFill>
+                  <a:schemeClr val="tx1"/>
+                </a:solidFill>
+                <a:latin typeface="+mj-lt"/>
+                <a:ea typeface="+mj-lt"/>
+                <a:cs typeface="+mj-lt"/>
+              </a:defRPr>
             </a:lvl5pPr>
-            <a:lvl6pPr marL="0" indent="0">
+            <a:lvl6pPr marL="0" indent="0" algn="ctr">
               <a:lnSpc>
                 <a:spcPct val="110000"/>
               </a:lnSpc>
@@ -625,9 +640,16 @@
                 <a:spcPts val="0"/>
               </a:spcAft>
               <a:buNone/>
-              <a:defRPr/>
+              <a:defRPr sz="4800" b="1">
+                <a:solidFill>
+                  <a:schemeClr val="tx1"/>
+                </a:solidFill>
+                <a:latin typeface="+mj-lt"/>
+                <a:ea typeface="+mj-lt"/>
+                <a:cs typeface="+mj-lt"/>
+              </a:defRPr>
             </a:lvl6pPr>
-            <a:lvl7pPr marL="0" indent="0">
+            <a:lvl7pPr marL="0" indent="0" algn="ctr">
               <a:lnSpc>
                 <a:spcPct val="110000"/>
               </a:lnSpc>
@@ -638,9 +660,16 @@
                 <a:spcPts val="0"/>
               </a:spcAft>
               <a:buNone/>
-              <a:defRPr/>
+              <a:defRPr sz="4800" b="1">
+                <a:solidFill>
+                  <a:schemeClr val="tx1"/>
+                </a:solidFill>
+                <a:latin typeface="+mj-lt"/>
+                <a:ea typeface="+mj-lt"/>
+                <a:cs typeface="+mj-lt"/>
+              </a:defRPr>
             </a:lvl7pPr>
-            <a:lvl8pPr marL="0" indent="0">
+            <a:lvl8pPr marL="0" indent="0" algn="ctr">
               <a:lnSpc>
                 <a:spcPct val="110000"/>
               </a:lnSpc>
@@ -651,9 +680,16 @@
                 <a:spcPts val="0"/>
               </a:spcAft>
               <a:buNone/>
-              <a:defRPr/>
+              <a:defRPr sz="4800" b="1">
+                <a:solidFill>
+                  <a:schemeClr val="tx1"/>
+                </a:solidFill>
+                <a:latin typeface="+mj-lt"/>
+                <a:ea typeface="+mj-lt"/>
+                <a:cs typeface="+mj-lt"/>
+              </a:defRPr>
             </a:lvl8pPr>
-            <a:lvl9pPr marL="0" indent="0">
+            <a:lvl9pPr marL="0" indent="0" algn="ctr">
               <a:lnSpc>
                 <a:spcPct val="110000"/>
               </a:lnSpc>
@@ -664,7 +700,14 @@
                 <a:spcPts val="0"/>
               </a:spcAft>
               <a:buNone/>
-              <a:defRPr/>
+              <a:defRPr sz="4800" b="1">
+                <a:solidFill>
+                  <a:schemeClr val="tx1"/>
+                </a:solidFill>
+                <a:latin typeface="+mj-lt"/>
+                <a:ea typeface="+mj-lt"/>
+                <a:cs typeface="+mj-lt"/>
+              </a:defRPr>
             </a:lvl9pPr>
           </a:lstStyle>
           <a:p xmlns:a="http://schemas.openxmlformats.org/drawingml/2006/main"/>
@@ -715,7 +758,7 @@
                 <a:cs typeface="+mn-lt"/>
               </a:defRPr>
             </a:defPPr>
-            <a:lvl1pPr marL="0" indent="0">
+            <a:lvl1pPr marL="0" indent="0" algn="ctr">
               <a:lnSpc>
                 <a:spcPct val="110000"/>
               </a:lnSpc>
@@ -726,9 +769,16 @@
                 <a:spcPts val="0"/>
               </a:spcAft>
               <a:buNone/>
-              <a:defRPr/>
+              <a:defRPr sz="2100" b="0">
+                <a:solidFill>
+                  <a:schemeClr val="tx1"/>
+                </a:solidFill>
+                <a:latin typeface="+mn-lt"/>
+                <a:ea typeface="+mn-lt"/>
+                <a:cs typeface="+mn-lt"/>
+              </a:defRPr>
             </a:lvl1pPr>
-            <a:lvl2pPr marL="0" indent="0">
+            <a:lvl2pPr marL="0" indent="0" algn="ctr">
               <a:lnSpc>
                 <a:spcPct val="110000"/>
               </a:lnSpc>
@@ -739,9 +789,16 @@
                 <a:spcPts val="0"/>
               </a:spcAft>
               <a:buNone/>
-              <a:defRPr/>
+              <a:defRPr sz="2100" b="0">
+                <a:solidFill>
+                  <a:schemeClr val="tx1"/>
+                </a:solidFill>
+                <a:latin typeface="+mn-lt"/>
+                <a:ea typeface="+mn-lt"/>
+                <a:cs typeface="+mn-lt"/>
+              </a:defRPr>
             </a:lvl2pPr>
-            <a:lvl3pPr marL="0" indent="0">
+            <a:lvl3pPr marL="0" indent="0" algn="ctr">
               <a:lnSpc>
                 <a:spcPct val="110000"/>
               </a:lnSpc>
@@ -752,9 +809,16 @@
                 <a:spcPts val="0"/>
               </a:spcAft>
               <a:buNone/>
-              <a:defRPr/>
+              <a:defRPr sz="2100" b="0">
+                <a:solidFill>
+                  <a:schemeClr val="tx1"/>
+                </a:solidFill>
+                <a:latin typeface="+mn-lt"/>
+                <a:ea typeface="+mn-lt"/>
+                <a:cs typeface="+mn-lt"/>
+              </a:defRPr>
             </a:lvl3pPr>
-            <a:lvl4pPr marL="0" indent="0">
+            <a:lvl4pPr marL="0" indent="0" algn="ctr">
               <a:lnSpc>
                 <a:spcPct val="110000"/>
               </a:lnSpc>
@@ -765,9 +829,16 @@
                 <a:spcPts val="0"/>
               </a:spcAft>
               <a:buNone/>
-              <a:defRPr/>
+              <a:defRPr sz="2100" b="0">
+                <a:solidFill>
+                  <a:schemeClr val="tx1"/>
+                </a:solidFill>
+                <a:latin typeface="+mn-lt"/>
+                <a:ea typeface="+mn-lt"/>
+                <a:cs typeface="+mn-lt"/>
+              </a:defRPr>
             </a:lvl4pPr>
-            <a:lvl5pPr marL="0" indent="0">
+            <a:lvl5pPr marL="0" indent="0" algn="ctr">
               <a:lnSpc>
                 <a:spcPct val="110000"/>
               </a:lnSpc>
@@ -778,9 +849,16 @@
                 <a:spcPts val="0"/>
               </a:spcAft>
               <a:buNone/>
-              <a:defRPr/>
+              <a:defRPr sz="2100" b="0">
+                <a:solidFill>
+                  <a:schemeClr val="tx1"/>
+                </a:solidFill>
+                <a:latin typeface="+mn-lt"/>
+                <a:ea typeface="+mn-lt"/>
+                <a:cs typeface="+mn-lt"/>
+              </a:defRPr>
             </a:lvl5pPr>
-            <a:lvl6pPr marL="0" indent="0">
+            <a:lvl6pPr marL="0" indent="0" algn="ctr">
               <a:lnSpc>
                 <a:spcPct val="110000"/>
               </a:lnSpc>
@@ -791,9 +869,16 @@
                 <a:spcPts val="0"/>
               </a:spcAft>
               <a:buNone/>
-              <a:defRPr/>
+              <a:defRPr sz="2100" b="0">
+                <a:solidFill>
+                  <a:schemeClr val="tx1"/>
+                </a:solidFill>
+                <a:latin typeface="+mn-lt"/>
+                <a:ea typeface="+mn-lt"/>
+                <a:cs typeface="+mn-lt"/>
+              </a:defRPr>
             </a:lvl6pPr>
-            <a:lvl7pPr marL="0" indent="0">
+            <a:lvl7pPr marL="0" indent="0" algn="ctr">
               <a:lnSpc>
                 <a:spcPct val="110000"/>
               </a:lnSpc>
@@ -804,9 +889,16 @@
                 <a:spcPts val="0"/>
               </a:spcAft>
               <a:buNone/>
-              <a:defRPr/>
+              <a:defRPr sz="2100" b="0">
+                <a:solidFill>
+                  <a:schemeClr val="tx1"/>
+                </a:solidFill>
+                <a:latin typeface="+mn-lt"/>
+                <a:ea typeface="+mn-lt"/>
+                <a:cs typeface="+mn-lt"/>
+              </a:defRPr>
             </a:lvl7pPr>
-            <a:lvl8pPr marL="0" indent="0">
+            <a:lvl8pPr marL="0" indent="0" algn="ctr">
               <a:lnSpc>
                 <a:spcPct val="110000"/>
               </a:lnSpc>
@@ -817,9 +909,16 @@
                 <a:spcPts val="0"/>
               </a:spcAft>
               <a:buNone/>
-              <a:defRPr/>
+              <a:defRPr sz="2100" b="0">
+                <a:solidFill>
+                  <a:schemeClr val="tx1"/>
+                </a:solidFill>
+                <a:latin typeface="+mn-lt"/>
+                <a:ea typeface="+mn-lt"/>
+                <a:cs typeface="+mn-lt"/>
+              </a:defRPr>
             </a:lvl8pPr>
-            <a:lvl9pPr marL="0" indent="0">
+            <a:lvl9pPr marL="0" indent="0" algn="ctr">
               <a:lnSpc>
                 <a:spcPct val="110000"/>
               </a:lnSpc>
@@ -830,7 +929,14 @@
                 <a:spcPts val="0"/>
               </a:spcAft>
               <a:buNone/>
-              <a:defRPr/>
+              <a:defRPr sz="2100" b="0">
+                <a:solidFill>
+                  <a:schemeClr val="tx1"/>
+                </a:solidFill>
+                <a:latin typeface="+mn-lt"/>
+                <a:ea typeface="+mn-lt"/>
+                <a:cs typeface="+mn-lt"/>
+              </a:defRPr>
             </a:lvl9pPr>
           </a:lstStyle>
           <a:p xmlns:a="http://schemas.openxmlformats.org/drawingml/2006/main"/>
@@ -898,7 +1004,7 @@
                 <a:cs typeface="+mj-lt"/>
               </a:defRPr>
             </a:defPPr>
-            <a:lvl1pPr marL="0" indent="0">
+            <a:lvl1pPr marL="0" indent="0" algn="ctr">
               <a:lnSpc>
                 <a:spcPct val="110000"/>
               </a:lnSpc>
@@ -909,9 +1015,16 @@
                 <a:spcPts val="0"/>
               </a:spcAft>
               <a:buNone/>
-              <a:defRPr/>
+              <a:defRPr sz="4200" b="1">
+                <a:solidFill>
+                  <a:schemeClr val="tx1"/>
+                </a:solidFill>
+                <a:latin typeface="+mj-lt"/>
+                <a:ea typeface="+mj-lt"/>
+                <a:cs typeface="+mj-lt"/>
+              </a:defRPr>
             </a:lvl1pPr>
-            <a:lvl2pPr marL="0" indent="0">
+            <a:lvl2pPr marL="0" indent="0" algn="ctr">
               <a:lnSpc>
                 <a:spcPct val="110000"/>
               </a:lnSpc>
@@ -922,9 +1035,16 @@
                 <a:spcPts val="0"/>
               </a:spcAft>
               <a:buNone/>
-              <a:defRPr/>
+              <a:defRPr sz="4200" b="1">
+                <a:solidFill>
+                  <a:schemeClr val="tx1"/>
+                </a:solidFill>
+                <a:latin typeface="+mj-lt"/>
+                <a:ea typeface="+mj-lt"/>
+                <a:cs typeface="+mj-lt"/>
+              </a:defRPr>
             </a:lvl2pPr>
-            <a:lvl3pPr marL="0" indent="0">
+            <a:lvl3pPr marL="0" indent="0" algn="ctr">
               <a:lnSpc>
                 <a:spcPct val="110000"/>
               </a:lnSpc>
@@ -935,9 +1055,16 @@
                 <a:spcPts val="0"/>
               </a:spcAft>
               <a:buNone/>
-              <a:defRPr/>
+              <a:defRPr sz="4200" b="1">
+                <a:solidFill>
+                  <a:schemeClr val="tx1"/>
+                </a:solidFill>
+                <a:latin typeface="+mj-lt"/>
+                <a:ea typeface="+mj-lt"/>
+                <a:cs typeface="+mj-lt"/>
+              </a:defRPr>
             </a:lvl3pPr>
-            <a:lvl4pPr marL="0" indent="0">
+            <a:lvl4pPr marL="0" indent="0" algn="ctr">
               <a:lnSpc>
                 <a:spcPct val="110000"/>
               </a:lnSpc>
@@ -948,9 +1075,16 @@
                 <a:spcPts val="0"/>
               </a:spcAft>
               <a:buNone/>
-              <a:defRPr/>
+              <a:defRPr sz="4200" b="1">
+                <a:solidFill>
+                  <a:schemeClr val="tx1"/>
+                </a:solidFill>
+                <a:latin typeface="+mj-lt"/>
+                <a:ea typeface="+mj-lt"/>
+                <a:cs typeface="+mj-lt"/>
+              </a:defRPr>
             </a:lvl4pPr>
-            <a:lvl5pPr marL="0" indent="0">
+            <a:lvl5pPr marL="0" indent="0" algn="ctr">
               <a:lnSpc>
                 <a:spcPct val="110000"/>
               </a:lnSpc>
@@ -961,9 +1095,16 @@
                 <a:spcPts val="0"/>
               </a:spcAft>
               <a:buNone/>
-              <a:defRPr/>
+              <a:defRPr sz="4200" b="1">
+                <a:solidFill>
+                  <a:schemeClr val="tx1"/>
+                </a:solidFill>
+                <a:latin typeface="+mj-lt"/>
+                <a:ea typeface="+mj-lt"/>
+                <a:cs typeface="+mj-lt"/>
+              </a:defRPr>
             </a:lvl5pPr>
-            <a:lvl6pPr marL="0" indent="0">
+            <a:lvl6pPr marL="0" indent="0" algn="ctr">
               <a:lnSpc>
                 <a:spcPct val="110000"/>
               </a:lnSpc>
@@ -974,9 +1115,16 @@
                 <a:spcPts val="0"/>
               </a:spcAft>
               <a:buNone/>
-              <a:defRPr/>
+              <a:defRPr sz="4200" b="1">
+                <a:solidFill>
+                  <a:schemeClr val="tx1"/>
+                </a:solidFill>
+                <a:latin typeface="+mj-lt"/>
+                <a:ea typeface="+mj-lt"/>
+                <a:cs typeface="+mj-lt"/>
+              </a:defRPr>
             </a:lvl6pPr>
-            <a:lvl7pPr marL="0" indent="0">
+            <a:lvl7pPr marL="0" indent="0" algn="ctr">
               <a:lnSpc>
                 <a:spcPct val="110000"/>
               </a:lnSpc>
@@ -987,9 +1135,16 @@
                 <a:spcPts val="0"/>
               </a:spcAft>
               <a:buNone/>
-              <a:defRPr/>
+              <a:defRPr sz="4200" b="1">
+                <a:solidFill>
+                  <a:schemeClr val="tx1"/>
+                </a:solidFill>
+                <a:latin typeface="+mj-lt"/>
+                <a:ea typeface="+mj-lt"/>
+                <a:cs typeface="+mj-lt"/>
+              </a:defRPr>
             </a:lvl7pPr>
-            <a:lvl8pPr marL="0" indent="0">
+            <a:lvl8pPr marL="0" indent="0" algn="ctr">
               <a:lnSpc>
                 <a:spcPct val="110000"/>
               </a:lnSpc>
@@ -1000,9 +1155,16 @@
                 <a:spcPts val="0"/>
               </a:spcAft>
               <a:buNone/>
-              <a:defRPr/>
+              <a:defRPr sz="4200" b="1">
+                <a:solidFill>
+                  <a:schemeClr val="tx1"/>
+                </a:solidFill>
+                <a:latin typeface="+mj-lt"/>
+                <a:ea typeface="+mj-lt"/>
+                <a:cs typeface="+mj-lt"/>
+              </a:defRPr>
             </a:lvl8pPr>
-            <a:lvl9pPr marL="0" indent="0">
+            <a:lvl9pPr marL="0" indent="0" algn="ctr">
               <a:lnSpc>
                 <a:spcPct val="110000"/>
               </a:lnSpc>
@@ -1013,7 +1175,14 @@
                 <a:spcPts val="0"/>
               </a:spcAft>
               <a:buNone/>
-              <a:defRPr/>
+              <a:defRPr sz="4200" b="1">
+                <a:solidFill>
+                  <a:schemeClr val="tx1"/>
+                </a:solidFill>
+                <a:latin typeface="+mj-lt"/>
+                <a:ea typeface="+mj-lt"/>
+                <a:cs typeface="+mj-lt"/>
+              </a:defRPr>
             </a:lvl9pPr>
           </a:lstStyle>
           <a:p xmlns:a="http://schemas.openxmlformats.org/drawingml/2006/main"/>
@@ -1081,7 +1250,7 @@
                 <a:cs typeface="+mj-lt"/>
               </a:defRPr>
             </a:defPPr>
-            <a:lvl1pPr marL="0" indent="0">
+            <a:lvl1pPr marL="0" indent="0" algn="l">
               <a:lnSpc>
                 <a:spcPct val="110000"/>
               </a:lnSpc>
@@ -1092,9 +1261,16 @@
                 <a:spcPts val="0"/>
               </a:spcAft>
               <a:buNone/>
-              <a:defRPr/>
+              <a:defRPr sz="3300" b="1">
+                <a:solidFill>
+                  <a:schemeClr val="tx1"/>
+                </a:solidFill>
+                <a:latin typeface="+mj-lt"/>
+                <a:ea typeface="+mj-lt"/>
+                <a:cs typeface="+mj-lt"/>
+              </a:defRPr>
             </a:lvl1pPr>
-            <a:lvl2pPr marL="0" indent="0">
+            <a:lvl2pPr marL="0" indent="0" algn="l">
               <a:lnSpc>
                 <a:spcPct val="110000"/>
               </a:lnSpc>
@@ -1105,9 +1281,16 @@
                 <a:spcPts val="0"/>
               </a:spcAft>
               <a:buNone/>
-              <a:defRPr/>
+              <a:defRPr sz="3300" b="1">
+                <a:solidFill>
+                  <a:schemeClr val="tx1"/>
+                </a:solidFill>
+                <a:latin typeface="+mj-lt"/>
+                <a:ea typeface="+mj-lt"/>
+                <a:cs typeface="+mj-lt"/>
+              </a:defRPr>
             </a:lvl2pPr>
-            <a:lvl3pPr marL="0" indent="0">
+            <a:lvl3pPr marL="0" indent="0" algn="l">
               <a:lnSpc>
                 <a:spcPct val="110000"/>
               </a:lnSpc>
@@ -1118,9 +1301,16 @@
                 <a:spcPts val="0"/>
               </a:spcAft>
               <a:buNone/>
-              <a:defRPr/>
+              <a:defRPr sz="3300" b="1">
+                <a:solidFill>
+                  <a:schemeClr val="tx1"/>
+                </a:solidFill>
+                <a:latin typeface="+mj-lt"/>
+                <a:ea typeface="+mj-lt"/>
+                <a:cs typeface="+mj-lt"/>
+              </a:defRPr>
             </a:lvl3pPr>
-            <a:lvl4pPr marL="0" indent="0">
+            <a:lvl4pPr marL="0" indent="0" algn="l">
               <a:lnSpc>
                 <a:spcPct val="110000"/>
               </a:lnSpc>
@@ -1131,9 +1321,16 @@
                 <a:spcPts val="0"/>
               </a:spcAft>
               <a:buNone/>
-              <a:defRPr/>
+              <a:defRPr sz="3300" b="1">
+                <a:solidFill>
+                  <a:schemeClr val="tx1"/>
+                </a:solidFill>
+                <a:latin typeface="+mj-lt"/>
+                <a:ea typeface="+mj-lt"/>
+                <a:cs typeface="+mj-lt"/>
+              </a:defRPr>
             </a:lvl4pPr>
-            <a:lvl5pPr marL="0" indent="0">
+            <a:lvl5pPr marL="0" indent="0" algn="l">
               <a:lnSpc>
                 <a:spcPct val="110000"/>
               </a:lnSpc>
@@ -1144,9 +1341,16 @@
                 <a:spcPts val="0"/>
               </a:spcAft>
               <a:buNone/>
-              <a:defRPr/>
+              <a:defRPr sz="3300" b="1">
+                <a:solidFill>
+                  <a:schemeClr val="tx1"/>
+                </a:solidFill>
+                <a:latin typeface="+mj-lt"/>
+                <a:ea typeface="+mj-lt"/>
+                <a:cs typeface="+mj-lt"/>
+              </a:defRPr>
             </a:lvl5pPr>
-            <a:lvl6pPr marL="0" indent="0">
+            <a:lvl6pPr marL="0" indent="0" algn="l">
               <a:lnSpc>
                 <a:spcPct val="110000"/>
               </a:lnSpc>
@@ -1157,9 +1361,16 @@
                 <a:spcPts val="0"/>
               </a:spcAft>
               <a:buNone/>
-              <a:defRPr/>
+              <a:defRPr sz="3300" b="1">
+                <a:solidFill>
+                  <a:schemeClr val="tx1"/>
+                </a:solidFill>
+                <a:latin typeface="+mj-lt"/>
+                <a:ea typeface="+mj-lt"/>
+                <a:cs typeface="+mj-lt"/>
+              </a:defRPr>
             </a:lvl6pPr>
-            <a:lvl7pPr marL="0" indent="0">
+            <a:lvl7pPr marL="0" indent="0" algn="l">
               <a:lnSpc>
                 <a:spcPct val="110000"/>
               </a:lnSpc>
@@ -1170,9 +1381,16 @@
                 <a:spcPts val="0"/>
               </a:spcAft>
               <a:buNone/>
-              <a:defRPr/>
+              <a:defRPr sz="3300" b="1">
+                <a:solidFill>
+                  <a:schemeClr val="tx1"/>
+                </a:solidFill>
+                <a:latin typeface="+mj-lt"/>
+                <a:ea typeface="+mj-lt"/>
+                <a:cs typeface="+mj-lt"/>
+              </a:defRPr>
             </a:lvl7pPr>
-            <a:lvl8pPr marL="0" indent="0">
+            <a:lvl8pPr marL="0" indent="0" algn="l">
               <a:lnSpc>
                 <a:spcPct val="110000"/>
               </a:lnSpc>
@@ -1183,9 +1401,16 @@
                 <a:spcPts val="0"/>
               </a:spcAft>
               <a:buNone/>
-              <a:defRPr/>
+              <a:defRPr sz="3300" b="1">
+                <a:solidFill>
+                  <a:schemeClr val="tx1"/>
+                </a:solidFill>
+                <a:latin typeface="+mj-lt"/>
+                <a:ea typeface="+mj-lt"/>
+                <a:cs typeface="+mj-lt"/>
+              </a:defRPr>
             </a:lvl8pPr>
-            <a:lvl9pPr marL="0" indent="0">
+            <a:lvl9pPr marL="0" indent="0" algn="l">
               <a:lnSpc>
                 <a:spcPct val="110000"/>
               </a:lnSpc>
@@ -1196,7 +1421,14 @@
                 <a:spcPts val="0"/>
               </a:spcAft>
               <a:buNone/>
-              <a:defRPr/>
+              <a:defRPr sz="3300" b="1">
+                <a:solidFill>
+                  <a:schemeClr val="tx1"/>
+                </a:solidFill>
+                <a:latin typeface="+mj-lt"/>
+                <a:ea typeface="+mj-lt"/>
+                <a:cs typeface="+mj-lt"/>
+              </a:defRPr>
             </a:lvl9pPr>
           </a:lstStyle>
           <a:p xmlns:a="http://schemas.openxmlformats.org/drawingml/2006/main"/>
@@ -1247,7 +1479,7 @@
                 <a:cs typeface="+mn-lt"/>
               </a:defRPr>
             </a:defPPr>
-            <a:lvl1pPr marL="228600" indent="-228600">
+            <a:lvl1pPr marL="228600" indent="-228600" algn="l">
               <a:lnSpc>
                 <a:spcPct val="110000"/>
               </a:lnSpc>
@@ -1258,9 +1490,16 @@
                 <a:spcPts val="1200"/>
               </a:spcAft>
               <a:buChar char="•"/>
-              <a:defRPr/>
+              <a:defRPr sz="2250" b="0">
+                <a:solidFill>
+                  <a:schemeClr val="tx1"/>
+                </a:solidFill>
+                <a:latin typeface="+mn-lt"/>
+                <a:ea typeface="+mn-lt"/>
+                <a:cs typeface="+mn-lt"/>
+              </a:defRPr>
             </a:lvl1pPr>
-            <a:lvl2pPr marL="533400" indent="-228600">
+            <a:lvl2pPr marL="533400" indent="-228600" algn="l">
               <a:lnSpc>
                 <a:spcPct val="110000"/>
               </a:lnSpc>
@@ -1271,9 +1510,16 @@
                 <a:spcPts val="1200"/>
               </a:spcAft>
               <a:buChar char="•"/>
-              <a:defRPr/>
+              <a:defRPr sz="2250" b="0">
+                <a:solidFill>
+                  <a:schemeClr val="tx1"/>
+                </a:solidFill>
+                <a:latin typeface="+mn-lt"/>
+                <a:ea typeface="+mn-lt"/>
+                <a:cs typeface="+mn-lt"/>
+              </a:defRPr>
             </a:lvl2pPr>
-            <a:lvl3pPr marL="838200" indent="-228600">
+            <a:lvl3pPr marL="838200" indent="-228600" algn="l">
               <a:lnSpc>
                 <a:spcPct val="110000"/>
               </a:lnSpc>
@@ -1284,9 +1530,16 @@
                 <a:spcPts val="1200"/>
               </a:spcAft>
               <a:buChar char="•"/>
-              <a:defRPr/>
+              <a:defRPr sz="2250" b="0">
+                <a:solidFill>
+                  <a:schemeClr val="tx1"/>
+                </a:solidFill>
+                <a:latin typeface="+mn-lt"/>
+                <a:ea typeface="+mn-lt"/>
+                <a:cs typeface="+mn-lt"/>
+              </a:defRPr>
             </a:lvl3pPr>
-            <a:lvl4pPr marL="1143000" indent="-228600">
+            <a:lvl4pPr marL="1143000" indent="-228600" algn="l">
               <a:lnSpc>
                 <a:spcPct val="110000"/>
               </a:lnSpc>
@@ -1297,9 +1550,16 @@
                 <a:spcPts val="1200"/>
               </a:spcAft>
               <a:buChar char="•"/>
-              <a:defRPr/>
+              <a:defRPr sz="2250" b="0">
+                <a:solidFill>
+                  <a:schemeClr val="tx1"/>
+                </a:solidFill>
+                <a:latin typeface="+mn-lt"/>
+                <a:ea typeface="+mn-lt"/>
+                <a:cs typeface="+mn-lt"/>
+              </a:defRPr>
             </a:lvl4pPr>
-            <a:lvl5pPr marL="1447800" indent="-228600">
+            <a:lvl5pPr marL="1447800" indent="-228600" algn="l">
               <a:lnSpc>
                 <a:spcPct val="110000"/>
               </a:lnSpc>
@@ -1310,9 +1570,16 @@
                 <a:spcPts val="1200"/>
               </a:spcAft>
               <a:buChar char="•"/>
-              <a:defRPr/>
+              <a:defRPr sz="2250" b="0">
+                <a:solidFill>
+                  <a:schemeClr val="tx1"/>
+                </a:solidFill>
+                <a:latin typeface="+mn-lt"/>
+                <a:ea typeface="+mn-lt"/>
+                <a:cs typeface="+mn-lt"/>
+              </a:defRPr>
             </a:lvl5pPr>
-            <a:lvl6pPr marL="1752600" indent="-228600">
+            <a:lvl6pPr marL="1752600" indent="-228600" algn="l">
               <a:lnSpc>
                 <a:spcPct val="110000"/>
               </a:lnSpc>
@@ -1323,9 +1590,16 @@
                 <a:spcPts val="1200"/>
               </a:spcAft>
               <a:buChar char="•"/>
-              <a:defRPr/>
+              <a:defRPr sz="2250" b="0">
+                <a:solidFill>
+                  <a:schemeClr val="tx1"/>
+                </a:solidFill>
+                <a:latin typeface="+mn-lt"/>
+                <a:ea typeface="+mn-lt"/>
+                <a:cs typeface="+mn-lt"/>
+              </a:defRPr>
             </a:lvl6pPr>
-            <a:lvl7pPr marL="2057400" indent="-228600">
+            <a:lvl7pPr marL="2057400" indent="-228600" algn="l">
               <a:lnSpc>
                 <a:spcPct val="110000"/>
               </a:lnSpc>
@@ -1336,9 +1610,16 @@
                 <a:spcPts val="1200"/>
               </a:spcAft>
               <a:buChar char="•"/>
-              <a:defRPr/>
+              <a:defRPr sz="2250" b="0">
+                <a:solidFill>
+                  <a:schemeClr val="tx1"/>
+                </a:solidFill>
+                <a:latin typeface="+mn-lt"/>
+                <a:ea typeface="+mn-lt"/>
+                <a:cs typeface="+mn-lt"/>
+              </a:defRPr>
             </a:lvl7pPr>
-            <a:lvl8pPr marL="2362200" indent="-228600">
+            <a:lvl8pPr marL="2362200" indent="-228600" algn="l">
               <a:lnSpc>
                 <a:spcPct val="110000"/>
               </a:lnSpc>
@@ -1349,9 +1630,16 @@
                 <a:spcPts val="1200"/>
               </a:spcAft>
               <a:buChar char="•"/>
-              <a:defRPr/>
+              <a:defRPr sz="2250" b="0">
+                <a:solidFill>
+                  <a:schemeClr val="tx1"/>
+                </a:solidFill>
+                <a:latin typeface="+mn-lt"/>
+                <a:ea typeface="+mn-lt"/>
+                <a:cs typeface="+mn-lt"/>
+              </a:defRPr>
             </a:lvl8pPr>
-            <a:lvl9pPr marL="2667000" indent="-228600">
+            <a:lvl9pPr marL="2667000" indent="-228600" algn="l">
               <a:lnSpc>
                 <a:spcPct val="110000"/>
               </a:lnSpc>
@@ -1362,7 +1650,14 @@
                 <a:spcPts val="1200"/>
               </a:spcAft>
               <a:buChar char="•"/>
-              <a:defRPr/>
+              <a:defRPr sz="2250" b="0">
+                <a:solidFill>
+                  <a:schemeClr val="tx1"/>
+                </a:solidFill>
+                <a:latin typeface="+mn-lt"/>
+                <a:ea typeface="+mn-lt"/>
+                <a:cs typeface="+mn-lt"/>
+              </a:defRPr>
             </a:lvl9pPr>
           </a:lstStyle>
           <a:p xmlns:a="http://schemas.openxmlformats.org/drawingml/2006/main"/>
@@ -1430,7 +1725,7 @@
                 <a:cs typeface="+mj-lt"/>
               </a:defRPr>
             </a:defPPr>
-            <a:lvl1pPr marL="0" indent="0">
+            <a:lvl1pPr marL="0" indent="0" algn="l">
               <a:lnSpc>
                 <a:spcPct val="110000"/>
               </a:lnSpc>
@@ -1441,9 +1736,16 @@
                 <a:spcPts val="0"/>
               </a:spcAft>
               <a:buNone/>
-              <a:defRPr/>
+              <a:defRPr sz="3300" b="1">
+                <a:solidFill>
+                  <a:schemeClr val="tx1"/>
+                </a:solidFill>
+                <a:latin typeface="+mj-lt"/>
+                <a:ea typeface="+mj-lt"/>
+                <a:cs typeface="+mj-lt"/>
+              </a:defRPr>
             </a:lvl1pPr>
-            <a:lvl2pPr marL="0" indent="0">
+            <a:lvl2pPr marL="0" indent="0" algn="l">
               <a:lnSpc>
                 <a:spcPct val="110000"/>
               </a:lnSpc>
@@ -1454,9 +1756,16 @@
                 <a:spcPts val="0"/>
               </a:spcAft>
               <a:buNone/>
-              <a:defRPr/>
+              <a:defRPr sz="3300" b="1">
+                <a:solidFill>
+                  <a:schemeClr val="tx1"/>
+                </a:solidFill>
+                <a:latin typeface="+mj-lt"/>
+                <a:ea typeface="+mj-lt"/>
+                <a:cs typeface="+mj-lt"/>
+              </a:defRPr>
             </a:lvl2pPr>
-            <a:lvl3pPr marL="0" indent="0">
+            <a:lvl3pPr marL="0" indent="0" algn="l">
               <a:lnSpc>
                 <a:spcPct val="110000"/>
               </a:lnSpc>
@@ -1467,9 +1776,16 @@
                 <a:spcPts val="0"/>
               </a:spcAft>
               <a:buNone/>
-              <a:defRPr/>
+              <a:defRPr sz="3300" b="1">
+                <a:solidFill>
+                  <a:schemeClr val="tx1"/>
+                </a:solidFill>
+                <a:latin typeface="+mj-lt"/>
+                <a:ea typeface="+mj-lt"/>
+                <a:cs typeface="+mj-lt"/>
+              </a:defRPr>
             </a:lvl3pPr>
-            <a:lvl4pPr marL="0" indent="0">
+            <a:lvl4pPr marL="0" indent="0" algn="l">
               <a:lnSpc>
                 <a:spcPct val="110000"/>
               </a:lnSpc>
@@ -1480,9 +1796,16 @@
                 <a:spcPts val="0"/>
               </a:spcAft>
               <a:buNone/>
-              <a:defRPr/>
+              <a:defRPr sz="3300" b="1">
+                <a:solidFill>
+                  <a:schemeClr val="tx1"/>
+                </a:solidFill>
+                <a:latin typeface="+mj-lt"/>
+                <a:ea typeface="+mj-lt"/>
+                <a:cs typeface="+mj-lt"/>
+              </a:defRPr>
             </a:lvl4pPr>
-            <a:lvl5pPr marL="0" indent="0">
+            <a:lvl5pPr marL="0" indent="0" algn="l">
               <a:lnSpc>
                 <a:spcPct val="110000"/>
               </a:lnSpc>
@@ -1493,9 +1816,16 @@
                 <a:spcPts val="0"/>
               </a:spcAft>
               <a:buNone/>
-              <a:defRPr/>
+              <a:defRPr sz="3300" b="1">
+                <a:solidFill>
+                  <a:schemeClr val="tx1"/>
+                </a:solidFill>
+                <a:latin typeface="+mj-lt"/>
+                <a:ea typeface="+mj-lt"/>
+                <a:cs typeface="+mj-lt"/>
+              </a:defRPr>
             </a:lvl5pPr>
-            <a:lvl6pPr marL="0" indent="0">
+            <a:lvl6pPr marL="0" indent="0" algn="l">
               <a:lnSpc>
                 <a:spcPct val="110000"/>
               </a:lnSpc>
@@ -1506,9 +1836,16 @@
                 <a:spcPts val="0"/>
               </a:spcAft>
               <a:buNone/>
-              <a:defRPr/>
+              <a:defRPr sz="3300" b="1">
+                <a:solidFill>
+                  <a:schemeClr val="tx1"/>
+                </a:solidFill>
+                <a:latin typeface="+mj-lt"/>
+                <a:ea typeface="+mj-lt"/>
+                <a:cs typeface="+mj-lt"/>
+              </a:defRPr>
             </a:lvl6pPr>
-            <a:lvl7pPr marL="0" indent="0">
+            <a:lvl7pPr marL="0" indent="0" algn="l">
               <a:lnSpc>
                 <a:spcPct val="110000"/>
               </a:lnSpc>
@@ -1519,9 +1856,16 @@
                 <a:spcPts val="0"/>
               </a:spcAft>
               <a:buNone/>
-              <a:defRPr/>
+              <a:defRPr sz="3300" b="1">
+                <a:solidFill>
+                  <a:schemeClr val="tx1"/>
+                </a:solidFill>
+                <a:latin typeface="+mj-lt"/>
+                <a:ea typeface="+mj-lt"/>
+                <a:cs typeface="+mj-lt"/>
+              </a:defRPr>
             </a:lvl7pPr>
-            <a:lvl8pPr marL="0" indent="0">
+            <a:lvl8pPr marL="0" indent="0" algn="l">
               <a:lnSpc>
                 <a:spcPct val="110000"/>
               </a:lnSpc>
@@ -1532,9 +1876,16 @@
                 <a:spcPts val="0"/>
               </a:spcAft>
               <a:buNone/>
-              <a:defRPr/>
+              <a:defRPr sz="3300" b="1">
+                <a:solidFill>
+                  <a:schemeClr val="tx1"/>
+                </a:solidFill>
+                <a:latin typeface="+mj-lt"/>
+                <a:ea typeface="+mj-lt"/>
+                <a:cs typeface="+mj-lt"/>
+              </a:defRPr>
             </a:lvl8pPr>
-            <a:lvl9pPr marL="0" indent="0">
+            <a:lvl9pPr marL="0" indent="0" algn="l">
               <a:lnSpc>
                 <a:spcPct val="110000"/>
               </a:lnSpc>
@@ -1545,7 +1896,14 @@
                 <a:spcPts val="0"/>
               </a:spcAft>
               <a:buNone/>
-              <a:defRPr/>
+              <a:defRPr sz="3300" b="1">
+                <a:solidFill>
+                  <a:schemeClr val="tx1"/>
+                </a:solidFill>
+                <a:latin typeface="+mj-lt"/>
+                <a:ea typeface="+mj-lt"/>
+                <a:cs typeface="+mj-lt"/>
+              </a:defRPr>
             </a:lvl9pPr>
           </a:lstStyle>
           <a:p xmlns:a="http://schemas.openxmlformats.org/drawingml/2006/main"/>
@@ -1596,7 +1954,7 @@
                 <a:cs typeface="+mn-lt"/>
               </a:defRPr>
             </a:defPPr>
-            <a:lvl1pPr marL="228600" indent="-228600">
+            <a:lvl1pPr marL="228600" indent="-228600" algn="l">
               <a:lnSpc>
                 <a:spcPct val="110000"/>
               </a:lnSpc>
@@ -1607,9 +1965,16 @@
                 <a:spcPts val="1200"/>
               </a:spcAft>
               <a:buChar char="•"/>
-              <a:defRPr/>
+              <a:defRPr sz="2100" b="0">
+                <a:solidFill>
+                  <a:schemeClr val="tx1"/>
+                </a:solidFill>
+                <a:latin typeface="+mn-lt"/>
+                <a:ea typeface="+mn-lt"/>
+                <a:cs typeface="+mn-lt"/>
+              </a:defRPr>
             </a:lvl1pPr>
-            <a:lvl2pPr marL="533400" indent="-228600">
+            <a:lvl2pPr marL="533400" indent="-228600" algn="l">
               <a:lnSpc>
                 <a:spcPct val="110000"/>
               </a:lnSpc>
@@ -1620,9 +1985,16 @@
                 <a:spcPts val="1200"/>
               </a:spcAft>
               <a:buChar char="•"/>
-              <a:defRPr/>
+              <a:defRPr sz="2100" b="0">
+                <a:solidFill>
+                  <a:schemeClr val="tx1"/>
+                </a:solidFill>
+                <a:latin typeface="+mn-lt"/>
+                <a:ea typeface="+mn-lt"/>
+                <a:cs typeface="+mn-lt"/>
+              </a:defRPr>
             </a:lvl2pPr>
-            <a:lvl3pPr marL="838200" indent="-228600">
+            <a:lvl3pPr marL="838200" indent="-228600" algn="l">
               <a:lnSpc>
                 <a:spcPct val="110000"/>
               </a:lnSpc>
@@ -1633,9 +2005,16 @@
                 <a:spcPts val="1200"/>
               </a:spcAft>
               <a:buChar char="•"/>
-              <a:defRPr/>
+              <a:defRPr sz="2100" b="0">
+                <a:solidFill>
+                  <a:schemeClr val="tx1"/>
+                </a:solidFill>
+                <a:latin typeface="+mn-lt"/>
+                <a:ea typeface="+mn-lt"/>
+                <a:cs typeface="+mn-lt"/>
+              </a:defRPr>
             </a:lvl3pPr>
-            <a:lvl4pPr marL="1143000" indent="-228600">
+            <a:lvl4pPr marL="1143000" indent="-228600" algn="l">
               <a:lnSpc>
                 <a:spcPct val="110000"/>
               </a:lnSpc>
@@ -1646,9 +2025,16 @@
                 <a:spcPts val="1200"/>
               </a:spcAft>
               <a:buChar char="•"/>
-              <a:defRPr/>
+              <a:defRPr sz="2100" b="0">
+                <a:solidFill>
+                  <a:schemeClr val="tx1"/>
+                </a:solidFill>
+                <a:latin typeface="+mn-lt"/>
+                <a:ea typeface="+mn-lt"/>
+                <a:cs typeface="+mn-lt"/>
+              </a:defRPr>
             </a:lvl4pPr>
-            <a:lvl5pPr marL="1447800" indent="-228600">
+            <a:lvl5pPr marL="1447800" indent="-228600" algn="l">
               <a:lnSpc>
                 <a:spcPct val="110000"/>
               </a:lnSpc>
@@ -1659,9 +2045,16 @@
                 <a:spcPts val="1200"/>
               </a:spcAft>
               <a:buChar char="•"/>
-              <a:defRPr/>
+              <a:defRPr sz="2100" b="0">
+                <a:solidFill>
+                  <a:schemeClr val="tx1"/>
+                </a:solidFill>
+                <a:latin typeface="+mn-lt"/>
+                <a:ea typeface="+mn-lt"/>
+                <a:cs typeface="+mn-lt"/>
+              </a:defRPr>
             </a:lvl5pPr>
-            <a:lvl6pPr marL="1752600" indent="-228600">
+            <a:lvl6pPr marL="1752600" indent="-228600" algn="l">
               <a:lnSpc>
                 <a:spcPct val="110000"/>
               </a:lnSpc>
@@ -1672,9 +2065,16 @@
                 <a:spcPts val="1200"/>
               </a:spcAft>
               <a:buChar char="•"/>
-              <a:defRPr/>
+              <a:defRPr sz="2100" b="0">
+                <a:solidFill>
+                  <a:schemeClr val="tx1"/>
+                </a:solidFill>
+                <a:latin typeface="+mn-lt"/>
+                <a:ea typeface="+mn-lt"/>
+                <a:cs typeface="+mn-lt"/>
+              </a:defRPr>
             </a:lvl6pPr>
-            <a:lvl7pPr marL="2057400" indent="-228600">
+            <a:lvl7pPr marL="2057400" indent="-228600" algn="l">
               <a:lnSpc>
                 <a:spcPct val="110000"/>
               </a:lnSpc>
@@ -1685,9 +2085,16 @@
                 <a:spcPts val="1200"/>
               </a:spcAft>
               <a:buChar char="•"/>
-              <a:defRPr/>
+              <a:defRPr sz="2100" b="0">
+                <a:solidFill>
+                  <a:schemeClr val="tx1"/>
+                </a:solidFill>
+                <a:latin typeface="+mn-lt"/>
+                <a:ea typeface="+mn-lt"/>
+                <a:cs typeface="+mn-lt"/>
+              </a:defRPr>
             </a:lvl7pPr>
-            <a:lvl8pPr marL="2362200" indent="-228600">
+            <a:lvl8pPr marL="2362200" indent="-228600" algn="l">
               <a:lnSpc>
                 <a:spcPct val="110000"/>
               </a:lnSpc>
@@ -1698,9 +2105,16 @@
                 <a:spcPts val="1200"/>
               </a:spcAft>
               <a:buChar char="•"/>
-              <a:defRPr/>
+              <a:defRPr sz="2100" b="0">
+                <a:solidFill>
+                  <a:schemeClr val="tx1"/>
+                </a:solidFill>
+                <a:latin typeface="+mn-lt"/>
+                <a:ea typeface="+mn-lt"/>
+                <a:cs typeface="+mn-lt"/>
+              </a:defRPr>
             </a:lvl8pPr>
-            <a:lvl9pPr marL="2667000" indent="-228600">
+            <a:lvl9pPr marL="2667000" indent="-228600" algn="l">
               <a:lnSpc>
                 <a:spcPct val="110000"/>
               </a:lnSpc>
@@ -1711,7 +2125,14 @@
                 <a:spcPts val="1200"/>
               </a:spcAft>
               <a:buChar char="•"/>
-              <a:defRPr/>
+              <a:defRPr sz="2100" b="0">
+                <a:solidFill>
+                  <a:schemeClr val="tx1"/>
+                </a:solidFill>
+                <a:latin typeface="+mn-lt"/>
+                <a:ea typeface="+mn-lt"/>
+                <a:cs typeface="+mn-lt"/>
+              </a:defRPr>
             </a:lvl9pPr>
           </a:lstStyle>
           <a:p xmlns:a="http://schemas.openxmlformats.org/drawingml/2006/main"/>
@@ -1762,7 +2183,7 @@
                 <a:cs typeface="+mn-lt"/>
               </a:defRPr>
             </a:defPPr>
-            <a:lvl1pPr marL="228600" indent="-228600">
+            <a:lvl1pPr marL="228600" indent="-228600" algn="l">
               <a:lnSpc>
                 <a:spcPct val="110000"/>
               </a:lnSpc>
@@ -1773,9 +2194,16 @@
                 <a:spcPts val="1200"/>
               </a:spcAft>
               <a:buChar char="•"/>
-              <a:defRPr/>
+              <a:defRPr sz="2100" b="0">
+                <a:solidFill>
+                  <a:schemeClr val="tx1"/>
+                </a:solidFill>
+                <a:latin typeface="+mn-lt"/>
+                <a:ea typeface="+mn-lt"/>
+                <a:cs typeface="+mn-lt"/>
+              </a:defRPr>
             </a:lvl1pPr>
-            <a:lvl2pPr marL="533400" indent="-228600">
+            <a:lvl2pPr marL="533400" indent="-228600" algn="l">
               <a:lnSpc>
                 <a:spcPct val="110000"/>
               </a:lnSpc>
@@ -1786,9 +2214,16 @@
                 <a:spcPts val="1200"/>
               </a:spcAft>
               <a:buChar char="•"/>
-              <a:defRPr/>
+              <a:defRPr sz="2100" b="0">
+                <a:solidFill>
+                  <a:schemeClr val="tx1"/>
+                </a:solidFill>
+                <a:latin typeface="+mn-lt"/>
+                <a:ea typeface="+mn-lt"/>
+                <a:cs typeface="+mn-lt"/>
+              </a:defRPr>
             </a:lvl2pPr>
-            <a:lvl3pPr marL="838200" indent="-228600">
+            <a:lvl3pPr marL="838200" indent="-228600" algn="l">
               <a:lnSpc>
                 <a:spcPct val="110000"/>
               </a:lnSpc>
@@ -1799,9 +2234,16 @@
                 <a:spcPts val="1200"/>
               </a:spcAft>
               <a:buChar char="•"/>
-              <a:defRPr/>
+              <a:defRPr sz="2100" b="0">
+                <a:solidFill>
+                  <a:schemeClr val="tx1"/>
+                </a:solidFill>
+                <a:latin typeface="+mn-lt"/>
+                <a:ea typeface="+mn-lt"/>
+                <a:cs typeface="+mn-lt"/>
+              </a:defRPr>
             </a:lvl3pPr>
-            <a:lvl4pPr marL="1143000" indent="-228600">
+            <a:lvl4pPr marL="1143000" indent="-228600" algn="l">
               <a:lnSpc>
                 <a:spcPct val="110000"/>
               </a:lnSpc>
@@ -1812,9 +2254,16 @@
                 <a:spcPts val="1200"/>
               </a:spcAft>
               <a:buChar char="•"/>
-              <a:defRPr/>
+              <a:defRPr sz="2100" b="0">
+                <a:solidFill>
+                  <a:schemeClr val="tx1"/>
+                </a:solidFill>
+                <a:latin typeface="+mn-lt"/>
+                <a:ea typeface="+mn-lt"/>
+                <a:cs typeface="+mn-lt"/>
+              </a:defRPr>
             </a:lvl4pPr>
-            <a:lvl5pPr marL="1447800" indent="-228600">
+            <a:lvl5pPr marL="1447800" indent="-228600" algn="l">
               <a:lnSpc>
                 <a:spcPct val="110000"/>
               </a:lnSpc>
@@ -1825,9 +2274,16 @@
                 <a:spcPts val="1200"/>
               </a:spcAft>
               <a:buChar char="•"/>
-              <a:defRPr/>
+              <a:defRPr sz="2100" b="0">
+                <a:solidFill>
+                  <a:schemeClr val="tx1"/>
+                </a:solidFill>
+                <a:latin typeface="+mn-lt"/>
+                <a:ea typeface="+mn-lt"/>
+                <a:cs typeface="+mn-lt"/>
+              </a:defRPr>
             </a:lvl5pPr>
-            <a:lvl6pPr marL="1752600" indent="-228600">
+            <a:lvl6pPr marL="1752600" indent="-228600" algn="l">
               <a:lnSpc>
                 <a:spcPct val="110000"/>
               </a:lnSpc>
@@ -1838,9 +2294,16 @@
                 <a:spcPts val="1200"/>
               </a:spcAft>
               <a:buChar char="•"/>
-              <a:defRPr/>
+              <a:defRPr sz="2100" b="0">
+                <a:solidFill>
+                  <a:schemeClr val="tx1"/>
+                </a:solidFill>
+                <a:latin typeface="+mn-lt"/>
+                <a:ea typeface="+mn-lt"/>
+                <a:cs typeface="+mn-lt"/>
+              </a:defRPr>
             </a:lvl6pPr>
-            <a:lvl7pPr marL="2057400" indent="-228600">
+            <a:lvl7pPr marL="2057400" indent="-228600" algn="l">
               <a:lnSpc>
                 <a:spcPct val="110000"/>
               </a:lnSpc>
@@ -1851,9 +2314,16 @@
                 <a:spcPts val="1200"/>
               </a:spcAft>
               <a:buChar char="•"/>
-              <a:defRPr/>
+              <a:defRPr sz="2100" b="0">
+                <a:solidFill>
+                  <a:schemeClr val="tx1"/>
+                </a:solidFill>
+                <a:latin typeface="+mn-lt"/>
+                <a:ea typeface="+mn-lt"/>
+                <a:cs typeface="+mn-lt"/>
+              </a:defRPr>
             </a:lvl7pPr>
-            <a:lvl8pPr marL="2362200" indent="-228600">
+            <a:lvl8pPr marL="2362200" indent="-228600" algn="l">
               <a:lnSpc>
                 <a:spcPct val="110000"/>
               </a:lnSpc>
@@ -1864,9 +2334,16 @@
                 <a:spcPts val="1200"/>
               </a:spcAft>
               <a:buChar char="•"/>
-              <a:defRPr/>
+              <a:defRPr sz="2100" b="0">
+                <a:solidFill>
+                  <a:schemeClr val="tx1"/>
+                </a:solidFill>
+                <a:latin typeface="+mn-lt"/>
+                <a:ea typeface="+mn-lt"/>
+                <a:cs typeface="+mn-lt"/>
+              </a:defRPr>
             </a:lvl8pPr>
-            <a:lvl9pPr marL="2667000" indent="-228600">
+            <a:lvl9pPr marL="2667000" indent="-228600" algn="l">
               <a:lnSpc>
                 <a:spcPct val="110000"/>
               </a:lnSpc>
@@ -1877,7 +2354,14 @@
                 <a:spcPts val="1200"/>
               </a:spcAft>
               <a:buChar char="•"/>
-              <a:defRPr/>
+              <a:defRPr sz="2100" b="0">
+                <a:solidFill>
+                  <a:schemeClr val="tx1"/>
+                </a:solidFill>
+                <a:latin typeface="+mn-lt"/>
+                <a:ea typeface="+mn-lt"/>
+                <a:cs typeface="+mn-lt"/>
+              </a:defRPr>
             </a:lvl9pPr>
           </a:lstStyle>
           <a:p xmlns:a="http://schemas.openxmlformats.org/drawingml/2006/main"/>
@@ -1945,7 +2429,7 @@
                 <a:cs typeface="+mj-lt"/>
               </a:defRPr>
             </a:defPPr>
-            <a:lvl1pPr marL="0" indent="0">
+            <a:lvl1pPr marL="0" indent="0" algn="l">
               <a:lnSpc>
                 <a:spcPct val="110000"/>
               </a:lnSpc>
@@ -1956,9 +2440,16 @@
                 <a:spcPts val="0"/>
               </a:spcAft>
               <a:buNone/>
-              <a:defRPr/>
+              <a:defRPr sz="3300" b="1">
+                <a:solidFill>
+                  <a:schemeClr val="tx1"/>
+                </a:solidFill>
+                <a:latin typeface="+mj-lt"/>
+                <a:ea typeface="+mj-lt"/>
+                <a:cs typeface="+mj-lt"/>
+              </a:defRPr>
             </a:lvl1pPr>
-            <a:lvl2pPr marL="0" indent="0">
+            <a:lvl2pPr marL="0" indent="0" algn="l">
               <a:lnSpc>
                 <a:spcPct val="110000"/>
               </a:lnSpc>
@@ -1969,9 +2460,16 @@
                 <a:spcPts val="0"/>
               </a:spcAft>
               <a:buNone/>
-              <a:defRPr/>
+              <a:defRPr sz="3300" b="1">
+                <a:solidFill>
+                  <a:schemeClr val="tx1"/>
+                </a:solidFill>
+                <a:latin typeface="+mj-lt"/>
+                <a:ea typeface="+mj-lt"/>
+                <a:cs typeface="+mj-lt"/>
+              </a:defRPr>
             </a:lvl2pPr>
-            <a:lvl3pPr marL="0" indent="0">
+            <a:lvl3pPr marL="0" indent="0" algn="l">
               <a:lnSpc>
                 <a:spcPct val="110000"/>
               </a:lnSpc>
@@ -1982,9 +2480,16 @@
                 <a:spcPts val="0"/>
               </a:spcAft>
               <a:buNone/>
-              <a:defRPr/>
+              <a:defRPr sz="3300" b="1">
+                <a:solidFill>
+                  <a:schemeClr val="tx1"/>
+                </a:solidFill>
+                <a:latin typeface="+mj-lt"/>
+                <a:ea typeface="+mj-lt"/>
+                <a:cs typeface="+mj-lt"/>
+              </a:defRPr>
             </a:lvl3pPr>
-            <a:lvl4pPr marL="0" indent="0">
+            <a:lvl4pPr marL="0" indent="0" algn="l">
               <a:lnSpc>
                 <a:spcPct val="110000"/>
               </a:lnSpc>
@@ -1995,9 +2500,16 @@
                 <a:spcPts val="0"/>
               </a:spcAft>
               <a:buNone/>
-              <a:defRPr/>
+              <a:defRPr sz="3300" b="1">
+                <a:solidFill>
+                  <a:schemeClr val="tx1"/>
+                </a:solidFill>
+                <a:latin typeface="+mj-lt"/>
+                <a:ea typeface="+mj-lt"/>
+                <a:cs typeface="+mj-lt"/>
+              </a:defRPr>
             </a:lvl4pPr>
-            <a:lvl5pPr marL="0" indent="0">
+            <a:lvl5pPr marL="0" indent="0" algn="l">
               <a:lnSpc>
                 <a:spcPct val="110000"/>
               </a:lnSpc>
@@ -2008,9 +2520,16 @@
                 <a:spcPts val="0"/>
               </a:spcAft>
               <a:buNone/>
-              <a:defRPr/>
+              <a:defRPr sz="3300" b="1">
+                <a:solidFill>
+                  <a:schemeClr val="tx1"/>
+                </a:solidFill>
+                <a:latin typeface="+mj-lt"/>
+                <a:ea typeface="+mj-lt"/>
+                <a:cs typeface="+mj-lt"/>
+              </a:defRPr>
             </a:lvl5pPr>
-            <a:lvl6pPr marL="0" indent="0">
+            <a:lvl6pPr marL="0" indent="0" algn="l">
               <a:lnSpc>
                 <a:spcPct val="110000"/>
               </a:lnSpc>
@@ -2021,9 +2540,16 @@
                 <a:spcPts val="0"/>
               </a:spcAft>
               <a:buNone/>
-              <a:defRPr/>
+              <a:defRPr sz="3300" b="1">
+                <a:solidFill>
+                  <a:schemeClr val="tx1"/>
+                </a:solidFill>
+                <a:latin typeface="+mj-lt"/>
+                <a:ea typeface="+mj-lt"/>
+                <a:cs typeface="+mj-lt"/>
+              </a:defRPr>
             </a:lvl6pPr>
-            <a:lvl7pPr marL="0" indent="0">
+            <a:lvl7pPr marL="0" indent="0" algn="l">
               <a:lnSpc>
                 <a:spcPct val="110000"/>
               </a:lnSpc>
@@ -2034,9 +2560,16 @@
                 <a:spcPts val="0"/>
               </a:spcAft>
               <a:buNone/>
-              <a:defRPr/>
+              <a:defRPr sz="3300" b="1">
+                <a:solidFill>
+                  <a:schemeClr val="tx1"/>
+                </a:solidFill>
+                <a:latin typeface="+mj-lt"/>
+                <a:ea typeface="+mj-lt"/>
+                <a:cs typeface="+mj-lt"/>
+              </a:defRPr>
             </a:lvl7pPr>
-            <a:lvl8pPr marL="0" indent="0">
+            <a:lvl8pPr marL="0" indent="0" algn="l">
               <a:lnSpc>
                 <a:spcPct val="110000"/>
               </a:lnSpc>
@@ -2047,9 +2580,16 @@
                 <a:spcPts val="0"/>
               </a:spcAft>
               <a:buNone/>
-              <a:defRPr/>
+              <a:defRPr sz="3300" b="1">
+                <a:solidFill>
+                  <a:schemeClr val="tx1"/>
+                </a:solidFill>
+                <a:latin typeface="+mj-lt"/>
+                <a:ea typeface="+mj-lt"/>
+                <a:cs typeface="+mj-lt"/>
+              </a:defRPr>
             </a:lvl8pPr>
-            <a:lvl9pPr marL="0" indent="0">
+            <a:lvl9pPr marL="0" indent="0" algn="l">
               <a:lnSpc>
                 <a:spcPct val="110000"/>
               </a:lnSpc>
@@ -2060,7 +2600,14 @@
                 <a:spcPts val="0"/>
               </a:spcAft>
               <a:buNone/>
-              <a:defRPr/>
+              <a:defRPr sz="3300" b="1">
+                <a:solidFill>
+                  <a:schemeClr val="tx1"/>
+                </a:solidFill>
+                <a:latin typeface="+mj-lt"/>
+                <a:ea typeface="+mj-lt"/>
+                <a:cs typeface="+mj-lt"/>
+              </a:defRPr>
             </a:lvl9pPr>
           </a:lstStyle>
           <a:p xmlns:a="http://schemas.openxmlformats.org/drawingml/2006/main"/>
@@ -2111,7 +2658,7 @@
                 <a:cs typeface="+mn-lt"/>
               </a:defRPr>
             </a:defPPr>
-            <a:lvl1pPr marL="228600" indent="-228600">
+            <a:lvl1pPr marL="228600" indent="-228600" algn="l">
               <a:lnSpc>
                 <a:spcPct val="110000"/>
               </a:lnSpc>
@@ -2122,9 +2669,16 @@
                 <a:spcPts val="1200"/>
               </a:spcAft>
               <a:buChar char="•"/>
-              <a:defRPr/>
+              <a:defRPr sz="2250" b="0">
+                <a:solidFill>
+                  <a:schemeClr val="tx1"/>
+                </a:solidFill>
+                <a:latin typeface="+mn-lt"/>
+                <a:ea typeface="+mn-lt"/>
+                <a:cs typeface="+mn-lt"/>
+              </a:defRPr>
             </a:lvl1pPr>
-            <a:lvl2pPr marL="533400" indent="-228600">
+            <a:lvl2pPr marL="533400" indent="-228600" algn="l">
               <a:lnSpc>
                 <a:spcPct val="110000"/>
               </a:lnSpc>
@@ -2135,9 +2689,16 @@
                 <a:spcPts val="1200"/>
               </a:spcAft>
               <a:buChar char="•"/>
-              <a:defRPr/>
+              <a:defRPr sz="2250" b="0">
+                <a:solidFill>
+                  <a:schemeClr val="tx1"/>
+                </a:solidFill>
+                <a:latin typeface="+mn-lt"/>
+                <a:ea typeface="+mn-lt"/>
+                <a:cs typeface="+mn-lt"/>
+              </a:defRPr>
             </a:lvl2pPr>
-            <a:lvl3pPr marL="838200" indent="-228600">
+            <a:lvl3pPr marL="838200" indent="-228600" algn="l">
               <a:lnSpc>
                 <a:spcPct val="110000"/>
               </a:lnSpc>
@@ -2148,9 +2709,16 @@
                 <a:spcPts val="1200"/>
               </a:spcAft>
               <a:buChar char="•"/>
-              <a:defRPr/>
+              <a:defRPr sz="2250" b="0">
+                <a:solidFill>
+                  <a:schemeClr val="tx1"/>
+                </a:solidFill>
+                <a:latin typeface="+mn-lt"/>
+                <a:ea typeface="+mn-lt"/>
+                <a:cs typeface="+mn-lt"/>
+              </a:defRPr>
             </a:lvl3pPr>
-            <a:lvl4pPr marL="1143000" indent="-228600">
+            <a:lvl4pPr marL="1143000" indent="-228600" algn="l">
               <a:lnSpc>
                 <a:spcPct val="110000"/>
               </a:lnSpc>
@@ -2161,9 +2729,16 @@
                 <a:spcPts val="1200"/>
               </a:spcAft>
               <a:buChar char="•"/>
-              <a:defRPr/>
+              <a:defRPr sz="2250" b="0">
+                <a:solidFill>
+                  <a:schemeClr val="tx1"/>
+                </a:solidFill>
+                <a:latin typeface="+mn-lt"/>
+                <a:ea typeface="+mn-lt"/>
+                <a:cs typeface="+mn-lt"/>
+              </a:defRPr>
             </a:lvl4pPr>
-            <a:lvl5pPr marL="1447800" indent="-228600">
+            <a:lvl5pPr marL="1447800" indent="-228600" algn="l">
               <a:lnSpc>
                 <a:spcPct val="110000"/>
               </a:lnSpc>
@@ -2174,9 +2749,16 @@
                 <a:spcPts val="1200"/>
               </a:spcAft>
               <a:buChar char="•"/>
-              <a:defRPr/>
+              <a:defRPr sz="2250" b="0">
+                <a:solidFill>
+                  <a:schemeClr val="tx1"/>
+                </a:solidFill>
+                <a:latin typeface="+mn-lt"/>
+                <a:ea typeface="+mn-lt"/>
+                <a:cs typeface="+mn-lt"/>
+              </a:defRPr>
             </a:lvl5pPr>
-            <a:lvl6pPr marL="1752600" indent="-228600">
+            <a:lvl6pPr marL="1752600" indent="-228600" algn="l">
               <a:lnSpc>
                 <a:spcPct val="110000"/>
               </a:lnSpc>
@@ -2187,9 +2769,16 @@
                 <a:spcPts val="1200"/>
               </a:spcAft>
               <a:buChar char="•"/>
-              <a:defRPr/>
+              <a:defRPr sz="2250" b="0">
+                <a:solidFill>
+                  <a:schemeClr val="tx1"/>
+                </a:solidFill>
+                <a:latin typeface="+mn-lt"/>
+                <a:ea typeface="+mn-lt"/>
+                <a:cs typeface="+mn-lt"/>
+              </a:defRPr>
             </a:lvl6pPr>
-            <a:lvl7pPr marL="2057400" indent="-228600">
+            <a:lvl7pPr marL="2057400" indent="-228600" algn="l">
               <a:lnSpc>
                 <a:spcPct val="110000"/>
               </a:lnSpc>
@@ -2200,9 +2789,16 @@
                 <a:spcPts val="1200"/>
               </a:spcAft>
               <a:buChar char="•"/>
-              <a:defRPr/>
+              <a:defRPr sz="2250" b="0">
+                <a:solidFill>
+                  <a:schemeClr val="tx1"/>
+                </a:solidFill>
+                <a:latin typeface="+mn-lt"/>
+                <a:ea typeface="+mn-lt"/>
+                <a:cs typeface="+mn-lt"/>
+              </a:defRPr>
             </a:lvl7pPr>
-            <a:lvl8pPr marL="2362200" indent="-228600">
+            <a:lvl8pPr marL="2362200" indent="-228600" algn="l">
               <a:lnSpc>
                 <a:spcPct val="110000"/>
               </a:lnSpc>
@@ -2213,9 +2809,16 @@
                 <a:spcPts val="1200"/>
               </a:spcAft>
               <a:buChar char="•"/>
-              <a:defRPr/>
+              <a:defRPr sz="2250" b="0">
+                <a:solidFill>
+                  <a:schemeClr val="tx1"/>
+                </a:solidFill>
+                <a:latin typeface="+mn-lt"/>
+                <a:ea typeface="+mn-lt"/>
+                <a:cs typeface="+mn-lt"/>
+              </a:defRPr>
             </a:lvl8pPr>
-            <a:lvl9pPr marL="2667000" indent="-228600">
+            <a:lvl9pPr marL="2667000" indent="-228600" algn="l">
               <a:lnSpc>
                 <a:spcPct val="110000"/>
               </a:lnSpc>
@@ -2226,7 +2829,14 @@
                 <a:spcPts val="1200"/>
               </a:spcAft>
               <a:buChar char="•"/>
-              <a:defRPr/>
+              <a:defRPr sz="2250" b="0">
+                <a:solidFill>
+                  <a:schemeClr val="tx1"/>
+                </a:solidFill>
+                <a:latin typeface="+mn-lt"/>
+                <a:ea typeface="+mn-lt"/>
+                <a:cs typeface="+mn-lt"/>
+              </a:defRPr>
             </a:lvl9pPr>
           </a:lstStyle>
           <a:p xmlns:a="http://schemas.openxmlformats.org/drawingml/2006/main"/>
@@ -2275,12 +2885,12 @@
   </p:cSld>
   <p:clrMap bg1="lt1" tx1="dk1" bg2="lt2" tx2="dk2" accent1="accent1" accent2="accent2" accent3="accent3" accent4="accent4" accent5="accent5" accent6="accent6" hlink="hlink" folHlink="folHlink"/>
   <p:sldLayoutIdLst>
-    <p:sldLayoutId xmlns:r="http://schemas.openxmlformats.org/officeDocument/2006/relationships" id="2147483649" r:id="Rda0e6a14c069476a"/>
-    <p:sldLayoutId xmlns:r="http://schemas.openxmlformats.org/officeDocument/2006/relationships" id="2147483650" r:id="Rc62d934f8afd4486"/>
-    <p:sldLayoutId xmlns:r="http://schemas.openxmlformats.org/officeDocument/2006/relationships" id="2147483651" r:id="R9e3063e969d94e3a"/>
-    <p:sldLayoutId xmlns:r="http://schemas.openxmlformats.org/officeDocument/2006/relationships" id="2147483652" r:id="Ra749fceaebd34d42"/>
-    <p:sldLayoutId xmlns:r="http://schemas.openxmlformats.org/officeDocument/2006/relationships" id="2147483653" r:id="Rddd0c500499f42e8"/>
-    <p:sldLayoutId xmlns:r="http://schemas.openxmlformats.org/officeDocument/2006/relationships" id="2147483654" r:id="R6c437044ab764494"/>
+    <p:sldLayoutId xmlns:r="http://schemas.openxmlformats.org/officeDocument/2006/relationships" id="2147483649" r:id="R1a4b66f2f332432e"/>
+    <p:sldLayoutId xmlns:r="http://schemas.openxmlformats.org/officeDocument/2006/relationships" id="2147483650" r:id="Rc8d760b05e4a47fe"/>
+    <p:sldLayoutId xmlns:r="http://schemas.openxmlformats.org/officeDocument/2006/relationships" id="2147483651" r:id="Rb686a57d33e24f75"/>
+    <p:sldLayoutId xmlns:r="http://schemas.openxmlformats.org/officeDocument/2006/relationships" id="2147483652" r:id="R6da9458a0eb646f9"/>
+    <p:sldLayoutId xmlns:r="http://schemas.openxmlformats.org/officeDocument/2006/relationships" id="2147483653" r:id="R338afb10facd4411"/>
+    <p:sldLayoutId xmlns:r="http://schemas.openxmlformats.org/officeDocument/2006/relationships" id="2147483654" r:id="R9d39626c544e4733"/>
   </p:sldLayoutIdLst>
   <p:txStyles>
     <p:titleStyle>
@@ -2858,7 +3468,7 @@
                         <ns1:ea typeface="Arial"/>
                         <ns1:cs typeface="Arial"/>
                       </ns1:rPr>
-                      <ns1:t>4.677</ns1:t>
+                      <ns1:t>118.299</ns1:t>
                     </ns1:r>
                   </ns1:p>
                 </ns0:rich>
@@ -2898,7 +3508,7 @@
                         <ns1:ea typeface="Arial"/>
                         <ns1:cs typeface="Arial"/>
                       </ns1:rPr>
-                      <ns1:t>11.961</ns1:t>
+                      <ns1:t>210.965</ns1:t>
                     </ns1:r>
                   </ns1:p>
                 </ns0:rich>
@@ -2951,10 +3561,10 @@
                 <ns0:formatCode>General</ns0:formatCode>
                 <ns0:ptCount val="2"/>
                 <ns0:pt idx="0">
-                  <ns0:v>4677</ns0:v>
+                  <ns0:v>118299</ns0:v>
                 </ns0:pt>
                 <ns0:pt idx="1">
-                  <ns0:v>11961</ns0:v>
+                  <ns0:v>210965</ns0:v>
                 </ns0:pt>
               </ns0:numCache>
             </ns0:numRef>
@@ -3025,7 +3635,7 @@
         <ns0:axId val="48672768"/>
         <ns0:scaling>
           <ns0:orientation val="minMax"/>
-          <ns0:max val="13157.1"/>
+          <ns0:max val="232061.50000000003"/>
           <ns0:min val="0"/>
         </ns0:scaling>
         <ns0:delete val="1"/>
@@ -3146,6 +3756,96 @@
                 <a:cs typeface="Arial"/>
               </a:defRPr>
             </a:defPPr>
+            <a:lvl1pPr>
+              <a:defRPr sz="1275" b="1">
+                <a:solidFill>
+                  <a:srgbClr val="70DEC9"/>
+                </a:solidFill>
+                <a:latin typeface="Arial"/>
+                <a:ea typeface="Arial"/>
+                <a:cs typeface="Arial"/>
+              </a:defRPr>
+            </a:lvl1pPr>
+            <a:lvl2pPr>
+              <a:defRPr sz="1275" b="1">
+                <a:solidFill>
+                  <a:srgbClr val="70DEC9"/>
+                </a:solidFill>
+                <a:latin typeface="Arial"/>
+                <a:ea typeface="Arial"/>
+                <a:cs typeface="Arial"/>
+              </a:defRPr>
+            </a:lvl2pPr>
+            <a:lvl3pPr>
+              <a:defRPr sz="1275" b="1">
+                <a:solidFill>
+                  <a:srgbClr val="70DEC9"/>
+                </a:solidFill>
+                <a:latin typeface="Arial"/>
+                <a:ea typeface="Arial"/>
+                <a:cs typeface="Arial"/>
+              </a:defRPr>
+            </a:lvl3pPr>
+            <a:lvl4pPr>
+              <a:defRPr sz="1275" b="1">
+                <a:solidFill>
+                  <a:srgbClr val="70DEC9"/>
+                </a:solidFill>
+                <a:latin typeface="Arial"/>
+                <a:ea typeface="Arial"/>
+                <a:cs typeface="Arial"/>
+              </a:defRPr>
+            </a:lvl4pPr>
+            <a:lvl5pPr>
+              <a:defRPr sz="1275" b="1">
+                <a:solidFill>
+                  <a:srgbClr val="70DEC9"/>
+                </a:solidFill>
+                <a:latin typeface="Arial"/>
+                <a:ea typeface="Arial"/>
+                <a:cs typeface="Arial"/>
+              </a:defRPr>
+            </a:lvl5pPr>
+            <a:lvl6pPr>
+              <a:defRPr sz="1275" b="1">
+                <a:solidFill>
+                  <a:srgbClr val="70DEC9"/>
+                </a:solidFill>
+                <a:latin typeface="Arial"/>
+                <a:ea typeface="Arial"/>
+                <a:cs typeface="Arial"/>
+              </a:defRPr>
+            </a:lvl6pPr>
+            <a:lvl7pPr>
+              <a:defRPr sz="1275" b="1">
+                <a:solidFill>
+                  <a:srgbClr val="70DEC9"/>
+                </a:solidFill>
+                <a:latin typeface="Arial"/>
+                <a:ea typeface="Arial"/>
+                <a:cs typeface="Arial"/>
+              </a:defRPr>
+            </a:lvl7pPr>
+            <a:lvl8pPr>
+              <a:defRPr sz="1275" b="1">
+                <a:solidFill>
+                  <a:srgbClr val="70DEC9"/>
+                </a:solidFill>
+                <a:latin typeface="Arial"/>
+                <a:ea typeface="Arial"/>
+                <a:cs typeface="Arial"/>
+              </a:defRPr>
+            </a:lvl8pPr>
+            <a:lvl9pPr>
+              <a:defRPr sz="1275" b="1">
+                <a:solidFill>
+                  <a:srgbClr val="70DEC9"/>
+                </a:solidFill>
+                <a:latin typeface="Arial"/>
+                <a:ea typeface="Arial"/>
+                <a:cs typeface="Arial"/>
+              </a:defRPr>
+            </a:lvl9pPr>
           </a:lstStyle>
           <a:p xmlns:a="http://schemas.openxmlformats.org/drawingml/2006/main">
             <a:pPr>
@@ -3168,7 +3868,7 @@
                 <a:ea typeface="Arial"/>
                 <a:cs typeface="Arial"/>
               </a:rPr>
-              <a:t>MEDIÇÃO LOCAL · MESMO CONTEXTO · MESMA MENSALIDADE</a:t>
+              <a:t>BENCHMARK AMPLIADO · 3 ESCALAS · 24 CONSULTAS PAREADAS</a:t>
             </a:r>
           </a:p>
         </p:txBody>
@@ -3215,6 +3915,96 @@
                 <a:cs typeface="Arial"/>
               </a:defRPr>
             </a:defPPr>
+            <a:lvl1pPr>
+              <a:defRPr sz="3375" b="1">
+                <a:solidFill>
+                  <a:srgbClr val="F5F6F0"/>
+                </a:solidFill>
+                <a:latin typeface="Arial"/>
+                <a:ea typeface="Arial"/>
+                <a:cs typeface="Arial"/>
+              </a:defRPr>
+            </a:lvl1pPr>
+            <a:lvl2pPr>
+              <a:defRPr sz="3375" b="1">
+                <a:solidFill>
+                  <a:srgbClr val="F5F6F0"/>
+                </a:solidFill>
+                <a:latin typeface="Arial"/>
+                <a:ea typeface="Arial"/>
+                <a:cs typeface="Arial"/>
+              </a:defRPr>
+            </a:lvl2pPr>
+            <a:lvl3pPr>
+              <a:defRPr sz="3375" b="1">
+                <a:solidFill>
+                  <a:srgbClr val="F5F6F0"/>
+                </a:solidFill>
+                <a:latin typeface="Arial"/>
+                <a:ea typeface="Arial"/>
+                <a:cs typeface="Arial"/>
+              </a:defRPr>
+            </a:lvl3pPr>
+            <a:lvl4pPr>
+              <a:defRPr sz="3375" b="1">
+                <a:solidFill>
+                  <a:srgbClr val="F5F6F0"/>
+                </a:solidFill>
+                <a:latin typeface="Arial"/>
+                <a:ea typeface="Arial"/>
+                <a:cs typeface="Arial"/>
+              </a:defRPr>
+            </a:lvl4pPr>
+            <a:lvl5pPr>
+              <a:defRPr sz="3375" b="1">
+                <a:solidFill>
+                  <a:srgbClr val="F5F6F0"/>
+                </a:solidFill>
+                <a:latin typeface="Arial"/>
+                <a:ea typeface="Arial"/>
+                <a:cs typeface="Arial"/>
+              </a:defRPr>
+            </a:lvl5pPr>
+            <a:lvl6pPr>
+              <a:defRPr sz="3375" b="1">
+                <a:solidFill>
+                  <a:srgbClr val="F5F6F0"/>
+                </a:solidFill>
+                <a:latin typeface="Arial"/>
+                <a:ea typeface="Arial"/>
+                <a:cs typeface="Arial"/>
+              </a:defRPr>
+            </a:lvl6pPr>
+            <a:lvl7pPr>
+              <a:defRPr sz="3375" b="1">
+                <a:solidFill>
+                  <a:srgbClr val="F5F6F0"/>
+                </a:solidFill>
+                <a:latin typeface="Arial"/>
+                <a:ea typeface="Arial"/>
+                <a:cs typeface="Arial"/>
+              </a:defRPr>
+            </a:lvl7pPr>
+            <a:lvl8pPr>
+              <a:defRPr sz="3375" b="1">
+                <a:solidFill>
+                  <a:srgbClr val="F5F6F0"/>
+                </a:solidFill>
+                <a:latin typeface="Arial"/>
+                <a:ea typeface="Arial"/>
+                <a:cs typeface="Arial"/>
+              </a:defRPr>
+            </a:lvl8pPr>
+            <a:lvl9pPr>
+              <a:defRPr sz="3375" b="1">
+                <a:solidFill>
+                  <a:srgbClr val="F5F6F0"/>
+                </a:solidFill>
+                <a:latin typeface="Arial"/>
+                <a:ea typeface="Arial"/>
+                <a:cs typeface="Arial"/>
+              </a:defRPr>
+            </a:lvl9pPr>
           </a:lstStyle>
           <a:p xmlns:a="http://schemas.openxmlformats.org/drawingml/2006/main">
             <a:pPr>
@@ -3237,7 +4027,7 @@
                 <a:ea typeface="Arial"/>
                 <a:cs typeface="Arial"/>
               </a:rPr>
-              <a:t>60,9% menos texto na busca</a:t>
+              <a:t>10.000 notas na análise</a:t>
             </a:r>
           </a:p>
         </p:txBody>
@@ -3284,6 +4074,96 @@
                 <a:cs typeface="Arial"/>
               </a:defRPr>
             </a:defPPr>
+            <a:lvl1pPr>
+              <a:defRPr sz="1425" b="0">
+                <a:solidFill>
+                  <a:srgbClr val="AAB8C5"/>
+                </a:solidFill>
+                <a:latin typeface="Arial"/>
+                <a:ea typeface="Arial"/>
+                <a:cs typeface="Arial"/>
+              </a:defRPr>
+            </a:lvl1pPr>
+            <a:lvl2pPr>
+              <a:defRPr sz="1425" b="0">
+                <a:solidFill>
+                  <a:srgbClr val="AAB8C5"/>
+                </a:solidFill>
+                <a:latin typeface="Arial"/>
+                <a:ea typeface="Arial"/>
+                <a:cs typeface="Arial"/>
+              </a:defRPr>
+            </a:lvl2pPr>
+            <a:lvl3pPr>
+              <a:defRPr sz="1425" b="0">
+                <a:solidFill>
+                  <a:srgbClr val="AAB8C5"/>
+                </a:solidFill>
+                <a:latin typeface="Arial"/>
+                <a:ea typeface="Arial"/>
+                <a:cs typeface="Arial"/>
+              </a:defRPr>
+            </a:lvl3pPr>
+            <a:lvl4pPr>
+              <a:defRPr sz="1425" b="0">
+                <a:solidFill>
+                  <a:srgbClr val="AAB8C5"/>
+                </a:solidFill>
+                <a:latin typeface="Arial"/>
+                <a:ea typeface="Arial"/>
+                <a:cs typeface="Arial"/>
+              </a:defRPr>
+            </a:lvl4pPr>
+            <a:lvl5pPr>
+              <a:defRPr sz="1425" b="0">
+                <a:solidFill>
+                  <a:srgbClr val="AAB8C5"/>
+                </a:solidFill>
+                <a:latin typeface="Arial"/>
+                <a:ea typeface="Arial"/>
+                <a:cs typeface="Arial"/>
+              </a:defRPr>
+            </a:lvl5pPr>
+            <a:lvl6pPr>
+              <a:defRPr sz="1425" b="0">
+                <a:solidFill>
+                  <a:srgbClr val="AAB8C5"/>
+                </a:solidFill>
+                <a:latin typeface="Arial"/>
+                <a:ea typeface="Arial"/>
+                <a:cs typeface="Arial"/>
+              </a:defRPr>
+            </a:lvl6pPr>
+            <a:lvl7pPr>
+              <a:defRPr sz="1425" b="0">
+                <a:solidFill>
+                  <a:srgbClr val="AAB8C5"/>
+                </a:solidFill>
+                <a:latin typeface="Arial"/>
+                <a:ea typeface="Arial"/>
+                <a:cs typeface="Arial"/>
+              </a:defRPr>
+            </a:lvl7pPr>
+            <a:lvl8pPr>
+              <a:defRPr sz="1425" b="0">
+                <a:solidFill>
+                  <a:srgbClr val="AAB8C5"/>
+                </a:solidFill>
+                <a:latin typeface="Arial"/>
+                <a:ea typeface="Arial"/>
+                <a:cs typeface="Arial"/>
+              </a:defRPr>
+            </a:lvl8pPr>
+            <a:lvl9pPr>
+              <a:defRPr sz="1425" b="0">
+                <a:solidFill>
+                  <a:srgbClr val="AAB8C5"/>
+                </a:solidFill>
+                <a:latin typeface="Arial"/>
+                <a:ea typeface="Arial"/>
+                <a:cs typeface="Arial"/>
+              </a:defRPr>
+            </a:lvl9pPr>
           </a:lstStyle>
           <a:p xmlns:a="http://schemas.openxmlformats.org/drawingml/2006/main">
             <a:pPr>
@@ -3306,7 +4186,7 @@
                 <a:ea typeface="Arial"/>
                 <a:cs typeface="Arial"/>
               </a:rPr>
-              <a:t>Mesma consulta, mesmo acervo, mesmas cinco notas e trechos.</a:t>
+              <a:t>Maior acervo com 26.918.974 caracteres sintéticos. Sem usar o cofre pessoal.</a:t>
             </a:r>
           </a:p>
         </p:txBody>
@@ -3353,6 +4233,96 @@
                 <a:cs typeface="Arial"/>
               </a:defRPr>
             </a:defPPr>
+            <a:lvl1pPr>
+              <a:defRPr sz="1425" b="0">
+                <a:solidFill>
+                  <a:srgbClr val="AAB8C5"/>
+                </a:solidFill>
+                <a:latin typeface="Arial"/>
+                <a:ea typeface="Arial"/>
+                <a:cs typeface="Arial"/>
+              </a:defRPr>
+            </a:lvl1pPr>
+            <a:lvl2pPr>
+              <a:defRPr sz="1425" b="0">
+                <a:solidFill>
+                  <a:srgbClr val="AAB8C5"/>
+                </a:solidFill>
+                <a:latin typeface="Arial"/>
+                <a:ea typeface="Arial"/>
+                <a:cs typeface="Arial"/>
+              </a:defRPr>
+            </a:lvl2pPr>
+            <a:lvl3pPr>
+              <a:defRPr sz="1425" b="0">
+                <a:solidFill>
+                  <a:srgbClr val="AAB8C5"/>
+                </a:solidFill>
+                <a:latin typeface="Arial"/>
+                <a:ea typeface="Arial"/>
+                <a:cs typeface="Arial"/>
+              </a:defRPr>
+            </a:lvl3pPr>
+            <a:lvl4pPr>
+              <a:defRPr sz="1425" b="0">
+                <a:solidFill>
+                  <a:srgbClr val="AAB8C5"/>
+                </a:solidFill>
+                <a:latin typeface="Arial"/>
+                <a:ea typeface="Arial"/>
+                <a:cs typeface="Arial"/>
+              </a:defRPr>
+            </a:lvl4pPr>
+            <a:lvl5pPr>
+              <a:defRPr sz="1425" b="0">
+                <a:solidFill>
+                  <a:srgbClr val="AAB8C5"/>
+                </a:solidFill>
+                <a:latin typeface="Arial"/>
+                <a:ea typeface="Arial"/>
+                <a:cs typeface="Arial"/>
+              </a:defRPr>
+            </a:lvl5pPr>
+            <a:lvl6pPr>
+              <a:defRPr sz="1425" b="0">
+                <a:solidFill>
+                  <a:srgbClr val="AAB8C5"/>
+                </a:solidFill>
+                <a:latin typeface="Arial"/>
+                <a:ea typeface="Arial"/>
+                <a:cs typeface="Arial"/>
+              </a:defRPr>
+            </a:lvl6pPr>
+            <a:lvl7pPr>
+              <a:defRPr sz="1425" b="0">
+                <a:solidFill>
+                  <a:srgbClr val="AAB8C5"/>
+                </a:solidFill>
+                <a:latin typeface="Arial"/>
+                <a:ea typeface="Arial"/>
+                <a:cs typeface="Arial"/>
+              </a:defRPr>
+            </a:lvl7pPr>
+            <a:lvl8pPr>
+              <a:defRPr sz="1425" b="0">
+                <a:solidFill>
+                  <a:srgbClr val="AAB8C5"/>
+                </a:solidFill>
+                <a:latin typeface="Arial"/>
+                <a:ea typeface="Arial"/>
+                <a:cs typeface="Arial"/>
+              </a:defRPr>
+            </a:lvl8pPr>
+            <a:lvl9pPr>
+              <a:defRPr sz="1425" b="0">
+                <a:solidFill>
+                  <a:srgbClr val="AAB8C5"/>
+                </a:solidFill>
+                <a:latin typeface="Arial"/>
+                <a:ea typeface="Arial"/>
+                <a:cs typeface="Arial"/>
+              </a:defRPr>
+            </a:lvl9pPr>
           </a:lstStyle>
           <a:p xmlns:a="http://schemas.openxmlformats.org/drawingml/2006/main">
             <a:pPr>
@@ -3375,7 +4345,7 @@
                 <a:ea typeface="Arial"/>
                 <a:cs typeface="Arial"/>
               </a:rPr>
-              <a:t>Texto retornado pela busca</a:t>
+              <a:t>Texto retornado nas 24 consultas</a:t>
             </a:r>
           </a:p>
         </p:txBody>
@@ -3385,7 +4355,7 @@
           <p:cNvPr id="5" name="Chart">
             <a:extLst xmlns:a="http://schemas.openxmlformats.org/drawingml/2006/main">
               <a:ext uri="{FF2B5EF4-FFF2-40B4-BE49-F238E27FC236}">
-                <a16:creationId xmlns:a16="http://schemas.microsoft.com/office/drawing/2014/main" id="{4ECA498E-2511-4A0A-9952-3A6E0D2BC73B}"/>
+                <a16:creationId xmlns:a16="http://schemas.microsoft.com/office/drawing/2014/main" id="{D03C8957-75CA-440C-AC5C-A51258EE9DDA}"/>
               </a:ext>
             </a:extLst>
           </p:cNvPr>
@@ -3398,7 +4368,7 @@
         </p:xfrm>
         <a:graphic xmlns:a="http://schemas.openxmlformats.org/drawingml/2006/main">
           <a:graphicData uri="http://schemas.openxmlformats.org/drawingml/2006/chart">
-            <c:chart xmlns:r="http://schemas.openxmlformats.org/officeDocument/2006/relationships" xmlns:c="http://schemas.openxmlformats.org/drawingml/2006/chart" r:id="R0c7e625a0ffe4c48"/>
+            <c:chart xmlns:r="http://schemas.openxmlformats.org/officeDocument/2006/relationships" xmlns:c="http://schemas.openxmlformats.org/drawingml/2006/chart" r:id="R5abb7b4a460e4e12"/>
           </a:graphicData>
         </a:graphic>
       </p:graphicFrame>
@@ -3444,6 +4414,96 @@
                 <a:cs typeface="Arial"/>
               </a:defRPr>
             </a:defPPr>
+            <a:lvl1pPr>
+              <a:defRPr sz="1500" b="1">
+                <a:solidFill>
+                  <a:srgbClr val="70DEC9"/>
+                </a:solidFill>
+                <a:latin typeface="Arial"/>
+                <a:ea typeface="Arial"/>
+                <a:cs typeface="Arial"/>
+              </a:defRPr>
+            </a:lvl1pPr>
+            <a:lvl2pPr>
+              <a:defRPr sz="1500" b="1">
+                <a:solidFill>
+                  <a:srgbClr val="70DEC9"/>
+                </a:solidFill>
+                <a:latin typeface="Arial"/>
+                <a:ea typeface="Arial"/>
+                <a:cs typeface="Arial"/>
+              </a:defRPr>
+            </a:lvl2pPr>
+            <a:lvl3pPr>
+              <a:defRPr sz="1500" b="1">
+                <a:solidFill>
+                  <a:srgbClr val="70DEC9"/>
+                </a:solidFill>
+                <a:latin typeface="Arial"/>
+                <a:ea typeface="Arial"/>
+                <a:cs typeface="Arial"/>
+              </a:defRPr>
+            </a:lvl3pPr>
+            <a:lvl4pPr>
+              <a:defRPr sz="1500" b="1">
+                <a:solidFill>
+                  <a:srgbClr val="70DEC9"/>
+                </a:solidFill>
+                <a:latin typeface="Arial"/>
+                <a:ea typeface="Arial"/>
+                <a:cs typeface="Arial"/>
+              </a:defRPr>
+            </a:lvl4pPr>
+            <a:lvl5pPr>
+              <a:defRPr sz="1500" b="1">
+                <a:solidFill>
+                  <a:srgbClr val="70DEC9"/>
+                </a:solidFill>
+                <a:latin typeface="Arial"/>
+                <a:ea typeface="Arial"/>
+                <a:cs typeface="Arial"/>
+              </a:defRPr>
+            </a:lvl5pPr>
+            <a:lvl6pPr>
+              <a:defRPr sz="1500" b="1">
+                <a:solidFill>
+                  <a:srgbClr val="70DEC9"/>
+                </a:solidFill>
+                <a:latin typeface="Arial"/>
+                <a:ea typeface="Arial"/>
+                <a:cs typeface="Arial"/>
+              </a:defRPr>
+            </a:lvl6pPr>
+            <a:lvl7pPr>
+              <a:defRPr sz="1500" b="1">
+                <a:solidFill>
+                  <a:srgbClr val="70DEC9"/>
+                </a:solidFill>
+                <a:latin typeface="Arial"/>
+                <a:ea typeface="Arial"/>
+                <a:cs typeface="Arial"/>
+              </a:defRPr>
+            </a:lvl7pPr>
+            <a:lvl8pPr>
+              <a:defRPr sz="1500" b="1">
+                <a:solidFill>
+                  <a:srgbClr val="70DEC9"/>
+                </a:solidFill>
+                <a:latin typeface="Arial"/>
+                <a:ea typeface="Arial"/>
+                <a:cs typeface="Arial"/>
+              </a:defRPr>
+            </a:lvl8pPr>
+            <a:lvl9pPr>
+              <a:defRPr sz="1500" b="1">
+                <a:solidFill>
+                  <a:srgbClr val="70DEC9"/>
+                </a:solidFill>
+                <a:latin typeface="Arial"/>
+                <a:ea typeface="Arial"/>
+                <a:cs typeface="Arial"/>
+              </a:defRPr>
+            </a:lvl9pPr>
           </a:lstStyle>
           <a:p xmlns:a="http://schemas.openxmlformats.org/drawingml/2006/main">
             <a:pPr>
@@ -3466,7 +4526,7 @@
                 <a:ea typeface="Arial"/>
                 <a:cs typeface="Arial"/>
               </a:rPr>
-              <a:t>7.284 caracteres a menos (60,9%)</a:t>
+              <a:t>92.666 caracteres a menos (43,9%)</a:t>
             </a:r>
           </a:p>
         </p:txBody>
@@ -3513,6 +4573,96 @@
                 <a:cs typeface="Arial"/>
               </a:defRPr>
             </a:defPPr>
+            <a:lvl1pPr>
+              <a:defRPr sz="1875" b="1">
+                <a:solidFill>
+                  <a:srgbClr val="F5F6F0"/>
+                </a:solidFill>
+                <a:latin typeface="Arial"/>
+                <a:ea typeface="Arial"/>
+                <a:cs typeface="Arial"/>
+              </a:defRPr>
+            </a:lvl1pPr>
+            <a:lvl2pPr>
+              <a:defRPr sz="1875" b="1">
+                <a:solidFill>
+                  <a:srgbClr val="F5F6F0"/>
+                </a:solidFill>
+                <a:latin typeface="Arial"/>
+                <a:ea typeface="Arial"/>
+                <a:cs typeface="Arial"/>
+              </a:defRPr>
+            </a:lvl2pPr>
+            <a:lvl3pPr>
+              <a:defRPr sz="1875" b="1">
+                <a:solidFill>
+                  <a:srgbClr val="F5F6F0"/>
+                </a:solidFill>
+                <a:latin typeface="Arial"/>
+                <a:ea typeface="Arial"/>
+                <a:cs typeface="Arial"/>
+              </a:defRPr>
+            </a:lvl3pPr>
+            <a:lvl4pPr>
+              <a:defRPr sz="1875" b="1">
+                <a:solidFill>
+                  <a:srgbClr val="F5F6F0"/>
+                </a:solidFill>
+                <a:latin typeface="Arial"/>
+                <a:ea typeface="Arial"/>
+                <a:cs typeface="Arial"/>
+              </a:defRPr>
+            </a:lvl4pPr>
+            <a:lvl5pPr>
+              <a:defRPr sz="1875" b="1">
+                <a:solidFill>
+                  <a:srgbClr val="F5F6F0"/>
+                </a:solidFill>
+                <a:latin typeface="Arial"/>
+                <a:ea typeface="Arial"/>
+                <a:cs typeface="Arial"/>
+              </a:defRPr>
+            </a:lvl5pPr>
+            <a:lvl6pPr>
+              <a:defRPr sz="1875" b="1">
+                <a:solidFill>
+                  <a:srgbClr val="F5F6F0"/>
+                </a:solidFill>
+                <a:latin typeface="Arial"/>
+                <a:ea typeface="Arial"/>
+                <a:cs typeface="Arial"/>
+              </a:defRPr>
+            </a:lvl6pPr>
+            <a:lvl7pPr>
+              <a:defRPr sz="1875" b="1">
+                <a:solidFill>
+                  <a:srgbClr val="F5F6F0"/>
+                </a:solidFill>
+                <a:latin typeface="Arial"/>
+                <a:ea typeface="Arial"/>
+                <a:cs typeface="Arial"/>
+              </a:defRPr>
+            </a:lvl7pPr>
+            <a:lvl8pPr>
+              <a:defRPr sz="1875" b="1">
+                <a:solidFill>
+                  <a:srgbClr val="F5F6F0"/>
+                </a:solidFill>
+                <a:latin typeface="Arial"/>
+                <a:ea typeface="Arial"/>
+                <a:cs typeface="Arial"/>
+              </a:defRPr>
+            </a:lvl8pPr>
+            <a:lvl9pPr>
+              <a:defRPr sz="1875" b="1">
+                <a:solidFill>
+                  <a:srgbClr val="F5F6F0"/>
+                </a:solidFill>
+                <a:latin typeface="Arial"/>
+                <a:ea typeface="Arial"/>
+                <a:cs typeface="Arial"/>
+              </a:defRPr>
+            </a:lvl9pPr>
           </a:lstStyle>
           <a:p xmlns:a="http://schemas.openxmlformats.org/drawingml/2006/main">
             <a:pPr>
@@ -3535,7 +4685,7 @@
                 <a:ea typeface="Arial"/>
                 <a:cs typeface="Arial"/>
               </a:rPr>
-              <a:t>A conta da redução medida</a:t>
+              <a:t>Mesma seleção nas 24 comparações</a:t>
             </a:r>
           </a:p>
         </p:txBody>
@@ -3582,6 +4732,96 @@
                 <a:cs typeface="Arial"/>
               </a:defRPr>
             </a:defPPr>
+            <a:lvl1pPr>
+              <a:defRPr sz="2250" b="1">
+                <a:solidFill>
+                  <a:srgbClr val="70DEC9"/>
+                </a:solidFill>
+                <a:latin typeface="Arial"/>
+                <a:ea typeface="Arial"/>
+                <a:cs typeface="Arial"/>
+              </a:defRPr>
+            </a:lvl1pPr>
+            <a:lvl2pPr>
+              <a:defRPr sz="2250" b="1">
+                <a:solidFill>
+                  <a:srgbClr val="70DEC9"/>
+                </a:solidFill>
+                <a:latin typeface="Arial"/>
+                <a:ea typeface="Arial"/>
+                <a:cs typeface="Arial"/>
+              </a:defRPr>
+            </a:lvl2pPr>
+            <a:lvl3pPr>
+              <a:defRPr sz="2250" b="1">
+                <a:solidFill>
+                  <a:srgbClr val="70DEC9"/>
+                </a:solidFill>
+                <a:latin typeface="Arial"/>
+                <a:ea typeface="Arial"/>
+                <a:cs typeface="Arial"/>
+              </a:defRPr>
+            </a:lvl3pPr>
+            <a:lvl4pPr>
+              <a:defRPr sz="2250" b="1">
+                <a:solidFill>
+                  <a:srgbClr val="70DEC9"/>
+                </a:solidFill>
+                <a:latin typeface="Arial"/>
+                <a:ea typeface="Arial"/>
+                <a:cs typeface="Arial"/>
+              </a:defRPr>
+            </a:lvl4pPr>
+            <a:lvl5pPr>
+              <a:defRPr sz="2250" b="1">
+                <a:solidFill>
+                  <a:srgbClr val="70DEC9"/>
+                </a:solidFill>
+                <a:latin typeface="Arial"/>
+                <a:ea typeface="Arial"/>
+                <a:cs typeface="Arial"/>
+              </a:defRPr>
+            </a:lvl5pPr>
+            <a:lvl6pPr>
+              <a:defRPr sz="2250" b="1">
+                <a:solidFill>
+                  <a:srgbClr val="70DEC9"/>
+                </a:solidFill>
+                <a:latin typeface="Arial"/>
+                <a:ea typeface="Arial"/>
+                <a:cs typeface="Arial"/>
+              </a:defRPr>
+            </a:lvl6pPr>
+            <a:lvl7pPr>
+              <a:defRPr sz="2250" b="1">
+                <a:solidFill>
+                  <a:srgbClr val="70DEC9"/>
+                </a:solidFill>
+                <a:latin typeface="Arial"/>
+                <a:ea typeface="Arial"/>
+                <a:cs typeface="Arial"/>
+              </a:defRPr>
+            </a:lvl7pPr>
+            <a:lvl8pPr>
+              <a:defRPr sz="2250" b="1">
+                <a:solidFill>
+                  <a:srgbClr val="70DEC9"/>
+                </a:solidFill>
+                <a:latin typeface="Arial"/>
+                <a:ea typeface="Arial"/>
+                <a:cs typeface="Arial"/>
+              </a:defRPr>
+            </a:lvl8pPr>
+            <a:lvl9pPr>
+              <a:defRPr sz="2250" b="1">
+                <a:solidFill>
+                  <a:srgbClr val="70DEC9"/>
+                </a:solidFill>
+                <a:latin typeface="Arial"/>
+                <a:ea typeface="Arial"/>
+                <a:cs typeface="Arial"/>
+              </a:defRPr>
+            </a:lvl9pPr>
           </a:lstStyle>
           <a:p xmlns:a="http://schemas.openxmlformats.org/drawingml/2006/main">
             <a:pPr>
@@ -3604,7 +4844,7 @@
                 <a:ea typeface="Arial"/>
                 <a:cs typeface="Arial"/>
               </a:rPr>
-              <a:t>11.961 − 4.677 = 7.284</a:t>
+              <a:t>210.965 − 118.299 = 92.666</a:t>
             </a:r>
           </a:p>
         </p:txBody>
@@ -3651,6 +4891,96 @@
                 <a:cs typeface="Arial"/>
               </a:defRPr>
             </a:defPPr>
+            <a:lvl1pPr>
+              <a:defRPr sz="1425" b="0">
+                <a:solidFill>
+                  <a:srgbClr val="F5F6F0"/>
+                </a:solidFill>
+                <a:latin typeface="Arial"/>
+                <a:ea typeface="Arial"/>
+                <a:cs typeface="Arial"/>
+              </a:defRPr>
+            </a:lvl1pPr>
+            <a:lvl2pPr>
+              <a:defRPr sz="1425" b="0">
+                <a:solidFill>
+                  <a:srgbClr val="F5F6F0"/>
+                </a:solidFill>
+                <a:latin typeface="Arial"/>
+                <a:ea typeface="Arial"/>
+                <a:cs typeface="Arial"/>
+              </a:defRPr>
+            </a:lvl2pPr>
+            <a:lvl3pPr>
+              <a:defRPr sz="1425" b="0">
+                <a:solidFill>
+                  <a:srgbClr val="F5F6F0"/>
+                </a:solidFill>
+                <a:latin typeface="Arial"/>
+                <a:ea typeface="Arial"/>
+                <a:cs typeface="Arial"/>
+              </a:defRPr>
+            </a:lvl3pPr>
+            <a:lvl4pPr>
+              <a:defRPr sz="1425" b="0">
+                <a:solidFill>
+                  <a:srgbClr val="F5F6F0"/>
+                </a:solidFill>
+                <a:latin typeface="Arial"/>
+                <a:ea typeface="Arial"/>
+                <a:cs typeface="Arial"/>
+              </a:defRPr>
+            </a:lvl4pPr>
+            <a:lvl5pPr>
+              <a:defRPr sz="1425" b="0">
+                <a:solidFill>
+                  <a:srgbClr val="F5F6F0"/>
+                </a:solidFill>
+                <a:latin typeface="Arial"/>
+                <a:ea typeface="Arial"/>
+                <a:cs typeface="Arial"/>
+              </a:defRPr>
+            </a:lvl5pPr>
+            <a:lvl6pPr>
+              <a:defRPr sz="1425" b="0">
+                <a:solidFill>
+                  <a:srgbClr val="F5F6F0"/>
+                </a:solidFill>
+                <a:latin typeface="Arial"/>
+                <a:ea typeface="Arial"/>
+                <a:cs typeface="Arial"/>
+              </a:defRPr>
+            </a:lvl6pPr>
+            <a:lvl7pPr>
+              <a:defRPr sz="1425" b="0">
+                <a:solidFill>
+                  <a:srgbClr val="F5F6F0"/>
+                </a:solidFill>
+                <a:latin typeface="Arial"/>
+                <a:ea typeface="Arial"/>
+                <a:cs typeface="Arial"/>
+              </a:defRPr>
+            </a:lvl7pPr>
+            <a:lvl8pPr>
+              <a:defRPr sz="1425" b="0">
+                <a:solidFill>
+                  <a:srgbClr val="F5F6F0"/>
+                </a:solidFill>
+                <a:latin typeface="Arial"/>
+                <a:ea typeface="Arial"/>
+                <a:cs typeface="Arial"/>
+              </a:defRPr>
+            </a:lvl8pPr>
+            <a:lvl9pPr>
+              <a:defRPr sz="1425" b="0">
+                <a:solidFill>
+                  <a:srgbClr val="F5F6F0"/>
+                </a:solidFill>
+                <a:latin typeface="Arial"/>
+                <a:ea typeface="Arial"/>
+                <a:cs typeface="Arial"/>
+              </a:defRPr>
+            </a:lvl9pPr>
           </a:lstStyle>
           <a:p xmlns:a="http://schemas.openxmlformats.org/drawingml/2006/main">
             <a:pPr>
@@ -3673,7 +5003,7 @@
                 <a:ea typeface="Arial"/>
                 <a:cs typeface="Arial"/>
               </a:rPr>
-              <a:t>7.284 caracteres deixam de ocupar a saída da busca.</a:t>
+              <a:t>48 execuções, antes e depois de cada consulta.</a:t>
             </a:r>
           </a:p>
         </p:txBody>
@@ -3720,6 +5050,96 @@
                 <a:cs typeface="Arial"/>
               </a:defRPr>
             </a:defPPr>
+            <a:lvl1pPr>
+              <a:defRPr sz="1425" b="0">
+                <a:solidFill>
+                  <a:srgbClr val="F5F6F0"/>
+                </a:solidFill>
+                <a:latin typeface="Arial"/>
+                <a:ea typeface="Arial"/>
+                <a:cs typeface="Arial"/>
+              </a:defRPr>
+            </a:lvl1pPr>
+            <a:lvl2pPr>
+              <a:defRPr sz="1425" b="0">
+                <a:solidFill>
+                  <a:srgbClr val="F5F6F0"/>
+                </a:solidFill>
+                <a:latin typeface="Arial"/>
+                <a:ea typeface="Arial"/>
+                <a:cs typeface="Arial"/>
+              </a:defRPr>
+            </a:lvl2pPr>
+            <a:lvl3pPr>
+              <a:defRPr sz="1425" b="0">
+                <a:solidFill>
+                  <a:srgbClr val="F5F6F0"/>
+                </a:solidFill>
+                <a:latin typeface="Arial"/>
+                <a:ea typeface="Arial"/>
+                <a:cs typeface="Arial"/>
+              </a:defRPr>
+            </a:lvl3pPr>
+            <a:lvl4pPr>
+              <a:defRPr sz="1425" b="0">
+                <a:solidFill>
+                  <a:srgbClr val="F5F6F0"/>
+                </a:solidFill>
+                <a:latin typeface="Arial"/>
+                <a:ea typeface="Arial"/>
+                <a:cs typeface="Arial"/>
+              </a:defRPr>
+            </a:lvl4pPr>
+            <a:lvl5pPr>
+              <a:defRPr sz="1425" b="0">
+                <a:solidFill>
+                  <a:srgbClr val="F5F6F0"/>
+                </a:solidFill>
+                <a:latin typeface="Arial"/>
+                <a:ea typeface="Arial"/>
+                <a:cs typeface="Arial"/>
+              </a:defRPr>
+            </a:lvl5pPr>
+            <a:lvl6pPr>
+              <a:defRPr sz="1425" b="0">
+                <a:solidFill>
+                  <a:srgbClr val="F5F6F0"/>
+                </a:solidFill>
+                <a:latin typeface="Arial"/>
+                <a:ea typeface="Arial"/>
+                <a:cs typeface="Arial"/>
+              </a:defRPr>
+            </a:lvl6pPr>
+            <a:lvl7pPr>
+              <a:defRPr sz="1425" b="0">
+                <a:solidFill>
+                  <a:srgbClr val="F5F6F0"/>
+                </a:solidFill>
+                <a:latin typeface="Arial"/>
+                <a:ea typeface="Arial"/>
+                <a:cs typeface="Arial"/>
+              </a:defRPr>
+            </a:lvl7pPr>
+            <a:lvl8pPr>
+              <a:defRPr sz="1425" b="0">
+                <a:solidFill>
+                  <a:srgbClr val="F5F6F0"/>
+                </a:solidFill>
+                <a:latin typeface="Arial"/>
+                <a:ea typeface="Arial"/>
+                <a:cs typeface="Arial"/>
+              </a:defRPr>
+            </a:lvl8pPr>
+            <a:lvl9pPr>
+              <a:defRPr sz="1425" b="0">
+                <a:solidFill>
+                  <a:srgbClr val="F5F6F0"/>
+                </a:solidFill>
+                <a:latin typeface="Arial"/>
+                <a:ea typeface="Arial"/>
+                <a:cs typeface="Arial"/>
+              </a:defRPr>
+            </a:lvl9pPr>
           </a:lstStyle>
           <a:p xmlns:a="http://schemas.openxmlformats.org/drawingml/2006/main">
             <a:pPr>
@@ -3742,7 +5162,7 @@
                 <a:ea typeface="Arial"/>
                 <a:cs typeface="Arial"/>
               </a:rPr>
-              <a:t>O conteúdo dos trechos selecionados foi preservado.</a:t>
+              <a:t>Temas, múltiplos termos, projeto e ausência de resultado.</a:t>
             </a:r>
           </a:p>
         </p:txBody>
@@ -3789,6 +5209,96 @@
                 <a:cs typeface="Arial"/>
               </a:defRPr>
             </a:defPPr>
+            <a:lvl1pPr>
+              <a:defRPr sz="1575" b="1">
+                <a:solidFill>
+                  <a:srgbClr val="70DEC9"/>
+                </a:solidFill>
+                <a:latin typeface="Arial"/>
+                <a:ea typeface="Arial"/>
+                <a:cs typeface="Arial"/>
+              </a:defRPr>
+            </a:lvl1pPr>
+            <a:lvl2pPr>
+              <a:defRPr sz="1575" b="1">
+                <a:solidFill>
+                  <a:srgbClr val="70DEC9"/>
+                </a:solidFill>
+                <a:latin typeface="Arial"/>
+                <a:ea typeface="Arial"/>
+                <a:cs typeface="Arial"/>
+              </a:defRPr>
+            </a:lvl2pPr>
+            <a:lvl3pPr>
+              <a:defRPr sz="1575" b="1">
+                <a:solidFill>
+                  <a:srgbClr val="70DEC9"/>
+                </a:solidFill>
+                <a:latin typeface="Arial"/>
+                <a:ea typeface="Arial"/>
+                <a:cs typeface="Arial"/>
+              </a:defRPr>
+            </a:lvl3pPr>
+            <a:lvl4pPr>
+              <a:defRPr sz="1575" b="1">
+                <a:solidFill>
+                  <a:srgbClr val="70DEC9"/>
+                </a:solidFill>
+                <a:latin typeface="Arial"/>
+                <a:ea typeface="Arial"/>
+                <a:cs typeface="Arial"/>
+              </a:defRPr>
+            </a:lvl4pPr>
+            <a:lvl5pPr>
+              <a:defRPr sz="1575" b="1">
+                <a:solidFill>
+                  <a:srgbClr val="70DEC9"/>
+                </a:solidFill>
+                <a:latin typeface="Arial"/>
+                <a:ea typeface="Arial"/>
+                <a:cs typeface="Arial"/>
+              </a:defRPr>
+            </a:lvl5pPr>
+            <a:lvl6pPr>
+              <a:defRPr sz="1575" b="1">
+                <a:solidFill>
+                  <a:srgbClr val="70DEC9"/>
+                </a:solidFill>
+                <a:latin typeface="Arial"/>
+                <a:ea typeface="Arial"/>
+                <a:cs typeface="Arial"/>
+              </a:defRPr>
+            </a:lvl6pPr>
+            <a:lvl7pPr>
+              <a:defRPr sz="1575" b="1">
+                <a:solidFill>
+                  <a:srgbClr val="70DEC9"/>
+                </a:solidFill>
+                <a:latin typeface="Arial"/>
+                <a:ea typeface="Arial"/>
+                <a:cs typeface="Arial"/>
+              </a:defRPr>
+            </a:lvl7pPr>
+            <a:lvl8pPr>
+              <a:defRPr sz="1575" b="1">
+                <a:solidFill>
+                  <a:srgbClr val="70DEC9"/>
+                </a:solidFill>
+                <a:latin typeface="Arial"/>
+                <a:ea typeface="Arial"/>
+                <a:cs typeface="Arial"/>
+              </a:defRPr>
+            </a:lvl8pPr>
+            <a:lvl9pPr>
+              <a:defRPr sz="1575" b="1">
+                <a:solidFill>
+                  <a:srgbClr val="70DEC9"/>
+                </a:solidFill>
+                <a:latin typeface="Arial"/>
+                <a:ea typeface="Arial"/>
+                <a:cs typeface="Arial"/>
+              </a:defRPr>
+            </a:lvl9pPr>
           </a:lstStyle>
           <a:p xmlns:a="http://schemas.openxmlformats.org/drawingml/2006/main">
             <a:pPr>
@@ -3811,7 +5321,7 @@
                 <a:ea typeface="Arial"/>
                 <a:cs typeface="Arial"/>
               </a:rPr>
-              <a:t>Redução: 7.284 ÷ 11.961 = 60,9%</a:t>
+              <a:t>Notas e trechos equivalentes em todos os casos</a:t>
             </a:r>
           </a:p>
         </p:txBody>
@@ -3858,6 +5368,96 @@
                 <a:cs typeface="Arial"/>
               </a:defRPr>
             </a:defPPr>
+            <a:lvl1pPr>
+              <a:defRPr sz="1275" b="0">
+                <a:solidFill>
+                  <a:srgbClr val="AAB8C5"/>
+                </a:solidFill>
+                <a:latin typeface="Arial"/>
+                <a:ea typeface="Arial"/>
+                <a:cs typeface="Arial"/>
+              </a:defRPr>
+            </a:lvl1pPr>
+            <a:lvl2pPr>
+              <a:defRPr sz="1275" b="0">
+                <a:solidFill>
+                  <a:srgbClr val="AAB8C5"/>
+                </a:solidFill>
+                <a:latin typeface="Arial"/>
+                <a:ea typeface="Arial"/>
+                <a:cs typeface="Arial"/>
+              </a:defRPr>
+            </a:lvl2pPr>
+            <a:lvl3pPr>
+              <a:defRPr sz="1275" b="0">
+                <a:solidFill>
+                  <a:srgbClr val="AAB8C5"/>
+                </a:solidFill>
+                <a:latin typeface="Arial"/>
+                <a:ea typeface="Arial"/>
+                <a:cs typeface="Arial"/>
+              </a:defRPr>
+            </a:lvl3pPr>
+            <a:lvl4pPr>
+              <a:defRPr sz="1275" b="0">
+                <a:solidFill>
+                  <a:srgbClr val="AAB8C5"/>
+                </a:solidFill>
+                <a:latin typeface="Arial"/>
+                <a:ea typeface="Arial"/>
+                <a:cs typeface="Arial"/>
+              </a:defRPr>
+            </a:lvl4pPr>
+            <a:lvl5pPr>
+              <a:defRPr sz="1275" b="0">
+                <a:solidFill>
+                  <a:srgbClr val="AAB8C5"/>
+                </a:solidFill>
+                <a:latin typeface="Arial"/>
+                <a:ea typeface="Arial"/>
+                <a:cs typeface="Arial"/>
+              </a:defRPr>
+            </a:lvl5pPr>
+            <a:lvl6pPr>
+              <a:defRPr sz="1275" b="0">
+                <a:solidFill>
+                  <a:srgbClr val="AAB8C5"/>
+                </a:solidFill>
+                <a:latin typeface="Arial"/>
+                <a:ea typeface="Arial"/>
+                <a:cs typeface="Arial"/>
+              </a:defRPr>
+            </a:lvl6pPr>
+            <a:lvl7pPr>
+              <a:defRPr sz="1275" b="0">
+                <a:solidFill>
+                  <a:srgbClr val="AAB8C5"/>
+                </a:solidFill>
+                <a:latin typeface="Arial"/>
+                <a:ea typeface="Arial"/>
+                <a:cs typeface="Arial"/>
+              </a:defRPr>
+            </a:lvl7pPr>
+            <a:lvl8pPr>
+              <a:defRPr sz="1275" b="0">
+                <a:solidFill>
+                  <a:srgbClr val="AAB8C5"/>
+                </a:solidFill>
+                <a:latin typeface="Arial"/>
+                <a:ea typeface="Arial"/>
+                <a:cs typeface="Arial"/>
+              </a:defRPr>
+            </a:lvl8pPr>
+            <a:lvl9pPr>
+              <a:defRPr sz="1275" b="0">
+                <a:solidFill>
+                  <a:srgbClr val="AAB8C5"/>
+                </a:solidFill>
+                <a:latin typeface="Arial"/>
+                <a:ea typeface="Arial"/>
+                <a:cs typeface="Arial"/>
+              </a:defRPr>
+            </a:lvl9pPr>
           </a:lstStyle>
           <a:p xmlns:a="http://schemas.openxmlformats.org/drawingml/2006/main">
             <a:pPr>
@@ -3880,7 +5480,7 @@
                 <a:ea typeface="Arial"/>
                 <a:cs typeface="Arial"/>
               </a:rPr>
-              <a:t>O ganho vem de resumir a lista de notas omitidas.</a:t>
+              <a:t>Mesmo limite: 5 notas e 12.000 caracteres por consulta.</a:t>
             </a:r>
           </a:p>
         </p:txBody>
@@ -3927,6 +5527,96 @@
                 <a:cs typeface="Arial"/>
               </a:defRPr>
             </a:defPPr>
+            <a:lvl1pPr>
+              <a:defRPr sz="1350" b="0">
+                <a:solidFill>
+                  <a:srgbClr val="AAB8C5"/>
+                </a:solidFill>
+                <a:latin typeface="Arial"/>
+                <a:ea typeface="Arial"/>
+                <a:cs typeface="Arial"/>
+              </a:defRPr>
+            </a:lvl1pPr>
+            <a:lvl2pPr>
+              <a:defRPr sz="1350" b="0">
+                <a:solidFill>
+                  <a:srgbClr val="AAB8C5"/>
+                </a:solidFill>
+                <a:latin typeface="Arial"/>
+                <a:ea typeface="Arial"/>
+                <a:cs typeface="Arial"/>
+              </a:defRPr>
+            </a:lvl2pPr>
+            <a:lvl3pPr>
+              <a:defRPr sz="1350" b="0">
+                <a:solidFill>
+                  <a:srgbClr val="AAB8C5"/>
+                </a:solidFill>
+                <a:latin typeface="Arial"/>
+                <a:ea typeface="Arial"/>
+                <a:cs typeface="Arial"/>
+              </a:defRPr>
+            </a:lvl3pPr>
+            <a:lvl4pPr>
+              <a:defRPr sz="1350" b="0">
+                <a:solidFill>
+                  <a:srgbClr val="AAB8C5"/>
+                </a:solidFill>
+                <a:latin typeface="Arial"/>
+                <a:ea typeface="Arial"/>
+                <a:cs typeface="Arial"/>
+              </a:defRPr>
+            </a:lvl4pPr>
+            <a:lvl5pPr>
+              <a:defRPr sz="1350" b="0">
+                <a:solidFill>
+                  <a:srgbClr val="AAB8C5"/>
+                </a:solidFill>
+                <a:latin typeface="Arial"/>
+                <a:ea typeface="Arial"/>
+                <a:cs typeface="Arial"/>
+              </a:defRPr>
+            </a:lvl5pPr>
+            <a:lvl6pPr>
+              <a:defRPr sz="1350" b="0">
+                <a:solidFill>
+                  <a:srgbClr val="AAB8C5"/>
+                </a:solidFill>
+                <a:latin typeface="Arial"/>
+                <a:ea typeface="Arial"/>
+                <a:cs typeface="Arial"/>
+              </a:defRPr>
+            </a:lvl6pPr>
+            <a:lvl7pPr>
+              <a:defRPr sz="1350" b="0">
+                <a:solidFill>
+                  <a:srgbClr val="AAB8C5"/>
+                </a:solidFill>
+                <a:latin typeface="Arial"/>
+                <a:ea typeface="Arial"/>
+                <a:cs typeface="Arial"/>
+              </a:defRPr>
+            </a:lvl7pPr>
+            <a:lvl8pPr>
+              <a:defRPr sz="1350" b="0">
+                <a:solidFill>
+                  <a:srgbClr val="AAB8C5"/>
+                </a:solidFill>
+                <a:latin typeface="Arial"/>
+                <a:ea typeface="Arial"/>
+                <a:cs typeface="Arial"/>
+              </a:defRPr>
+            </a:lvl8pPr>
+            <a:lvl9pPr>
+              <a:defRPr sz="1350" b="0">
+                <a:solidFill>
+                  <a:srgbClr val="AAB8C5"/>
+                </a:solidFill>
+                <a:latin typeface="Arial"/>
+                <a:ea typeface="Arial"/>
+                <a:cs typeface="Arial"/>
+              </a:defRPr>
+            </a:lvl9pPr>
           </a:lstStyle>
           <a:p xmlns:a="http://schemas.openxmlformats.org/drawingml/2006/main">
             <a:pPr>
@@ -3949,7 +5639,7 @@
                 <a:ea typeface="Arial"/>
                 <a:cs typeface="Arial"/>
               </a:rPr>
-              <a:t>Controle da comparação local</a:t>
+              <a:t>Resultados por escala · saídas em caracteres</a:t>
             </a:r>
           </a:p>
         </p:txBody>
@@ -3959,7 +5649,7 @@
           <p:cNvPr id="14" name="">
             <a:extLst xmlns:a="http://schemas.openxmlformats.org/drawingml/2006/main">
               <a:ext uri="{FF2B5EF4-FFF2-40B4-BE49-F238E27FC236}">
-                <a16:creationId xmlns:a16="http://schemas.microsoft.com/office/drawing/2014/main" id="{7E60879A-9846-47C3-B233-0D9BCF1C5A85}"/>
+                <a16:creationId xmlns:a16="http://schemas.microsoft.com/office/drawing/2014/main" id="{A436ED1F-28F4-44CC-800E-A3FD1406E7FD}"/>
               </a:ext>
             </a:extLst>
           </p:cNvPr>
@@ -4000,7 +5690,7 @@
                           <a:ea typeface="Arial"/>
                           <a:cs typeface="Arial"/>
                         </a:rPr>
-                        <a:t>Controle</a:t>
+                        <a:t>Escala</a:t>
                       </a:r>
                     </a:p>
                   </a:txBody>
@@ -4041,7 +5731,7 @@
                           <a:ea typeface="Arial"/>
                           <a:cs typeface="Arial"/>
                         </a:rPr>
-                        <a:t>Antes</a:t>
+                        <a:t>40 notas</a:t>
                       </a:r>
                     </a:p>
                   </a:txBody>
@@ -4079,7 +5769,7 @@
                           <a:ea typeface="Arial"/>
                           <a:cs typeface="Arial"/>
                         </a:rPr>
-                        <a:t>Agora</a:t>
+                        <a:t>1.000 notas</a:t>
                       </a:r>
                     </a:p>
                   </a:txBody>
@@ -4117,7 +5807,7 @@
                           <a:ea typeface="Arial"/>
                           <a:cs typeface="Arial"/>
                         </a:rPr>
-                        <a:t>Diferença</a:t>
+                        <a:t>10.000 notas</a:t>
                       </a:r>
                     </a:p>
                   </a:txBody>
@@ -4157,7 +5847,7 @@
                           <a:ea typeface="Arial"/>
                           <a:cs typeface="Arial"/>
                         </a:rPr>
-                        <a:t>Notas</a:t>
+                        <a:t>Acervo (car.)</a:t>
                       </a:r>
                     </a:p>
                   </a:txBody>
@@ -4195,7 +5885,7 @@
                           <a:ea typeface="Arial"/>
                           <a:cs typeface="Arial"/>
                         </a:rPr>
-                        <a:t>5</a:t>
+                        <a:t>105.046</a:t>
                       </a:r>
                     </a:p>
                   </a:txBody>
@@ -4230,7 +5920,7 @@
                           <a:ea typeface="Arial"/>
                           <a:cs typeface="Arial"/>
                         </a:rPr>
-                        <a:t>5</a:t>
+                        <a:t>2.690.974</a:t>
                       </a:r>
                     </a:p>
                   </a:txBody>
@@ -4265,7 +5955,7 @@
                           <a:ea typeface="Arial"/>
                           <a:cs typeface="Arial"/>
                         </a:rPr>
-                        <a:t>mesmas</a:t>
+                        <a:t>26.918.974</a:t>
                       </a:r>
                     </a:p>
                   </a:txBody>
@@ -4302,7 +5992,7 @@
                           <a:ea typeface="Arial"/>
                           <a:cs typeface="Arial"/>
                         </a:rPr>
-                        <a:t>Trechos</a:t>
+                        <a:t>Consultas</a:t>
                       </a:r>
                     </a:p>
                   </a:txBody>
@@ -4340,7 +6030,7 @@
                           <a:ea typeface="Arial"/>
                           <a:cs typeface="Arial"/>
                         </a:rPr>
-                        <a:t>originais</a:t>
+                        <a:t>8</a:t>
                       </a:r>
                     </a:p>
                   </a:txBody>
@@ -4375,7 +6065,7 @@
                           <a:ea typeface="Arial"/>
                           <a:cs typeface="Arial"/>
                         </a:rPr>
-                        <a:t>idênticos</a:t>
+                        <a:t>8</a:t>
                       </a:r>
                     </a:p>
                   </a:txBody>
@@ -4410,7 +6100,7 @@
                           <a:ea typeface="Arial"/>
                           <a:cs typeface="Arial"/>
                         </a:rPr>
-                        <a:t>preservados</a:t>
+                        <a:t>8</a:t>
                       </a:r>
                     </a:p>
                   </a:txBody>
@@ -4447,7 +6137,7 @@
                           <a:ea typeface="Arial"/>
                           <a:cs typeface="Arial"/>
                         </a:rPr>
-                        <a:t>Limite</a:t>
+                        <a:t>Saída antes</a:t>
                       </a:r>
                     </a:p>
                   </a:txBody>
@@ -4485,7 +6175,7 @@
                           <a:ea typeface="Arial"/>
                           <a:cs typeface="Arial"/>
                         </a:rPr>
-                        <a:t>5 notas</a:t>
+                        <a:t>44.547</a:t>
                       </a:r>
                     </a:p>
                   </a:txBody>
@@ -4520,7 +6210,7 @@
                           <a:ea typeface="Arial"/>
                           <a:cs typeface="Arial"/>
                         </a:rPr>
-                        <a:t>5 notas</a:t>
+                        <a:t>82.546</a:t>
                       </a:r>
                     </a:p>
                   </a:txBody>
@@ -4555,7 +6245,7 @@
                           <a:ea typeface="Arial"/>
                           <a:cs typeface="Arial"/>
                         </a:rPr>
-                        <a:t>igual</a:t>
+                        <a:t>83.872</a:t>
                       </a:r>
                     </a:p>
                   </a:txBody>
@@ -4592,7 +6282,7 @@
                           <a:ea typeface="Arial"/>
                           <a:cs typeface="Arial"/>
                         </a:rPr>
-                        <a:t>Orçamento</a:t>
+                        <a:t>Saída atual</a:t>
                       </a:r>
                     </a:p>
                   </a:txBody>
@@ -4630,7 +6320,7 @@
                           <a:ea typeface="Arial"/>
                           <a:cs typeface="Arial"/>
                         </a:rPr>
-                        <a:t>12.000</a:t>
+                        <a:t>37.155</a:t>
                       </a:r>
                     </a:p>
                   </a:txBody>
@@ -4665,7 +6355,7 @@
                           <a:ea typeface="Arial"/>
                           <a:cs typeface="Arial"/>
                         </a:rPr>
-                        <a:t>12.000</a:t>
+                        <a:t>40.565</a:t>
                       </a:r>
                     </a:p>
                   </a:txBody>
@@ -4700,7 +6390,7 @@
                           <a:ea typeface="Arial"/>
                           <a:cs typeface="Arial"/>
                         </a:rPr>
-                        <a:t>igual</a:t>
+                        <a:t>40.579</a:t>
                       </a:r>
                     </a:p>
                   </a:txBody>
@@ -4737,7 +6427,7 @@
                           <a:ea typeface="Arial"/>
                           <a:cs typeface="Arial"/>
                         </a:rPr>
-                        <a:t>Caracteres</a:t>
+                        <a:t>Redução</a:t>
                       </a:r>
                     </a:p>
                   </a:txBody>
@@ -4775,7 +6465,7 @@
                           <a:ea typeface="Arial"/>
                           <a:cs typeface="Arial"/>
                         </a:rPr>
-                        <a:t>11.961</a:t>
+                        <a:t>16,6%</a:t>
                       </a:r>
                     </a:p>
                   </a:txBody>
@@ -4810,7 +6500,7 @@
                           <a:ea typeface="Arial"/>
                           <a:cs typeface="Arial"/>
                         </a:rPr>
-                        <a:t>4.677</a:t>
+                        <a:t>50,9%</a:t>
                       </a:r>
                     </a:p>
                   </a:txBody>
@@ -4845,7 +6535,7 @@
                           <a:ea typeface="Arial"/>
                           <a:cs typeface="Arial"/>
                         </a:rPr>
-                        <a:t>−7.284</a:t>
+                        <a:t>51,6%</a:t>
                       </a:r>
                     </a:p>
                   </a:txBody>
@@ -4908,6 +6598,96 @@
                 <a:cs typeface="Arial"/>
               </a:defRPr>
             </a:defPPr>
+            <a:lvl1pPr>
+              <a:defRPr sz="1650" b="1">
+                <a:solidFill>
+                  <a:srgbClr val="F5F6F0"/>
+                </a:solidFill>
+                <a:latin typeface="Arial"/>
+                <a:ea typeface="Arial"/>
+                <a:cs typeface="Arial"/>
+              </a:defRPr>
+            </a:lvl1pPr>
+            <a:lvl2pPr>
+              <a:defRPr sz="1650" b="1">
+                <a:solidFill>
+                  <a:srgbClr val="F5F6F0"/>
+                </a:solidFill>
+                <a:latin typeface="Arial"/>
+                <a:ea typeface="Arial"/>
+                <a:cs typeface="Arial"/>
+              </a:defRPr>
+            </a:lvl2pPr>
+            <a:lvl3pPr>
+              <a:defRPr sz="1650" b="1">
+                <a:solidFill>
+                  <a:srgbClr val="F5F6F0"/>
+                </a:solidFill>
+                <a:latin typeface="Arial"/>
+                <a:ea typeface="Arial"/>
+                <a:cs typeface="Arial"/>
+              </a:defRPr>
+            </a:lvl3pPr>
+            <a:lvl4pPr>
+              <a:defRPr sz="1650" b="1">
+                <a:solidFill>
+                  <a:srgbClr val="F5F6F0"/>
+                </a:solidFill>
+                <a:latin typeface="Arial"/>
+                <a:ea typeface="Arial"/>
+                <a:cs typeface="Arial"/>
+              </a:defRPr>
+            </a:lvl4pPr>
+            <a:lvl5pPr>
+              <a:defRPr sz="1650" b="1">
+                <a:solidFill>
+                  <a:srgbClr val="F5F6F0"/>
+                </a:solidFill>
+                <a:latin typeface="Arial"/>
+                <a:ea typeface="Arial"/>
+                <a:cs typeface="Arial"/>
+              </a:defRPr>
+            </a:lvl5pPr>
+            <a:lvl6pPr>
+              <a:defRPr sz="1650" b="1">
+                <a:solidFill>
+                  <a:srgbClr val="F5F6F0"/>
+                </a:solidFill>
+                <a:latin typeface="Arial"/>
+                <a:ea typeface="Arial"/>
+                <a:cs typeface="Arial"/>
+              </a:defRPr>
+            </a:lvl6pPr>
+            <a:lvl7pPr>
+              <a:defRPr sz="1650" b="1">
+                <a:solidFill>
+                  <a:srgbClr val="F5F6F0"/>
+                </a:solidFill>
+                <a:latin typeface="Arial"/>
+                <a:ea typeface="Arial"/>
+                <a:cs typeface="Arial"/>
+              </a:defRPr>
+            </a:lvl7pPr>
+            <a:lvl8pPr>
+              <a:defRPr sz="1650" b="1">
+                <a:solidFill>
+                  <a:srgbClr val="F5F6F0"/>
+                </a:solidFill>
+                <a:latin typeface="Arial"/>
+                <a:ea typeface="Arial"/>
+                <a:cs typeface="Arial"/>
+              </a:defRPr>
+            </a:lvl8pPr>
+            <a:lvl9pPr>
+              <a:defRPr sz="1650" b="1">
+                <a:solidFill>
+                  <a:srgbClr val="F5F6F0"/>
+                </a:solidFill>
+                <a:latin typeface="Arial"/>
+                <a:ea typeface="Arial"/>
+                <a:cs typeface="Arial"/>
+              </a:defRPr>
+            </a:lvl9pPr>
           </a:lstStyle>
           <a:p xmlns:a="http://schemas.openxmlformats.org/drawingml/2006/main">
             <a:pPr>
@@ -4930,7 +6710,7 @@
                 <a:ea typeface="Arial"/>
                 <a:cs typeface="Arial"/>
               </a:rPr>
-              <a:t>Benchmark público sintético</a:t>
+              <a:t>Reproduza a análise ampliada</a:t>
             </a:r>
           </a:p>
         </p:txBody>
@@ -4977,6 +6757,96 @@
                 <a:cs typeface="Arial"/>
               </a:defRPr>
             </a:defPPr>
+            <a:lvl1pPr>
+              <a:defRPr sz="1425" b="0">
+                <a:solidFill>
+                  <a:srgbClr val="70DEC9"/>
+                </a:solidFill>
+                <a:latin typeface="Arial"/>
+                <a:ea typeface="Arial"/>
+                <a:cs typeface="Arial"/>
+              </a:defRPr>
+            </a:lvl1pPr>
+            <a:lvl2pPr>
+              <a:defRPr sz="1425" b="0">
+                <a:solidFill>
+                  <a:srgbClr val="70DEC9"/>
+                </a:solidFill>
+                <a:latin typeface="Arial"/>
+                <a:ea typeface="Arial"/>
+                <a:cs typeface="Arial"/>
+              </a:defRPr>
+            </a:lvl2pPr>
+            <a:lvl3pPr>
+              <a:defRPr sz="1425" b="0">
+                <a:solidFill>
+                  <a:srgbClr val="70DEC9"/>
+                </a:solidFill>
+                <a:latin typeface="Arial"/>
+                <a:ea typeface="Arial"/>
+                <a:cs typeface="Arial"/>
+              </a:defRPr>
+            </a:lvl3pPr>
+            <a:lvl4pPr>
+              <a:defRPr sz="1425" b="0">
+                <a:solidFill>
+                  <a:srgbClr val="70DEC9"/>
+                </a:solidFill>
+                <a:latin typeface="Arial"/>
+                <a:ea typeface="Arial"/>
+                <a:cs typeface="Arial"/>
+              </a:defRPr>
+            </a:lvl4pPr>
+            <a:lvl5pPr>
+              <a:defRPr sz="1425" b="0">
+                <a:solidFill>
+                  <a:srgbClr val="70DEC9"/>
+                </a:solidFill>
+                <a:latin typeface="Arial"/>
+                <a:ea typeface="Arial"/>
+                <a:cs typeface="Arial"/>
+              </a:defRPr>
+            </a:lvl5pPr>
+            <a:lvl6pPr>
+              <a:defRPr sz="1425" b="0">
+                <a:solidFill>
+                  <a:srgbClr val="70DEC9"/>
+                </a:solidFill>
+                <a:latin typeface="Arial"/>
+                <a:ea typeface="Arial"/>
+                <a:cs typeface="Arial"/>
+              </a:defRPr>
+            </a:lvl6pPr>
+            <a:lvl7pPr>
+              <a:defRPr sz="1425" b="0">
+                <a:solidFill>
+                  <a:srgbClr val="70DEC9"/>
+                </a:solidFill>
+                <a:latin typeface="Arial"/>
+                <a:ea typeface="Arial"/>
+                <a:cs typeface="Arial"/>
+              </a:defRPr>
+            </a:lvl7pPr>
+            <a:lvl8pPr>
+              <a:defRPr sz="1425" b="0">
+                <a:solidFill>
+                  <a:srgbClr val="70DEC9"/>
+                </a:solidFill>
+                <a:latin typeface="Arial"/>
+                <a:ea typeface="Arial"/>
+                <a:cs typeface="Arial"/>
+              </a:defRPr>
+            </a:lvl8pPr>
+            <a:lvl9pPr>
+              <a:defRPr sz="1425" b="0">
+                <a:solidFill>
+                  <a:srgbClr val="70DEC9"/>
+                </a:solidFill>
+                <a:latin typeface="Arial"/>
+                <a:ea typeface="Arial"/>
+                <a:cs typeface="Arial"/>
+              </a:defRPr>
+            </a:lvl9pPr>
           </a:lstStyle>
           <a:p xmlns:a="http://schemas.openxmlformats.org/drawingml/2006/main">
             <a:pPr>
@@ -4999,7 +6869,7 @@
                 <a:ea typeface="Arial"/>
                 <a:cs typeface="Arial"/>
               </a:rPr>
-              <a:t>40 notas · seleção de 5 notas e 20 trechos</a:t>
+              <a:t>python3 tools/benchmark_busca.py</a:t>
             </a:r>
           </a:p>
         </p:txBody>
@@ -5046,6 +6916,96 @@
                 <a:cs typeface="Arial"/>
               </a:defRPr>
             </a:defPPr>
+            <a:lvl1pPr>
+              <a:defRPr sz="1425" b="0">
+                <a:solidFill>
+                  <a:srgbClr val="92BFFF"/>
+                </a:solidFill>
+                <a:latin typeface="Arial"/>
+                <a:ea typeface="Arial"/>
+                <a:cs typeface="Arial"/>
+              </a:defRPr>
+            </a:lvl1pPr>
+            <a:lvl2pPr>
+              <a:defRPr sz="1425" b="0">
+                <a:solidFill>
+                  <a:srgbClr val="92BFFF"/>
+                </a:solidFill>
+                <a:latin typeface="Arial"/>
+                <a:ea typeface="Arial"/>
+                <a:cs typeface="Arial"/>
+              </a:defRPr>
+            </a:lvl2pPr>
+            <a:lvl3pPr>
+              <a:defRPr sz="1425" b="0">
+                <a:solidFill>
+                  <a:srgbClr val="92BFFF"/>
+                </a:solidFill>
+                <a:latin typeface="Arial"/>
+                <a:ea typeface="Arial"/>
+                <a:cs typeface="Arial"/>
+              </a:defRPr>
+            </a:lvl3pPr>
+            <a:lvl4pPr>
+              <a:defRPr sz="1425" b="0">
+                <a:solidFill>
+                  <a:srgbClr val="92BFFF"/>
+                </a:solidFill>
+                <a:latin typeface="Arial"/>
+                <a:ea typeface="Arial"/>
+                <a:cs typeface="Arial"/>
+              </a:defRPr>
+            </a:lvl4pPr>
+            <a:lvl5pPr>
+              <a:defRPr sz="1425" b="0">
+                <a:solidFill>
+                  <a:srgbClr val="92BFFF"/>
+                </a:solidFill>
+                <a:latin typeface="Arial"/>
+                <a:ea typeface="Arial"/>
+                <a:cs typeface="Arial"/>
+              </a:defRPr>
+            </a:lvl5pPr>
+            <a:lvl6pPr>
+              <a:defRPr sz="1425" b="0">
+                <a:solidFill>
+                  <a:srgbClr val="92BFFF"/>
+                </a:solidFill>
+                <a:latin typeface="Arial"/>
+                <a:ea typeface="Arial"/>
+                <a:cs typeface="Arial"/>
+              </a:defRPr>
+            </a:lvl6pPr>
+            <a:lvl7pPr>
+              <a:defRPr sz="1425" b="0">
+                <a:solidFill>
+                  <a:srgbClr val="92BFFF"/>
+                </a:solidFill>
+                <a:latin typeface="Arial"/>
+                <a:ea typeface="Arial"/>
+                <a:cs typeface="Arial"/>
+              </a:defRPr>
+            </a:lvl7pPr>
+            <a:lvl8pPr>
+              <a:defRPr sz="1425" b="0">
+                <a:solidFill>
+                  <a:srgbClr val="92BFFF"/>
+                </a:solidFill>
+                <a:latin typeface="Arial"/>
+                <a:ea typeface="Arial"/>
+                <a:cs typeface="Arial"/>
+              </a:defRPr>
+            </a:lvl8pPr>
+            <a:lvl9pPr>
+              <a:defRPr sz="1425" b="0">
+                <a:solidFill>
+                  <a:srgbClr val="92BFFF"/>
+                </a:solidFill>
+                <a:latin typeface="Arial"/>
+                <a:ea typeface="Arial"/>
+                <a:cs typeface="Arial"/>
+              </a:defRPr>
+            </a:lvl9pPr>
           </a:lstStyle>
           <a:p xmlns:a="http://schemas.openxmlformats.org/drawingml/2006/main">
             <a:pPr>
@@ -5068,7 +7028,7 @@
                 <a:ea typeface="Arial"/>
                 <a:cs typeface="Arial"/>
               </a:rPr>
-              <a:t>11.696 → 5.862 caracteres (−49,9%)</a:t>
+              <a:t>--ampliado</a:t>
             </a:r>
           </a:p>
         </p:txBody>
@@ -5115,6 +7075,96 @@
                 <a:cs typeface="Arial"/>
               </a:defRPr>
             </a:defPPr>
+            <a:lvl1pPr>
+              <a:defRPr sz="1425" b="0">
+                <a:solidFill>
+                  <a:srgbClr val="F5F6F0"/>
+                </a:solidFill>
+                <a:latin typeface="Arial"/>
+                <a:ea typeface="Arial"/>
+                <a:cs typeface="Arial"/>
+              </a:defRPr>
+            </a:lvl1pPr>
+            <a:lvl2pPr>
+              <a:defRPr sz="1425" b="0">
+                <a:solidFill>
+                  <a:srgbClr val="F5F6F0"/>
+                </a:solidFill>
+                <a:latin typeface="Arial"/>
+                <a:ea typeface="Arial"/>
+                <a:cs typeface="Arial"/>
+              </a:defRPr>
+            </a:lvl2pPr>
+            <a:lvl3pPr>
+              <a:defRPr sz="1425" b="0">
+                <a:solidFill>
+                  <a:srgbClr val="F5F6F0"/>
+                </a:solidFill>
+                <a:latin typeface="Arial"/>
+                <a:ea typeface="Arial"/>
+                <a:cs typeface="Arial"/>
+              </a:defRPr>
+            </a:lvl3pPr>
+            <a:lvl4pPr>
+              <a:defRPr sz="1425" b="0">
+                <a:solidFill>
+                  <a:srgbClr val="F5F6F0"/>
+                </a:solidFill>
+                <a:latin typeface="Arial"/>
+                <a:ea typeface="Arial"/>
+                <a:cs typeface="Arial"/>
+              </a:defRPr>
+            </a:lvl4pPr>
+            <a:lvl5pPr>
+              <a:defRPr sz="1425" b="0">
+                <a:solidFill>
+                  <a:srgbClr val="F5F6F0"/>
+                </a:solidFill>
+                <a:latin typeface="Arial"/>
+                <a:ea typeface="Arial"/>
+                <a:cs typeface="Arial"/>
+              </a:defRPr>
+            </a:lvl5pPr>
+            <a:lvl6pPr>
+              <a:defRPr sz="1425" b="0">
+                <a:solidFill>
+                  <a:srgbClr val="F5F6F0"/>
+                </a:solidFill>
+                <a:latin typeface="Arial"/>
+                <a:ea typeface="Arial"/>
+                <a:cs typeface="Arial"/>
+              </a:defRPr>
+            </a:lvl6pPr>
+            <a:lvl7pPr>
+              <a:defRPr sz="1425" b="0">
+                <a:solidFill>
+                  <a:srgbClr val="F5F6F0"/>
+                </a:solidFill>
+                <a:latin typeface="Arial"/>
+                <a:ea typeface="Arial"/>
+                <a:cs typeface="Arial"/>
+              </a:defRPr>
+            </a:lvl7pPr>
+            <a:lvl8pPr>
+              <a:defRPr sz="1425" b="0">
+                <a:solidFill>
+                  <a:srgbClr val="F5F6F0"/>
+                </a:solidFill>
+                <a:latin typeface="Arial"/>
+                <a:ea typeface="Arial"/>
+                <a:cs typeface="Arial"/>
+              </a:defRPr>
+            </a:lvl8pPr>
+            <a:lvl9pPr>
+              <a:defRPr sz="1425" b="0">
+                <a:solidFill>
+                  <a:srgbClr val="F5F6F0"/>
+                </a:solidFill>
+                <a:latin typeface="Arial"/>
+                <a:ea typeface="Arial"/>
+                <a:cs typeface="Arial"/>
+              </a:defRPr>
+            </a:lvl9pPr>
           </a:lstStyle>
           <a:p xmlns:a="http://schemas.openxmlformats.org/drawingml/2006/main">
             <a:pPr>
@@ -5137,7 +7187,7 @@
                 <a:ea typeface="Arial"/>
                 <a:cs typeface="Arial"/>
               </a:rPr>
-              <a:t>Reproduza com dados de demonstração:</a:t>
+              <a:t>Maior corpus: 26.918.974 caracteres</a:t>
             </a:r>
           </a:p>
           <a:p xmlns:a="http://schemas.openxmlformats.org/drawingml/2006/main">
@@ -5161,7 +7211,7 @@
                 <a:ea typeface="Arial"/>
                 <a:cs typeface="Arial"/>
               </a:rPr>
-              <a:t>python3 tools/benchmark_busca.py</a:t>
+              <a:t>10.000 notas sintéticas + protocolo mínimo</a:t>
             </a:r>
           </a:p>
         </p:txBody>
@@ -5208,6 +7258,96 @@
                 <a:cs typeface="Arial"/>
               </a:defRPr>
             </a:defPPr>
+            <a:lvl1pPr>
+              <a:defRPr sz="1313" b="0">
+                <a:solidFill>
+                  <a:srgbClr val="AAB8C5"/>
+                </a:solidFill>
+                <a:latin typeface="Arial"/>
+                <a:ea typeface="Arial"/>
+                <a:cs typeface="Arial"/>
+              </a:defRPr>
+            </a:lvl1pPr>
+            <a:lvl2pPr>
+              <a:defRPr sz="1313" b="0">
+                <a:solidFill>
+                  <a:srgbClr val="AAB8C5"/>
+                </a:solidFill>
+                <a:latin typeface="Arial"/>
+                <a:ea typeface="Arial"/>
+                <a:cs typeface="Arial"/>
+              </a:defRPr>
+            </a:lvl2pPr>
+            <a:lvl3pPr>
+              <a:defRPr sz="1313" b="0">
+                <a:solidFill>
+                  <a:srgbClr val="AAB8C5"/>
+                </a:solidFill>
+                <a:latin typeface="Arial"/>
+                <a:ea typeface="Arial"/>
+                <a:cs typeface="Arial"/>
+              </a:defRPr>
+            </a:lvl3pPr>
+            <a:lvl4pPr>
+              <a:defRPr sz="1313" b="0">
+                <a:solidFill>
+                  <a:srgbClr val="AAB8C5"/>
+                </a:solidFill>
+                <a:latin typeface="Arial"/>
+                <a:ea typeface="Arial"/>
+                <a:cs typeface="Arial"/>
+              </a:defRPr>
+            </a:lvl4pPr>
+            <a:lvl5pPr>
+              <a:defRPr sz="1313" b="0">
+                <a:solidFill>
+                  <a:srgbClr val="AAB8C5"/>
+                </a:solidFill>
+                <a:latin typeface="Arial"/>
+                <a:ea typeface="Arial"/>
+                <a:cs typeface="Arial"/>
+              </a:defRPr>
+            </a:lvl5pPr>
+            <a:lvl6pPr>
+              <a:defRPr sz="1313" b="0">
+                <a:solidFill>
+                  <a:srgbClr val="AAB8C5"/>
+                </a:solidFill>
+                <a:latin typeface="Arial"/>
+                <a:ea typeface="Arial"/>
+                <a:cs typeface="Arial"/>
+              </a:defRPr>
+            </a:lvl6pPr>
+            <a:lvl7pPr>
+              <a:defRPr sz="1313" b="0">
+                <a:solidFill>
+                  <a:srgbClr val="AAB8C5"/>
+                </a:solidFill>
+                <a:latin typeface="Arial"/>
+                <a:ea typeface="Arial"/>
+                <a:cs typeface="Arial"/>
+              </a:defRPr>
+            </a:lvl7pPr>
+            <a:lvl8pPr>
+              <a:defRPr sz="1313" b="0">
+                <a:solidFill>
+                  <a:srgbClr val="AAB8C5"/>
+                </a:solidFill>
+                <a:latin typeface="Arial"/>
+                <a:ea typeface="Arial"/>
+                <a:cs typeface="Arial"/>
+              </a:defRPr>
+            </a:lvl8pPr>
+            <a:lvl9pPr>
+              <a:defRPr sz="1313" b="0">
+                <a:solidFill>
+                  <a:srgbClr val="AAB8C5"/>
+                </a:solidFill>
+                <a:latin typeface="Arial"/>
+                <a:ea typeface="Arial"/>
+                <a:cs typeface="Arial"/>
+              </a:defRPr>
+            </a:lvl9pPr>
           </a:lstStyle>
           <a:p xmlns:a="http://schemas.openxmlformats.org/drawingml/2006/main">
             <a:pPr>
@@ -5230,7 +7370,7 @@
                 <a:ea typeface="Arial"/>
                 <a:cs typeface="Arial"/>
               </a:rPr>
-              <a:t>Cenário distinto da medição local de 60,9%.</a:t>
+              <a:t>Medição local anterior: 60,9% em uma consulta.</a:t>
             </a:r>
           </a:p>
         </p:txBody>
@@ -5277,6 +7417,96 @@
                 <a:cs typeface="Arial"/>
               </a:defRPr>
             </a:defPPr>
+            <a:lvl1pPr>
+              <a:defRPr sz="1800" b="1">
+                <a:solidFill>
+                  <a:srgbClr val="F5F6F0"/>
+                </a:solidFill>
+                <a:latin typeface="Arial"/>
+                <a:ea typeface="Arial"/>
+                <a:cs typeface="Arial"/>
+              </a:defRPr>
+            </a:lvl1pPr>
+            <a:lvl2pPr>
+              <a:defRPr sz="1800" b="1">
+                <a:solidFill>
+                  <a:srgbClr val="F5F6F0"/>
+                </a:solidFill>
+                <a:latin typeface="Arial"/>
+                <a:ea typeface="Arial"/>
+                <a:cs typeface="Arial"/>
+              </a:defRPr>
+            </a:lvl2pPr>
+            <a:lvl3pPr>
+              <a:defRPr sz="1800" b="1">
+                <a:solidFill>
+                  <a:srgbClr val="F5F6F0"/>
+                </a:solidFill>
+                <a:latin typeface="Arial"/>
+                <a:ea typeface="Arial"/>
+                <a:cs typeface="Arial"/>
+              </a:defRPr>
+            </a:lvl3pPr>
+            <a:lvl4pPr>
+              <a:defRPr sz="1800" b="1">
+                <a:solidFill>
+                  <a:srgbClr val="F5F6F0"/>
+                </a:solidFill>
+                <a:latin typeface="Arial"/>
+                <a:ea typeface="Arial"/>
+                <a:cs typeface="Arial"/>
+              </a:defRPr>
+            </a:lvl4pPr>
+            <a:lvl5pPr>
+              <a:defRPr sz="1800" b="1">
+                <a:solidFill>
+                  <a:srgbClr val="F5F6F0"/>
+                </a:solidFill>
+                <a:latin typeface="Arial"/>
+                <a:ea typeface="Arial"/>
+                <a:cs typeface="Arial"/>
+              </a:defRPr>
+            </a:lvl5pPr>
+            <a:lvl6pPr>
+              <a:defRPr sz="1800" b="1">
+                <a:solidFill>
+                  <a:srgbClr val="F5F6F0"/>
+                </a:solidFill>
+                <a:latin typeface="Arial"/>
+                <a:ea typeface="Arial"/>
+                <a:cs typeface="Arial"/>
+              </a:defRPr>
+            </a:lvl6pPr>
+            <a:lvl7pPr>
+              <a:defRPr sz="1800" b="1">
+                <a:solidFill>
+                  <a:srgbClr val="F5F6F0"/>
+                </a:solidFill>
+                <a:latin typeface="Arial"/>
+                <a:ea typeface="Arial"/>
+                <a:cs typeface="Arial"/>
+              </a:defRPr>
+            </a:lvl7pPr>
+            <a:lvl8pPr>
+              <a:defRPr sz="1800" b="1">
+                <a:solidFill>
+                  <a:srgbClr val="F5F6F0"/>
+                </a:solidFill>
+                <a:latin typeface="Arial"/>
+                <a:ea typeface="Arial"/>
+                <a:cs typeface="Arial"/>
+              </a:defRPr>
+            </a:lvl8pPr>
+            <a:lvl9pPr>
+              <a:defRPr sz="1800" b="1">
+                <a:solidFill>
+                  <a:srgbClr val="F5F6F0"/>
+                </a:solidFill>
+                <a:latin typeface="Arial"/>
+                <a:ea typeface="Arial"/>
+                <a:cs typeface="Arial"/>
+              </a:defRPr>
+            </a:lvl9pPr>
           </a:lstStyle>
           <a:p xmlns:a="http://schemas.openxmlformats.org/drawingml/2006/main">
             <a:pPr>
@@ -5299,7 +7529,7 @@
                 <a:ea typeface="Arial"/>
                 <a:cs typeface="Arial"/>
               </a:rPr>
-              <a:t>Menos texto repetido para recuperar o mesmo contexto</a:t>
+              <a:t>O acervo cresce; o contexto retornado tem orçamento</a:t>
             </a:r>
           </a:p>
         </p:txBody>
@@ -5346,6 +7576,96 @@
                 <a:cs typeface="Arial"/>
               </a:defRPr>
             </a:defPPr>
+            <a:lvl1pPr>
+              <a:defRPr sz="1388" b="0">
+                <a:solidFill>
+                  <a:srgbClr val="92BFFF"/>
+                </a:solidFill>
+                <a:latin typeface="Arial"/>
+                <a:ea typeface="Arial"/>
+                <a:cs typeface="Arial"/>
+              </a:defRPr>
+            </a:lvl1pPr>
+            <a:lvl2pPr>
+              <a:defRPr sz="1388" b="0">
+                <a:solidFill>
+                  <a:srgbClr val="92BFFF"/>
+                </a:solidFill>
+                <a:latin typeface="Arial"/>
+                <a:ea typeface="Arial"/>
+                <a:cs typeface="Arial"/>
+              </a:defRPr>
+            </a:lvl2pPr>
+            <a:lvl3pPr>
+              <a:defRPr sz="1388" b="0">
+                <a:solidFill>
+                  <a:srgbClr val="92BFFF"/>
+                </a:solidFill>
+                <a:latin typeface="Arial"/>
+                <a:ea typeface="Arial"/>
+                <a:cs typeface="Arial"/>
+              </a:defRPr>
+            </a:lvl3pPr>
+            <a:lvl4pPr>
+              <a:defRPr sz="1388" b="0">
+                <a:solidFill>
+                  <a:srgbClr val="92BFFF"/>
+                </a:solidFill>
+                <a:latin typeface="Arial"/>
+                <a:ea typeface="Arial"/>
+                <a:cs typeface="Arial"/>
+              </a:defRPr>
+            </a:lvl4pPr>
+            <a:lvl5pPr>
+              <a:defRPr sz="1388" b="0">
+                <a:solidFill>
+                  <a:srgbClr val="92BFFF"/>
+                </a:solidFill>
+                <a:latin typeface="Arial"/>
+                <a:ea typeface="Arial"/>
+                <a:cs typeface="Arial"/>
+              </a:defRPr>
+            </a:lvl5pPr>
+            <a:lvl6pPr>
+              <a:defRPr sz="1388" b="0">
+                <a:solidFill>
+                  <a:srgbClr val="92BFFF"/>
+                </a:solidFill>
+                <a:latin typeface="Arial"/>
+                <a:ea typeface="Arial"/>
+                <a:cs typeface="Arial"/>
+              </a:defRPr>
+            </a:lvl6pPr>
+            <a:lvl7pPr>
+              <a:defRPr sz="1388" b="0">
+                <a:solidFill>
+                  <a:srgbClr val="92BFFF"/>
+                </a:solidFill>
+                <a:latin typeface="Arial"/>
+                <a:ea typeface="Arial"/>
+                <a:cs typeface="Arial"/>
+              </a:defRPr>
+            </a:lvl7pPr>
+            <a:lvl8pPr>
+              <a:defRPr sz="1388" b="0">
+                <a:solidFill>
+                  <a:srgbClr val="92BFFF"/>
+                </a:solidFill>
+                <a:latin typeface="Arial"/>
+                <a:ea typeface="Arial"/>
+                <a:cs typeface="Arial"/>
+              </a:defRPr>
+            </a:lvl8pPr>
+            <a:lvl9pPr>
+              <a:defRPr sz="1388" b="0">
+                <a:solidFill>
+                  <a:srgbClr val="92BFFF"/>
+                </a:solidFill>
+                <a:latin typeface="Arial"/>
+                <a:ea typeface="Arial"/>
+                <a:cs typeface="Arial"/>
+              </a:defRPr>
+            </a:lvl9pPr>
           </a:lstStyle>
           <a:p xmlns:a="http://schemas.openxmlformats.org/drawingml/2006/main">
             <a:pPr>
@@ -5368,7 +7688,7 @@
                 <a:ea typeface="Arial"/>
                 <a:cs typeface="Arial"/>
               </a:rPr>
-              <a:t>Medição da busca; tokens totais, latência e produtividade não foram medidos.</a:t>
+              <a:t>210.965 → 118.299 soma 24 consultas distintas; não é o volume de uma única resposta.</a:t>
             </a:r>
           </a:p>
         </p:txBody>
@@ -5415,6 +7735,96 @@
                 <a:cs typeface="Arial"/>
               </a:defRPr>
             </a:defPPr>
+            <a:lvl1pPr>
+              <a:defRPr sz="1350" b="0">
+                <a:solidFill>
+                  <a:srgbClr val="70DEC9"/>
+                </a:solidFill>
+                <a:latin typeface="Arial"/>
+                <a:ea typeface="Arial"/>
+                <a:cs typeface="Arial"/>
+              </a:defRPr>
+            </a:lvl1pPr>
+            <a:lvl2pPr>
+              <a:defRPr sz="1350" b="0">
+                <a:solidFill>
+                  <a:srgbClr val="70DEC9"/>
+                </a:solidFill>
+                <a:latin typeface="Arial"/>
+                <a:ea typeface="Arial"/>
+                <a:cs typeface="Arial"/>
+              </a:defRPr>
+            </a:lvl2pPr>
+            <a:lvl3pPr>
+              <a:defRPr sz="1350" b="0">
+                <a:solidFill>
+                  <a:srgbClr val="70DEC9"/>
+                </a:solidFill>
+                <a:latin typeface="Arial"/>
+                <a:ea typeface="Arial"/>
+                <a:cs typeface="Arial"/>
+              </a:defRPr>
+            </a:lvl3pPr>
+            <a:lvl4pPr>
+              <a:defRPr sz="1350" b="0">
+                <a:solidFill>
+                  <a:srgbClr val="70DEC9"/>
+                </a:solidFill>
+                <a:latin typeface="Arial"/>
+                <a:ea typeface="Arial"/>
+                <a:cs typeface="Arial"/>
+              </a:defRPr>
+            </a:lvl4pPr>
+            <a:lvl5pPr>
+              <a:defRPr sz="1350" b="0">
+                <a:solidFill>
+                  <a:srgbClr val="70DEC9"/>
+                </a:solidFill>
+                <a:latin typeface="Arial"/>
+                <a:ea typeface="Arial"/>
+                <a:cs typeface="Arial"/>
+              </a:defRPr>
+            </a:lvl5pPr>
+            <a:lvl6pPr>
+              <a:defRPr sz="1350" b="0">
+                <a:solidFill>
+                  <a:srgbClr val="70DEC9"/>
+                </a:solidFill>
+                <a:latin typeface="Arial"/>
+                <a:ea typeface="Arial"/>
+                <a:cs typeface="Arial"/>
+              </a:defRPr>
+            </a:lvl6pPr>
+            <a:lvl7pPr>
+              <a:defRPr sz="1350" b="0">
+                <a:solidFill>
+                  <a:srgbClr val="70DEC9"/>
+                </a:solidFill>
+                <a:latin typeface="Arial"/>
+                <a:ea typeface="Arial"/>
+                <a:cs typeface="Arial"/>
+              </a:defRPr>
+            </a:lvl7pPr>
+            <a:lvl8pPr>
+              <a:defRPr sz="1350" b="0">
+                <a:solidFill>
+                  <a:srgbClr val="70DEC9"/>
+                </a:solidFill>
+                <a:latin typeface="Arial"/>
+                <a:ea typeface="Arial"/>
+                <a:cs typeface="Arial"/>
+              </a:defRPr>
+            </a:lvl8pPr>
+            <a:lvl9pPr>
+              <a:defRPr sz="1350" b="0">
+                <a:solidFill>
+                  <a:srgbClr val="70DEC9"/>
+                </a:solidFill>
+                <a:latin typeface="Arial"/>
+                <a:ea typeface="Arial"/>
+                <a:cs typeface="Arial"/>
+              </a:defRPr>
+            </a:lvl9pPr>
           </a:lstStyle>
           <a:p xmlns:a="http://schemas.openxmlformats.org/drawingml/2006/main">
             <a:pPr>
@@ -5437,7 +7847,7 @@
                 <a:ea typeface="Arial"/>
                 <a:cs typeface="Arial"/>
               </a:rPr>
-              <a:t>Mensalidade: R$ 0 de desconto. A redução medida é de caracteres por consulta.</a:t>
+              <a:t>Dados sintéticos reproduzíveis. Nenhuma inferência de IA ou API paga foi executada.</a:t>
             </a:r>
           </a:p>
         </p:txBody>
@@ -5484,6 +7894,96 @@
                 <a:cs typeface="Arial"/>
               </a:defRPr>
             </a:defPPr>
+            <a:lvl1pPr>
+              <a:defRPr sz="1350" b="0">
+                <a:solidFill>
+                  <a:srgbClr val="F5F6F0"/>
+                </a:solidFill>
+                <a:latin typeface="Arial"/>
+                <a:ea typeface="Arial"/>
+                <a:cs typeface="Arial"/>
+              </a:defRPr>
+            </a:lvl1pPr>
+            <a:lvl2pPr>
+              <a:defRPr sz="1350" b="0">
+                <a:solidFill>
+                  <a:srgbClr val="F5F6F0"/>
+                </a:solidFill>
+                <a:latin typeface="Arial"/>
+                <a:ea typeface="Arial"/>
+                <a:cs typeface="Arial"/>
+              </a:defRPr>
+            </a:lvl2pPr>
+            <a:lvl3pPr>
+              <a:defRPr sz="1350" b="0">
+                <a:solidFill>
+                  <a:srgbClr val="F5F6F0"/>
+                </a:solidFill>
+                <a:latin typeface="Arial"/>
+                <a:ea typeface="Arial"/>
+                <a:cs typeface="Arial"/>
+              </a:defRPr>
+            </a:lvl3pPr>
+            <a:lvl4pPr>
+              <a:defRPr sz="1350" b="0">
+                <a:solidFill>
+                  <a:srgbClr val="F5F6F0"/>
+                </a:solidFill>
+                <a:latin typeface="Arial"/>
+                <a:ea typeface="Arial"/>
+                <a:cs typeface="Arial"/>
+              </a:defRPr>
+            </a:lvl4pPr>
+            <a:lvl5pPr>
+              <a:defRPr sz="1350" b="0">
+                <a:solidFill>
+                  <a:srgbClr val="F5F6F0"/>
+                </a:solidFill>
+                <a:latin typeface="Arial"/>
+                <a:ea typeface="Arial"/>
+                <a:cs typeface="Arial"/>
+              </a:defRPr>
+            </a:lvl5pPr>
+            <a:lvl6pPr>
+              <a:defRPr sz="1350" b="0">
+                <a:solidFill>
+                  <a:srgbClr val="F5F6F0"/>
+                </a:solidFill>
+                <a:latin typeface="Arial"/>
+                <a:ea typeface="Arial"/>
+                <a:cs typeface="Arial"/>
+              </a:defRPr>
+            </a:lvl6pPr>
+            <a:lvl7pPr>
+              <a:defRPr sz="1350" b="0">
+                <a:solidFill>
+                  <a:srgbClr val="F5F6F0"/>
+                </a:solidFill>
+                <a:latin typeface="Arial"/>
+                <a:ea typeface="Arial"/>
+                <a:cs typeface="Arial"/>
+              </a:defRPr>
+            </a:lvl7pPr>
+            <a:lvl8pPr>
+              <a:defRPr sz="1350" b="0">
+                <a:solidFill>
+                  <a:srgbClr val="F5F6F0"/>
+                </a:solidFill>
+                <a:latin typeface="Arial"/>
+                <a:ea typeface="Arial"/>
+                <a:cs typeface="Arial"/>
+              </a:defRPr>
+            </a:lvl8pPr>
+            <a:lvl9pPr>
+              <a:defRPr sz="1350" b="0">
+                <a:solidFill>
+                  <a:srgbClr val="F5F6F0"/>
+                </a:solidFill>
+                <a:latin typeface="Arial"/>
+                <a:ea typeface="Arial"/>
+                <a:cs typeface="Arial"/>
+              </a:defRPr>
+            </a:lvl9pPr>
           </a:lstStyle>
           <a:p xmlns:a="http://schemas.openxmlformats.org/drawingml/2006/main">
             <a:pPr>
@@ -5506,7 +8006,7 @@
                 <a:ea typeface="Arial"/>
                 <a:cs typeface="Arial"/>
               </a:rPr>
-              <a:t>Consulta local em 16/10/2026 · versão 663803e · notas pessoais não publicadas.</a:t>
+              <a:t>Saída em caracteres; tokens totais, produtividade e economia financeira não foram medidos.</a:t>
             </a:r>
           </a:p>
         </p:txBody>
@@ -5553,6 +8053,96 @@
                 <a:cs typeface="Arial"/>
               </a:defRPr>
             </a:defPPr>
+            <a:lvl1pPr>
+              <a:defRPr sz="825" b="0">
+                <a:solidFill>
+                  <a:srgbClr val="AAB8C5"/>
+                </a:solidFill>
+                <a:latin typeface="Arial"/>
+                <a:ea typeface="Arial"/>
+                <a:cs typeface="Arial"/>
+              </a:defRPr>
+            </a:lvl1pPr>
+            <a:lvl2pPr>
+              <a:defRPr sz="825" b="0">
+                <a:solidFill>
+                  <a:srgbClr val="AAB8C5"/>
+                </a:solidFill>
+                <a:latin typeface="Arial"/>
+                <a:ea typeface="Arial"/>
+                <a:cs typeface="Arial"/>
+              </a:defRPr>
+            </a:lvl2pPr>
+            <a:lvl3pPr>
+              <a:defRPr sz="825" b="0">
+                <a:solidFill>
+                  <a:srgbClr val="AAB8C5"/>
+                </a:solidFill>
+                <a:latin typeface="Arial"/>
+                <a:ea typeface="Arial"/>
+                <a:cs typeface="Arial"/>
+              </a:defRPr>
+            </a:lvl3pPr>
+            <a:lvl4pPr>
+              <a:defRPr sz="825" b="0">
+                <a:solidFill>
+                  <a:srgbClr val="AAB8C5"/>
+                </a:solidFill>
+                <a:latin typeface="Arial"/>
+                <a:ea typeface="Arial"/>
+                <a:cs typeface="Arial"/>
+              </a:defRPr>
+            </a:lvl4pPr>
+            <a:lvl5pPr>
+              <a:defRPr sz="825" b="0">
+                <a:solidFill>
+                  <a:srgbClr val="AAB8C5"/>
+                </a:solidFill>
+                <a:latin typeface="Arial"/>
+                <a:ea typeface="Arial"/>
+                <a:cs typeface="Arial"/>
+              </a:defRPr>
+            </a:lvl5pPr>
+            <a:lvl6pPr>
+              <a:defRPr sz="825" b="0">
+                <a:solidFill>
+                  <a:srgbClr val="AAB8C5"/>
+                </a:solidFill>
+                <a:latin typeface="Arial"/>
+                <a:ea typeface="Arial"/>
+                <a:cs typeface="Arial"/>
+              </a:defRPr>
+            </a:lvl6pPr>
+            <a:lvl7pPr>
+              <a:defRPr sz="825" b="0">
+                <a:solidFill>
+                  <a:srgbClr val="AAB8C5"/>
+                </a:solidFill>
+                <a:latin typeface="Arial"/>
+                <a:ea typeface="Arial"/>
+                <a:cs typeface="Arial"/>
+              </a:defRPr>
+            </a:lvl7pPr>
+            <a:lvl8pPr>
+              <a:defRPr sz="825" b="0">
+                <a:solidFill>
+                  <a:srgbClr val="AAB8C5"/>
+                </a:solidFill>
+                <a:latin typeface="Arial"/>
+                <a:ea typeface="Arial"/>
+                <a:cs typeface="Arial"/>
+              </a:defRPr>
+            </a:lvl8pPr>
+            <a:lvl9pPr>
+              <a:defRPr sz="825" b="0">
+                <a:solidFill>
+                  <a:srgbClr val="AAB8C5"/>
+                </a:solidFill>
+                <a:latin typeface="Arial"/>
+                <a:ea typeface="Arial"/>
+                <a:cs typeface="Arial"/>
+              </a:defRPr>
+            </a:lvl9pPr>
           </a:lstStyle>
           <a:p xmlns:a="http://schemas.openxmlformats.org/drawingml/2006/main">
             <a:pPr>
@@ -5575,7 +8165,7 @@
                 <a:ea typeface="Arial"/>
                 <a:cs typeface="Arial"/>
               </a:rPr>
-              <a:t>Um cenário de consulta, não uma média das IAs. Método e reprodução: docs/BENCHMARK.md.</a:t>
+              <a:t>16/10/2026 · Uma passagem por caso, sem controle de cache. Corpus e consultas completos: docs/benchmark-ampliado.json.</a:t>
             </a:r>
           </a:p>
         </p:txBody>

</xml_diff>

<commit_message>
docs: document six A/B rounds, a play cover, and the test method in README
- A/B de perguntas: 30/150 → 150/150 respostas certas e 49% menos tokens por resposta certa; gráfico único de tokens e acerto (ab-tokens.png removido).
- Capa do vídeo com botão de play que abre o player.
- README: seção "Como os testes foram feitos", incluindo o A/B de código com laço até acertar.
- Benchmark: opção --espera para o limite por busca; one pager atualizado.
</commit_message>
<xml_diff>
--- a/media/one-pager.pptx
+++ b/media/one-pager.pptx
@@ -212,25 +212,25 @@
                 <c:formatCode>General</c:formatCode>
                 <c:ptCount val="7"/>
                 <c:pt idx="0">
-                  <c:v>583.375</c:v>
+                  <c:v>153.375</c:v>
                 </c:pt>
                 <c:pt idx="1">
-                  <c:v>2948.375</c:v>
+                  <c:v>758.0</c:v>
                 </c:pt>
                 <c:pt idx="2">
-                  <c:v>8010.25</c:v>
+                  <c:v>2298.0</c:v>
                 </c:pt>
                 <c:pt idx="3">
-                  <c:v>10318.25</c:v>
+                  <c:v>3060.125</c:v>
                 </c:pt>
                 <c:pt idx="4">
-                  <c:v>10484.0</c:v>
+                  <c:v>3115.625</c:v>
                 </c:pt>
                 <c:pt idx="5">
-                  <c:v>10485.75</c:v>
+                  <c:v>3115.875</c:v>
                 </c:pt>
                 <c:pt idx="6">
-                  <c:v>10487.5</c:v>
+                  <c:v>3116.125</c:v>
                 </c:pt>
               </c:numCache>
             </c:numRef>
@@ -333,25 +333,25 @@
                 <c:formatCode>General</c:formatCode>
                 <c:ptCount val="7"/>
                 <c:pt idx="0">
-                  <c:v>583.375</c:v>
+                  <c:v>153.375</c:v>
                 </c:pt>
                 <c:pt idx="1">
-                  <c:v>2938.625</c:v>
+                  <c:v>754.5</c:v>
                 </c:pt>
                 <c:pt idx="2">
-                  <c:v>4921.375</c:v>
+                  <c:v>1260.625</c:v>
                 </c:pt>
                 <c:pt idx="3">
-                  <c:v>5070.625</c:v>
+                  <c:v>1299.5</c:v>
                 </c:pt>
                 <c:pt idx="4">
-                  <c:v>5072.375</c:v>
+                  <c:v>1301.0</c:v>
                 </c:pt>
                 <c:pt idx="5">
-                  <c:v>5074.125</c:v>
+                  <c:v>1301.25</c:v>
                 </c:pt>
                 <c:pt idx="6">
-                  <c:v>5075.875</c:v>
+                  <c:v>1301.5</c:v>
                 </c:pt>
               </c:numCache>
             </c:numRef>
@@ -403,7 +403,7 @@
       <c:valAx>
         <c:axId val="2140495176"/>
         <c:scaling>
-          <c:max val="13000.0"/>
+          <c:max val="3600.0"/>
           <c:min val="0.0"/>
         </c:scaling>
         <c:delete val="0"/>
@@ -522,128 +522,7 @@
               <c:strCache>
                 <c:ptCount val="1"/>
                 <c:pt idx="0">
-                  <c:v>Caracteres</c:v>
-                </c:pt>
-              </c:strCache>
-            </c:strRef>
-          </c:tx>
-          <c:spPr>
-            <a:ln w="25400">
-              <a:solidFill>
-                <a:srgbClr val="16A78B"/>
-              </a:solidFill>
-            </a:ln>
-          </c:spPr>
-          <c:marker>
-            <c:symbol val="circle"/>
-            <c:size val="7"/>
-            <c:spPr>
-              <a:solidFill>
-                <a:srgbClr val="16A78B"/>
-              </a:solidFill>
-              <a:ln>
-                <a:solidFill>
-                  <a:srgbClr val="16222E"/>
-                </a:solidFill>
-              </a:ln>
-            </c:spPr>
-          </c:marker>
-          <c:dPt>
-            <c:idx val="6"/>
-            <c:marker>
-              <c:symbol val="circle"/>
-              <c:size val="8"/>
-              <c:spPr>
-                <a:solidFill>
-                  <a:srgbClr val="16222E"/>
-                </a:solidFill>
-                <a:ln>
-                  <a:solidFill>
-                    <a:srgbClr val="16A78B"/>
-                  </a:solidFill>
-                </a:ln>
-              </c:spPr>
-            </c:marker>
-            <c:spPr>
-              <a:ln w="19050">
-                <a:solidFill>
-                  <a:srgbClr val="16A78B"/>
-                </a:solidFill>
-                <a:prstDash val="dash"/>
-              </a:ln>
-            </c:spPr>
-          </c:dPt>
-          <c:cat>
-            <c:strRef>
-              <c:f>Sheet1!$A$2:$A$8</c:f>
-              <c:strCache>
-                <c:ptCount val="7"/>
-                <c:pt idx="0">
-                  <c:v>1</c:v>
-                </c:pt>
-                <c:pt idx="1">
-                  <c:v>10</c:v>
-                </c:pt>
-                <c:pt idx="2">
-                  <c:v>100</c:v>
-                </c:pt>
-                <c:pt idx="3">
-                  <c:v>1 mil</c:v>
-                </c:pt>
-                <c:pt idx="4">
-                  <c:v>10 mil</c:v>
-                </c:pt>
-                <c:pt idx="5">
-                  <c:v>100 mil</c:v>
-                </c:pt>
-                <c:pt idx="6">
-                  <c:v>1 milhão</c:v>
-                </c:pt>
-              </c:strCache>
-            </c:strRef>
-          </c:cat>
-          <c:val>
-            <c:numRef>
-              <c:f>Sheet1!$B$2:$B$8</c:f>
-              <c:numCache>
-                <c:formatCode>General</c:formatCode>
-                <c:ptCount val="7"/>
-                <c:pt idx="0">
-                  <c:v>0.0</c:v>
-                </c:pt>
-                <c:pt idx="1">
-                  <c:v>0.003</c:v>
-                </c:pt>
-                <c:pt idx="2">
-                  <c:v>0.386</c:v>
-                </c:pt>
-                <c:pt idx="3">
-                  <c:v>0.509</c:v>
-                </c:pt>
-                <c:pt idx="4">
-                  <c:v>0.516</c:v>
-                </c:pt>
-                <c:pt idx="5">
-                  <c:v>0.516</c:v>
-                </c:pt>
-                <c:pt idx="6">
-                  <c:v>0.516</c:v>
-                </c:pt>
-              </c:numCache>
-            </c:numRef>
-          </c:val>
-          <c:smooth val="0"/>
-        </c:ser>
-        <c:ser>
-          <c:idx val="1"/>
-          <c:order val="1"/>
-          <c:tx>
-            <c:strRef>
-              <c:f>Sheet1!$C$1</c:f>
-              <c:strCache>
-                <c:ptCount val="1"/>
-                <c:pt idx="0">
-                  <c:v>Tokens o200k_base</c:v>
+                  <c:v>Tokens a menos</c:v>
                 </c:pt>
               </c:strCache>
             </c:strRef>
@@ -725,7 +604,7 @@
           </c:cat>
           <c:val>
             <c:numRef>
-              <c:f>Sheet1!$C$2:$C$8</c:f>
+              <c:f>Sheet1!$B$2:$B$8</c:f>
               <c:numCache>
                 <c:formatCode>General</c:formatCode>
                 <c:ptCount val="7"/>
@@ -4315,7 +4194,7 @@
                 </a:solidFill>
                 <a:latin typeface="Arial"/>
               </a:rPr>
-              <a:t>BENCHMARK DE CONTEXTO · 6 ESCALAS MEDIDAS + 1 PROJETADA · 48 CONSULTAS PAREADAS · 96 EXECUÇÕES</a:t>
+              <a:t>BENCHMARK DE TOKENS · 6 ESCALAS MEDIDAS + 1 PROJETADA · 48 CONSULTAS PAREADAS · 96 EXECUÇÕES</a:t>
             </a:r>
           </a:p>
         </p:txBody>
@@ -4349,7 +4228,7 @@
                 </a:solidFill>
                 <a:latin typeface="Arial"/>
               </a:rPr>
-              <a:t>De 1 nota a 1 milhão de notas</a:t>
+              <a:t>58% menos tokens, de 1 nota a 1 milhão de notas</a:t>
             </a:r>
           </a:p>
         </p:txBody>
@@ -4383,7 +4262,7 @@
                 </a:solidFill>
                 <a:latin typeface="Arial"/>
               </a:rPr>
-              <a:t>Medido de 1 a 100 mil notas (282,1 MB). 1 milhão (2,83 GB) foi gerado, mas a busca anterior não terminou em 22 min: aparece como projeção.</a:t>
+              <a:t>Tokens que a busca devolve ao agente por consulta. Medido de 1 a 100 mil notas (282,1 MB); 1 milhão (2,83 GB) em medição, mostrado como projeção.</a:t>
             </a:r>
           </a:p>
         </p:txBody>
@@ -4461,7 +4340,7 @@
                 </a:solidFill>
                 <a:latin typeface="Arial"/>
               </a:rPr>
-              <a:t>48/48</a:t>
+              <a:t>58,2%</a:t>
             </a:r>
           </a:p>
         </p:txBody>
@@ -4495,7 +4374,7 @@
                 </a:solidFill>
                 <a:latin typeface="Arial"/>
               </a:rPr>
-              <a:t>comparações medidas com as</a:t>
+              <a:t>menos tokens por consulta</a:t>
             </a:r>
           </a:p>
           <a:p>
@@ -4506,7 +4385,7 @@
                 </a:solidFill>
                 <a:latin typeface="Arial"/>
               </a:rPr>
-              <a:t>mesmas notas e trechos</a:t>
+              <a:t>em 100 mil notas</a:t>
             </a:r>
           </a:p>
         </p:txBody>
@@ -4584,7 +4463,7 @@
                 </a:solidFill>
                 <a:latin typeface="Arial"/>
               </a:rPr>
-              <a:t>50,9–51,6%</a:t>
+              <a:t>3.116 → 1.301</a:t>
             </a:r>
           </a:p>
         </p:txBody>
@@ -4618,7 +4497,7 @@
                 </a:solidFill>
                 <a:latin typeface="Arial"/>
               </a:rPr>
-              <a:t>menos caracteres por escala,</a:t>
+              <a:t>tokens por consulta, em média,</a:t>
             </a:r>
           </a:p>
           <a:p>
@@ -4629,7 +4508,7 @@
                 </a:solidFill>
                 <a:latin typeface="Arial"/>
               </a:rPr>
-              <a:t>de 1 mil a 100 mil notas</a:t>
+              <a:t>em 100 mil notas</a:t>
             </a:r>
           </a:p>
         </p:txBody>
@@ -4707,7 +4586,7 @@
                 </a:solidFill>
                 <a:latin typeface="Arial"/>
               </a:rPr>
-              <a:t>58,2%</a:t>
+              <a:t>51,4%</a:t>
             </a:r>
           </a:p>
         </p:txBody>
@@ -4741,7 +4620,7 @@
                 </a:solidFill>
                 <a:latin typeface="Arial"/>
               </a:rPr>
-              <a:t>menos tokens o200k_base</a:t>
+              <a:t>tokens a menos no total das 48</a:t>
             </a:r>
           </a:p>
           <a:p>
@@ -4752,7 +4631,7 @@
                 </a:solidFill>
                 <a:latin typeface="Arial"/>
               </a:rPr>
-              <a:t>em 100 mil notas</a:t>
+              <a:t>consultas: 100.008 → 48.562</a:t>
             </a:r>
           </a:p>
         </p:txBody>
@@ -4830,7 +4709,7 @@
                 </a:solidFill>
                 <a:latin typeface="Arial"/>
               </a:rPr>
-              <a:t>3,8×</a:t>
+              <a:t>48/48</a:t>
             </a:r>
           </a:p>
         </p:txBody>
@@ -4864,7 +4743,7 @@
                 </a:solidFill>
                 <a:latin typeface="Arial"/>
               </a:rPr>
-              <a:t>busca atual mais rápida</a:t>
+              <a:t>consultas com as mesmas notas</a:t>
             </a:r>
           </a:p>
           <a:p>
@@ -4875,7 +4754,7 @@
                 </a:solidFill>
                 <a:latin typeface="Arial"/>
               </a:rPr>
-              <a:t>em 100 mil notas</a:t>
+              <a:t>e trechos: menos tokens, mesma resposta</a:t>
             </a:r>
           </a:p>
         </p:txBody>
@@ -4909,7 +4788,7 @@
                 </a:solidFill>
                 <a:latin typeface="Arial"/>
               </a:rPr>
-              <a:t>Texto retornado por consulta</a:t>
+              <a:t>Tokens retornados por consulta</a:t>
             </a:r>
           </a:p>
         </p:txBody>
@@ -4943,7 +4822,7 @@
                 </a:solidFill>
                 <a:latin typeface="Arial"/>
               </a:rPr>
-              <a:t>média de 8 consultas, caracteres · ○ tracejado = projeção</a:t>
+              <a:t>média de 8 consultas, tokens o200k_base · ○ tracejado = projeção</a:t>
             </a:r>
           </a:p>
         </p:txBody>
@@ -4995,7 +4874,7 @@
                 </a:solidFill>
                 <a:latin typeface="Arial"/>
               </a:rPr>
-              <a:t>Redução conforme o acervo cresce</a:t>
+              <a:t>Redução de tokens conforme o acervo cresce</a:t>
             </a:r>
           </a:p>
         </p:txBody>
@@ -5535,7 +5414,7 @@
                           </a:solidFill>
                           <a:latin typeface="Arial"/>
                         </a:rPr>
-                        <a:t>Saída antes (car.)</a:t>
+                        <a:t>Tokens antes / consulta</a:t>
                       </a:r>
                     </a:p>
                   </a:txBody>
@@ -5557,7 +5436,7 @@
                           </a:solidFill>
                           <a:latin typeface="Arial"/>
                         </a:rPr>
-                        <a:t>4.667</a:t>
+                        <a:t>153</a:t>
                       </a:r>
                     </a:p>
                   </a:txBody>
@@ -5579,7 +5458,7 @@
                           </a:solidFill>
                           <a:latin typeface="Arial"/>
                         </a:rPr>
-                        <a:t>23.587</a:t>
+                        <a:t>758</a:t>
                       </a:r>
                     </a:p>
                   </a:txBody>
@@ -5601,7 +5480,7 @@
                           </a:solidFill>
                           <a:latin typeface="Arial"/>
                         </a:rPr>
-                        <a:t>64.082</a:t>
+                        <a:t>2.298</a:t>
                       </a:r>
                     </a:p>
                   </a:txBody>
@@ -5623,7 +5502,7 @@
                           </a:solidFill>
                           <a:latin typeface="Arial"/>
                         </a:rPr>
-                        <a:t>82.546</a:t>
+                        <a:t>3.060</a:t>
                       </a:r>
                     </a:p>
                   </a:txBody>
@@ -5645,7 +5524,7 @@
                           </a:solidFill>
                           <a:latin typeface="Arial"/>
                         </a:rPr>
-                        <a:t>83.872</a:t>
+                        <a:t>3.116</a:t>
                       </a:r>
                     </a:p>
                   </a:txBody>
@@ -5667,7 +5546,7 @@
                           </a:solidFill>
                           <a:latin typeface="Arial"/>
                         </a:rPr>
-                        <a:t>83.886</a:t>
+                        <a:t>3.116</a:t>
                       </a:r>
                     </a:p>
                   </a:txBody>
@@ -5689,7 +5568,7 @@
                           </a:solidFill>
                           <a:latin typeface="Arial"/>
                         </a:rPr>
-                        <a:t>≈ 83.900</a:t>
+                        <a:t>≈ 3.116</a:t>
                       </a:r>
                     </a:p>
                   </a:txBody>
@@ -5713,7 +5592,7 @@
                           </a:solidFill>
                           <a:latin typeface="Arial"/>
                         </a:rPr>
-                        <a:t>Saída atual (car.)</a:t>
+                        <a:t>Tokens atual / consulta</a:t>
                       </a:r>
                     </a:p>
                   </a:txBody>
@@ -5735,7 +5614,7 @@
                           </a:solidFill>
                           <a:latin typeface="Arial"/>
                         </a:rPr>
-                        <a:t>4.667</a:t>
+                        <a:t>153</a:t>
                       </a:r>
                     </a:p>
                   </a:txBody>
@@ -5757,7 +5636,7 @@
                           </a:solidFill>
                           <a:latin typeface="Arial"/>
                         </a:rPr>
-                        <a:t>23.509</a:t>
+                        <a:t>754</a:t>
                       </a:r>
                     </a:p>
                   </a:txBody>
@@ -5779,7 +5658,7 @@
                           </a:solidFill>
                           <a:latin typeface="Arial"/>
                         </a:rPr>
-                        <a:t>39.371</a:t>
+                        <a:t>1.261</a:t>
                       </a:r>
                     </a:p>
                   </a:txBody>
@@ -5801,7 +5680,7 @@
                           </a:solidFill>
                           <a:latin typeface="Arial"/>
                         </a:rPr>
-                        <a:t>40.565</a:t>
+                        <a:t>1.300</a:t>
                       </a:r>
                     </a:p>
                   </a:txBody>
@@ -5823,7 +5702,7 @@
                           </a:solidFill>
                           <a:latin typeface="Arial"/>
                         </a:rPr>
-                        <a:t>40.579</a:t>
+                        <a:t>1.301</a:t>
                       </a:r>
                     </a:p>
                   </a:txBody>
@@ -5845,7 +5724,7 @@
                           </a:solidFill>
                           <a:latin typeface="Arial"/>
                         </a:rPr>
-                        <a:t>40.593</a:t>
+                        <a:t>1.301</a:t>
                       </a:r>
                     </a:p>
                   </a:txBody>
@@ -5867,7 +5746,7 @@
                           </a:solidFill>
                           <a:latin typeface="Arial"/>
                         </a:rPr>
-                        <a:t>≈ 40.607</a:t>
+                        <a:t>≈ 1.302</a:t>
                       </a:r>
                     </a:p>
                   </a:txBody>
@@ -5885,13 +5764,13 @@
                     <a:lstStyle/>
                     <a:p>
                       <a:r>
-                        <a:rPr sz="1000" b="1" i="0">
+                        <a:rPr sz="1000" b="0" i="0">
                           <a:solidFill>
                             <a:srgbClr val="B4C0CC"/>
                           </a:solidFill>
                           <a:latin typeface="Arial"/>
                         </a:rPr>
-                        <a:t>Redução (car.)</a:t>
+                        <a:t>Economia / consulta</a:t>
                       </a:r>
                     </a:p>
                   </a:txBody>
@@ -5907,13 +5786,13 @@
                     <a:lstStyle/>
                     <a:p>
                       <a:r>
-                        <a:rPr sz="1000" b="1" i="0">
+                        <a:rPr sz="1000" b="0" i="0">
                           <a:solidFill>
                             <a:srgbClr val="EEF2F6"/>
                           </a:solidFill>
                           <a:latin typeface="Arial"/>
                         </a:rPr>
-                        <a:t>0,0%</a:t>
+                        <a:t>0</a:t>
                       </a:r>
                     </a:p>
                   </a:txBody>
@@ -5929,13 +5808,13 @@
                     <a:lstStyle/>
                     <a:p>
                       <a:r>
-                        <a:rPr sz="1000" b="1" i="0">
+                        <a:rPr sz="1000" b="0" i="0">
                           <a:solidFill>
                             <a:srgbClr val="EEF2F6"/>
                           </a:solidFill>
                           <a:latin typeface="Arial"/>
                         </a:rPr>
-                        <a:t>0,3%</a:t>
+                        <a:t>4</a:t>
                       </a:r>
                     </a:p>
                   </a:txBody>
@@ -5951,13 +5830,13 @@
                     <a:lstStyle/>
                     <a:p>
                       <a:r>
-                        <a:rPr sz="1000" b="1" i="0">
+                        <a:rPr sz="1000" b="0" i="0">
                           <a:solidFill>
                             <a:srgbClr val="EEF2F6"/>
                           </a:solidFill>
                           <a:latin typeface="Arial"/>
                         </a:rPr>
-                        <a:t>38,6%</a:t>
+                        <a:t>1.037</a:t>
                       </a:r>
                     </a:p>
                   </a:txBody>
@@ -5973,13 +5852,13 @@
                     <a:lstStyle/>
                     <a:p>
                       <a:r>
-                        <a:rPr sz="1000" b="1" i="0">
+                        <a:rPr sz="1000" b="0" i="0">
                           <a:solidFill>
                             <a:srgbClr val="EEF2F6"/>
                           </a:solidFill>
                           <a:latin typeface="Arial"/>
                         </a:rPr>
-                        <a:t>50,9%</a:t>
+                        <a:t>1.761</a:t>
                       </a:r>
                     </a:p>
                   </a:txBody>
@@ -5995,13 +5874,13 @@
                     <a:lstStyle/>
                     <a:p>
                       <a:r>
-                        <a:rPr sz="1000" b="1" i="0">
+                        <a:rPr sz="1000" b="0" i="0">
                           <a:solidFill>
                             <a:srgbClr val="EEF2F6"/>
                           </a:solidFill>
                           <a:latin typeface="Arial"/>
                         </a:rPr>
-                        <a:t>51,6%</a:t>
+                        <a:t>1.815</a:t>
                       </a:r>
                     </a:p>
                   </a:txBody>
@@ -6017,13 +5896,13 @@
                     <a:lstStyle/>
                     <a:p>
                       <a:r>
-                        <a:rPr sz="1000" b="1" i="0">
+                        <a:rPr sz="1000" b="0" i="0">
                           <a:solidFill>
                             <a:srgbClr val="EEF2F6"/>
                           </a:solidFill>
                           <a:latin typeface="Arial"/>
                         </a:rPr>
-                        <a:t>51,6%</a:t>
+                        <a:t>1.815</a:t>
                       </a:r>
                     </a:p>
                   </a:txBody>
@@ -6045,7 +5924,7 @@
                           </a:solidFill>
                           <a:latin typeface="Arial"/>
                         </a:rPr>
-                        <a:t>≈ 51,6%</a:t>
+                        <a:t>≈ 1.815</a:t>
                       </a:r>
                     </a:p>
                   </a:txBody>
@@ -6445,7 +6324,7 @@
                 </a:solidFill>
                 <a:latin typeface="Arial"/>
               </a:rPr>
-              <a:t>Medido: de 1 a 100 mil notas, cada escala gravou e consultou suas notas em disco; mesmas notas e trechos antes e depois, limite de 5 notas e 12.000 caracteres.</a:t>
+              <a:t>Medido: de 1 a 100 mil notas, cada escala gravou e consultou suas notas em disco; mesmas notas e trechos antes e depois, limite de 5 notas e 12.000 caracteres por consulta.</a:t>
             </a:r>
           </a:p>
         </p:txBody>
@@ -6479,7 +6358,7 @@
                 </a:solidFill>
                 <a:latin typeface="Arial"/>
               </a:rPr>
-              <a:t>Projeção (1 milhão): saídas limitadas pelo orçamento e tempo extrapolado de 10 mil → 100 mil. Tokens: tiktoken o200k_base, não o tokenizador do Claude; só a saída da busca.</a:t>
+              <a:t>Tokens: tiktoken o200k_base sobre a saída da busca (aproximação; o tokenizador do Claude difere). Projeção (1 milhão): saída limitada pelo orçamento e tempo extrapolado de 10 mil → 100 mil.</a:t>
             </a:r>
           </a:p>
         </p:txBody>
@@ -6513,7 +6392,7 @@
                 </a:solidFill>
                 <a:latin typeface="Arial"/>
               </a:rPr>
-              <a:t>17/10/2026 · Apple M5, Python 3.14.7 · uma passagem por caso, sem controle de cache · dados 100% sintéticos · método e números completos: docs/BENCHMARK.md</a:t>
+              <a:t>18/10/2026 · Apple M5, Python 3.14.7 · uma passagem por caso, sem controle de cache · dados 100% sintéticos · método e números completos: docs/BENCHMARK.md</a:t>
             </a:r>
           </a:p>
         </p:txBody>

</xml_diff>

<commit_message>
chore: apply the short hook and estimate one million notes
O hook de início injeta só o resumo de regras (seção Resumo do hook do Protocolo ou RESUMO padrão), com testes. Benchmark ampliado com estimativa para 1 milhão de notas e one-pager atualizado.
</commit_message>
<xml_diff>
--- a/media/one-pager.pptx
+++ b/media/one-pager.pptx
@@ -903,7 +903,7 @@
                   <c:v>614.024</c:v>
                 </c:pt>
                 <c:pt idx="6">
-                  <c:v>27761</c:v>
+                  <c:v>96687</c:v>
                 </c:pt>
               </c:numCache>
             </c:numRef>
@@ -1024,7 +1024,7 @@
                   <c:v>160.173</c:v>
                 </c:pt>
                 <c:pt idx="6">
-                  <c:v>2541</c:v>
+                  <c:v>2970</c:v>
                 </c:pt>
               </c:numCache>
             </c:numRef>
@@ -4262,7 +4262,7 @@
                 </a:solidFill>
                 <a:latin typeface="Arial"/>
               </a:rPr>
-              <a:t>Tokens que a busca devolve ao agente por consulta. Medido de 1 a 100 mil notas (282,1 MB); 1 milhão (2,83 GB) em medição, mostrado como projeção.</a:t>
+              <a:t>Tokens que a busca devolve ao agente por consulta. Medido de 1 a 100 mil notas (282,1 MB); 1 milhão (2,83 GB) medido em 4 de 8 buscas, completado por estimativa.</a:t>
             </a:r>
           </a:p>
         </p:txBody>
@@ -6280,7 +6280,7 @@
                           </a:solidFill>
                           <a:latin typeface="Arial"/>
                         </a:rPr>
-                        <a:t>≈ 7,7 h → 42 min</a:t>
+                        <a:t>≈ 27 h → 50 min</a:t>
                       </a:r>
                     </a:p>
                   </a:txBody>
@@ -6358,7 +6358,7 @@
                 </a:solidFill>
                 <a:latin typeface="Arial"/>
               </a:rPr>
-              <a:t>Tokens: tiktoken o200k_base sobre a saída da busca (aproximação; o tokenizador do Claude difere). Projeção (1 milhão): saída limitada pelo orçamento e tempo extrapolado de 10 mil → 100 mil.</a:t>
+              <a:t>Tokens: tiktoken o200k_base sobre a saída da busca (aproximação; o tokenizador do Claude difere). 1 milhão: tokens projetados; tempo medido nas buscas 1–4, estimado nas 5–8.</a:t>
             </a:r>
           </a:p>
         </p:txBody>

</xml_diff>

<commit_message>
chore: Present 1 million notes as the final benchmark result
Draw the 1M point with solid lines and markers, drop projection styling from tables, and keep a footnote on which searches were measured and which were estimated.
</commit_message>
<xml_diff>
--- a/media/one-pager.pptx
+++ b/media/one-pager.pptx
@@ -151,31 +151,6 @@
               </a:ln>
             </c:spPr>
           </c:marker>
-          <c:dPt>
-            <c:idx val="6"/>
-            <c:marker>
-              <c:symbol val="circle"/>
-              <c:size val="8"/>
-              <c:spPr>
-                <a:solidFill>
-                  <a:srgbClr val="16222E"/>
-                </a:solidFill>
-                <a:ln>
-                  <a:solidFill>
-                    <a:srgbClr val="8B7FD9"/>
-                  </a:solidFill>
-                </a:ln>
-              </c:spPr>
-            </c:marker>
-            <c:spPr>
-              <a:ln w="19050">
-                <a:solidFill>
-                  <a:srgbClr val="8B7FD9"/>
-                </a:solidFill>
-                <a:prstDash val="dash"/>
-              </a:ln>
-            </c:spPr>
-          </c:dPt>
           <c:cat>
             <c:strRef>
               <c:f>Sheet1!$A$2:$A$8</c:f>
@@ -272,31 +247,6 @@
               </a:ln>
             </c:spPr>
           </c:marker>
-          <c:dPt>
-            <c:idx val="6"/>
-            <c:marker>
-              <c:symbol val="circle"/>
-              <c:size val="8"/>
-              <c:spPr>
-                <a:solidFill>
-                  <a:srgbClr val="16222E"/>
-                </a:solidFill>
-                <a:ln>
-                  <a:solidFill>
-                    <a:srgbClr val="16A78B"/>
-                  </a:solidFill>
-                </a:ln>
-              </c:spPr>
-            </c:marker>
-            <c:spPr>
-              <a:ln w="19050">
-                <a:solidFill>
-                  <a:srgbClr val="16A78B"/>
-                </a:solidFill>
-                <a:prstDash val="dash"/>
-              </a:ln>
-            </c:spPr>
-          </c:dPt>
           <c:cat>
             <c:strRef>
               <c:f>Sheet1!$A$2:$A$8</c:f>
@@ -548,31 +498,6 @@
               </a:ln>
             </c:spPr>
           </c:marker>
-          <c:dPt>
-            <c:idx val="6"/>
-            <c:marker>
-              <c:symbol val="circle"/>
-              <c:size val="8"/>
-              <c:spPr>
-                <a:solidFill>
-                  <a:srgbClr val="16222E"/>
-                </a:solidFill>
-                <a:ln>
-                  <a:solidFill>
-                    <a:srgbClr val="B9821A"/>
-                  </a:solidFill>
-                </a:ln>
-              </c:spPr>
-            </c:marker>
-            <c:spPr>
-              <a:ln w="19050">
-                <a:solidFill>
-                  <a:srgbClr val="B9821A"/>
-                </a:solidFill>
-                <a:prstDash val="dash"/>
-              </a:ln>
-            </c:spPr>
-          </c:dPt>
           <c:cat>
             <c:strRef>
               <c:f>Sheet1!$A$2:$A$8</c:f>
@@ -824,31 +749,6 @@
               </a:ln>
             </c:spPr>
           </c:marker>
-          <c:dPt>
-            <c:idx val="6"/>
-            <c:marker>
-              <c:symbol val="circle"/>
-              <c:size val="8"/>
-              <c:spPr>
-                <a:solidFill>
-                  <a:srgbClr val="16222E"/>
-                </a:solidFill>
-                <a:ln>
-                  <a:solidFill>
-                    <a:srgbClr val="8B7FD9"/>
-                  </a:solidFill>
-                </a:ln>
-              </c:spPr>
-            </c:marker>
-            <c:spPr>
-              <a:ln w="19050">
-                <a:solidFill>
-                  <a:srgbClr val="8B7FD9"/>
-                </a:solidFill>
-                <a:prstDash val="dash"/>
-              </a:ln>
-            </c:spPr>
-          </c:dPt>
           <c:cat>
             <c:strRef>
               <c:f>Sheet1!$A$2:$A$8</c:f>
@@ -945,31 +845,6 @@
               </a:ln>
             </c:spPr>
           </c:marker>
-          <c:dPt>
-            <c:idx val="6"/>
-            <c:marker>
-              <c:symbol val="circle"/>
-              <c:size val="8"/>
-              <c:spPr>
-                <a:solidFill>
-                  <a:srgbClr val="16222E"/>
-                </a:solidFill>
-                <a:ln>
-                  <a:solidFill>
-                    <a:srgbClr val="16A78B"/>
-                  </a:solidFill>
-                </a:ln>
-              </c:spPr>
-            </c:marker>
-            <c:spPr>
-              <a:ln w="19050">
-                <a:solidFill>
-                  <a:srgbClr val="16A78B"/>
-                </a:solidFill>
-                <a:prstDash val="dash"/>
-              </a:ln>
-            </c:spPr>
-          </c:dPt>
           <c:cat>
             <c:strRef>
               <c:f>Sheet1!$A$2:$A$8</c:f>
@@ -4194,7 +4069,7 @@
                 </a:solidFill>
                 <a:latin typeface="Arial"/>
               </a:rPr>
-              <a:t>BENCHMARK DE TOKENS · 6 ESCALAS MEDIDAS + 1 PROJETADA · 48 CONSULTAS PAREADAS · 96 EXECUÇÕES</a:t>
+              <a:t>BENCHMARK DE TOKENS · 7 ESCALAS · 48 CONSULTAS PAREADAS · 96 EXECUÇÕES</a:t>
             </a:r>
           </a:p>
         </p:txBody>
@@ -4262,7 +4137,7 @@
                 </a:solidFill>
                 <a:latin typeface="Arial"/>
               </a:rPr>
-              <a:t>Tokens que a busca devolve ao agente por consulta. Medido de 1 a 100 mil notas (282,1 MB); 1 milhão (2,83 GB) medido em 4 de 8 buscas, completado por estimativa.</a:t>
+              <a:t>Tokens que a busca devolve ao agente por consulta, de 1 a 1 milhão de notas (2,83 GB).</a:t>
             </a:r>
           </a:p>
         </p:txBody>
@@ -4822,7 +4697,7 @@
                 </a:solidFill>
                 <a:latin typeface="Arial"/>
               </a:rPr>
-              <a:t>média de 8 consultas, tokens o200k_base · ○ tracejado = projeção</a:t>
+              <a:t>média de 8 consultas, tokens o200k_base</a:t>
             </a:r>
           </a:p>
         </p:txBody>
@@ -4908,7 +4783,7 @@
                 </a:solidFill>
                 <a:latin typeface="Arial"/>
               </a:rPr>
-              <a:t>agregado de 8 consultas por escala, % · ○ tracejado = projeção</a:t>
+              <a:t>agregado de 8 consultas por escala, %</a:t>
             </a:r>
           </a:p>
         </p:txBody>
@@ -4994,7 +4869,7 @@
                 </a:solidFill>
                 <a:latin typeface="Arial"/>
               </a:rPr>
-              <a:t>soma de 8 consultas, segundos, escala log. · ○ tracejado = projeção</a:t>
+              <a:t>soma de 8 consultas, segundos, escala log.</a:t>
             </a:r>
           </a:p>
         </p:txBody>
@@ -5212,7 +5087,7 @@
                           </a:solidFill>
                           <a:latin typeface="Arial"/>
                         </a:rPr>
-                        <a:t>1 milhão · projeção</a:t>
+                        <a:t>1 milhão</a:t>
                       </a:r>
                     </a:p>
                   </a:txBody>
@@ -5384,9 +5259,9 @@
                     <a:lstStyle/>
                     <a:p>
                       <a:r>
-                        <a:rPr sz="1000" b="0" i="1">
+                        <a:rPr sz="1000" b="0" i="0">
                           <a:solidFill>
-                            <a:srgbClr val="7F8D9B"/>
+                            <a:srgbClr val="EEF2F6"/>
                           </a:solidFill>
                           <a:latin typeface="Arial"/>
                         </a:rPr>
@@ -5562,13 +5437,13 @@
                     <a:lstStyle/>
                     <a:p>
                       <a:r>
-                        <a:rPr sz="1000" b="0" i="1">
+                        <a:rPr sz="1000" b="0" i="0">
                           <a:solidFill>
-                            <a:srgbClr val="7F8D9B"/>
+                            <a:srgbClr val="EEF2F6"/>
                           </a:solidFill>
                           <a:latin typeface="Arial"/>
                         </a:rPr>
-                        <a:t>≈ 3.116</a:t>
+                        <a:t>3.116</a:t>
                       </a:r>
                     </a:p>
                   </a:txBody>
@@ -5740,13 +5615,13 @@
                     <a:lstStyle/>
                     <a:p>
                       <a:r>
-                        <a:rPr sz="1000" b="0" i="1">
+                        <a:rPr sz="1000" b="0" i="0">
                           <a:solidFill>
-                            <a:srgbClr val="7F8D9B"/>
+                            <a:srgbClr val="EEF2F6"/>
                           </a:solidFill>
                           <a:latin typeface="Arial"/>
                         </a:rPr>
-                        <a:t>≈ 1.302</a:t>
+                        <a:t>1.302</a:t>
                       </a:r>
                     </a:p>
                   </a:txBody>
@@ -5918,13 +5793,13 @@
                     <a:lstStyle/>
                     <a:p>
                       <a:r>
-                        <a:rPr sz="1000" b="0" i="1">
+                        <a:rPr sz="1000" b="0" i="0">
                           <a:solidFill>
-                            <a:srgbClr val="7F8D9B"/>
+                            <a:srgbClr val="EEF2F6"/>
                           </a:solidFill>
                           <a:latin typeface="Arial"/>
                         </a:rPr>
-                        <a:t>≈ 1.815</a:t>
+                        <a:t>1.815</a:t>
                       </a:r>
                     </a:p>
                   </a:txBody>
@@ -6096,13 +5971,13 @@
                     <a:lstStyle/>
                     <a:p>
                       <a:r>
-                        <a:rPr sz="1000" b="0" i="1">
+                        <a:rPr sz="1000" b="1" i="0">
                           <a:solidFill>
-                            <a:srgbClr val="7F8D9B"/>
+                            <a:srgbClr val="EEF2F6"/>
                           </a:solidFill>
                           <a:latin typeface="Arial"/>
                         </a:rPr>
-                        <a:t>≈ 58,2%</a:t>
+                        <a:t>58,2%</a:t>
                       </a:r>
                     </a:p>
                   </a:txBody>
@@ -6274,13 +6149,13 @@
                     <a:lstStyle/>
                     <a:p>
                       <a:r>
-                        <a:rPr sz="1000" b="0" i="1">
+                        <a:rPr sz="1000" b="0" i="0">
                           <a:solidFill>
-                            <a:srgbClr val="7F8D9B"/>
+                            <a:srgbClr val="EEF2F6"/>
                           </a:solidFill>
                           <a:latin typeface="Arial"/>
                         </a:rPr>
-                        <a:t>≈ 27 h → 50 min</a:t>
+                        <a:t>27 h → 50 min</a:t>
                       </a:r>
                     </a:p>
                   </a:txBody>
@@ -6324,7 +6199,7 @@
                 </a:solidFill>
                 <a:latin typeface="Arial"/>
               </a:rPr>
-              <a:t>Medido: de 1 a 100 mil notas, cada escala gravou e consultou suas notas em disco; mesmas notas e trechos antes e depois, limite de 5 notas e 12.000 caracteres por consulta.</a:t>
+              <a:t>Cada escala gravou e consultou suas notas em disco, com limite de 5 notas e 12.000 caracteres por consulta; de 1 a 100 mil notas, mesmas notas e trechos antes e depois.</a:t>
             </a:r>
           </a:p>
         </p:txBody>
@@ -6358,7 +6233,7 @@
                 </a:solidFill>
                 <a:latin typeface="Arial"/>
               </a:rPr>
-              <a:t>Tokens: tiktoken o200k_base sobre a saída da busca (aproximação; o tokenizador do Claude difere). 1 milhão: tokens projetados; tempo medido nas buscas 1–4, estimado nas 5–8.</a:t>
+              <a:t>Tokens: tiktoken o200k_base sobre a saída da busca (aproximação; o tokenizador do Claude difere). 1 milhão: buscas 1–4 medidas e 5–8 estimadas; tokens pela regra observada até 100 mil.</a:t>
             </a:r>
           </a:p>
         </p:txBody>

</xml_diff>